<commit_message>
Pitch deck: round photo frames, cleaner Arabic punctuation for Canva
Co-Authored-By: Claude Opus 5.5 (1M context) <noreply@anthropic.com>
Claude-Session: https://claude.ai/code/session_011TSHxy9drUC1JZWNcfUL3E
</commit_message>
<xml_diff>
--- a/pitch/SSB_VentureX.pptx
+++ b/pitch/SSB_VentureX.pptx
@@ -9997,7 +9997,7 @@
             <a:off x="9227668" y="3017520"/>
             <a:ext cx="1600200" cy="1600200"/>
           </a:xfrm>
-          <a:prstGeom prst="ellipse">
+          <a:prstGeom prst="rect">
             <a:avLst/>
           </a:prstGeom>
         </p:spPr>
@@ -10126,7 +10126,7 @@
             <a:off x="5295748" y="3017520"/>
             <a:ext cx="1600200" cy="1600200"/>
           </a:xfrm>
-          <a:prstGeom prst="ellipse">
+          <a:prstGeom prst="rect">
             <a:avLst/>
           </a:prstGeom>
         </p:spPr>
@@ -10255,7 +10255,7 @@
             <a:off x="1363828" y="3017520"/>
             <a:ext cx="1600200" cy="1600200"/>
           </a:xfrm>
-          <a:prstGeom prst="ellipse">
+          <a:prstGeom prst="rect">
             <a:avLst/>
           </a:prstGeom>
         </p:spPr>
@@ -11292,7 +11292,7 @@
                 <a:ea typeface="IBM Plex Sans Arabic" pitchFamily="34" charset="-122"/>
                 <a:cs typeface="IBM Plex Sans Arabic" pitchFamily="34" charset="-120"/>
               </a:rPr>
-              <a:t>هدر مالي صامت في فواتير السحابة للشركات الصغيرة والمتوسطة، من سيرفرات منسية وموارد زائدة، مع أدوات عالمية معقدة لا ترى السحب المحلية.</a:t>
+              <a:t>هدر مالي صامت في فواتير السحابة للشركات الصغيرة والمتوسطة، من سيرفرات منسية وموارد زائدة، مع أدوات عالمية معقدة لا ترى السحب المحلية</a:t>
             </a:r>
             <a:endParaRPr lang="en-US" sz="1600" dirty="0"/>
           </a:p>
@@ -11335,7 +11335,7 @@
                 <a:ea typeface="IBM Plex Sans Arabic" pitchFamily="34" charset="-122"/>
                 <a:cs typeface="IBM Plex Sans Arabic" pitchFamily="34" charset="-120"/>
               </a:rPr>
-              <a:t>لا توجد منصة محلية مستقلة تجمع السحب السعودية مع العالمية، وتنفّذ الحل بموافقة بشرية بدل تقارير لا ينفذها أحد.</a:t>
+              <a:t>لا توجد منصة محلية مستقلة تجمع السحب السعودية مع العالمية، وتنفّذ الحل بموافقة بشرية بدل تقارير لا ينفذها أحد</a:t>
             </a:r>
             <a:endParaRPr lang="en-US" sz="1600" dirty="0"/>
           </a:p>
@@ -11374,7 +11374,7 @@
                 <a:ea typeface="IBM Plex Sans Arabic" pitchFamily="34" charset="-122"/>
                 <a:cs typeface="IBM Plex Sans Arabic" pitchFamily="34" charset="-120"/>
               </a:rPr>
-              <a:t>المصادر: Flexera State of the Cloud 2026 (29%، 17%) · Uptime Institute, Annual Outage Analysis (40%) · MarketsandMarkets, Saudi Arabia Cloud Computing Market (5.1 مليار دولار)</a:t>
+              <a:t>المصادر: Flexera State of the Cloud 2026 · Uptime Institute Annual Outage Analysis · MarketsandMarkets Saudi Arabia Cloud Computing Market</a:t>
             </a:r>
             <a:endParaRPr lang="en-US" sz="1000" dirty="0"/>
           </a:p>
@@ -19791,7 +19791,7 @@
                 <a:ea typeface="IBM Plex Sans Arabic" pitchFamily="34" charset="-122"/>
                 <a:cs typeface="IBM Plex Sans Arabic" pitchFamily="34" charset="-120"/>
               </a:rPr>
-              <a:t>صلاحية مؤقتة لإجراء واحد (Just-in-time access) بدل صلاحيات كتابة دائمة.</a:t>
+              <a:t>صلاحية مؤقتة لإجراء واحد (Just-in-time access) بدل صلاحيات كتابة دائمة</a:t>
             </a:r>
             <a:endParaRPr lang="en-US" sz="1400" dirty="0"/>
           </a:p>

</xml_diff>

<commit_message>
Pitch deck: feasibility slide as two questions (how now, which tech)
Co-Authored-By: Claude Opus 5.5 (1M context) <noreply@anthropic.com>
Claude-Session: https://claude.ai/code/session_011TSHxy9drUC1JZWNcfUL3E
</commit_message>
<xml_diff>
--- a/pitch/SSB_VentureX.pptx
+++ b/pitch/SSB_VentureX.pptx
@@ -11814,8 +11814,8 @@
         </p:nvSpPr>
         <p:spPr>
           <a:xfrm>
-            <a:off x="457200" y="1600200"/>
-            <a:ext cx="11277295" cy="731520"/>
+            <a:off x="6172200" y="1691640"/>
+            <a:ext cx="5562295" cy="502920"/>
           </a:xfrm>
           <a:prstGeom prst="rect">
             <a:avLst/>
@@ -11831,17 +11831,17 @@
               <a:buNone/>
             </a:pPr>
             <a:r>
-              <a:rPr lang="en-US" sz="3400" b="1" dirty="0">
-                <a:solidFill>
-                  <a:srgbClr val="21141A"/>
-                </a:solidFill>
-                <a:latin typeface="IBM Plex Sans Arabic" pitchFamily="34" charset="0"/>
-                <a:ea typeface="IBM Plex Sans Arabic" pitchFamily="34" charset="-122"/>
-                <a:cs typeface="IBM Plex Sans Arabic" pitchFamily="34" charset="-120"/>
-              </a:rPr>
-              <a:t>AWS اليوم، والسحب المحلية تالياً</a:t>
-            </a:r>
-            <a:endParaRPr lang="en-US" sz="3400" dirty="0"/>
+              <a:rPr lang="en-US" sz="2100" b="1" dirty="0">
+                <a:solidFill>
+                  <a:srgbClr val="8E2F3C"/>
+                </a:solidFill>
+                <a:latin typeface="IBM Plex Sans Arabic" pitchFamily="34" charset="0"/>
+                <a:ea typeface="IBM Plex Sans Arabic" pitchFamily="34" charset="-122"/>
+                <a:cs typeface="IBM Plex Sans Arabic" pitchFamily="34" charset="-120"/>
+              </a:rPr>
+              <a:t>كيف يمكن تنفيذ الحل في الوقت الحالي؟</a:t>
+            </a:r>
+            <a:endParaRPr lang="en-US" sz="2100" dirty="0"/>
           </a:p>
         </p:txBody>
       </p:sp>
@@ -11853,23 +11853,50 @@
         </p:nvSpPr>
         <p:spPr>
           <a:xfrm>
-            <a:off x="8188757" y="2697480"/>
-            <a:ext cx="3545738" cy="2103120"/>
+            <a:off x="6172200" y="2423160"/>
+            <a:ext cx="5562295" cy="1005840"/>
           </a:xfrm>
           <a:prstGeom prst="roundRect">
             <a:avLst>
-              <a:gd name="adj" fmla="val 8696"/>
+              <a:gd name="adj" fmla="val 14545"/>
             </a:avLst>
           </a:prstGeom>
           <a:solidFill>
-            <a:srgbClr val="8E2F3C"/>
+            <a:srgbClr val="FFFBF8"/>
+          </a:solidFill>
+          <a:ln w="9525">
+            <a:solidFill>
+              <a:srgbClr val="E3D5CC"/>
+            </a:solidFill>
+            <a:prstDash val="solid"/>
+          </a:ln>
+        </p:spPr>
+      </p:sp>
+      <p:sp>
+        <p:nvSpPr>
+          <p:cNvPr id="24" name="Shape 19"/>
+          <p:cNvSpPr/>
+          <p:nvPr/>
+        </p:nvSpPr>
+        <p:spPr>
+          <a:xfrm>
+            <a:off x="10865815" y="2606040"/>
+            <a:ext cx="640080" cy="640080"/>
+          </a:xfrm>
+          <a:prstGeom prst="roundRect">
+            <a:avLst>
+              <a:gd name="adj" fmla="val 20000"/>
+            </a:avLst>
+          </a:prstGeom>
+          <a:solidFill>
+            <a:srgbClr val="F1E4DF"/>
           </a:solidFill>
           <a:ln/>
         </p:spPr>
       </p:sp>
       <p:pic>
         <p:nvPicPr>
-          <p:cNvPr id="24" name="Image 3" descr="/tmp/claude-0/-home-claude/750ff410-f4aa-5276-9360-1e19d018b112/scratchpad/c/assets/i-cloud-cr.png">    </p:cNvPr>
+          <p:cNvPr id="25" name="Image 3" descr="/tmp/claude-0/-home-claude/750ff410-f4aa-5276-9360-1e19d018b112/scratchpad/c/assets/i-plug-br.png">    </p:cNvPr>
           <p:cNvPicPr>
             <a:picLocks noChangeAspect="1"/>
           </p:cNvPicPr>
@@ -11883,8 +11910,8 @@
         </p:blipFill>
         <p:spPr>
           <a:xfrm>
-            <a:off x="9641586" y="2971800"/>
-            <a:ext cx="640080" cy="640080"/>
+            <a:off x="10957255" y="2697480"/>
+            <a:ext cx="457200" cy="457200"/>
           </a:xfrm>
           <a:prstGeom prst="rect">
             <a:avLst/>
@@ -11893,38 +11920,41 @@
       </p:pic>
       <p:sp>
         <p:nvSpPr>
-          <p:cNvPr id="25" name="Text 19"/>
-          <p:cNvSpPr txBox="1"/>
-          <p:nvPr/>
-        </p:nvSpPr>
-        <p:spPr>
-          <a:xfrm>
-            <a:off x="8188757" y="3703320"/>
-            <a:ext cx="3545738" cy="365760"/>
-          </a:xfrm>
-          <a:prstGeom prst="rect">
-            <a:avLst/>
-          </a:prstGeom>
-          <a:noFill/>
-          <a:ln/>
-        </p:spPr>
-        <p:txBody>
-          <a:bodyPr wrap="square" lIns="0" tIns="0" rIns="0" bIns="0" rtlCol="0" anchor="t"/>
-          <a:lstStyle/>
-          <a:p>
-            <a:pPr rtl="1" algn="ctr" indent="0" marL="0">
+          <p:cNvPr id="26" name="Text 20"/>
+          <p:cNvSpPr txBox="1"/>
+          <p:nvPr/>
+        </p:nvSpPr>
+        <p:spPr>
+          <a:xfrm>
+            <a:off x="6446520" y="2423160"/>
+            <a:ext cx="4236415" cy="1005840"/>
+          </a:xfrm>
+          <a:prstGeom prst="rect">
+            <a:avLst/>
+          </a:prstGeom>
+          <a:noFill/>
+          <a:ln/>
+        </p:spPr>
+        <p:txBody>
+          <a:bodyPr wrap="square" lIns="0" tIns="0" rIns="0" bIns="0" rtlCol="0" anchor="ctr"/>
+          <a:lstStyle/>
+          <a:p>
+            <a:pPr rtl="1" algn="r" indent="0" marL="0">
+              <a:lnSpc>
+                <a:spcPct val="110000"/>
+              </a:lnSpc>
               <a:buNone/>
             </a:pPr>
             <a:r>
               <a:rPr lang="en-US" sz="1600" dirty="0">
                 <a:solidFill>
-                  <a:srgbClr val="F1E4DF"/>
-                </a:solidFill>
-                <a:latin typeface="IBM Plex Sans Arabic" pitchFamily="34" charset="0"/>
-                <a:ea typeface="IBM Plex Sans Arabic" pitchFamily="34" charset="-122"/>
-                <a:cs typeface="IBM Plex Sans Arabic" pitchFamily="34" charset="-120"/>
-              </a:rPr>
-              <a:t>الآن</a:t>
+                  <a:srgbClr val="21141A"/>
+                </a:solidFill>
+                <a:latin typeface="IBM Plex Sans Arabic" pitchFamily="34" charset="0"/>
+                <a:ea typeface="IBM Plex Sans Arabic" pitchFamily="34" charset="-122"/>
+                <a:cs typeface="IBM Plex Sans Arabic" pitchFamily="34" charset="-120"/>
+              </a:rPr>
+              <a:t>ربط المنصة بحساب الشركة السحابي عبر API</a:t>
             </a:r>
             <a:endParaRPr lang="en-US" sz="1600" dirty="0"/>
           </a:p>
@@ -11932,57 +11962,18 @@
       </p:sp>
       <p:sp>
         <p:nvSpPr>
-          <p:cNvPr id="26" name="Text 20"/>
-          <p:cNvSpPr txBox="1"/>
-          <p:nvPr/>
-        </p:nvSpPr>
-        <p:spPr>
-          <a:xfrm>
-            <a:off x="8188757" y="4069080"/>
-            <a:ext cx="3545738" cy="502920"/>
-          </a:xfrm>
-          <a:prstGeom prst="rect">
-            <a:avLst/>
-          </a:prstGeom>
-          <a:noFill/>
-          <a:ln/>
-        </p:spPr>
-        <p:txBody>
-          <a:bodyPr wrap="square" lIns="0" tIns="0" rIns="0" bIns="0" rtlCol="0" anchor="t"/>
-          <a:lstStyle/>
-          <a:p>
-            <a:pPr rtl="1" algn="ctr" indent="0" marL="0">
-              <a:buNone/>
-            </a:pPr>
-            <a:r>
-              <a:rPr lang="en-US" sz="2400" b="1" dirty="0">
-                <a:solidFill>
-                  <a:srgbClr val="FBF6EE"/>
-                </a:solidFill>
-                <a:latin typeface="IBM Plex Sans Arabic" pitchFamily="34" charset="0"/>
-                <a:ea typeface="IBM Plex Sans Arabic" pitchFamily="34" charset="-122"/>
-                <a:cs typeface="IBM Plex Sans Arabic" pitchFamily="34" charset="-120"/>
-              </a:rPr>
-              <a:t>AWS</a:t>
-            </a:r>
-            <a:endParaRPr lang="en-US" sz="2400" dirty="0"/>
-          </a:p>
-        </p:txBody>
-      </p:sp>
-      <p:sp>
-        <p:nvSpPr>
           <p:cNvPr id="27" name="Shape 21"/>
           <p:cNvSpPr/>
           <p:nvPr/>
         </p:nvSpPr>
         <p:spPr>
           <a:xfrm>
-            <a:off x="4322978" y="2697480"/>
-            <a:ext cx="3545738" cy="2103120"/>
+            <a:off x="6172200" y="3611880"/>
+            <a:ext cx="5562295" cy="1005840"/>
           </a:xfrm>
           <a:prstGeom prst="roundRect">
             <a:avLst>
-              <a:gd name="adj" fmla="val 8696"/>
+              <a:gd name="adj" fmla="val 14545"/>
             </a:avLst>
           </a:prstGeom>
           <a:solidFill>
@@ -11996,9 +11987,31 @@
           </a:ln>
         </p:spPr>
       </p:sp>
+      <p:sp>
+        <p:nvSpPr>
+          <p:cNvPr id="28" name="Shape 22"/>
+          <p:cNvSpPr/>
+          <p:nvPr/>
+        </p:nvSpPr>
+        <p:spPr>
+          <a:xfrm>
+            <a:off x="10865815" y="3794760"/>
+            <a:ext cx="640080" cy="640080"/>
+          </a:xfrm>
+          <a:prstGeom prst="roundRect">
+            <a:avLst>
+              <a:gd name="adj" fmla="val 20000"/>
+            </a:avLst>
+          </a:prstGeom>
+          <a:solidFill>
+            <a:srgbClr val="F1E4DF"/>
+          </a:solidFill>
+          <a:ln/>
+        </p:spPr>
+      </p:sp>
       <p:pic>
         <p:nvPicPr>
-          <p:cNvPr id="28" name="Image 4" descr="/tmp/claude-0/-home-claude/750ff410-f4aa-5276-9360-1e19d018b112/scratchpad/c/assets/i-layers-br.png">    </p:cNvPr>
+          <p:cNvPr id="29" name="Image 4" descr="/tmp/claude-0/-home-claude/750ff410-f4aa-5276-9360-1e19d018b112/scratchpad/c/assets/i-bot-br.png">    </p:cNvPr>
           <p:cNvPicPr>
             <a:picLocks noChangeAspect="1"/>
           </p:cNvPicPr>
@@ -12012,8 +12025,8 @@
         </p:blipFill>
         <p:spPr>
           <a:xfrm>
-            <a:off x="5775808" y="2971800"/>
-            <a:ext cx="640080" cy="640080"/>
+            <a:off x="10957255" y="3886200"/>
+            <a:ext cx="457200" cy="457200"/>
           </a:xfrm>
           <a:prstGeom prst="rect">
             <a:avLst/>
@@ -12022,38 +12035,41 @@
       </p:pic>
       <p:sp>
         <p:nvSpPr>
-          <p:cNvPr id="29" name="Text 22"/>
-          <p:cNvSpPr txBox="1"/>
-          <p:nvPr/>
-        </p:nvSpPr>
-        <p:spPr>
-          <a:xfrm>
-            <a:off x="4322978" y="3703320"/>
-            <a:ext cx="3545738" cy="365760"/>
-          </a:xfrm>
-          <a:prstGeom prst="rect">
-            <a:avLst/>
-          </a:prstGeom>
-          <a:noFill/>
-          <a:ln/>
-        </p:spPr>
-        <p:txBody>
-          <a:bodyPr wrap="square" lIns="0" tIns="0" rIns="0" bIns="0" rtlCol="0" anchor="t"/>
-          <a:lstStyle/>
-          <a:p>
-            <a:pPr rtl="1" algn="ctr" indent="0" marL="0">
+          <p:cNvPr id="30" name="Text 23"/>
+          <p:cNvSpPr txBox="1"/>
+          <p:nvPr/>
+        </p:nvSpPr>
+        <p:spPr>
+          <a:xfrm>
+            <a:off x="6446520" y="3611880"/>
+            <a:ext cx="4236415" cy="1005840"/>
+          </a:xfrm>
+          <a:prstGeom prst="rect">
+            <a:avLst/>
+          </a:prstGeom>
+          <a:noFill/>
+          <a:ln/>
+        </p:spPr>
+        <p:txBody>
+          <a:bodyPr wrap="square" lIns="0" tIns="0" rIns="0" bIns="0" rtlCol="0" anchor="ctr"/>
+          <a:lstStyle/>
+          <a:p>
+            <a:pPr rtl="1" algn="r" indent="0" marL="0">
+              <a:lnSpc>
+                <a:spcPct val="110000"/>
+              </a:lnSpc>
               <a:buNone/>
             </a:pPr>
             <a:r>
               <a:rPr lang="en-US" sz="1600" dirty="0">
                 <a:solidFill>
-                  <a:srgbClr val="7F6C72"/>
-                </a:solidFill>
-                <a:latin typeface="IBM Plex Sans Arabic" pitchFamily="34" charset="0"/>
-                <a:ea typeface="IBM Plex Sans Arabic" pitchFamily="34" charset="-122"/>
-                <a:cs typeface="IBM Plex Sans Arabic" pitchFamily="34" charset="-120"/>
-              </a:rPr>
-              <a:t>التالي</a:t>
+                  <a:srgbClr val="21141A"/>
+                </a:solidFill>
+                <a:latin typeface="IBM Plex Sans Arabic" pitchFamily="34" charset="0"/>
+                <a:ea typeface="IBM Plex Sans Arabic" pitchFamily="34" charset="-122"/>
+                <a:cs typeface="IBM Plex Sans Arabic" pitchFamily="34" charset="-120"/>
+              </a:rPr>
+              <a:t>نموذج ذكاء اصطناعي يمسح البنية فوراً ويطابقها مع أفضل الممارسات ويحلل الأحمال</a:t>
             </a:r>
             <a:endParaRPr lang="en-US" sz="1600" dirty="0"/>
           </a:p>
@@ -12061,57 +12077,18 @@
       </p:sp>
       <p:sp>
         <p:nvSpPr>
-          <p:cNvPr id="30" name="Text 23"/>
-          <p:cNvSpPr txBox="1"/>
-          <p:nvPr/>
-        </p:nvSpPr>
-        <p:spPr>
-          <a:xfrm>
-            <a:off x="4322978" y="4069080"/>
-            <a:ext cx="3545738" cy="502920"/>
-          </a:xfrm>
-          <a:prstGeom prst="rect">
-            <a:avLst/>
-          </a:prstGeom>
-          <a:noFill/>
-          <a:ln/>
-        </p:spPr>
-        <p:txBody>
-          <a:bodyPr wrap="square" lIns="0" tIns="0" rIns="0" bIns="0" rtlCol="0" anchor="t"/>
-          <a:lstStyle/>
-          <a:p>
-            <a:pPr rtl="1" algn="ctr" indent="0" marL="0">
-              <a:buNone/>
-            </a:pPr>
-            <a:r>
-              <a:rPr lang="en-US" sz="2400" b="1" dirty="0">
-                <a:solidFill>
-                  <a:srgbClr val="8E2F3C"/>
-                </a:solidFill>
-                <a:latin typeface="IBM Plex Sans Arabic" pitchFamily="34" charset="0"/>
-                <a:ea typeface="IBM Plex Sans Arabic" pitchFamily="34" charset="-122"/>
-                <a:cs typeface="IBM Plex Sans Arabic" pitchFamily="34" charset="-120"/>
-              </a:rPr>
-              <a:t>Azure وGCP</a:t>
-            </a:r>
-            <a:endParaRPr lang="en-US" sz="2400" dirty="0"/>
-          </a:p>
-        </p:txBody>
-      </p:sp>
-      <p:sp>
-        <p:nvSpPr>
           <p:cNvPr id="31" name="Shape 24"/>
           <p:cNvSpPr/>
           <p:nvPr/>
         </p:nvSpPr>
         <p:spPr>
           <a:xfrm>
-            <a:off x="457200" y="2697480"/>
-            <a:ext cx="3545738" cy="2103120"/>
+            <a:off x="6172200" y="4800600"/>
+            <a:ext cx="5562295" cy="1005840"/>
           </a:xfrm>
           <a:prstGeom prst="roundRect">
             <a:avLst>
-              <a:gd name="adj" fmla="val 8696"/>
+              <a:gd name="adj" fmla="val 14545"/>
             </a:avLst>
           </a:prstGeom>
           <a:solidFill>
@@ -12125,9 +12102,31 @@
           </a:ln>
         </p:spPr>
       </p:sp>
+      <p:sp>
+        <p:nvSpPr>
+          <p:cNvPr id="32" name="Shape 25"/>
+          <p:cNvSpPr/>
+          <p:nvPr/>
+        </p:nvSpPr>
+        <p:spPr>
+          <a:xfrm>
+            <a:off x="10865815" y="4983480"/>
+            <a:ext cx="640080" cy="640080"/>
+          </a:xfrm>
+          <a:prstGeom prst="roundRect">
+            <a:avLst>
+              <a:gd name="adj" fmla="val 20000"/>
+            </a:avLst>
+          </a:prstGeom>
+          <a:solidFill>
+            <a:srgbClr val="F1E4DF"/>
+          </a:solidFill>
+          <a:ln/>
+        </p:spPr>
+      </p:sp>
       <p:pic>
         <p:nvPicPr>
-          <p:cNvPr id="32" name="Image 5" descr="/tmp/claude-0/-home-claude/750ff410-f4aa-5276-9360-1e19d018b112/scratchpad/c/assets/i-map-br.png">    </p:cNvPr>
+          <p:cNvPr id="33" name="Image 5" descr="/tmp/claude-0/-home-claude/750ff410-f4aa-5276-9360-1e19d018b112/scratchpad/c/assets/i-check-br.png">    </p:cNvPr>
           <p:cNvPicPr>
             <a:picLocks noChangeAspect="1"/>
           </p:cNvPicPr>
@@ -12141,8 +12140,8 @@
         </p:blipFill>
         <p:spPr>
           <a:xfrm>
-            <a:off x="1910029" y="2971800"/>
-            <a:ext cx="640080" cy="640080"/>
+            <a:off x="10957255" y="5074920"/>
+            <a:ext cx="457200" cy="457200"/>
           </a:xfrm>
           <a:prstGeom prst="rect">
             <a:avLst/>
@@ -12151,38 +12150,41 @@
       </p:pic>
       <p:sp>
         <p:nvSpPr>
-          <p:cNvPr id="33" name="Text 25"/>
-          <p:cNvSpPr txBox="1"/>
-          <p:nvPr/>
-        </p:nvSpPr>
-        <p:spPr>
-          <a:xfrm>
-            <a:off x="457200" y="3703320"/>
-            <a:ext cx="3545738" cy="365760"/>
-          </a:xfrm>
-          <a:prstGeom prst="rect">
-            <a:avLst/>
-          </a:prstGeom>
-          <a:noFill/>
-          <a:ln/>
-        </p:spPr>
-        <p:txBody>
-          <a:bodyPr wrap="square" lIns="0" tIns="0" rIns="0" bIns="0" rtlCol="0" anchor="t"/>
-          <a:lstStyle/>
-          <a:p>
-            <a:pPr rtl="1" algn="ctr" indent="0" marL="0">
+          <p:cNvPr id="34" name="Text 26"/>
+          <p:cNvSpPr txBox="1"/>
+          <p:nvPr/>
+        </p:nvSpPr>
+        <p:spPr>
+          <a:xfrm>
+            <a:off x="6446520" y="4800600"/>
+            <a:ext cx="4236415" cy="1005840"/>
+          </a:xfrm>
+          <a:prstGeom prst="rect">
+            <a:avLst/>
+          </a:prstGeom>
+          <a:noFill/>
+          <a:ln/>
+        </p:spPr>
+        <p:txBody>
+          <a:bodyPr wrap="square" lIns="0" tIns="0" rIns="0" bIns="0" rtlCol="0" anchor="ctr"/>
+          <a:lstStyle/>
+          <a:p>
+            <a:pPr rtl="1" algn="r" indent="0" marL="0">
+              <a:lnSpc>
+                <a:spcPct val="110000"/>
+              </a:lnSpc>
               <a:buNone/>
             </a:pPr>
             <a:r>
               <a:rPr lang="en-US" sz="1600" dirty="0">
                 <a:solidFill>
-                  <a:srgbClr val="7F6C72"/>
-                </a:solidFill>
-                <a:latin typeface="IBM Plex Sans Arabic" pitchFamily="34" charset="0"/>
-                <a:ea typeface="IBM Plex Sans Arabic" pitchFamily="34" charset="-122"/>
-                <a:cs typeface="IBM Plex Sans Arabic" pitchFamily="34" charset="-120"/>
-              </a:rPr>
-              <a:t>ثم</a:t>
+                  <a:srgbClr val="21141A"/>
+                </a:solidFill>
+                <a:latin typeface="IBM Plex Sans Arabic" pitchFamily="34" charset="0"/>
+                <a:ea typeface="IBM Plex Sans Arabic" pitchFamily="34" charset="-122"/>
+                <a:cs typeface="IBM Plex Sans Arabic" pitchFamily="34" charset="-120"/>
+              </a:rPr>
+              <a:t>زر تفاعلي بضغطة واحدة لإيقاف المورد أو تقليصه عبر API</a:t>
             </a:r>
             <a:endParaRPr lang="en-US" sz="1600" dirty="0"/>
           </a:p>
@@ -12190,68 +12192,24 @@
       </p:sp>
       <p:sp>
         <p:nvSpPr>
-          <p:cNvPr id="34" name="Text 26"/>
-          <p:cNvSpPr txBox="1"/>
-          <p:nvPr/>
-        </p:nvSpPr>
-        <p:spPr>
-          <a:xfrm>
-            <a:off x="457200" y="4069080"/>
-            <a:ext cx="3545738" cy="502920"/>
-          </a:xfrm>
-          <a:prstGeom prst="rect">
-            <a:avLst/>
-          </a:prstGeom>
-          <a:noFill/>
-          <a:ln/>
-        </p:spPr>
-        <p:txBody>
-          <a:bodyPr wrap="square" lIns="0" tIns="0" rIns="0" bIns="0" rtlCol="0" anchor="t"/>
-          <a:lstStyle/>
-          <a:p>
-            <a:pPr rtl="1" algn="ctr" indent="0" marL="0">
-              <a:buNone/>
-            </a:pPr>
-            <a:r>
-              <a:rPr lang="en-US" sz="2400" b="1" dirty="0">
-                <a:solidFill>
-                  <a:srgbClr val="8E2F3C"/>
-                </a:solidFill>
-                <a:latin typeface="IBM Plex Sans Arabic" pitchFamily="34" charset="0"/>
-                <a:ea typeface="IBM Plex Sans Arabic" pitchFamily="34" charset="-122"/>
-                <a:cs typeface="IBM Plex Sans Arabic" pitchFamily="34" charset="-120"/>
-              </a:rPr>
-              <a:t>STC وSCCC وCNTXT</a:t>
-            </a:r>
-            <a:endParaRPr lang="en-US" sz="2400" dirty="0"/>
-          </a:p>
-        </p:txBody>
-      </p:sp>
-      <p:sp>
-        <p:nvSpPr>
           <p:cNvPr id="35" name="Shape 27"/>
           <p:cNvSpPr/>
           <p:nvPr/>
         </p:nvSpPr>
         <p:spPr>
           <a:xfrm>
-            <a:off x="7353148" y="5257800"/>
-            <a:ext cx="1097280" cy="384048"/>
+            <a:off x="457200" y="1691640"/>
+            <a:ext cx="5257800" cy="4114800"/>
           </a:xfrm>
           <a:prstGeom prst="roundRect">
             <a:avLst>
-              <a:gd name="adj" fmla="val 50000"/>
+              <a:gd name="adj" fmla="val 4444"/>
             </a:avLst>
           </a:prstGeom>
           <a:solidFill>
-            <a:srgbClr val="FFFBF8"/>
-          </a:solidFill>
-          <a:ln w="9525">
-            <a:solidFill>
-              <a:srgbClr val="E3D5CC"/>
-            </a:solidFill>
-            <a:prstDash val="solid"/>
-          </a:ln>
+            <a:srgbClr val="8E2F3C"/>
+          </a:solidFill>
+          <a:ln/>
         </p:spPr>
       </p:sp>
       <p:sp>
@@ -12262,8 +12220,8 @@
         </p:nvSpPr>
         <p:spPr>
           <a:xfrm>
-            <a:off x="7353148" y="5257800"/>
-            <a:ext cx="1097280" cy="384048"/>
+            <a:off x="777240" y="1920240"/>
+            <a:ext cx="4617720" cy="502920"/>
           </a:xfrm>
           <a:prstGeom prst="rect">
             <a:avLst/>
@@ -12275,21 +12233,21 @@
           <a:bodyPr wrap="square" lIns="0" tIns="0" rIns="0" bIns="0" rtlCol="0" anchor="ctr"/>
           <a:lstStyle/>
           <a:p>
-            <a:pPr rtl="1" algn="ctr" indent="0" marL="0">
-              <a:buNone/>
-            </a:pPr>
-            <a:r>
-              <a:rPr lang="en-US" sz="1300" b="1" dirty="0">
-                <a:solidFill>
-                  <a:srgbClr val="21141A"/>
-                </a:solidFill>
-                <a:latin typeface="IBM Plex Sans Arabic" pitchFamily="34" charset="0"/>
-                <a:ea typeface="IBM Plex Sans Arabic" pitchFamily="34" charset="-122"/>
-                <a:cs typeface="IBM Plex Sans Arabic" pitchFamily="34" charset="-120"/>
-              </a:rPr>
-              <a:t>Next.js</a:t>
-            </a:r>
-            <a:endParaRPr lang="en-US" sz="1300" dirty="0"/>
+            <a:pPr rtl="1" algn="r" indent="0" marL="0">
+              <a:buNone/>
+            </a:pPr>
+            <a:r>
+              <a:rPr lang="en-US" sz="2100" b="1" dirty="0">
+                <a:solidFill>
+                  <a:srgbClr val="FBF6EE"/>
+                </a:solidFill>
+                <a:latin typeface="IBM Plex Sans Arabic" pitchFamily="34" charset="0"/>
+                <a:ea typeface="IBM Plex Sans Arabic" pitchFamily="34" charset="-122"/>
+                <a:cs typeface="IBM Plex Sans Arabic" pitchFamily="34" charset="-120"/>
+              </a:rPr>
+              <a:t>ما التقنيات المتوفرة لتنفيذه؟</a:t>
+            </a:r>
+            <a:endParaRPr lang="en-US" sz="2100" dirty="0"/>
           </a:p>
         </p:txBody>
       </p:sp>
@@ -12301,35 +12259,54 @@
         </p:nvSpPr>
         <p:spPr>
           <a:xfrm>
-            <a:off x="5844388" y="5257800"/>
-            <a:ext cx="1371600" cy="384048"/>
+            <a:off x="777240" y="2651760"/>
+            <a:ext cx="4617720" cy="804672"/>
           </a:xfrm>
           <a:prstGeom prst="roundRect">
             <a:avLst>
-              <a:gd name="adj" fmla="val 50000"/>
+              <a:gd name="adj" fmla="val 15909"/>
             </a:avLst>
           </a:prstGeom>
           <a:solidFill>
-            <a:srgbClr val="FFFBF8"/>
-          </a:solidFill>
-          <a:ln w="9525">
-            <a:solidFill>
-              <a:srgbClr val="E3D5CC"/>
-            </a:solidFill>
-            <a:prstDash val="solid"/>
-          </a:ln>
-        </p:spPr>
-      </p:sp>
-      <p:sp>
-        <p:nvSpPr>
-          <p:cNvPr id="38" name="Text 30"/>
-          <p:cNvSpPr txBox="1"/>
-          <p:nvPr/>
-        </p:nvSpPr>
-        <p:spPr>
-          <a:xfrm>
-            <a:off x="5844388" y="5257800"/>
-            <a:ext cx="1371600" cy="384048"/>
+            <a:srgbClr val="FBF6EE"/>
+          </a:solidFill>
+          <a:ln/>
+        </p:spPr>
+      </p:sp>
+      <p:pic>
+        <p:nvPicPr>
+          <p:cNvPr id="38" name="Image 6" descr="/tmp/claude-0/-home-claude/750ff410-f4aa-5276-9360-1e19d018b112/scratchpad/c/assets/i-cloud-br.png">    </p:cNvPr>
+          <p:cNvPicPr>
+            <a:picLocks noChangeAspect="1"/>
+          </p:cNvPicPr>
+          <p:nvPr/>
+        </p:nvPicPr>
+        <p:blipFill>
+          <a:blip r:embed="rId7"/>
+          <a:stretch>
+            <a:fillRect/>
+          </a:stretch>
+        </p:blipFill>
+        <p:spPr>
+          <a:xfrm>
+            <a:off x="4754880" y="2825496"/>
+            <a:ext cx="457200" cy="457200"/>
+          </a:xfrm>
+          <a:prstGeom prst="rect">
+            <a:avLst/>
+          </a:prstGeom>
+        </p:spPr>
+      </p:pic>
+      <p:sp>
+        <p:nvSpPr>
+          <p:cNvPr id="39" name="Text 30"/>
+          <p:cNvSpPr txBox="1"/>
+          <p:nvPr/>
+        </p:nvSpPr>
+        <p:spPr>
+          <a:xfrm>
+            <a:off x="1005840" y="2651760"/>
+            <a:ext cx="3657600" cy="804672"/>
           </a:xfrm>
           <a:prstGeom prst="rect">
             <a:avLst/>
@@ -12341,11 +12318,11 @@
           <a:bodyPr wrap="square" lIns="0" tIns="0" rIns="0" bIns="0" rtlCol="0" anchor="ctr"/>
           <a:lstStyle/>
           <a:p>
-            <a:pPr rtl="1" algn="ctr" indent="0" marL="0">
-              <a:buNone/>
-            </a:pPr>
-            <a:r>
-              <a:rPr lang="en-US" sz="1300" b="1" dirty="0">
+            <a:pPr rtl="1" algn="r" indent="0" marL="0">
+              <a:buNone/>
+            </a:pPr>
+            <a:r>
+              <a:rPr lang="en-US" sz="1800" b="1" dirty="0">
                 <a:solidFill>
                   <a:srgbClr val="21141A"/>
                 </a:solidFill>
@@ -12355,47 +12332,66 @@
               </a:rPr>
               <a:t>Cloud APIs</a:t>
             </a:r>
-            <a:endParaRPr lang="en-US" sz="1300" dirty="0"/>
-          </a:p>
-        </p:txBody>
-      </p:sp>
-      <p:sp>
-        <p:nvSpPr>
-          <p:cNvPr id="39" name="Shape 31"/>
-          <p:cNvSpPr/>
-          <p:nvPr/>
-        </p:nvSpPr>
-        <p:spPr>
-          <a:xfrm>
-            <a:off x="5067148" y="5257800"/>
-            <a:ext cx="640080" cy="384048"/>
+            <a:endParaRPr lang="en-US" sz="1800" dirty="0"/>
+          </a:p>
+        </p:txBody>
+      </p:sp>
+      <p:sp>
+        <p:nvSpPr>
+          <p:cNvPr id="40" name="Shape 31"/>
+          <p:cNvSpPr/>
+          <p:nvPr/>
+        </p:nvSpPr>
+        <p:spPr>
+          <a:xfrm>
+            <a:off x="777240" y="3639312"/>
+            <a:ext cx="4617720" cy="804672"/>
           </a:xfrm>
           <a:prstGeom prst="roundRect">
             <a:avLst>
-              <a:gd name="adj" fmla="val 50000"/>
+              <a:gd name="adj" fmla="val 15909"/>
             </a:avLst>
           </a:prstGeom>
           <a:solidFill>
-            <a:srgbClr val="FFFBF8"/>
-          </a:solidFill>
-          <a:ln w="9525">
-            <a:solidFill>
-              <a:srgbClr val="E3D5CC"/>
-            </a:solidFill>
-            <a:prstDash val="solid"/>
-          </a:ln>
-        </p:spPr>
-      </p:sp>
-      <p:sp>
-        <p:nvSpPr>
-          <p:cNvPr id="40" name="Text 32"/>
-          <p:cNvSpPr txBox="1"/>
-          <p:nvPr/>
-        </p:nvSpPr>
-        <p:spPr>
-          <a:xfrm>
-            <a:off x="5067148" y="5257800"/>
-            <a:ext cx="640080" cy="384048"/>
+            <a:srgbClr val="FBF6EE"/>
+          </a:solidFill>
+          <a:ln/>
+        </p:spPr>
+      </p:sp>
+      <p:pic>
+        <p:nvPicPr>
+          <p:cNvPr id="41" name="Image 7" descr="/tmp/claude-0/-home-claude/750ff410-f4aa-5276-9360-1e19d018b112/scratchpad/c/assets/i-brain-br.png">    </p:cNvPr>
+          <p:cNvPicPr>
+            <a:picLocks noChangeAspect="1"/>
+          </p:cNvPicPr>
+          <p:nvPr/>
+        </p:nvPicPr>
+        <p:blipFill>
+          <a:blip r:embed="rId8"/>
+          <a:stretch>
+            <a:fillRect/>
+          </a:stretch>
+        </p:blipFill>
+        <p:spPr>
+          <a:xfrm>
+            <a:off x="4754880" y="3813048"/>
+            <a:ext cx="457200" cy="457200"/>
+          </a:xfrm>
+          <a:prstGeom prst="rect">
+            <a:avLst/>
+          </a:prstGeom>
+        </p:spPr>
+      </p:pic>
+      <p:sp>
+        <p:nvSpPr>
+          <p:cNvPr id="42" name="Text 32"/>
+          <p:cNvSpPr txBox="1"/>
+          <p:nvPr/>
+        </p:nvSpPr>
+        <p:spPr>
+          <a:xfrm>
+            <a:off x="1005840" y="3639312"/>
+            <a:ext cx="3657600" cy="804672"/>
           </a:xfrm>
           <a:prstGeom prst="rect">
             <a:avLst/>
@@ -12407,11 +12403,11 @@
           <a:bodyPr wrap="square" lIns="0" tIns="0" rIns="0" bIns="0" rtlCol="0" anchor="ctr"/>
           <a:lstStyle/>
           <a:p>
-            <a:pPr rtl="1" algn="ctr" indent="0" marL="0">
-              <a:buNone/>
-            </a:pPr>
-            <a:r>
-              <a:rPr lang="en-US" sz="1300" b="1" dirty="0">
+            <a:pPr rtl="1" algn="r" indent="0" marL="0">
+              <a:buNone/>
+            </a:pPr>
+            <a:r>
+              <a:rPr lang="en-US" sz="1800" b="1" dirty="0">
                 <a:solidFill>
                   <a:srgbClr val="21141A"/>
                 </a:solidFill>
@@ -12419,49 +12415,68 @@
                 <a:ea typeface="IBM Plex Sans Arabic" pitchFamily="34" charset="-122"/>
                 <a:cs typeface="IBM Plex Sans Arabic" pitchFamily="34" charset="-120"/>
               </a:rPr>
-              <a:t>AI</a:t>
-            </a:r>
-            <a:endParaRPr lang="en-US" sz="1300" dirty="0"/>
-          </a:p>
-        </p:txBody>
-      </p:sp>
-      <p:sp>
-        <p:nvSpPr>
-          <p:cNvPr id="41" name="Shape 33"/>
-          <p:cNvSpPr/>
-          <p:nvPr/>
-        </p:nvSpPr>
-        <p:spPr>
-          <a:xfrm>
-            <a:off x="3741268" y="5257800"/>
-            <a:ext cx="1188720" cy="384048"/>
+              <a:t>AI Models</a:t>
+            </a:r>
+            <a:endParaRPr lang="en-US" sz="1800" dirty="0"/>
+          </a:p>
+        </p:txBody>
+      </p:sp>
+      <p:sp>
+        <p:nvSpPr>
+          <p:cNvPr id="43" name="Shape 33"/>
+          <p:cNvSpPr/>
+          <p:nvPr/>
+        </p:nvSpPr>
+        <p:spPr>
+          <a:xfrm>
+            <a:off x="777240" y="4626864"/>
+            <a:ext cx="4617720" cy="804672"/>
           </a:xfrm>
           <a:prstGeom prst="roundRect">
             <a:avLst>
-              <a:gd name="adj" fmla="val 50000"/>
+              <a:gd name="adj" fmla="val 15909"/>
             </a:avLst>
           </a:prstGeom>
           <a:solidFill>
-            <a:srgbClr val="FFFBF8"/>
-          </a:solidFill>
-          <a:ln w="9525">
-            <a:solidFill>
-              <a:srgbClr val="E3D5CC"/>
-            </a:solidFill>
-            <a:prstDash val="solid"/>
-          </a:ln>
-        </p:spPr>
-      </p:sp>
-      <p:sp>
-        <p:nvSpPr>
-          <p:cNvPr id="42" name="Text 34"/>
-          <p:cNvSpPr txBox="1"/>
-          <p:nvPr/>
-        </p:nvSpPr>
-        <p:spPr>
-          <a:xfrm>
-            <a:off x="3741268" y="5257800"/>
-            <a:ext cx="1188720" cy="384048"/>
+            <a:srgbClr val="FBF6EE"/>
+          </a:solidFill>
+          <a:ln/>
+        </p:spPr>
+      </p:sp>
+      <p:pic>
+        <p:nvPicPr>
+          <p:cNvPr id="44" name="Image 8" descr="/tmp/claude-0/-home-claude/750ff410-f4aa-5276-9360-1e19d018b112/scratchpad/c/assets/i-code-br.png">    </p:cNvPr>
+          <p:cNvPicPr>
+            <a:picLocks noChangeAspect="1"/>
+          </p:cNvPicPr>
+          <p:nvPr/>
+        </p:nvPicPr>
+        <p:blipFill>
+          <a:blip r:embed="rId9"/>
+          <a:stretch>
+            <a:fillRect/>
+          </a:stretch>
+        </p:blipFill>
+        <p:spPr>
+          <a:xfrm>
+            <a:off x="4754880" y="4800600"/>
+            <a:ext cx="457200" cy="457200"/>
+          </a:xfrm>
+          <a:prstGeom prst="rect">
+            <a:avLst/>
+          </a:prstGeom>
+        </p:spPr>
+      </p:pic>
+      <p:sp>
+        <p:nvSpPr>
+          <p:cNvPr id="45" name="Text 34"/>
+          <p:cNvSpPr txBox="1"/>
+          <p:nvPr/>
+        </p:nvSpPr>
+        <p:spPr>
+          <a:xfrm>
+            <a:off x="1005840" y="4626864"/>
+            <a:ext cx="3657600" cy="804672"/>
           </a:xfrm>
           <a:prstGeom prst="rect">
             <a:avLst/>
@@ -12473,11 +12488,11 @@
           <a:bodyPr wrap="square" lIns="0" tIns="0" rIns="0" bIns="0" rtlCol="0" anchor="ctr"/>
           <a:lstStyle/>
           <a:p>
-            <a:pPr rtl="1" algn="ctr" indent="0" marL="0">
-              <a:buNone/>
-            </a:pPr>
-            <a:r>
-              <a:rPr lang="en-US" sz="1300" b="1" dirty="0">
+            <a:pPr rtl="1" algn="r" indent="0" marL="0">
+              <a:buNone/>
+            </a:pPr>
+            <a:r>
+              <a:rPr lang="en-US" sz="1800" b="1" dirty="0">
                 <a:solidFill>
                   <a:srgbClr val="21141A"/>
                 </a:solidFill>
@@ -12485,9 +12500,9 @@
                 <a:ea typeface="IBM Plex Sans Arabic" pitchFamily="34" charset="-122"/>
                 <a:cs typeface="IBM Plex Sans Arabic" pitchFamily="34" charset="-120"/>
               </a:rPr>
-              <a:t>Telegram</a:t>
-            </a:r>
-            <a:endParaRPr lang="en-US" sz="1300" dirty="0"/>
+              <a:t>أدوات تطوير الواجهات والمواقع</a:t>
+            </a:r>
+            <a:endParaRPr lang="en-US" sz="1800" dirty="0"/>
           </a:p>
         </p:txBody>
       </p:sp>

</xml_diff>

<commit_message>
Pitch deck: site screenshots in laptop and phone frames
Co-Authored-By: Claude Opus 5.5 (1M context) <noreply@anthropic.com>
Claude-Session: https://claude.ai/code/session_011TSHxy9drUC1JZWNcfUL3E
</commit_message>
<xml_diff>
--- a/pitch/SSB_VentureX.pptx
+++ b/pitch/SSB_VentureX.pptx
@@ -7277,36 +7277,9 @@
           </a:p>
         </p:txBody>
       </p:sp>
-      <p:sp>
-        <p:nvSpPr>
-          <p:cNvPr id="35" name="Shape 26"/>
-          <p:cNvSpPr/>
-          <p:nvPr/>
-        </p:nvSpPr>
-        <p:spPr>
-          <a:xfrm>
-            <a:off x="1005840" y="1600200"/>
-            <a:ext cx="3840480" cy="4217286"/>
-          </a:xfrm>
-          <a:prstGeom prst="roundRect">
-            <a:avLst>
-              <a:gd name="adj" fmla="val 2857"/>
-            </a:avLst>
-          </a:prstGeom>
-          <a:solidFill>
-            <a:srgbClr val="FFFBF8"/>
-          </a:solidFill>
-          <a:ln w="9525">
-            <a:solidFill>
-              <a:srgbClr val="E3D5CC"/>
-            </a:solidFill>
-            <a:prstDash val="solid"/>
-          </a:ln>
-        </p:spPr>
-      </p:sp>
       <p:pic>
         <p:nvPicPr>
-          <p:cNvPr id="36" name="Image 7" descr="/tmp/claude-0/-home-claude/750ff410-f4aa-5276-9360-1e19d018b112/scratchpad/c/assets/s-approve.png">    </p:cNvPr>
+          <p:cNvPr id="35" name="Image 7" descr="/tmp/claude-0/-home-claude/750ff410-f4aa-5276-9360-1e19d018b112/scratchpad/c/assets/m-lap-demo.png">    </p:cNvPr>
           <p:cNvPicPr>
             <a:picLocks noChangeAspect="1"/>
           </p:cNvPicPr>
@@ -7320,8 +7293,32 @@
         </p:blipFill>
         <p:spPr>
           <a:xfrm>
-            <a:off x="1078992" y="1673352"/>
-            <a:ext cx="3694176" cy="4070982"/>
+            <a:off x="914400" y="1828800"/>
+            <a:ext cx="4846320" cy="2971646"/>
+          </a:xfrm>
+          <a:prstGeom prst="rect">
+            <a:avLst/>
+          </a:prstGeom>
+        </p:spPr>
+      </p:pic>
+      <p:pic>
+        <p:nvPicPr>
+          <p:cNvPr id="36" name="Image 8" descr="/tmp/claude-0/-home-claude/750ff410-f4aa-5276-9360-1e19d018b112/scratchpad/c/assets/m-ph-demo.png">    </p:cNvPr>
+          <p:cNvPicPr>
+            <a:picLocks noChangeAspect="1"/>
+          </p:cNvPicPr>
+          <p:nvPr/>
+        </p:nvPicPr>
+        <p:blipFill>
+          <a:blip r:embed="rId9"/>
+          <a:stretch>
+            <a:fillRect/>
+          </a:stretch>
+        </p:blipFill>
+        <p:spPr>
+          <a:xfrm>
+            <a:off x="457200" y="2697480"/>
+            <a:ext cx="1547307" cy="3200400"/>
           </a:xfrm>
           <a:prstGeom prst="rect">
             <a:avLst/>
@@ -13067,36 +13064,9 @@
           </a:p>
         </p:txBody>
       </p:sp>
-      <p:sp>
-        <p:nvSpPr>
-          <p:cNvPr id="23" name="Shape 18"/>
-          <p:cNvSpPr/>
-          <p:nvPr/>
-        </p:nvSpPr>
-        <p:spPr>
-          <a:xfrm>
-            <a:off x="5699455" y="2606040"/>
-            <a:ext cx="6035040" cy="3278124"/>
-          </a:xfrm>
-          <a:prstGeom prst="roundRect">
-            <a:avLst>
-              <a:gd name="adj" fmla="val 3347"/>
-            </a:avLst>
-          </a:prstGeom>
-          <a:solidFill>
-            <a:srgbClr val="FFFBF8"/>
-          </a:solidFill>
-          <a:ln w="9525">
-            <a:solidFill>
-              <a:srgbClr val="E3D5CC"/>
-            </a:solidFill>
-            <a:prstDash val="solid"/>
-          </a:ln>
-        </p:spPr>
-      </p:sp>
       <p:pic>
         <p:nvPicPr>
-          <p:cNvPr id="24" name="Image 3" descr="/tmp/claude-0/-home-claude/750ff410-f4aa-5276-9360-1e19d018b112/scratchpad/c/assets/s-overview.png">    </p:cNvPr>
+          <p:cNvPr id="23" name="Image 3" descr="/tmp/claude-0/-home-claude/750ff410-f4aa-5276-9360-1e19d018b112/scratchpad/c/assets/m-lap-ar.png">    </p:cNvPr>
           <p:cNvPicPr>
             <a:picLocks noChangeAspect="1"/>
           </p:cNvPicPr>
@@ -13110,44 +13080,17 @@
         </p:blipFill>
         <p:spPr>
           <a:xfrm>
-            <a:off x="5772607" y="2679192"/>
-            <a:ext cx="5888736" cy="3131820"/>
+            <a:off x="6156655" y="2514600"/>
+            <a:ext cx="5577840" cy="3420196"/>
           </a:xfrm>
           <a:prstGeom prst="rect">
             <a:avLst/>
           </a:prstGeom>
         </p:spPr>
       </p:pic>
-      <p:sp>
-        <p:nvSpPr>
-          <p:cNvPr id="25" name="Shape 19"/>
-          <p:cNvSpPr/>
-          <p:nvPr/>
-        </p:nvSpPr>
-        <p:spPr>
-          <a:xfrm>
-            <a:off x="2773375" y="2606040"/>
-            <a:ext cx="2651760" cy="2907317"/>
-          </a:xfrm>
-          <a:prstGeom prst="roundRect">
-            <a:avLst>
-              <a:gd name="adj" fmla="val 4138"/>
-            </a:avLst>
-          </a:prstGeom>
-          <a:solidFill>
-            <a:srgbClr val="FFFBF8"/>
-          </a:solidFill>
-          <a:ln w="9525">
-            <a:solidFill>
-              <a:srgbClr val="E3D5CC"/>
-            </a:solidFill>
-            <a:prstDash val="solid"/>
-          </a:ln>
-        </p:spPr>
-      </p:sp>
       <p:pic>
         <p:nvPicPr>
-          <p:cNvPr id="26" name="Image 4" descr="/tmp/claude-0/-home-claude/750ff410-f4aa-5276-9360-1e19d018b112/scratchpad/c/assets/s-approve.png">    </p:cNvPr>
+          <p:cNvPr id="24" name="Image 4" descr="/tmp/claude-0/-home-claude/750ff410-f4aa-5276-9360-1e19d018b112/scratchpad/c/assets/m-ph-start.png">    </p:cNvPr>
           <p:cNvPicPr>
             <a:picLocks noChangeAspect="1"/>
           </p:cNvPicPr>
@@ -13161,8 +13104,8 @@
         </p:blipFill>
         <p:spPr>
           <a:xfrm>
-            <a:off x="2846527" y="2679192"/>
-            <a:ext cx="2505456" cy="2761013"/>
+            <a:off x="5090163" y="2697480"/>
+            <a:ext cx="1569412" cy="3246120"/>
           </a:xfrm>
           <a:prstGeom prst="rect">
             <a:avLst/>
@@ -13171,18 +13114,18 @@
       </p:pic>
       <p:sp>
         <p:nvSpPr>
-          <p:cNvPr id="27" name="Shape 20"/>
-          <p:cNvSpPr/>
-          <p:nvPr/>
-        </p:nvSpPr>
-        <p:spPr>
-          <a:xfrm>
-            <a:off x="457200" y="2606040"/>
-            <a:ext cx="2041855" cy="3154680"/>
+          <p:cNvPr id="25" name="Shape 18"/>
+          <p:cNvSpPr/>
+          <p:nvPr/>
+        </p:nvSpPr>
+        <p:spPr>
+          <a:xfrm>
+            <a:off x="640080" y="2606040"/>
+            <a:ext cx="2651760" cy="3246120"/>
           </a:xfrm>
           <a:prstGeom prst="roundRect">
             <a:avLst>
-              <a:gd name="adj" fmla="val 8061"/>
+              <a:gd name="adj" fmla="val 6207"/>
             </a:avLst>
           </a:prstGeom>
           <a:solidFill>
@@ -13193,18 +13136,18 @@
       </p:sp>
       <p:sp>
         <p:nvSpPr>
-          <p:cNvPr id="28" name="Shape 21"/>
-          <p:cNvSpPr/>
-          <p:nvPr/>
-        </p:nvSpPr>
-        <p:spPr>
-          <a:xfrm>
-            <a:off x="640080" y="2788920"/>
-            <a:ext cx="1676095" cy="1676095"/>
+          <p:cNvPr id="26" name="Shape 19"/>
+          <p:cNvSpPr/>
+          <p:nvPr/>
+        </p:nvSpPr>
+        <p:spPr>
+          <a:xfrm>
+            <a:off x="822960" y="2788920"/>
+            <a:ext cx="2286000" cy="2286000"/>
           </a:xfrm>
           <a:prstGeom prst="roundRect">
             <a:avLst>
-              <a:gd name="adj" fmla="val 6547"/>
+              <a:gd name="adj" fmla="val 4800"/>
             </a:avLst>
           </a:prstGeom>
           <a:solidFill>
@@ -13215,7 +13158,7 @@
       </p:sp>
       <p:pic>
         <p:nvPicPr>
-          <p:cNvPr id="29" name="Image 5" descr="/tmp/claude-0/-home-claude/750ff410-f4aa-5276-9360-1e19d018b112/scratchpad/c/assets/qr.png">    </p:cNvPr>
+          <p:cNvPr id="27" name="Image 5" descr="/tmp/claude-0/-home-claude/750ff410-f4aa-5276-9360-1e19d018b112/scratchpad/c/assets/qr.png">    </p:cNvPr>
           <p:cNvPicPr>
             <a:picLocks noChangeAspect="1"/>
           </p:cNvPicPr>
@@ -13229,8 +13172,8 @@
         </p:blipFill>
         <p:spPr>
           <a:xfrm>
-            <a:off x="731520" y="2880360"/>
-            <a:ext cx="1493215" cy="1493215"/>
+            <a:off x="914400" y="2880360"/>
+            <a:ext cx="2103120" cy="2103120"/>
           </a:xfrm>
           <a:prstGeom prst="rect">
             <a:avLst/>
@@ -13239,14 +13182,14 @@
       </p:pic>
       <p:sp>
         <p:nvSpPr>
-          <p:cNvPr id="30" name="Text 22"/>
-          <p:cNvSpPr txBox="1"/>
-          <p:nvPr/>
-        </p:nvSpPr>
-        <p:spPr>
-          <a:xfrm>
-            <a:off x="457200" y="4556455"/>
-            <a:ext cx="2041855" cy="365760"/>
+          <p:cNvPr id="28" name="Text 20"/>
+          <p:cNvSpPr txBox="1"/>
+          <p:nvPr/>
+        </p:nvSpPr>
+        <p:spPr>
+          <a:xfrm>
+            <a:off x="640080" y="5212080"/>
+            <a:ext cx="2651760" cy="365760"/>
           </a:xfrm>
           <a:prstGeom prst="rect">
             <a:avLst/>

</xml_diff>

<commit_message>
Pitch deck: simpler solution slide (title, 3 steps, laptop)
Co-Authored-By: Claude Opus 5.5 (1M context) <noreply@anthropic.com>
Claude-Session: https://claude.ai/code/session_011TSHxy9drUC1JZWNcfUL3E
</commit_message>
<xml_diff>
--- a/pitch/SSB_VentureX.pptx
+++ b/pitch/SSB_VentureX.pptx
@@ -6878,9 +6878,342 @@
           </a:p>
         </p:txBody>
       </p:sp>
+      <p:sp>
+        <p:nvSpPr>
+          <p:cNvPr id="22" name="Text 17"/>
+          <p:cNvSpPr txBox="1"/>
+          <p:nvPr/>
+        </p:nvSpPr>
+        <p:spPr>
+          <a:xfrm>
+            <a:off x="457200" y="1600200"/>
+            <a:ext cx="11277295" cy="731520"/>
+          </a:xfrm>
+          <a:prstGeom prst="rect">
+            <a:avLst/>
+          </a:prstGeom>
+          <a:noFill/>
+          <a:ln/>
+        </p:spPr>
+        <p:txBody>
+          <a:bodyPr wrap="square" lIns="0" tIns="0" rIns="0" bIns="0" rtlCol="0" anchor="ctr"/>
+          <a:lstStyle/>
+          <a:p>
+            <a:pPr rtl="1" algn="r" indent="0" marL="0">
+              <a:buNone/>
+            </a:pPr>
+            <a:r>
+              <a:rPr lang="en-US" sz="3400" b="1" dirty="0">
+                <a:solidFill>
+                  <a:srgbClr val="21141A"/>
+                </a:solidFill>
+                <a:latin typeface="IBM Plex Sans Arabic" pitchFamily="34" charset="0"/>
+                <a:ea typeface="IBM Plex Sans Arabic" pitchFamily="34" charset="-122"/>
+                <a:cs typeface="IBM Plex Sans Arabic" pitchFamily="34" charset="-120"/>
+              </a:rPr>
+              <a:t>CloudTrim يكتشف الهدر… وأنت تقرّر</a:t>
+            </a:r>
+            <a:endParaRPr lang="en-US" sz="3400" dirty="0"/>
+          </a:p>
+        </p:txBody>
+      </p:sp>
+      <p:sp>
+        <p:nvSpPr>
+          <p:cNvPr id="23" name="Shape 18"/>
+          <p:cNvSpPr/>
+          <p:nvPr/>
+        </p:nvSpPr>
+        <p:spPr>
+          <a:xfrm>
+            <a:off x="11167567" y="2743200"/>
+            <a:ext cx="566928" cy="566928"/>
+          </a:xfrm>
+          <a:prstGeom prst="ellipse">
+            <a:avLst/>
+          </a:prstGeom>
+          <a:solidFill>
+            <a:srgbClr val="8E2F3C"/>
+          </a:solidFill>
+          <a:ln/>
+        </p:spPr>
+      </p:sp>
+      <p:sp>
+        <p:nvSpPr>
+          <p:cNvPr id="24" name="Text 19"/>
+          <p:cNvSpPr txBox="1"/>
+          <p:nvPr/>
+        </p:nvSpPr>
+        <p:spPr>
+          <a:xfrm>
+            <a:off x="11167567" y="2743200"/>
+            <a:ext cx="566928" cy="566928"/>
+          </a:xfrm>
+          <a:prstGeom prst="rect">
+            <a:avLst/>
+          </a:prstGeom>
+          <a:noFill/>
+          <a:ln/>
+        </p:spPr>
+        <p:txBody>
+          <a:bodyPr wrap="square" lIns="0" tIns="0" rIns="0" bIns="0" rtlCol="0" anchor="ctr"/>
+          <a:lstStyle/>
+          <a:p>
+            <a:pPr algn="ctr" indent="0" marL="0">
+              <a:buNone/>
+            </a:pPr>
+            <a:r>
+              <a:rPr lang="en-US" sz="2000" b="1" dirty="0">
+                <a:solidFill>
+                  <a:srgbClr val="FBF6EE"/>
+                </a:solidFill>
+                <a:latin typeface="IBM Plex Sans Arabic" pitchFamily="34" charset="0"/>
+                <a:ea typeface="IBM Plex Sans Arabic" pitchFamily="34" charset="-122"/>
+                <a:cs typeface="IBM Plex Sans Arabic" pitchFamily="34" charset="-120"/>
+              </a:rPr>
+              <a:t>1</a:t>
+            </a:r>
+            <a:endParaRPr lang="en-US" sz="2000" dirty="0"/>
+          </a:p>
+        </p:txBody>
+      </p:sp>
+      <p:sp>
+        <p:nvSpPr>
+          <p:cNvPr id="25" name="Text 20"/>
+          <p:cNvSpPr txBox="1"/>
+          <p:nvPr/>
+        </p:nvSpPr>
+        <p:spPr>
+          <a:xfrm>
+            <a:off x="6766560" y="2651760"/>
+            <a:ext cx="4190695" cy="749808"/>
+          </a:xfrm>
+          <a:prstGeom prst="rect">
+            <a:avLst/>
+          </a:prstGeom>
+          <a:noFill/>
+          <a:ln/>
+        </p:spPr>
+        <p:txBody>
+          <a:bodyPr wrap="square" lIns="0" tIns="0" rIns="0" bIns="0" rtlCol="0" anchor="ctr"/>
+          <a:lstStyle/>
+          <a:p>
+            <a:pPr rtl="1" algn="r" indent="0" marL="0">
+              <a:buNone/>
+            </a:pPr>
+            <a:r>
+              <a:rPr lang="en-US" sz="2000" b="1" dirty="0">
+                <a:solidFill>
+                  <a:srgbClr val="21141A"/>
+                </a:solidFill>
+                <a:latin typeface="IBM Plex Sans Arabic" pitchFamily="34" charset="0"/>
+                <a:ea typeface="IBM Plex Sans Arabic" pitchFamily="34" charset="-122"/>
+                <a:cs typeface="IBM Plex Sans Arabic" pitchFamily="34" charset="-120"/>
+              </a:rPr>
+              <a:t>نربط حسابك السحابي بصلاحية قراءة فقط</a:t>
+            </a:r>
+            <a:endParaRPr lang="en-US" sz="2000" dirty="0"/>
+          </a:p>
+        </p:txBody>
+      </p:sp>
+      <p:sp>
+        <p:nvSpPr>
+          <p:cNvPr id="26" name="Shape 21"/>
+          <p:cNvSpPr/>
+          <p:nvPr/>
+        </p:nvSpPr>
+        <p:spPr>
+          <a:xfrm>
+            <a:off x="11167567" y="3749040"/>
+            <a:ext cx="566928" cy="566928"/>
+          </a:xfrm>
+          <a:prstGeom prst="ellipse">
+            <a:avLst/>
+          </a:prstGeom>
+          <a:solidFill>
+            <a:srgbClr val="8E2F3C"/>
+          </a:solidFill>
+          <a:ln/>
+        </p:spPr>
+      </p:sp>
+      <p:sp>
+        <p:nvSpPr>
+          <p:cNvPr id="27" name="Text 22"/>
+          <p:cNvSpPr txBox="1"/>
+          <p:nvPr/>
+        </p:nvSpPr>
+        <p:spPr>
+          <a:xfrm>
+            <a:off x="11167567" y="3749040"/>
+            <a:ext cx="566928" cy="566928"/>
+          </a:xfrm>
+          <a:prstGeom prst="rect">
+            <a:avLst/>
+          </a:prstGeom>
+          <a:noFill/>
+          <a:ln/>
+        </p:spPr>
+        <p:txBody>
+          <a:bodyPr wrap="square" lIns="0" tIns="0" rIns="0" bIns="0" rtlCol="0" anchor="ctr"/>
+          <a:lstStyle/>
+          <a:p>
+            <a:pPr algn="ctr" indent="0" marL="0">
+              <a:buNone/>
+            </a:pPr>
+            <a:r>
+              <a:rPr lang="en-US" sz="2000" b="1" dirty="0">
+                <a:solidFill>
+                  <a:srgbClr val="FBF6EE"/>
+                </a:solidFill>
+                <a:latin typeface="IBM Plex Sans Arabic" pitchFamily="34" charset="0"/>
+                <a:ea typeface="IBM Plex Sans Arabic" pitchFamily="34" charset="-122"/>
+                <a:cs typeface="IBM Plex Sans Arabic" pitchFamily="34" charset="-120"/>
+              </a:rPr>
+              <a:t>2</a:t>
+            </a:r>
+            <a:endParaRPr lang="en-US" sz="2000" dirty="0"/>
+          </a:p>
+        </p:txBody>
+      </p:sp>
+      <p:sp>
+        <p:nvSpPr>
+          <p:cNvPr id="28" name="Text 23"/>
+          <p:cNvSpPr txBox="1"/>
+          <p:nvPr/>
+        </p:nvSpPr>
+        <p:spPr>
+          <a:xfrm>
+            <a:off x="6766560" y="3657600"/>
+            <a:ext cx="4190695" cy="749808"/>
+          </a:xfrm>
+          <a:prstGeom prst="rect">
+            <a:avLst/>
+          </a:prstGeom>
+          <a:noFill/>
+          <a:ln/>
+        </p:spPr>
+        <p:txBody>
+          <a:bodyPr wrap="square" lIns="0" tIns="0" rIns="0" bIns="0" rtlCol="0" anchor="ctr"/>
+          <a:lstStyle/>
+          <a:p>
+            <a:pPr rtl="1" algn="r" indent="0" marL="0">
+              <a:buNone/>
+            </a:pPr>
+            <a:r>
+              <a:rPr lang="en-US" sz="2000" b="1" dirty="0">
+                <a:solidFill>
+                  <a:srgbClr val="21141A"/>
+                </a:solidFill>
+                <a:latin typeface="IBM Plex Sans Arabic" pitchFamily="34" charset="0"/>
+                <a:ea typeface="IBM Plex Sans Arabic" pitchFamily="34" charset="-122"/>
+                <a:cs typeface="IBM Plex Sans Arabic" pitchFamily="34" charset="-120"/>
+              </a:rPr>
+              <a:t>الذكاء الاصطناعي يكتشف الهدر</a:t>
+            </a:r>
+            <a:endParaRPr lang="en-US" sz="2000" dirty="0"/>
+          </a:p>
+        </p:txBody>
+      </p:sp>
+      <p:sp>
+        <p:nvSpPr>
+          <p:cNvPr id="29" name="Shape 24"/>
+          <p:cNvSpPr/>
+          <p:nvPr/>
+        </p:nvSpPr>
+        <p:spPr>
+          <a:xfrm>
+            <a:off x="11167567" y="4754880"/>
+            <a:ext cx="566928" cy="566928"/>
+          </a:xfrm>
+          <a:prstGeom prst="ellipse">
+            <a:avLst/>
+          </a:prstGeom>
+          <a:solidFill>
+            <a:srgbClr val="8E2F3C"/>
+          </a:solidFill>
+          <a:ln/>
+        </p:spPr>
+      </p:sp>
+      <p:sp>
+        <p:nvSpPr>
+          <p:cNvPr id="30" name="Text 25"/>
+          <p:cNvSpPr txBox="1"/>
+          <p:nvPr/>
+        </p:nvSpPr>
+        <p:spPr>
+          <a:xfrm>
+            <a:off x="11167567" y="4754880"/>
+            <a:ext cx="566928" cy="566928"/>
+          </a:xfrm>
+          <a:prstGeom prst="rect">
+            <a:avLst/>
+          </a:prstGeom>
+          <a:noFill/>
+          <a:ln/>
+        </p:spPr>
+        <p:txBody>
+          <a:bodyPr wrap="square" lIns="0" tIns="0" rIns="0" bIns="0" rtlCol="0" anchor="ctr"/>
+          <a:lstStyle/>
+          <a:p>
+            <a:pPr algn="ctr" indent="0" marL="0">
+              <a:buNone/>
+            </a:pPr>
+            <a:r>
+              <a:rPr lang="en-US" sz="2000" b="1" dirty="0">
+                <a:solidFill>
+                  <a:srgbClr val="FBF6EE"/>
+                </a:solidFill>
+                <a:latin typeface="IBM Plex Sans Arabic" pitchFamily="34" charset="0"/>
+                <a:ea typeface="IBM Plex Sans Arabic" pitchFamily="34" charset="-122"/>
+                <a:cs typeface="IBM Plex Sans Arabic" pitchFamily="34" charset="-120"/>
+              </a:rPr>
+              <a:t>3</a:t>
+            </a:r>
+            <a:endParaRPr lang="en-US" sz="2000" dirty="0"/>
+          </a:p>
+        </p:txBody>
+      </p:sp>
+      <p:sp>
+        <p:nvSpPr>
+          <p:cNvPr id="31" name="Text 26"/>
+          <p:cNvSpPr txBox="1"/>
+          <p:nvPr/>
+        </p:nvSpPr>
+        <p:spPr>
+          <a:xfrm>
+            <a:off x="6766560" y="4663440"/>
+            <a:ext cx="4190695" cy="749808"/>
+          </a:xfrm>
+          <a:prstGeom prst="rect">
+            <a:avLst/>
+          </a:prstGeom>
+          <a:noFill/>
+          <a:ln/>
+        </p:spPr>
+        <p:txBody>
+          <a:bodyPr wrap="square" lIns="0" tIns="0" rIns="0" bIns="0" rtlCol="0" anchor="ctr"/>
+          <a:lstStyle/>
+          <a:p>
+            <a:pPr rtl="1" algn="r" indent="0" marL="0">
+              <a:buNone/>
+            </a:pPr>
+            <a:r>
+              <a:rPr lang="en-US" sz="2000" b="1" dirty="0">
+                <a:solidFill>
+                  <a:srgbClr val="21141A"/>
+                </a:solidFill>
+                <a:latin typeface="IBM Plex Sans Arabic" pitchFamily="34" charset="0"/>
+                <a:ea typeface="IBM Plex Sans Arabic" pitchFamily="34" charset="-122"/>
+                <a:cs typeface="IBM Plex Sans Arabic" pitchFamily="34" charset="-120"/>
+              </a:rPr>
+              <a:t>توافق بنقرة واحدة… وتوفّر</a:t>
+            </a:r>
+            <a:endParaRPr lang="en-US" sz="2000" dirty="0"/>
+          </a:p>
+        </p:txBody>
+      </p:sp>
       <p:pic>
         <p:nvPicPr>
-          <p:cNvPr id="22" name="Image 3" descr="/tmp/claude-0/-home-claude/750ff410-f4aa-5276-9360-1e19d018b112/scratchpad/c/assets/ct-icon.png">    </p:cNvPr>
+          <p:cNvPr id="32" name="Image 3" descr="/tmp/claude-0/-home-claude/750ff410-f4aa-5276-9360-1e19d018b112/scratchpad/c/assets/m-lap-demo.png">    </p:cNvPr>
           <p:cNvPicPr>
             <a:picLocks noChangeAspect="1"/>
           </p:cNvPicPr>
@@ -6894,431 +7227,8 @@
         </p:blipFill>
         <p:spPr>
           <a:xfrm>
-            <a:off x="11002975" y="1691640"/>
-            <a:ext cx="731520" cy="731520"/>
-          </a:xfrm>
-          <a:prstGeom prst="rect">
-            <a:avLst/>
-          </a:prstGeom>
-        </p:spPr>
-      </p:pic>
-      <p:sp>
-        <p:nvSpPr>
-          <p:cNvPr id="23" name="Text 17"/>
-          <p:cNvSpPr txBox="1"/>
-          <p:nvPr/>
-        </p:nvSpPr>
-        <p:spPr>
-          <a:xfrm>
-            <a:off x="5852160" y="1645920"/>
-            <a:ext cx="4967935" cy="822960"/>
-          </a:xfrm>
-          <a:prstGeom prst="rect">
-            <a:avLst/>
-          </a:prstGeom>
-          <a:noFill/>
-          <a:ln/>
-        </p:spPr>
-        <p:txBody>
-          <a:bodyPr wrap="square" lIns="0" tIns="0" rIns="0" bIns="0" rtlCol="0" anchor="ctr"/>
-          <a:lstStyle/>
-          <a:p>
-            <a:pPr algn="r" indent="0" marL="0">
-              <a:buNone/>
-            </a:pPr>
-            <a:r>
-              <a:rPr lang="en-US" sz="4400" b="1" dirty="0">
-                <a:solidFill>
-                  <a:srgbClr val="8E2F3C"/>
-                </a:solidFill>
-                <a:latin typeface="IBM Plex Sans Arabic" pitchFamily="34" charset="0"/>
-                <a:ea typeface="IBM Plex Sans Arabic" pitchFamily="34" charset="-122"/>
-                <a:cs typeface="IBM Plex Sans Arabic" pitchFamily="34" charset="-120"/>
-              </a:rPr>
-              <a:t>CloudTrim</a:t>
-            </a:r>
-            <a:endParaRPr lang="en-US" sz="4400" dirty="0"/>
-          </a:p>
-        </p:txBody>
-      </p:sp>
-      <p:sp>
-        <p:nvSpPr>
-          <p:cNvPr id="24" name="Text 18"/>
-          <p:cNvSpPr txBox="1"/>
-          <p:nvPr/>
-        </p:nvSpPr>
-        <p:spPr>
-          <a:xfrm>
-            <a:off x="5852160" y="2606040"/>
-            <a:ext cx="5882335" cy="822960"/>
-          </a:xfrm>
-          <a:prstGeom prst="rect">
-            <a:avLst/>
-          </a:prstGeom>
-          <a:noFill/>
-          <a:ln/>
-        </p:spPr>
-        <p:txBody>
-          <a:bodyPr wrap="square" lIns="0" tIns="0" rIns="0" bIns="0" rtlCol="0" anchor="t"/>
-          <a:lstStyle/>
-          <a:p>
-            <a:pPr rtl="1" algn="r" indent="0" marL="0">
-              <a:lnSpc>
-                <a:spcPct val="110000"/>
-              </a:lnSpc>
-              <a:buNone/>
-            </a:pPr>
-            <a:r>
-              <a:rPr lang="en-US" sz="2000" dirty="0">
-                <a:solidFill>
-                  <a:srgbClr val="21141A"/>
-                </a:solidFill>
-                <a:latin typeface="IBM Plex Sans Arabic" pitchFamily="34" charset="0"/>
-                <a:ea typeface="IBM Plex Sans Arabic" pitchFamily="34" charset="-122"/>
-                <a:cs typeface="IBM Plex Sans Arabic" pitchFamily="34" charset="-120"/>
-              </a:rPr>
-              <a:t>يكتشف الهدر في فاتورة السحابة ويوفّره بموافقتك بنقرة واحدة</a:t>
-            </a:r>
-            <a:endParaRPr lang="en-US" sz="2000" dirty="0"/>
-          </a:p>
-        </p:txBody>
-      </p:sp>
-      <p:sp>
-        <p:nvSpPr>
-          <p:cNvPr id="25" name="Shape 19"/>
-          <p:cNvSpPr/>
-          <p:nvPr/>
-        </p:nvSpPr>
-        <p:spPr>
-          <a:xfrm>
-            <a:off x="11222431" y="3657600"/>
-            <a:ext cx="512064" cy="512064"/>
-          </a:xfrm>
-          <a:prstGeom prst="roundRect">
-            <a:avLst>
-              <a:gd name="adj" fmla="val 21429"/>
-            </a:avLst>
-          </a:prstGeom>
-          <a:solidFill>
-            <a:srgbClr val="F1E4DF"/>
-          </a:solidFill>
-          <a:ln/>
-        </p:spPr>
-      </p:sp>
-      <p:pic>
-        <p:nvPicPr>
-          <p:cNvPr id="26" name="Image 4" descr="/tmp/claude-0/-home-claude/750ff410-f4aa-5276-9360-1e19d018b112/scratchpad/c/assets/i-eye-br.png">    </p:cNvPr>
-          <p:cNvPicPr>
-            <a:picLocks noChangeAspect="1"/>
-          </p:cNvPicPr>
-          <p:nvPr/>
-        </p:nvPicPr>
-        <p:blipFill>
-          <a:blip r:embed="rId5"/>
-          <a:stretch>
-            <a:fillRect/>
-          </a:stretch>
-        </p:blipFill>
-        <p:spPr>
-          <a:xfrm>
-            <a:off x="11295583" y="3730752"/>
-            <a:ext cx="365760" cy="365760"/>
-          </a:xfrm>
-          <a:prstGeom prst="rect">
-            <a:avLst/>
-          </a:prstGeom>
-        </p:spPr>
-      </p:pic>
-      <p:sp>
-        <p:nvSpPr>
-          <p:cNvPr id="27" name="Text 20"/>
-          <p:cNvSpPr txBox="1"/>
-          <p:nvPr/>
-        </p:nvSpPr>
-        <p:spPr>
-          <a:xfrm>
-            <a:off x="5852160" y="3657600"/>
-            <a:ext cx="5196535" cy="512064"/>
-          </a:xfrm>
-          <a:prstGeom prst="rect">
-            <a:avLst/>
-          </a:prstGeom>
-          <a:noFill/>
-          <a:ln/>
-        </p:spPr>
-        <p:txBody>
-          <a:bodyPr wrap="square" lIns="0" tIns="0" rIns="0" bIns="0" rtlCol="0" anchor="ctr"/>
-          <a:lstStyle/>
-          <a:p>
-            <a:pPr rtl="1" algn="r" indent="0" marL="0">
-              <a:buNone/>
-            </a:pPr>
-            <a:r>
-              <a:rPr lang="en-US" sz="1800" b="1" dirty="0">
-                <a:solidFill>
-                  <a:srgbClr val="21141A"/>
-                </a:solidFill>
-                <a:latin typeface="IBM Plex Sans Arabic" pitchFamily="34" charset="0"/>
-                <a:ea typeface="IBM Plex Sans Arabic" pitchFamily="34" charset="-122"/>
-                <a:cs typeface="IBM Plex Sans Arabic" pitchFamily="34" charset="-120"/>
-              </a:rPr>
-              <a:t>قراءة فقط</a:t>
-            </a:r>
-            <a:endParaRPr lang="en-US" sz="1800" dirty="0"/>
-          </a:p>
-        </p:txBody>
-      </p:sp>
-      <p:sp>
-        <p:nvSpPr>
-          <p:cNvPr id="28" name="Shape 21"/>
-          <p:cNvSpPr/>
-          <p:nvPr/>
-        </p:nvSpPr>
-        <p:spPr>
-          <a:xfrm>
-            <a:off x="11222431" y="4279392"/>
-            <a:ext cx="512064" cy="512064"/>
-          </a:xfrm>
-          <a:prstGeom prst="roundRect">
-            <a:avLst>
-              <a:gd name="adj" fmla="val 21429"/>
-            </a:avLst>
-          </a:prstGeom>
-          <a:solidFill>
-            <a:srgbClr val="F1E4DF"/>
-          </a:solidFill>
-          <a:ln/>
-        </p:spPr>
-      </p:sp>
-      <p:pic>
-        <p:nvPicPr>
-          <p:cNvPr id="29" name="Image 5" descr="/tmp/claude-0/-home-claude/750ff410-f4aa-5276-9360-1e19d018b112/scratchpad/c/assets/i-bot-br.png">    </p:cNvPr>
-          <p:cNvPicPr>
-            <a:picLocks noChangeAspect="1"/>
-          </p:cNvPicPr>
-          <p:nvPr/>
-        </p:nvPicPr>
-        <p:blipFill>
-          <a:blip r:embed="rId6"/>
-          <a:stretch>
-            <a:fillRect/>
-          </a:stretch>
-        </p:blipFill>
-        <p:spPr>
-          <a:xfrm>
-            <a:off x="11295583" y="4352544"/>
-            <a:ext cx="365760" cy="365760"/>
-          </a:xfrm>
-          <a:prstGeom prst="rect">
-            <a:avLst/>
-          </a:prstGeom>
-        </p:spPr>
-      </p:pic>
-      <p:sp>
-        <p:nvSpPr>
-          <p:cNvPr id="30" name="Text 22"/>
-          <p:cNvSpPr txBox="1"/>
-          <p:nvPr/>
-        </p:nvSpPr>
-        <p:spPr>
-          <a:xfrm>
-            <a:off x="5852160" y="4279392"/>
-            <a:ext cx="5196535" cy="512064"/>
-          </a:xfrm>
-          <a:prstGeom prst="rect">
-            <a:avLst/>
-          </a:prstGeom>
-          <a:noFill/>
-          <a:ln/>
-        </p:spPr>
-        <p:txBody>
-          <a:bodyPr wrap="square" lIns="0" tIns="0" rIns="0" bIns="0" rtlCol="0" anchor="ctr"/>
-          <a:lstStyle/>
-          <a:p>
-            <a:pPr rtl="1" algn="r" indent="0" marL="0">
-              <a:buNone/>
-            </a:pPr>
-            <a:r>
-              <a:rPr lang="en-US" sz="1800" b="1" dirty="0">
-                <a:solidFill>
-                  <a:srgbClr val="21141A"/>
-                </a:solidFill>
-                <a:latin typeface="IBM Plex Sans Arabic" pitchFamily="34" charset="0"/>
-                <a:ea typeface="IBM Plex Sans Arabic" pitchFamily="34" charset="-122"/>
-                <a:cs typeface="IBM Plex Sans Arabic" pitchFamily="34" charset="-120"/>
-              </a:rPr>
-              <a:t>الذكاء الاصطناعي يقترح</a:t>
-            </a:r>
-            <a:endParaRPr lang="en-US" sz="1800" dirty="0"/>
-          </a:p>
-        </p:txBody>
-      </p:sp>
-      <p:sp>
-        <p:nvSpPr>
-          <p:cNvPr id="31" name="Shape 23"/>
-          <p:cNvSpPr/>
-          <p:nvPr/>
-        </p:nvSpPr>
-        <p:spPr>
-          <a:xfrm>
-            <a:off x="11222431" y="4901184"/>
-            <a:ext cx="512064" cy="512064"/>
-          </a:xfrm>
-          <a:prstGeom prst="roundRect">
-            <a:avLst>
-              <a:gd name="adj" fmla="val 21429"/>
-            </a:avLst>
-          </a:prstGeom>
-          <a:solidFill>
-            <a:srgbClr val="F1E4DF"/>
-          </a:solidFill>
-          <a:ln/>
-        </p:spPr>
-      </p:sp>
-      <p:pic>
-        <p:nvPicPr>
-          <p:cNvPr id="32" name="Image 6" descr="/tmp/claude-0/-home-claude/750ff410-f4aa-5276-9360-1e19d018b112/scratchpad/c/assets/i-check-br.png">    </p:cNvPr>
-          <p:cNvPicPr>
-            <a:picLocks noChangeAspect="1"/>
-          </p:cNvPicPr>
-          <p:nvPr/>
-        </p:nvPicPr>
-        <p:blipFill>
-          <a:blip r:embed="rId7"/>
-          <a:stretch>
-            <a:fillRect/>
-          </a:stretch>
-        </p:blipFill>
-        <p:spPr>
-          <a:xfrm>
-            <a:off x="11295583" y="4974336"/>
-            <a:ext cx="365760" cy="365760"/>
-          </a:xfrm>
-          <a:prstGeom prst="rect">
-            <a:avLst/>
-          </a:prstGeom>
-        </p:spPr>
-      </p:pic>
-      <p:sp>
-        <p:nvSpPr>
-          <p:cNvPr id="33" name="Text 24"/>
-          <p:cNvSpPr txBox="1"/>
-          <p:nvPr/>
-        </p:nvSpPr>
-        <p:spPr>
-          <a:xfrm>
-            <a:off x="5852160" y="4901184"/>
-            <a:ext cx="5196535" cy="512064"/>
-          </a:xfrm>
-          <a:prstGeom prst="rect">
-            <a:avLst/>
-          </a:prstGeom>
-          <a:noFill/>
-          <a:ln/>
-        </p:spPr>
-        <p:txBody>
-          <a:bodyPr wrap="square" lIns="0" tIns="0" rIns="0" bIns="0" rtlCol="0" anchor="ctr"/>
-          <a:lstStyle/>
-          <a:p>
-            <a:pPr rtl="1" algn="r" indent="0" marL="0">
-              <a:buNone/>
-            </a:pPr>
-            <a:r>
-              <a:rPr lang="en-US" sz="1800" b="1" dirty="0">
-                <a:solidFill>
-                  <a:srgbClr val="21141A"/>
-                </a:solidFill>
-                <a:latin typeface="IBM Plex Sans Arabic" pitchFamily="34" charset="0"/>
-                <a:ea typeface="IBM Plex Sans Arabic" pitchFamily="34" charset="-122"/>
-                <a:cs typeface="IBM Plex Sans Arabic" pitchFamily="34" charset="-120"/>
-              </a:rPr>
-              <a:t>أنت توافق بنقرة</a:t>
-            </a:r>
-            <a:endParaRPr lang="en-US" sz="1800" dirty="0"/>
-          </a:p>
-        </p:txBody>
-      </p:sp>
-      <p:sp>
-        <p:nvSpPr>
-          <p:cNvPr id="34" name="Text 25"/>
-          <p:cNvSpPr txBox="1"/>
-          <p:nvPr/>
-        </p:nvSpPr>
-        <p:spPr>
-          <a:xfrm>
-            <a:off x="5852160" y="5623560"/>
-            <a:ext cx="5882335" cy="320040"/>
-          </a:xfrm>
-          <a:prstGeom prst="rect">
-            <a:avLst/>
-          </a:prstGeom>
-          <a:noFill/>
-          <a:ln/>
-        </p:spPr>
-        <p:txBody>
-          <a:bodyPr wrap="square" lIns="0" tIns="0" rIns="0" bIns="0" rtlCol="0" anchor="ctr"/>
-          <a:lstStyle/>
-          <a:p>
-            <a:pPr rtl="1" algn="r" indent="0" marL="0">
-              <a:buNone/>
-            </a:pPr>
-            <a:r>
-              <a:rPr lang="en-US" sz="1200" dirty="0">
-                <a:solidFill>
-                  <a:srgbClr val="7F6C72"/>
-                </a:solidFill>
-                <a:latin typeface="IBM Plex Sans Arabic" pitchFamily="34" charset="0"/>
-                <a:ea typeface="IBM Plex Sans Arabic" pitchFamily="34" charset="-122"/>
-                <a:cs typeface="IBM Plex Sans Arabic" pitchFamily="34" charset="-120"/>
-              </a:rPr>
-              <a:t>متوافق مع NCA وPDPL وISO 27001</a:t>
-            </a:r>
-            <a:endParaRPr lang="en-US" sz="1200" dirty="0"/>
-          </a:p>
-        </p:txBody>
-      </p:sp>
-      <p:pic>
-        <p:nvPicPr>
-          <p:cNvPr id="35" name="Image 7" descr="/tmp/claude-0/-home-claude/750ff410-f4aa-5276-9360-1e19d018b112/scratchpad/c/assets/m-lap-demo.png">    </p:cNvPr>
-          <p:cNvPicPr>
-            <a:picLocks noChangeAspect="1"/>
-          </p:cNvPicPr>
-          <p:nvPr/>
-        </p:nvPicPr>
-        <p:blipFill>
-          <a:blip r:embed="rId8"/>
-          <a:stretch>
-            <a:fillRect/>
-          </a:stretch>
-        </p:blipFill>
-        <p:spPr>
-          <a:xfrm>
-            <a:off x="914400" y="1828800"/>
-            <a:ext cx="4846320" cy="2971646"/>
-          </a:xfrm>
-          <a:prstGeom prst="rect">
-            <a:avLst/>
-          </a:prstGeom>
-        </p:spPr>
-      </p:pic>
-      <p:pic>
-        <p:nvPicPr>
-          <p:cNvPr id="36" name="Image 8" descr="/tmp/claude-0/-home-claude/750ff410-f4aa-5276-9360-1e19d018b112/scratchpad/c/assets/m-ph-demo.png">    </p:cNvPr>
-          <p:cNvPicPr>
-            <a:picLocks noChangeAspect="1"/>
-          </p:cNvPicPr>
-          <p:nvPr/>
-        </p:nvPicPr>
-        <p:blipFill>
-          <a:blip r:embed="rId9"/>
-          <a:stretch>
-            <a:fillRect/>
-          </a:stretch>
-        </p:blipFill>
-        <p:spPr>
-          <a:xfrm>
-            <a:off x="457200" y="2697480"/>
-            <a:ext cx="1547307" cy="3200400"/>
+            <a:off x="457200" y="2514600"/>
+            <a:ext cx="5852160" cy="3588402"/>
           </a:xfrm>
           <a:prstGeom prst="rect">
             <a:avLst/>

</xml_diff>

<commit_message>
Pitch deck: business model slide (free scan, per resource, consulting)
Co-Authored-By: Claude Opus 5.5 (1M context) <noreply@anthropic.com>
Claude-Session: https://claude.ai/code/session_011TSHxy9drUC1JZWNcfUL3E
</commit_message>
<xml_diff>
--- a/pitch/SSB_VentureX.pptx
+++ b/pitch/SSB_VentureX.pptx
@@ -16,9 +16,10 @@
     <p:sldId id="264" r:id="rId10"/>
     <p:sldId id="265" r:id="rId11"/>
     <p:sldId id="266" r:id="rId12"/>
+    <p:sldId id="267" r:id="rId13"/>
   </p:sldIdLst>
   <p:notesMasterIdLst>
-    <p:notesMasterId r:id="rId13"/>
+    <p:notesMasterId r:id="rId14"/>
   </p:notesMasterIdLst>
   <p:sldSz cx="12192000" cy="6858000"/>
   <p:notesSz cx="6858000" cy="12192000"/>
@@ -730,6 +731,94 @@
 </p:notes>
 </file>
 
+<file path=ppt/notesSlides/notesSlide12.xml><?xml version="1.0" encoding="utf-8"?>
+<p:notes xmlns:a="http://schemas.openxmlformats.org/drawingml/2006/main" xmlns:r="http://schemas.openxmlformats.org/officeDocument/2006/relationships" xmlns:p="http://schemas.openxmlformats.org/presentationml/2006/main">
+  <p:cSld>
+    <p:spTree>
+      <p:nvGrpSpPr>
+        <p:cNvPr id="1" name=""/>
+        <p:cNvGrpSpPr/>
+        <p:nvPr/>
+      </p:nvGrpSpPr>
+      <p:grpSpPr>
+        <a:xfrm>
+          <a:off x="0" y="0"/>
+          <a:ext cx="0" cy="0"/>
+          <a:chOff x="0" y="0"/>
+          <a:chExt cx="0" cy="0"/>
+        </a:xfrm>
+      </p:grpSpPr>
+      <p:sp>
+        <p:nvSpPr>
+          <p:cNvPr id="2" name="Slide Image Placeholder 1"/>
+          <p:cNvSpPr>
+            <a:spLocks noGrp="1" noRot="1" noChangeAspect="1"/>
+          </p:cNvSpPr>
+          <p:nvPr>
+            <p:ph type="sldImg"/>
+          </p:nvPr>
+        </p:nvSpPr>
+        <p:spPr/>
+      </p:sp>
+      <p:sp>
+        <p:nvSpPr>
+          <p:cNvPr id="3" name="Notes Placeholder 2"/>
+          <p:cNvSpPr>
+            <a:spLocks noGrp="1"/>
+          </p:cNvSpPr>
+          <p:nvPr>
+            <p:ph type="body" idx="1"/>
+          </p:nvPr>
+        </p:nvSpPr>
+        <p:spPr/>
+        <p:txBody>
+          <a:bodyPr/>
+          <a:lstStyle/>
+          <a:p>
+            <a:r>
+              <a:rPr lang="en-US" dirty="0"/>
+              <a:t/>
+            </a:r>
+            <a:endParaRPr lang="en-US" dirty="0"/>
+          </a:p>
+        </p:txBody>
+      </p:sp>
+      <p:sp>
+        <p:nvSpPr>
+          <p:cNvPr id="4" name="Slide Number Placeholder 3"/>
+          <p:cNvSpPr>
+            <a:spLocks noGrp="1"/>
+          </p:cNvSpPr>
+          <p:nvPr>
+            <p:ph type="sldNum" sz="quarter" idx="10"/>
+          </p:nvPr>
+        </p:nvSpPr>
+        <p:spPr/>
+        <p:txBody>
+          <a:bodyPr/>
+          <a:lstStyle/>
+          <a:p>
+            <a:fld id="{F7021451-1387-4CA6-816F-3879F97B5CBC}" type="slidenum">
+              <a:rPr lang="en-US"/>
+              <a:t>12</a:t>
+            </a:fld>
+            <a:endParaRPr lang="en-US"/>
+          </a:p>
+        </p:txBody>
+      </p:sp>
+    </p:spTree>
+    <p:extLst>
+      <p:ext uri="{BB962C8B-B14F-4D97-AF65-F5344CB8AC3E}">
+        <p14:creationId xmlns:p14="http://schemas.microsoft.com/office/powerpoint/2010/main" val="1024086991"/>
+      </p:ext>
+    </p:extLst>
+  </p:cSld>
+  <p:clrMapOvr>
+    <a:masterClrMapping/>
+  </p:clrMapOvr>
+</p:notes>
+</file>
+
 <file path=ppt/notesSlides/notesSlide2.xml><?xml version="1.0" encoding="utf-8"?>
 <p:notes xmlns:a="http://schemas.openxmlformats.org/drawingml/2006/main" xmlns:r="http://schemas.openxmlformats.org/officeDocument/2006/relationships" xmlns:p="http://schemas.openxmlformats.org/presentationml/2006/main">
   <p:cSld>
@@ -3081,8 +3170,8 @@
         </p:nvSpPr>
         <p:spPr>
           <a:xfrm>
-            <a:off x="9759391" y="987552"/>
-            <a:ext cx="1975104" cy="384048"/>
+            <a:off x="8918143" y="987552"/>
+            <a:ext cx="2816352" cy="384048"/>
           </a:xfrm>
           <a:prstGeom prst="roundRect">
             <a:avLst>
@@ -3103,8 +3192,8 @@
         </p:nvSpPr>
         <p:spPr>
           <a:xfrm>
-            <a:off x="9759391" y="987552"/>
-            <a:ext cx="1975104" cy="384048"/>
+            <a:off x="8918143" y="987552"/>
+            <a:ext cx="2816352" cy="384048"/>
           </a:xfrm>
           <a:prstGeom prst="rect">
             <a:avLst/>
@@ -3128,7 +3217,7 @@
                 <a:ea typeface="IBM Plex Sans Arabic" pitchFamily="34" charset="-122"/>
                 <a:cs typeface="IBM Plex Sans Arabic" pitchFamily="34" charset="-120"/>
               </a:rPr>
-              <a:t>الخطوة التالية</a:t>
+              <a:t>الأثر والقيمة المتوقعة</a:t>
             </a:r>
             <a:endParaRPr lang="en-US" sz="1300" dirty="0"/>
           </a:p>
@@ -3269,7 +3358,7 @@
                 <a:ea typeface="IBM Plex Sans Arabic" pitchFamily="34" charset="-122"/>
                 <a:cs typeface="IBM Plex Sans Arabic" pitchFamily="34" charset="-120"/>
               </a:rPr>
-              <a:t>ما بعد التحدي</a:t>
+              <a:t>أثر بالأرقام</a:t>
             </a:r>
             <a:endParaRPr lang="en-US" sz="3400" dirty="0"/>
           </a:p>
@@ -3284,22 +3373,27 @@
         <p:spPr>
           <a:xfrm>
             <a:off x="8188757" y="2697480"/>
-            <a:ext cx="3545738" cy="1920240"/>
+            <a:ext cx="3545738" cy="2377440"/>
           </a:xfrm>
           <a:prstGeom prst="roundRect">
             <a:avLst>
-              <a:gd name="adj" fmla="val 9524"/>
+              <a:gd name="adj" fmla="val 7692"/>
             </a:avLst>
           </a:prstGeom>
           <a:solidFill>
-            <a:srgbClr val="8E2F3C"/>
-          </a:solidFill>
-          <a:ln/>
+            <a:srgbClr val="FFFBF8"/>
+          </a:solidFill>
+          <a:ln w="9525">
+            <a:solidFill>
+              <a:srgbClr val="E3D5CC"/>
+            </a:solidFill>
+            <a:prstDash val="solid"/>
+          </a:ln>
         </p:spPr>
       </p:sp>
       <p:pic>
         <p:nvPicPr>
-          <p:cNvPr id="24" name="Image 3" descr="/tmp/claude-0/-home-claude/750ff410-f4aa-5276-9360-1e19d018b112/scratchpad/c/assets/i-scale-cr.png">    </p:cNvPr>
+          <p:cNvPr id="24" name="Image 3" descr="/tmp/claude-0/-home-claude/750ff410-f4aa-5276-9360-1e19d018b112/scratchpad/c/assets/i-wallet-br.png">    </p:cNvPr>
           <p:cNvPicPr>
             <a:picLocks noChangeAspect="1"/>
           </p:cNvPicPr>
@@ -3313,8 +3407,8 @@
         </p:blipFill>
         <p:spPr>
           <a:xfrm>
-            <a:off x="9618726" y="3017520"/>
-            <a:ext cx="685800" cy="685800"/>
+            <a:off x="9687306" y="2971800"/>
+            <a:ext cx="548640" cy="548640"/>
           </a:xfrm>
           <a:prstGeom prst="rect">
             <a:avLst/>
@@ -3329,51 +3423,90 @@
         </p:nvSpPr>
         <p:spPr>
           <a:xfrm>
-            <a:off x="8188757" y="3886200"/>
-            <a:ext cx="3545738" cy="457200"/>
-          </a:xfrm>
-          <a:prstGeom prst="rect">
-            <a:avLst/>
-          </a:prstGeom>
-          <a:noFill/>
-          <a:ln/>
-        </p:spPr>
-        <p:txBody>
-          <a:bodyPr wrap="square" lIns="0" tIns="0" rIns="0" bIns="0" rtlCol="0" anchor="t"/>
+            <a:off x="8188757" y="3566160"/>
+            <a:ext cx="3545738" cy="868680"/>
+          </a:xfrm>
+          <a:prstGeom prst="rect">
+            <a:avLst/>
+          </a:prstGeom>
+          <a:noFill/>
+          <a:ln/>
+        </p:spPr>
+        <p:txBody>
+          <a:bodyPr wrap="square" lIns="0" tIns="0" rIns="0" bIns="0" rtlCol="0" anchor="ctr"/>
+          <a:lstStyle/>
+          <a:p>
+            <a:pPr algn="ctr" indent="0" marL="0">
+              <a:buNone/>
+            </a:pPr>
+            <a:r>
+              <a:rPr lang="en-US" sz="5400" b="1" dirty="0">
+                <a:solidFill>
+                  <a:srgbClr val="8E2F3C"/>
+                </a:solidFill>
+                <a:latin typeface="IBM Plex Sans Arabic" pitchFamily="34" charset="0"/>
+                <a:ea typeface="IBM Plex Sans Arabic" pitchFamily="34" charset="-122"/>
+                <a:cs typeface="IBM Plex Sans Arabic" pitchFamily="34" charset="-120"/>
+              </a:rPr>
+              <a:t>10.8%</a:t>
+            </a:r>
+            <a:endParaRPr lang="en-US" sz="5400" dirty="0"/>
+          </a:p>
+        </p:txBody>
+      </p:sp>
+      <p:sp>
+        <p:nvSpPr>
+          <p:cNvPr id="26" name="Text 20"/>
+          <p:cNvSpPr txBox="1"/>
+          <p:nvPr/>
+        </p:nvSpPr>
+        <p:spPr>
+          <a:xfrm>
+            <a:off x="8463077" y="4480560"/>
+            <a:ext cx="2997098" cy="411480"/>
+          </a:xfrm>
+          <a:prstGeom prst="rect">
+            <a:avLst/>
+          </a:prstGeom>
+          <a:noFill/>
+          <a:ln/>
+        </p:spPr>
+        <p:txBody>
+          <a:bodyPr wrap="square" lIns="0" tIns="0" rIns="0" bIns="0" rtlCol="0" anchor="ctr"/>
           <a:lstStyle/>
           <a:p>
             <a:pPr rtl="1" algn="ctr" indent="0" marL="0">
               <a:buNone/>
             </a:pPr>
             <a:r>
-              <a:rPr lang="en-US" sz="2200" b="1" dirty="0">
-                <a:solidFill>
-                  <a:srgbClr val="FBF6EE"/>
-                </a:solidFill>
-                <a:latin typeface="IBM Plex Sans Arabic" pitchFamily="34" charset="0"/>
-                <a:ea typeface="IBM Plex Sans Arabic" pitchFamily="34" charset="-122"/>
-                <a:cs typeface="IBM Plex Sans Arabic" pitchFamily="34" charset="-120"/>
-              </a:rPr>
-              <a:t>مقارنة السحابات</a:t>
-            </a:r>
-            <a:endParaRPr lang="en-US" sz="2200" dirty="0"/>
-          </a:p>
-        </p:txBody>
-      </p:sp>
-      <p:sp>
-        <p:nvSpPr>
-          <p:cNvPr id="26" name="Shape 20"/>
+              <a:rPr lang="en-US" sz="1800" dirty="0">
+                <a:solidFill>
+                  <a:srgbClr val="21141A"/>
+                </a:solidFill>
+                <a:latin typeface="IBM Plex Sans Arabic" pitchFamily="34" charset="0"/>
+                <a:ea typeface="IBM Plex Sans Arabic" pitchFamily="34" charset="-122"/>
+                <a:cs typeface="IBM Plex Sans Arabic" pitchFamily="34" charset="-120"/>
+              </a:rPr>
+              <a:t>توفير من الفاتورة</a:t>
+            </a:r>
+            <a:endParaRPr lang="en-US" sz="1800" dirty="0"/>
+          </a:p>
+        </p:txBody>
+      </p:sp>
+      <p:sp>
+        <p:nvSpPr>
+          <p:cNvPr id="27" name="Shape 21"/>
           <p:cNvSpPr/>
           <p:nvPr/>
         </p:nvSpPr>
         <p:spPr>
           <a:xfrm>
             <a:off x="4322978" y="2697480"/>
-            <a:ext cx="3545738" cy="1920240"/>
+            <a:ext cx="3545738" cy="2377440"/>
           </a:xfrm>
           <a:prstGeom prst="roundRect">
             <a:avLst>
-              <a:gd name="adj" fmla="val 9524"/>
+              <a:gd name="adj" fmla="val 7692"/>
             </a:avLst>
           </a:prstGeom>
           <a:solidFill>
@@ -3384,7 +3517,7 @@
       </p:sp>
       <p:pic>
         <p:nvPicPr>
-          <p:cNvPr id="27" name="Image 4" descr="/tmp/claude-0/-home-claude/750ff410-f4aa-5276-9360-1e19d018b112/scratchpad/c/assets/i-server-cr.png">    </p:cNvPr>
+          <p:cNvPr id="28" name="Image 4" descr="/tmp/claude-0/-home-claude/750ff410-f4aa-5276-9360-1e19d018b112/scratchpad/c/assets/i-trend-cr.png">    </p:cNvPr>
           <p:cNvPicPr>
             <a:picLocks noChangeAspect="1"/>
           </p:cNvPicPr>
@@ -3398,8 +3531,8 @@
         </p:blipFill>
         <p:spPr>
           <a:xfrm>
-            <a:off x="5752948" y="3017520"/>
-            <a:ext cx="685800" cy="685800"/>
+            <a:off x="5821528" y="2971800"/>
+            <a:ext cx="548640" cy="548640"/>
           </a:xfrm>
           <a:prstGeom prst="rect">
             <a:avLst/>
@@ -3408,30 +3541,69 @@
       </p:pic>
       <p:sp>
         <p:nvSpPr>
-          <p:cNvPr id="28" name="Text 21"/>
-          <p:cNvSpPr txBox="1"/>
-          <p:nvPr/>
-        </p:nvSpPr>
-        <p:spPr>
-          <a:xfrm>
-            <a:off x="4322978" y="3886200"/>
-            <a:ext cx="3545738" cy="457200"/>
-          </a:xfrm>
-          <a:prstGeom prst="rect">
-            <a:avLst/>
-          </a:prstGeom>
-          <a:noFill/>
-          <a:ln/>
-        </p:spPr>
-        <p:txBody>
-          <a:bodyPr wrap="square" lIns="0" tIns="0" rIns="0" bIns="0" rtlCol="0" anchor="t"/>
+          <p:cNvPr id="29" name="Text 22"/>
+          <p:cNvSpPr txBox="1"/>
+          <p:nvPr/>
+        </p:nvSpPr>
+        <p:spPr>
+          <a:xfrm>
+            <a:off x="4322978" y="3566160"/>
+            <a:ext cx="3545738" cy="868680"/>
+          </a:xfrm>
+          <a:prstGeom prst="rect">
+            <a:avLst/>
+          </a:prstGeom>
+          <a:noFill/>
+          <a:ln/>
+        </p:spPr>
+        <p:txBody>
+          <a:bodyPr wrap="square" lIns="0" tIns="0" rIns="0" bIns="0" rtlCol="0" anchor="ctr"/>
+          <a:lstStyle/>
+          <a:p>
+            <a:pPr algn="ctr" indent="0" marL="0">
+              <a:buNone/>
+            </a:pPr>
+            <a:r>
+              <a:rPr lang="en-US" sz="5400" b="1" dirty="0">
+                <a:solidFill>
+                  <a:srgbClr val="FBF6EE"/>
+                </a:solidFill>
+                <a:latin typeface="IBM Plex Sans Arabic" pitchFamily="34" charset="0"/>
+                <a:ea typeface="IBM Plex Sans Arabic" pitchFamily="34" charset="-122"/>
+                <a:cs typeface="IBM Plex Sans Arabic" pitchFamily="34" charset="-120"/>
+              </a:rPr>
+              <a:t>110K</a:t>
+            </a:r>
+            <a:endParaRPr lang="en-US" sz="5400" dirty="0"/>
+          </a:p>
+        </p:txBody>
+      </p:sp>
+      <p:sp>
+        <p:nvSpPr>
+          <p:cNvPr id="30" name="Text 23"/>
+          <p:cNvSpPr txBox="1"/>
+          <p:nvPr/>
+        </p:nvSpPr>
+        <p:spPr>
+          <a:xfrm>
+            <a:off x="4597298" y="4480560"/>
+            <a:ext cx="2997098" cy="411480"/>
+          </a:xfrm>
+          <a:prstGeom prst="rect">
+            <a:avLst/>
+          </a:prstGeom>
+          <a:noFill/>
+          <a:ln/>
+        </p:spPr>
+        <p:txBody>
+          <a:bodyPr wrap="square" lIns="0" tIns="0" rIns="0" bIns="0" rtlCol="0" anchor="ctr"/>
           <a:lstStyle/>
           <a:p>
             <a:pPr rtl="1" algn="ctr" indent="0" marL="0">
               <a:buNone/>
             </a:pPr>
             <a:r>
-              <a:rPr lang="en-US" sz="2200" b="1" dirty="0">
+              <a:rPr lang="en-US" sz="1800" dirty="0">
                 <a:solidFill>
                   <a:srgbClr val="FBF6EE"/>
                 </a:solidFill>
@@ -3439,37 +3611,42 @@
                 <a:ea typeface="IBM Plex Sans Arabic" pitchFamily="34" charset="-122"/>
                 <a:cs typeface="IBM Plex Sans Arabic" pitchFamily="34" charset="-120"/>
               </a:rPr>
-              <a:t>البنية الهجينة</a:t>
-            </a:r>
-            <a:endParaRPr lang="en-US" sz="2200" dirty="0"/>
-          </a:p>
-        </p:txBody>
-      </p:sp>
-      <p:sp>
-        <p:nvSpPr>
-          <p:cNvPr id="29" name="Shape 22"/>
+              <a:t>ريال سنوياً</a:t>
+            </a:r>
+            <a:endParaRPr lang="en-US" sz="1800" dirty="0"/>
+          </a:p>
+        </p:txBody>
+      </p:sp>
+      <p:sp>
+        <p:nvSpPr>
+          <p:cNvPr id="31" name="Shape 24"/>
           <p:cNvSpPr/>
           <p:nvPr/>
         </p:nvSpPr>
         <p:spPr>
           <a:xfrm>
             <a:off x="457200" y="2697480"/>
-            <a:ext cx="3545738" cy="1920240"/>
+            <a:ext cx="3545738" cy="2377440"/>
           </a:xfrm>
           <a:prstGeom prst="roundRect">
             <a:avLst>
-              <a:gd name="adj" fmla="val 9524"/>
+              <a:gd name="adj" fmla="val 7692"/>
             </a:avLst>
           </a:prstGeom>
           <a:solidFill>
-            <a:srgbClr val="8E2F3C"/>
-          </a:solidFill>
-          <a:ln/>
+            <a:srgbClr val="FFFBF8"/>
+          </a:solidFill>
+          <a:ln w="9525">
+            <a:solidFill>
+              <a:srgbClr val="E3D5CC"/>
+            </a:solidFill>
+            <a:prstDash val="solid"/>
+          </a:ln>
         </p:spPr>
       </p:sp>
       <p:pic>
         <p:nvPicPr>
-          <p:cNvPr id="30" name="Image 5" descr="/tmp/claude-0/-home-claude/750ff410-f4aa-5276-9360-1e19d018b112/scratchpad/c/assets/i-bell-cr.png">    </p:cNvPr>
+          <p:cNvPr id="32" name="Image 5" descr="/tmp/claude-0/-home-claude/750ff410-f4aa-5276-9360-1e19d018b112/scratchpad/c/assets/i-clock-br.png">    </p:cNvPr>
           <p:cNvPicPr>
             <a:picLocks noChangeAspect="1"/>
           </p:cNvPicPr>
@@ -3483,8 +3660,8 @@
         </p:blipFill>
         <p:spPr>
           <a:xfrm>
-            <a:off x="1887169" y="3017520"/>
-            <a:ext cx="685800" cy="685800"/>
+            <a:off x="1955749" y="2971800"/>
+            <a:ext cx="548640" cy="548640"/>
           </a:xfrm>
           <a:prstGeom prst="rect">
             <a:avLst/>
@@ -3493,14 +3670,92 @@
       </p:pic>
       <p:sp>
         <p:nvSpPr>
-          <p:cNvPr id="31" name="Text 23"/>
-          <p:cNvSpPr txBox="1"/>
-          <p:nvPr/>
-        </p:nvSpPr>
-        <p:spPr>
-          <a:xfrm>
-            <a:off x="457200" y="3886200"/>
-            <a:ext cx="3545738" cy="457200"/>
+          <p:cNvPr id="33" name="Text 25"/>
+          <p:cNvSpPr txBox="1"/>
+          <p:nvPr/>
+        </p:nvSpPr>
+        <p:spPr>
+          <a:xfrm>
+            <a:off x="457200" y="3566160"/>
+            <a:ext cx="3545738" cy="868680"/>
+          </a:xfrm>
+          <a:prstGeom prst="rect">
+            <a:avLst/>
+          </a:prstGeom>
+          <a:noFill/>
+          <a:ln/>
+        </p:spPr>
+        <p:txBody>
+          <a:bodyPr wrap="square" lIns="0" tIns="0" rIns="0" bIns="0" rtlCol="0" anchor="ctr"/>
+          <a:lstStyle/>
+          <a:p>
+            <a:pPr algn="ctr" indent="0" marL="0">
+              <a:buNone/>
+            </a:pPr>
+            <a:r>
+              <a:rPr lang="en-US" sz="5400" b="1" dirty="0">
+                <a:solidFill>
+                  <a:srgbClr val="8E2F3C"/>
+                </a:solidFill>
+                <a:latin typeface="IBM Plex Sans Arabic" pitchFamily="34" charset="0"/>
+                <a:ea typeface="IBM Plex Sans Arabic" pitchFamily="34" charset="-122"/>
+                <a:cs typeface="IBM Plex Sans Arabic" pitchFamily="34" charset="-120"/>
+              </a:rPr>
+              <a:t>دقائق</a:t>
+            </a:r>
+            <a:endParaRPr lang="en-US" sz="5400" dirty="0"/>
+          </a:p>
+        </p:txBody>
+      </p:sp>
+      <p:sp>
+        <p:nvSpPr>
+          <p:cNvPr id="34" name="Text 26"/>
+          <p:cNvSpPr txBox="1"/>
+          <p:nvPr/>
+        </p:nvSpPr>
+        <p:spPr>
+          <a:xfrm>
+            <a:off x="731520" y="4480560"/>
+            <a:ext cx="2997098" cy="411480"/>
+          </a:xfrm>
+          <a:prstGeom prst="rect">
+            <a:avLst/>
+          </a:prstGeom>
+          <a:noFill/>
+          <a:ln/>
+        </p:spPr>
+        <p:txBody>
+          <a:bodyPr wrap="square" lIns="0" tIns="0" rIns="0" bIns="0" rtlCol="0" anchor="ctr"/>
+          <a:lstStyle/>
+          <a:p>
+            <a:pPr rtl="1" algn="ctr" indent="0" marL="0">
+              <a:buNone/>
+            </a:pPr>
+            <a:r>
+              <a:rPr lang="en-US" sz="1800" dirty="0">
+                <a:solidFill>
+                  <a:srgbClr val="21141A"/>
+                </a:solidFill>
+                <a:latin typeface="IBM Plex Sans Arabic" pitchFamily="34" charset="0"/>
+                <a:ea typeface="IBM Plex Sans Arabic" pitchFamily="34" charset="-122"/>
+                <a:cs typeface="IBM Plex Sans Arabic" pitchFamily="34" charset="-120"/>
+              </a:rPr>
+              <a:t>بدل أسابيع</a:t>
+            </a:r>
+            <a:endParaRPr lang="en-US" sz="1800" dirty="0"/>
+          </a:p>
+        </p:txBody>
+      </p:sp>
+      <p:sp>
+        <p:nvSpPr>
+          <p:cNvPr id="35" name="Text 27"/>
+          <p:cNvSpPr txBox="1"/>
+          <p:nvPr/>
+        </p:nvSpPr>
+        <p:spPr>
+          <a:xfrm>
+            <a:off x="457200" y="5349240"/>
+            <a:ext cx="11277295" cy="365760"/>
           </a:xfrm>
           <a:prstGeom prst="rect">
             <a:avLst/>
@@ -3516,56 +3771,17 @@
               <a:buNone/>
             </a:pPr>
             <a:r>
-              <a:rPr lang="en-US" sz="2200" b="1" dirty="0">
-                <a:solidFill>
-                  <a:srgbClr val="FBF6EE"/>
-                </a:solidFill>
-                <a:latin typeface="IBM Plex Sans Arabic" pitchFamily="34" charset="0"/>
-                <a:ea typeface="IBM Plex Sans Arabic" pitchFamily="34" charset="-122"/>
-                <a:cs typeface="IBM Plex Sans Arabic" pitchFamily="34" charset="-120"/>
-              </a:rPr>
-              <a:t>إنذار مبكر 24/7</a:t>
-            </a:r>
-            <a:endParaRPr lang="en-US" sz="2200" dirty="0"/>
-          </a:p>
-        </p:txBody>
-      </p:sp>
-      <p:sp>
-        <p:nvSpPr>
-          <p:cNvPr id="32" name="Text 24"/>
-          <p:cNvSpPr txBox="1"/>
-          <p:nvPr/>
-        </p:nvSpPr>
-        <p:spPr>
-          <a:xfrm>
-            <a:off x="457200" y="5029200"/>
-            <a:ext cx="11277295" cy="457200"/>
-          </a:xfrm>
-          <a:prstGeom prst="rect">
-            <a:avLst/>
-          </a:prstGeom>
-          <a:noFill/>
-          <a:ln/>
-        </p:spPr>
-        <p:txBody>
-          <a:bodyPr wrap="square" lIns="0" tIns="0" rIns="0" bIns="0" rtlCol="0" anchor="ctr"/>
-          <a:lstStyle/>
-          <a:p>
-            <a:pPr rtl="1" algn="ctr" indent="0" marL="0">
-              <a:buNone/>
-            </a:pPr>
-            <a:r>
-              <a:rPr lang="en-US" sz="1800" b="1" dirty="0">
-                <a:solidFill>
-                  <a:srgbClr val="21141A"/>
-                </a:solidFill>
-                <a:latin typeface="IBM Plex Sans Arabic" pitchFamily="34" charset="0"/>
-                <a:ea typeface="IBM Plex Sans Arabic" pitchFamily="34" charset="-122"/>
-                <a:cs typeface="IBM Plex Sans Arabic" pitchFamily="34" charset="-120"/>
-              </a:rPr>
-              <a:t>نحتاج: توجيه خبراء · شريك سحابي محلي · 10 شركات للتجربة</a:t>
-            </a:r>
-            <a:endParaRPr lang="en-US" sz="1800" dirty="0"/>
+              <a:rPr lang="en-US" sz="1500" dirty="0">
+                <a:solidFill>
+                  <a:srgbClr val="7F6C72"/>
+                </a:solidFill>
+                <a:latin typeface="IBM Plex Sans Arabic" pitchFamily="34" charset="0"/>
+                <a:ea typeface="IBM Plex Sans Arabic" pitchFamily="34" charset="-122"/>
+                <a:cs typeface="IBM Plex Sans Arabic" pitchFamily="34" charset="-120"/>
+              </a:rPr>
+              <a:t>مثال: شركة افتراضية من 120 موظفاً</a:t>
+            </a:r>
+            <a:endParaRPr lang="en-US" sz="1500" dirty="0"/>
           </a:p>
         </p:txBody>
       </p:sp>
@@ -3936,8 +4152,8 @@
         </p:nvSpPr>
         <p:spPr>
           <a:xfrm>
-            <a:off x="10600639" y="987552"/>
-            <a:ext cx="1133856" cy="384048"/>
+            <a:off x="9759391" y="987552"/>
+            <a:ext cx="1975104" cy="384048"/>
           </a:xfrm>
           <a:prstGeom prst="roundRect">
             <a:avLst>
@@ -3958,8 +4174,8 @@
         </p:nvSpPr>
         <p:spPr>
           <a:xfrm>
-            <a:off x="10600639" y="987552"/>
-            <a:ext cx="1133856" cy="384048"/>
+            <a:off x="9759391" y="987552"/>
+            <a:ext cx="1975104" cy="384048"/>
           </a:xfrm>
           <a:prstGeom prst="rect">
             <a:avLst/>
@@ -3983,7 +4199,7 @@
                 <a:ea typeface="IBM Plex Sans Arabic" pitchFamily="34" charset="-122"/>
                 <a:cs typeface="IBM Plex Sans Arabic" pitchFamily="34" charset="-120"/>
               </a:rPr>
-              <a:t>الختام</a:t>
+              <a:t>الخطوة التالية</a:t>
             </a:r>
             <a:endParaRPr lang="en-US" sz="1300" dirty="0"/>
           </a:p>
@@ -4086,6 +4302,861 @@
                 <a:cs typeface="IBM Plex Sans Arabic" pitchFamily="34" charset="-120"/>
               </a:rPr>
               <a:t>11</a:t>
+            </a:r>
+            <a:endParaRPr lang="en-US" sz="1100" dirty="0"/>
+          </a:p>
+        </p:txBody>
+      </p:sp>
+      <p:sp>
+        <p:nvSpPr>
+          <p:cNvPr id="22" name="Text 17"/>
+          <p:cNvSpPr txBox="1"/>
+          <p:nvPr/>
+        </p:nvSpPr>
+        <p:spPr>
+          <a:xfrm>
+            <a:off x="457200" y="1600200"/>
+            <a:ext cx="11277295" cy="731520"/>
+          </a:xfrm>
+          <a:prstGeom prst="rect">
+            <a:avLst/>
+          </a:prstGeom>
+          <a:noFill/>
+          <a:ln/>
+        </p:spPr>
+        <p:txBody>
+          <a:bodyPr wrap="square" lIns="0" tIns="0" rIns="0" bIns="0" rtlCol="0" anchor="ctr"/>
+          <a:lstStyle/>
+          <a:p>
+            <a:pPr rtl="1" algn="r" indent="0" marL="0">
+              <a:buNone/>
+            </a:pPr>
+            <a:r>
+              <a:rPr lang="en-US" sz="3400" b="1" dirty="0">
+                <a:solidFill>
+                  <a:srgbClr val="21141A"/>
+                </a:solidFill>
+                <a:latin typeface="IBM Plex Sans Arabic" pitchFamily="34" charset="0"/>
+                <a:ea typeface="IBM Plex Sans Arabic" pitchFamily="34" charset="-122"/>
+                <a:cs typeface="IBM Plex Sans Arabic" pitchFamily="34" charset="-120"/>
+              </a:rPr>
+              <a:t>ما بعد التحدي</a:t>
+            </a:r>
+            <a:endParaRPr lang="en-US" sz="3400" dirty="0"/>
+          </a:p>
+        </p:txBody>
+      </p:sp>
+      <p:sp>
+        <p:nvSpPr>
+          <p:cNvPr id="23" name="Shape 18"/>
+          <p:cNvSpPr/>
+          <p:nvPr/>
+        </p:nvSpPr>
+        <p:spPr>
+          <a:xfrm>
+            <a:off x="8188757" y="2697480"/>
+            <a:ext cx="3545738" cy="1920240"/>
+          </a:xfrm>
+          <a:prstGeom prst="roundRect">
+            <a:avLst>
+              <a:gd name="adj" fmla="val 9524"/>
+            </a:avLst>
+          </a:prstGeom>
+          <a:solidFill>
+            <a:srgbClr val="8E2F3C"/>
+          </a:solidFill>
+          <a:ln/>
+        </p:spPr>
+      </p:sp>
+      <p:pic>
+        <p:nvPicPr>
+          <p:cNvPr id="24" name="Image 3" descr="/tmp/claude-0/-home-claude/750ff410-f4aa-5276-9360-1e19d018b112/scratchpad/c/assets/i-scale-cr.png">    </p:cNvPr>
+          <p:cNvPicPr>
+            <a:picLocks noChangeAspect="1"/>
+          </p:cNvPicPr>
+          <p:nvPr/>
+        </p:nvPicPr>
+        <p:blipFill>
+          <a:blip r:embed="rId4"/>
+          <a:stretch>
+            <a:fillRect/>
+          </a:stretch>
+        </p:blipFill>
+        <p:spPr>
+          <a:xfrm>
+            <a:off x="9618726" y="3017520"/>
+            <a:ext cx="685800" cy="685800"/>
+          </a:xfrm>
+          <a:prstGeom prst="rect">
+            <a:avLst/>
+          </a:prstGeom>
+        </p:spPr>
+      </p:pic>
+      <p:sp>
+        <p:nvSpPr>
+          <p:cNvPr id="25" name="Text 19"/>
+          <p:cNvSpPr txBox="1"/>
+          <p:nvPr/>
+        </p:nvSpPr>
+        <p:spPr>
+          <a:xfrm>
+            <a:off x="8188757" y="3886200"/>
+            <a:ext cx="3545738" cy="457200"/>
+          </a:xfrm>
+          <a:prstGeom prst="rect">
+            <a:avLst/>
+          </a:prstGeom>
+          <a:noFill/>
+          <a:ln/>
+        </p:spPr>
+        <p:txBody>
+          <a:bodyPr wrap="square" lIns="0" tIns="0" rIns="0" bIns="0" rtlCol="0" anchor="t"/>
+          <a:lstStyle/>
+          <a:p>
+            <a:pPr rtl="1" algn="ctr" indent="0" marL="0">
+              <a:buNone/>
+            </a:pPr>
+            <a:r>
+              <a:rPr lang="en-US" sz="2200" b="1" dirty="0">
+                <a:solidFill>
+                  <a:srgbClr val="FBF6EE"/>
+                </a:solidFill>
+                <a:latin typeface="IBM Plex Sans Arabic" pitchFamily="34" charset="0"/>
+                <a:ea typeface="IBM Plex Sans Arabic" pitchFamily="34" charset="-122"/>
+                <a:cs typeface="IBM Plex Sans Arabic" pitchFamily="34" charset="-120"/>
+              </a:rPr>
+              <a:t>مقارنة السحابات</a:t>
+            </a:r>
+            <a:endParaRPr lang="en-US" sz="2200" dirty="0"/>
+          </a:p>
+        </p:txBody>
+      </p:sp>
+      <p:sp>
+        <p:nvSpPr>
+          <p:cNvPr id="26" name="Shape 20"/>
+          <p:cNvSpPr/>
+          <p:nvPr/>
+        </p:nvSpPr>
+        <p:spPr>
+          <a:xfrm>
+            <a:off x="4322978" y="2697480"/>
+            <a:ext cx="3545738" cy="1920240"/>
+          </a:xfrm>
+          <a:prstGeom prst="roundRect">
+            <a:avLst>
+              <a:gd name="adj" fmla="val 9524"/>
+            </a:avLst>
+          </a:prstGeom>
+          <a:solidFill>
+            <a:srgbClr val="8E2F3C"/>
+          </a:solidFill>
+          <a:ln/>
+        </p:spPr>
+      </p:sp>
+      <p:pic>
+        <p:nvPicPr>
+          <p:cNvPr id="27" name="Image 4" descr="/tmp/claude-0/-home-claude/750ff410-f4aa-5276-9360-1e19d018b112/scratchpad/c/assets/i-server-cr.png">    </p:cNvPr>
+          <p:cNvPicPr>
+            <a:picLocks noChangeAspect="1"/>
+          </p:cNvPicPr>
+          <p:nvPr/>
+        </p:nvPicPr>
+        <p:blipFill>
+          <a:blip r:embed="rId5"/>
+          <a:stretch>
+            <a:fillRect/>
+          </a:stretch>
+        </p:blipFill>
+        <p:spPr>
+          <a:xfrm>
+            <a:off x="5752948" y="3017520"/>
+            <a:ext cx="685800" cy="685800"/>
+          </a:xfrm>
+          <a:prstGeom prst="rect">
+            <a:avLst/>
+          </a:prstGeom>
+        </p:spPr>
+      </p:pic>
+      <p:sp>
+        <p:nvSpPr>
+          <p:cNvPr id="28" name="Text 21"/>
+          <p:cNvSpPr txBox="1"/>
+          <p:nvPr/>
+        </p:nvSpPr>
+        <p:spPr>
+          <a:xfrm>
+            <a:off x="4322978" y="3886200"/>
+            <a:ext cx="3545738" cy="457200"/>
+          </a:xfrm>
+          <a:prstGeom prst="rect">
+            <a:avLst/>
+          </a:prstGeom>
+          <a:noFill/>
+          <a:ln/>
+        </p:spPr>
+        <p:txBody>
+          <a:bodyPr wrap="square" lIns="0" tIns="0" rIns="0" bIns="0" rtlCol="0" anchor="t"/>
+          <a:lstStyle/>
+          <a:p>
+            <a:pPr rtl="1" algn="ctr" indent="0" marL="0">
+              <a:buNone/>
+            </a:pPr>
+            <a:r>
+              <a:rPr lang="en-US" sz="2200" b="1" dirty="0">
+                <a:solidFill>
+                  <a:srgbClr val="FBF6EE"/>
+                </a:solidFill>
+                <a:latin typeface="IBM Plex Sans Arabic" pitchFamily="34" charset="0"/>
+                <a:ea typeface="IBM Plex Sans Arabic" pitchFamily="34" charset="-122"/>
+                <a:cs typeface="IBM Plex Sans Arabic" pitchFamily="34" charset="-120"/>
+              </a:rPr>
+              <a:t>البنية الهجينة</a:t>
+            </a:r>
+            <a:endParaRPr lang="en-US" sz="2200" dirty="0"/>
+          </a:p>
+        </p:txBody>
+      </p:sp>
+      <p:sp>
+        <p:nvSpPr>
+          <p:cNvPr id="29" name="Shape 22"/>
+          <p:cNvSpPr/>
+          <p:nvPr/>
+        </p:nvSpPr>
+        <p:spPr>
+          <a:xfrm>
+            <a:off x="457200" y="2697480"/>
+            <a:ext cx="3545738" cy="1920240"/>
+          </a:xfrm>
+          <a:prstGeom prst="roundRect">
+            <a:avLst>
+              <a:gd name="adj" fmla="val 9524"/>
+            </a:avLst>
+          </a:prstGeom>
+          <a:solidFill>
+            <a:srgbClr val="8E2F3C"/>
+          </a:solidFill>
+          <a:ln/>
+        </p:spPr>
+      </p:sp>
+      <p:pic>
+        <p:nvPicPr>
+          <p:cNvPr id="30" name="Image 5" descr="/tmp/claude-0/-home-claude/750ff410-f4aa-5276-9360-1e19d018b112/scratchpad/c/assets/i-bell-cr.png">    </p:cNvPr>
+          <p:cNvPicPr>
+            <a:picLocks noChangeAspect="1"/>
+          </p:cNvPicPr>
+          <p:nvPr/>
+        </p:nvPicPr>
+        <p:blipFill>
+          <a:blip r:embed="rId6"/>
+          <a:stretch>
+            <a:fillRect/>
+          </a:stretch>
+        </p:blipFill>
+        <p:spPr>
+          <a:xfrm>
+            <a:off x="1887169" y="3017520"/>
+            <a:ext cx="685800" cy="685800"/>
+          </a:xfrm>
+          <a:prstGeom prst="rect">
+            <a:avLst/>
+          </a:prstGeom>
+        </p:spPr>
+      </p:pic>
+      <p:sp>
+        <p:nvSpPr>
+          <p:cNvPr id="31" name="Text 23"/>
+          <p:cNvSpPr txBox="1"/>
+          <p:nvPr/>
+        </p:nvSpPr>
+        <p:spPr>
+          <a:xfrm>
+            <a:off x="457200" y="3886200"/>
+            <a:ext cx="3545738" cy="457200"/>
+          </a:xfrm>
+          <a:prstGeom prst="rect">
+            <a:avLst/>
+          </a:prstGeom>
+          <a:noFill/>
+          <a:ln/>
+        </p:spPr>
+        <p:txBody>
+          <a:bodyPr wrap="square" lIns="0" tIns="0" rIns="0" bIns="0" rtlCol="0" anchor="t"/>
+          <a:lstStyle/>
+          <a:p>
+            <a:pPr rtl="1" algn="ctr" indent="0" marL="0">
+              <a:buNone/>
+            </a:pPr>
+            <a:r>
+              <a:rPr lang="en-US" sz="2200" b="1" dirty="0">
+                <a:solidFill>
+                  <a:srgbClr val="FBF6EE"/>
+                </a:solidFill>
+                <a:latin typeface="IBM Plex Sans Arabic" pitchFamily="34" charset="0"/>
+                <a:ea typeface="IBM Plex Sans Arabic" pitchFamily="34" charset="-122"/>
+                <a:cs typeface="IBM Plex Sans Arabic" pitchFamily="34" charset="-120"/>
+              </a:rPr>
+              <a:t>إنذار مبكر 24/7</a:t>
+            </a:r>
+            <a:endParaRPr lang="en-US" sz="2200" dirty="0"/>
+          </a:p>
+        </p:txBody>
+      </p:sp>
+      <p:sp>
+        <p:nvSpPr>
+          <p:cNvPr id="32" name="Text 24"/>
+          <p:cNvSpPr txBox="1"/>
+          <p:nvPr/>
+        </p:nvSpPr>
+        <p:spPr>
+          <a:xfrm>
+            <a:off x="457200" y="5029200"/>
+            <a:ext cx="11277295" cy="457200"/>
+          </a:xfrm>
+          <a:prstGeom prst="rect">
+            <a:avLst/>
+          </a:prstGeom>
+          <a:noFill/>
+          <a:ln/>
+        </p:spPr>
+        <p:txBody>
+          <a:bodyPr wrap="square" lIns="0" tIns="0" rIns="0" bIns="0" rtlCol="0" anchor="ctr"/>
+          <a:lstStyle/>
+          <a:p>
+            <a:pPr rtl="1" algn="ctr" indent="0" marL="0">
+              <a:buNone/>
+            </a:pPr>
+            <a:r>
+              <a:rPr lang="en-US" sz="1800" b="1" dirty="0">
+                <a:solidFill>
+                  <a:srgbClr val="21141A"/>
+                </a:solidFill>
+                <a:latin typeface="IBM Plex Sans Arabic" pitchFamily="34" charset="0"/>
+                <a:ea typeface="IBM Plex Sans Arabic" pitchFamily="34" charset="-122"/>
+                <a:cs typeface="IBM Plex Sans Arabic" pitchFamily="34" charset="-120"/>
+              </a:rPr>
+              <a:t>نحتاج: توجيه خبراء · شريك سحابي محلي · 10 شركات للتجربة</a:t>
+            </a:r>
+            <a:endParaRPr lang="en-US" sz="1800" dirty="0"/>
+          </a:p>
+        </p:txBody>
+      </p:sp>
+    </p:spTree>
+  </p:cSld>
+  <p:clrMapOvr>
+    <a:masterClrMapping/>
+  </p:clrMapOvr>
+</p:sld>
+</file>
+
+<file path=ppt/slides/slide12.xml><?xml version="1.0" encoding="utf-8"?>
+<p:sld xmlns:a="http://schemas.openxmlformats.org/drawingml/2006/main" xmlns:r="http://schemas.openxmlformats.org/officeDocument/2006/relationships" xmlns:p="http://schemas.openxmlformats.org/presentationml/2006/main">
+  <p:cSld name="Slide 12">
+    <p:bg>
+      <p:bgPr>
+        <a:solidFill>
+          <a:srgbClr val="F8F3EF"/>
+        </a:solidFill>
+      </p:bgPr>
+    </p:bg>
+    <p:spTree>
+      <p:nvGrpSpPr>
+        <p:cNvPr id="1" name=""/>
+        <p:cNvGrpSpPr/>
+        <p:nvPr/>
+      </p:nvGrpSpPr>
+      <p:grpSpPr>
+        <a:xfrm>
+          <a:off x="0" y="0"/>
+          <a:ext cx="0" cy="0"/>
+          <a:chOff x="0" y="0"/>
+          <a:chExt cx="0" cy="0"/>
+        </a:xfrm>
+      </p:grpSpPr>
+      <p:sp>
+        <p:nvSpPr>
+          <p:cNvPr id="2" name="Shape 0"/>
+          <p:cNvSpPr/>
+          <p:nvPr/>
+        </p:nvSpPr>
+        <p:spPr>
+          <a:xfrm>
+            <a:off x="3017520" y="384048"/>
+            <a:ext cx="100584" cy="100584"/>
+          </a:xfrm>
+          <a:prstGeom prst="rect">
+            <a:avLst/>
+          </a:prstGeom>
+          <a:solidFill>
+            <a:srgbClr val="D48A93"/>
+          </a:solidFill>
+          <a:ln/>
+        </p:spPr>
+      </p:sp>
+      <p:sp>
+        <p:nvSpPr>
+          <p:cNvPr id="3" name="Shape 1"/>
+          <p:cNvSpPr/>
+          <p:nvPr/>
+        </p:nvSpPr>
+        <p:spPr>
+          <a:xfrm>
+            <a:off x="3429000" y="658368"/>
+            <a:ext cx="64008" cy="64008"/>
+          </a:xfrm>
+          <a:prstGeom prst="rect">
+            <a:avLst/>
+          </a:prstGeom>
+          <a:solidFill>
+            <a:srgbClr val="C9A46E"/>
+          </a:solidFill>
+          <a:ln/>
+        </p:spPr>
+      </p:sp>
+      <p:sp>
+        <p:nvSpPr>
+          <p:cNvPr id="4" name="Shape 2"/>
+          <p:cNvSpPr/>
+          <p:nvPr/>
+        </p:nvSpPr>
+        <p:spPr>
+          <a:xfrm>
+            <a:off x="4206240" y="329184"/>
+            <a:ext cx="82296" cy="82296"/>
+          </a:xfrm>
+          <a:prstGeom prst="rect">
+            <a:avLst/>
+          </a:prstGeom>
+          <a:solidFill>
+            <a:srgbClr val="7FB27A"/>
+          </a:solidFill>
+          <a:ln/>
+        </p:spPr>
+      </p:sp>
+      <p:sp>
+        <p:nvSpPr>
+          <p:cNvPr id="5" name="Shape 3"/>
+          <p:cNvSpPr/>
+          <p:nvPr/>
+        </p:nvSpPr>
+        <p:spPr>
+          <a:xfrm>
+            <a:off x="4937760" y="603504"/>
+            <a:ext cx="54864" cy="54864"/>
+          </a:xfrm>
+          <a:prstGeom prst="rect">
+            <a:avLst/>
+          </a:prstGeom>
+          <a:solidFill>
+            <a:srgbClr val="D48A93"/>
+          </a:solidFill>
+          <a:ln/>
+        </p:spPr>
+      </p:sp>
+      <p:sp>
+        <p:nvSpPr>
+          <p:cNvPr id="6" name="Shape 4"/>
+          <p:cNvSpPr/>
+          <p:nvPr/>
+        </p:nvSpPr>
+        <p:spPr>
+          <a:xfrm>
+            <a:off x="7223760" y="365760"/>
+            <a:ext cx="73152" cy="73152"/>
+          </a:xfrm>
+          <a:prstGeom prst="rect">
+            <a:avLst/>
+          </a:prstGeom>
+          <a:solidFill>
+            <a:srgbClr val="C9A46E"/>
+          </a:solidFill>
+          <a:ln/>
+        </p:spPr>
+      </p:sp>
+      <p:sp>
+        <p:nvSpPr>
+          <p:cNvPr id="7" name="Shape 5"/>
+          <p:cNvSpPr/>
+          <p:nvPr/>
+        </p:nvSpPr>
+        <p:spPr>
+          <a:xfrm>
+            <a:off x="7955280" y="640080"/>
+            <a:ext cx="100584" cy="100584"/>
+          </a:xfrm>
+          <a:prstGeom prst="rect">
+            <a:avLst/>
+          </a:prstGeom>
+          <a:solidFill>
+            <a:srgbClr val="D48A93"/>
+          </a:solidFill>
+          <a:ln/>
+        </p:spPr>
+      </p:sp>
+      <p:sp>
+        <p:nvSpPr>
+          <p:cNvPr id="8" name="Shape 6"/>
+          <p:cNvSpPr/>
+          <p:nvPr/>
+        </p:nvSpPr>
+        <p:spPr>
+          <a:xfrm>
+            <a:off x="8686800" y="329184"/>
+            <a:ext cx="54864" cy="54864"/>
+          </a:xfrm>
+          <a:prstGeom prst="rect">
+            <a:avLst/>
+          </a:prstGeom>
+          <a:solidFill>
+            <a:srgbClr val="7FB27A"/>
+          </a:solidFill>
+          <a:ln/>
+        </p:spPr>
+      </p:sp>
+      <p:sp>
+        <p:nvSpPr>
+          <p:cNvPr id="9" name="Shape 7"/>
+          <p:cNvSpPr/>
+          <p:nvPr/>
+        </p:nvSpPr>
+        <p:spPr>
+          <a:xfrm>
+            <a:off x="9372600" y="566928"/>
+            <a:ext cx="73152" cy="73152"/>
+          </a:xfrm>
+          <a:prstGeom prst="rect">
+            <a:avLst/>
+          </a:prstGeom>
+          <a:solidFill>
+            <a:srgbClr val="E3D5CC"/>
+          </a:solidFill>
+          <a:ln/>
+        </p:spPr>
+      </p:sp>
+      <p:sp>
+        <p:nvSpPr>
+          <p:cNvPr id="10" name="Shape 8"/>
+          <p:cNvSpPr/>
+          <p:nvPr/>
+        </p:nvSpPr>
+        <p:spPr>
+          <a:xfrm>
+            <a:off x="2194560" y="6473952"/>
+            <a:ext cx="64008" cy="64008"/>
+          </a:xfrm>
+          <a:prstGeom prst="rect">
+            <a:avLst/>
+          </a:prstGeom>
+          <a:solidFill>
+            <a:srgbClr val="C9A46E"/>
+          </a:solidFill>
+          <a:ln/>
+        </p:spPr>
+      </p:sp>
+      <p:sp>
+        <p:nvSpPr>
+          <p:cNvPr id="11" name="Shape 9"/>
+          <p:cNvSpPr/>
+          <p:nvPr/>
+        </p:nvSpPr>
+        <p:spPr>
+          <a:xfrm>
+            <a:off x="4480560" y="6547104"/>
+            <a:ext cx="45720" cy="45720"/>
+          </a:xfrm>
+          <a:prstGeom prst="rect">
+            <a:avLst/>
+          </a:prstGeom>
+          <a:solidFill>
+            <a:srgbClr val="D48A93"/>
+          </a:solidFill>
+          <a:ln/>
+        </p:spPr>
+      </p:sp>
+      <p:sp>
+        <p:nvSpPr>
+          <p:cNvPr id="12" name="Shape 10"/>
+          <p:cNvSpPr/>
+          <p:nvPr/>
+        </p:nvSpPr>
+        <p:spPr>
+          <a:xfrm>
+            <a:off x="7589520" y="6492240"/>
+            <a:ext cx="54864" cy="54864"/>
+          </a:xfrm>
+          <a:prstGeom prst="rect">
+            <a:avLst/>
+          </a:prstGeom>
+          <a:solidFill>
+            <a:srgbClr val="7FB27A"/>
+          </a:solidFill>
+          <a:ln/>
+        </p:spPr>
+      </p:sp>
+      <p:sp>
+        <p:nvSpPr>
+          <p:cNvPr id="13" name="Shape 11"/>
+          <p:cNvSpPr/>
+          <p:nvPr/>
+        </p:nvSpPr>
+        <p:spPr>
+          <a:xfrm>
+            <a:off x="9692640" y="6528816"/>
+            <a:ext cx="73152" cy="73152"/>
+          </a:xfrm>
+          <a:prstGeom prst="rect">
+            <a:avLst/>
+          </a:prstGeom>
+          <a:solidFill>
+            <a:srgbClr val="D48A93"/>
+          </a:solidFill>
+          <a:ln/>
+        </p:spPr>
+      </p:sp>
+      <p:pic>
+        <p:nvPicPr>
+          <p:cNvPr id="14" name="Image 0" descr="/tmp/claude-0/-home-claude/750ff410-f4aa-5276-9360-1e19d018b112/scratchpad/c/assets/ct-icon.png">    </p:cNvPr>
+          <p:cNvPicPr>
+            <a:picLocks noChangeAspect="1"/>
+          </p:cNvPicPr>
+          <p:nvPr/>
+        </p:nvPicPr>
+        <p:blipFill>
+          <a:blip r:embed="rId1"/>
+          <a:stretch>
+            <a:fillRect/>
+          </a:stretch>
+        </p:blipFill>
+        <p:spPr>
+          <a:xfrm>
+            <a:off x="457200" y="329184"/>
+            <a:ext cx="384048" cy="384048"/>
+          </a:xfrm>
+          <a:prstGeom prst="rect">
+            <a:avLst/>
+          </a:prstGeom>
+        </p:spPr>
+      </p:pic>
+      <p:sp>
+        <p:nvSpPr>
+          <p:cNvPr id="15" name="Text 12"/>
+          <p:cNvSpPr txBox="1"/>
+          <p:nvPr/>
+        </p:nvSpPr>
+        <p:spPr>
+          <a:xfrm>
+            <a:off x="932688" y="320040"/>
+            <a:ext cx="1828800" cy="402336"/>
+          </a:xfrm>
+          <a:prstGeom prst="rect">
+            <a:avLst/>
+          </a:prstGeom>
+          <a:noFill/>
+          <a:ln/>
+        </p:spPr>
+        <p:txBody>
+          <a:bodyPr wrap="square" lIns="0" tIns="0" rIns="0" bIns="0" rtlCol="0" anchor="ctr"/>
+          <a:lstStyle/>
+          <a:p>
+            <a:pPr algn="l" indent="0" marL="0">
+              <a:buNone/>
+            </a:pPr>
+            <a:r>
+              <a:rPr lang="en-US" sz="1800" b="1" dirty="0">
+                <a:solidFill>
+                  <a:srgbClr val="21141A"/>
+                </a:solidFill>
+                <a:latin typeface="IBM Plex Sans Arabic" pitchFamily="34" charset="0"/>
+                <a:ea typeface="IBM Plex Sans Arabic" pitchFamily="34" charset="-122"/>
+                <a:cs typeface="IBM Plex Sans Arabic" pitchFamily="34" charset="-120"/>
+              </a:rPr>
+              <a:t>CloudTrim</a:t>
+            </a:r>
+            <a:endParaRPr lang="en-US" sz="1800" dirty="0"/>
+          </a:p>
+        </p:txBody>
+      </p:sp>
+      <p:pic>
+        <p:nvPicPr>
+          <p:cNvPr id="16" name="Image 1" descr="/tmp/claude-0/-home-claude/750ff410-f4aa-5276-9360-1e19d018b112/scratchpad/c/assets/venturex-ink.png">    </p:cNvPr>
+          <p:cNvPicPr>
+            <a:picLocks noChangeAspect="1"/>
+          </p:cNvPicPr>
+          <p:nvPr/>
+        </p:nvPicPr>
+        <p:blipFill>
+          <a:blip r:embed="rId2"/>
+          <a:stretch>
+            <a:fillRect/>
+          </a:stretch>
+        </p:blipFill>
+        <p:spPr>
+          <a:xfrm>
+            <a:off x="10490566" y="256032"/>
+            <a:ext cx="1243929" cy="548640"/>
+          </a:xfrm>
+          <a:prstGeom prst="rect">
+            <a:avLst/>
+          </a:prstGeom>
+        </p:spPr>
+      </p:pic>
+      <p:sp>
+        <p:nvSpPr>
+          <p:cNvPr id="17" name="Shape 13"/>
+          <p:cNvSpPr/>
+          <p:nvPr/>
+        </p:nvSpPr>
+        <p:spPr>
+          <a:xfrm>
+            <a:off x="10600639" y="987552"/>
+            <a:ext cx="1133856" cy="384048"/>
+          </a:xfrm>
+          <a:prstGeom prst="roundRect">
+            <a:avLst>
+              <a:gd name="adj" fmla="val 50000"/>
+            </a:avLst>
+          </a:prstGeom>
+          <a:solidFill>
+            <a:srgbClr val="8E2F3C"/>
+          </a:solidFill>
+          <a:ln/>
+        </p:spPr>
+      </p:sp>
+      <p:sp>
+        <p:nvSpPr>
+          <p:cNvPr id="18" name="Text 14"/>
+          <p:cNvSpPr txBox="1"/>
+          <p:nvPr/>
+        </p:nvSpPr>
+        <p:spPr>
+          <a:xfrm>
+            <a:off x="10600639" y="987552"/>
+            <a:ext cx="1133856" cy="384048"/>
+          </a:xfrm>
+          <a:prstGeom prst="rect">
+            <a:avLst/>
+          </a:prstGeom>
+          <a:noFill/>
+          <a:ln/>
+        </p:spPr>
+        <p:txBody>
+          <a:bodyPr wrap="square" lIns="0" tIns="0" rIns="0" bIns="0" rtlCol="0" anchor="ctr"/>
+          <a:lstStyle/>
+          <a:p>
+            <a:pPr rtl="1" algn="ctr" indent="0" marL="0">
+              <a:buNone/>
+            </a:pPr>
+            <a:r>
+              <a:rPr lang="en-US" sz="1300" b="1" dirty="0">
+                <a:solidFill>
+                  <a:srgbClr val="FBF6EE"/>
+                </a:solidFill>
+                <a:latin typeface="IBM Plex Sans Arabic" pitchFamily="34" charset="0"/>
+                <a:ea typeface="IBM Plex Sans Arabic" pitchFamily="34" charset="-122"/>
+                <a:cs typeface="IBM Plex Sans Arabic" pitchFamily="34" charset="-120"/>
+              </a:rPr>
+              <a:t>الختام</a:t>
+            </a:r>
+            <a:endParaRPr lang="en-US" sz="1300" dirty="0"/>
+          </a:p>
+        </p:txBody>
+      </p:sp>
+      <p:pic>
+        <p:nvPicPr>
+          <p:cNvPr id="19" name="Image 2" descr="/tmp/claude-0/-home-claude/750ff410-f4aa-5276-9360-1e19d018b112/scratchpad/c/assets/organizers-ink.png">    </p:cNvPr>
+          <p:cNvPicPr>
+            <a:picLocks noChangeAspect="1"/>
+          </p:cNvPicPr>
+          <p:nvPr/>
+        </p:nvPicPr>
+        <p:blipFill>
+          <a:blip r:embed="rId3"/>
+          <a:stretch>
+            <a:fillRect/>
+          </a:stretch>
+        </p:blipFill>
+        <p:spPr>
+          <a:xfrm>
+            <a:off x="457200" y="6309360"/>
+            <a:ext cx="848839" cy="365760"/>
+          </a:xfrm>
+          <a:prstGeom prst="rect">
+            <a:avLst/>
+          </a:prstGeom>
+        </p:spPr>
+      </p:pic>
+      <p:sp>
+        <p:nvSpPr>
+          <p:cNvPr id="20" name="Text 15"/>
+          <p:cNvSpPr txBox="1"/>
+          <p:nvPr/>
+        </p:nvSpPr>
+        <p:spPr>
+          <a:xfrm>
+            <a:off x="4270248" y="6382512"/>
+            <a:ext cx="3657600" cy="274320"/>
+          </a:xfrm>
+          <a:prstGeom prst="rect">
+            <a:avLst/>
+          </a:prstGeom>
+          <a:noFill/>
+          <a:ln/>
+        </p:spPr>
+        <p:txBody>
+          <a:bodyPr wrap="square" lIns="0" tIns="0" rIns="0" bIns="0" rtlCol="0" anchor="t"/>
+          <a:lstStyle/>
+          <a:p>
+            <a:pPr rtl="1" algn="ctr" indent="0" marL="0">
+              <a:buNone/>
+            </a:pPr>
+            <a:r>
+              <a:rPr lang="en-US" sz="1000" dirty="0">
+                <a:solidFill>
+                  <a:srgbClr val="7F6C72"/>
+                </a:solidFill>
+                <a:latin typeface="IBM Plex Sans Arabic" pitchFamily="34" charset="0"/>
+                <a:ea typeface="IBM Plex Sans Arabic" pitchFamily="34" charset="-122"/>
+                <a:cs typeface="IBM Plex Sans Arabic" pitchFamily="34" charset="-120"/>
+              </a:rPr>
+              <a:t>VentureX 2026 · فريق SSB</a:t>
+            </a:r>
+            <a:endParaRPr lang="en-US" sz="1000" dirty="0"/>
+          </a:p>
+        </p:txBody>
+      </p:sp>
+      <p:sp>
+        <p:nvSpPr>
+          <p:cNvPr id="21" name="Text 16"/>
+          <p:cNvSpPr txBox="1"/>
+          <p:nvPr/>
+        </p:nvSpPr>
+        <p:spPr>
+          <a:xfrm>
+            <a:off x="11185855" y="6382512"/>
+            <a:ext cx="548640" cy="274320"/>
+          </a:xfrm>
+          <a:prstGeom prst="rect">
+            <a:avLst/>
+          </a:prstGeom>
+          <a:noFill/>
+          <a:ln/>
+        </p:spPr>
+        <p:txBody>
+          <a:bodyPr wrap="square" lIns="0" tIns="0" rIns="0" bIns="0" rtlCol="0" anchor="t"/>
+          <a:lstStyle/>
+          <a:p>
+            <a:pPr algn="r" indent="0" marL="0">
+              <a:buNone/>
+            </a:pPr>
+            <a:r>
+              <a:rPr lang="en-US" sz="1100" b="1" dirty="0">
+                <a:solidFill>
+                  <a:srgbClr val="7F6C72"/>
+                </a:solidFill>
+                <a:latin typeface="IBM Plex Sans Arabic" pitchFamily="34" charset="0"/>
+                <a:ea typeface="IBM Plex Sans Arabic" pitchFamily="34" charset="-122"/>
+                <a:cs typeface="IBM Plex Sans Arabic" pitchFamily="34" charset="-120"/>
+              </a:rPr>
+              <a:t>12</a:t>
             </a:r>
             <a:endParaRPr lang="en-US" sz="1100" dirty="0"/>
           </a:p>
@@ -11558,8 +12629,8 @@
         </p:nvSpPr>
         <p:spPr>
           <a:xfrm>
-            <a:off x="9759391" y="987552"/>
-            <a:ext cx="1975104" cy="384048"/>
+            <a:off x="10074859" y="987552"/>
+            <a:ext cx="1659636" cy="384048"/>
           </a:xfrm>
           <a:prstGeom prst="roundRect">
             <a:avLst>
@@ -11580,8 +12651,8 @@
         </p:nvSpPr>
         <p:spPr>
           <a:xfrm>
-            <a:off x="9759391" y="987552"/>
-            <a:ext cx="1975104" cy="384048"/>
+            <a:off x="10074859" y="987552"/>
+            <a:ext cx="1659636" cy="384048"/>
           </a:xfrm>
           <a:prstGeom prst="rect">
             <a:avLst/>
@@ -11605,7 +12676,7 @@
                 <a:ea typeface="IBM Plex Sans Arabic" pitchFamily="34" charset="-122"/>
                 <a:cs typeface="IBM Plex Sans Arabic" pitchFamily="34" charset="-120"/>
               </a:rPr>
-              <a:t>قابلية التنفيذ</a:t>
+              <a:t>نموذج العمل</a:t>
             </a:r>
             <a:endParaRPr lang="en-US" sz="1300" dirty="0"/>
           </a:p>
@@ -11721,8 +12792,8 @@
         </p:nvSpPr>
         <p:spPr>
           <a:xfrm>
-            <a:off x="6172200" y="1691640"/>
-            <a:ext cx="5562295" cy="502920"/>
+            <a:off x="457200" y="1600200"/>
+            <a:ext cx="11277295" cy="731520"/>
           </a:xfrm>
           <a:prstGeom prst="rect">
             <a:avLst/>
@@ -11738,17 +12809,17 @@
               <a:buNone/>
             </a:pPr>
             <a:r>
-              <a:rPr lang="en-US" sz="2100" b="1" dirty="0">
-                <a:solidFill>
-                  <a:srgbClr val="8E2F3C"/>
-                </a:solidFill>
-                <a:latin typeface="IBM Plex Sans Arabic" pitchFamily="34" charset="0"/>
-                <a:ea typeface="IBM Plex Sans Arabic" pitchFamily="34" charset="-122"/>
-                <a:cs typeface="IBM Plex Sans Arabic" pitchFamily="34" charset="-120"/>
-              </a:rPr>
-              <a:t>كيف يمكن تنفيذ الحل في الوقت الحالي؟</a:t>
-            </a:r>
-            <a:endParaRPr lang="en-US" sz="2100" dirty="0"/>
+              <a:rPr lang="en-US" sz="3400" b="1" dirty="0">
+                <a:solidFill>
+                  <a:srgbClr val="21141A"/>
+                </a:solidFill>
+                <a:latin typeface="IBM Plex Sans Arabic" pitchFamily="34" charset="0"/>
+                <a:ea typeface="IBM Plex Sans Arabic" pitchFamily="34" charset="-122"/>
+                <a:cs typeface="IBM Plex Sans Arabic" pitchFamily="34" charset="-120"/>
+              </a:rPr>
+              <a:t>ابدأ مجاناً، ثم ادفع لكل مورد</a:t>
+            </a:r>
+            <a:endParaRPr lang="en-US" sz="3400" dirty="0"/>
           </a:p>
         </p:txBody>
       </p:sp>
@@ -11760,12 +12831,12 @@
         </p:nvSpPr>
         <p:spPr>
           <a:xfrm>
-            <a:off x="6172200" y="2423160"/>
-            <a:ext cx="5562295" cy="1005840"/>
+            <a:off x="8188757" y="2606040"/>
+            <a:ext cx="3545738" cy="2606040"/>
           </a:xfrm>
           <a:prstGeom prst="roundRect">
             <a:avLst>
-              <a:gd name="adj" fmla="val 14545"/>
+              <a:gd name="adj" fmla="val 7018"/>
             </a:avLst>
           </a:prstGeom>
           <a:solidFill>
@@ -11779,31 +12850,9 @@
           </a:ln>
         </p:spPr>
       </p:sp>
-      <p:sp>
-        <p:nvSpPr>
-          <p:cNvPr id="24" name="Shape 19"/>
-          <p:cNvSpPr/>
-          <p:nvPr/>
-        </p:nvSpPr>
-        <p:spPr>
-          <a:xfrm>
-            <a:off x="10865815" y="2606040"/>
-            <a:ext cx="640080" cy="640080"/>
-          </a:xfrm>
-          <a:prstGeom prst="roundRect">
-            <a:avLst>
-              <a:gd name="adj" fmla="val 20000"/>
-            </a:avLst>
-          </a:prstGeom>
-          <a:solidFill>
-            <a:srgbClr val="F1E4DF"/>
-          </a:solidFill>
-          <a:ln/>
-        </p:spPr>
-      </p:sp>
       <p:pic>
         <p:nvPicPr>
-          <p:cNvPr id="25" name="Image 3" descr="/tmp/claude-0/-home-claude/750ff410-f4aa-5276-9360-1e19d018b112/scratchpad/c/assets/i-plug-br.png">    </p:cNvPr>
+          <p:cNvPr id="24" name="Image 3" descr="/tmp/claude-0/-home-claude/750ff410-f4aa-5276-9360-1e19d018b112/scratchpad/c/assets/i-gift-br.png">    </p:cNvPr>
           <p:cNvPicPr>
             <a:picLocks noChangeAspect="1"/>
           </p:cNvPicPr>
@@ -11817,8 +12866,8 @@
         </p:blipFill>
         <p:spPr>
           <a:xfrm>
-            <a:off x="10957255" y="2697480"/>
-            <a:ext cx="457200" cy="457200"/>
+            <a:off x="9687306" y="2880360"/>
+            <a:ext cx="548640" cy="548640"/>
           </a:xfrm>
           <a:prstGeom prst="rect">
             <a:avLst/>
@@ -11827,14 +12876,53 @@
       </p:pic>
       <p:sp>
         <p:nvSpPr>
+          <p:cNvPr id="25" name="Text 19"/>
+          <p:cNvSpPr txBox="1"/>
+          <p:nvPr/>
+        </p:nvSpPr>
+        <p:spPr>
+          <a:xfrm>
+            <a:off x="8188757" y="3520440"/>
+            <a:ext cx="3545738" cy="365760"/>
+          </a:xfrm>
+          <a:prstGeom prst="rect">
+            <a:avLst/>
+          </a:prstGeom>
+          <a:noFill/>
+          <a:ln/>
+        </p:spPr>
+        <p:txBody>
+          <a:bodyPr wrap="square" lIns="0" tIns="0" rIns="0" bIns="0" rtlCol="0" anchor="ctr"/>
+          <a:lstStyle/>
+          <a:p>
+            <a:pPr rtl="1" algn="ctr" indent="0" marL="0">
+              <a:buNone/>
+            </a:pPr>
+            <a:r>
+              <a:rPr lang="en-US" sz="1700" b="1" dirty="0">
+                <a:solidFill>
+                  <a:srgbClr val="7F6C72"/>
+                </a:solidFill>
+                <a:latin typeface="IBM Plex Sans Arabic" pitchFamily="34" charset="0"/>
+                <a:ea typeface="IBM Plex Sans Arabic" pitchFamily="34" charset="-122"/>
+                <a:cs typeface="IBM Plex Sans Arabic" pitchFamily="34" charset="-120"/>
+              </a:rPr>
+              <a:t>الفحص الأول</a:t>
+            </a:r>
+            <a:endParaRPr lang="en-US" sz="1700" dirty="0"/>
+          </a:p>
+        </p:txBody>
+      </p:sp>
+      <p:sp>
+        <p:nvSpPr>
           <p:cNvPr id="26" name="Text 20"/>
           <p:cNvSpPr txBox="1"/>
           <p:nvPr/>
         </p:nvSpPr>
         <p:spPr>
           <a:xfrm>
-            <a:off x="6446520" y="2423160"/>
-            <a:ext cx="4236415" cy="1005840"/>
+            <a:off x="8188757" y="3886200"/>
+            <a:ext cx="3545738" cy="777240"/>
           </a:xfrm>
           <a:prstGeom prst="rect">
             <a:avLst/>
@@ -11846,10 +12934,46 @@
           <a:bodyPr wrap="square" lIns="0" tIns="0" rIns="0" bIns="0" rtlCol="0" anchor="ctr"/>
           <a:lstStyle/>
           <a:p>
-            <a:pPr rtl="1" algn="r" indent="0" marL="0">
-              <a:lnSpc>
-                <a:spcPct val="110000"/>
-              </a:lnSpc>
+            <a:pPr rtl="1" algn="ctr" indent="0" marL="0">
+              <a:buNone/>
+            </a:pPr>
+            <a:r>
+              <a:rPr lang="en-US" sz="4000" b="1" dirty="0">
+                <a:solidFill>
+                  <a:srgbClr val="8E2F3C"/>
+                </a:solidFill>
+                <a:latin typeface="IBM Plex Sans Arabic" pitchFamily="34" charset="0"/>
+                <a:ea typeface="IBM Plex Sans Arabic" pitchFamily="34" charset="-122"/>
+                <a:cs typeface="IBM Plex Sans Arabic" pitchFamily="34" charset="-120"/>
+              </a:rPr>
+              <a:t>مجاني</a:t>
+            </a:r>
+            <a:endParaRPr lang="en-US" sz="4000" dirty="0"/>
+          </a:p>
+        </p:txBody>
+      </p:sp>
+      <p:sp>
+        <p:nvSpPr>
+          <p:cNvPr id="27" name="Text 21"/>
+          <p:cNvSpPr txBox="1"/>
+          <p:nvPr/>
+        </p:nvSpPr>
+        <p:spPr>
+          <a:xfrm>
+            <a:off x="8188757" y="4663440"/>
+            <a:ext cx="3545738" cy="365760"/>
+          </a:xfrm>
+          <a:prstGeom prst="rect">
+            <a:avLst/>
+          </a:prstGeom>
+          <a:noFill/>
+          <a:ln/>
+        </p:spPr>
+        <p:txBody>
+          <a:bodyPr wrap="square" lIns="0" tIns="0" rIns="0" bIns="0" rtlCol="0" anchor="ctr"/>
+          <a:lstStyle/>
+          <a:p>
+            <a:pPr rtl="1" algn="ctr" indent="0" marL="0">
               <a:buNone/>
             </a:pPr>
             <a:r>
@@ -11861,7 +12985,7 @@
                 <a:ea typeface="IBM Plex Sans Arabic" pitchFamily="34" charset="-122"/>
                 <a:cs typeface="IBM Plex Sans Arabic" pitchFamily="34" charset="-120"/>
               </a:rPr>
-              <a:t>ربط المنصة بحساب الشركة السحابي عبر API</a:t>
+              <a:t>تقرير الهدر كاملاً</a:t>
             </a:r>
             <a:endParaRPr lang="en-US" sz="1600" dirty="0"/>
           </a:p>
@@ -11869,56 +12993,29 @@
       </p:sp>
       <p:sp>
         <p:nvSpPr>
-          <p:cNvPr id="27" name="Shape 21"/>
-          <p:cNvSpPr/>
-          <p:nvPr/>
-        </p:nvSpPr>
-        <p:spPr>
-          <a:xfrm>
-            <a:off x="6172200" y="3611880"/>
-            <a:ext cx="5562295" cy="1005840"/>
+          <p:cNvPr id="28" name="Shape 22"/>
+          <p:cNvSpPr/>
+          <p:nvPr/>
+        </p:nvSpPr>
+        <p:spPr>
+          <a:xfrm>
+            <a:off x="4322978" y="2606040"/>
+            <a:ext cx="3545738" cy="2606040"/>
           </a:xfrm>
           <a:prstGeom prst="roundRect">
             <a:avLst>
-              <a:gd name="adj" fmla="val 14545"/>
+              <a:gd name="adj" fmla="val 7018"/>
             </a:avLst>
           </a:prstGeom>
           <a:solidFill>
-            <a:srgbClr val="FFFBF8"/>
-          </a:solidFill>
-          <a:ln w="9525">
-            <a:solidFill>
-              <a:srgbClr val="E3D5CC"/>
-            </a:solidFill>
-            <a:prstDash val="solid"/>
-          </a:ln>
-        </p:spPr>
-      </p:sp>
-      <p:sp>
-        <p:nvSpPr>
-          <p:cNvPr id="28" name="Shape 22"/>
-          <p:cNvSpPr/>
-          <p:nvPr/>
-        </p:nvSpPr>
-        <p:spPr>
-          <a:xfrm>
-            <a:off x="10865815" y="3794760"/>
-            <a:ext cx="640080" cy="640080"/>
-          </a:xfrm>
-          <a:prstGeom prst="roundRect">
-            <a:avLst>
-              <a:gd name="adj" fmla="val 20000"/>
-            </a:avLst>
-          </a:prstGeom>
-          <a:solidFill>
-            <a:srgbClr val="F1E4DF"/>
+            <a:srgbClr val="8E2F3C"/>
           </a:solidFill>
           <a:ln/>
         </p:spPr>
       </p:sp>
       <p:pic>
         <p:nvPicPr>
-          <p:cNvPr id="29" name="Image 4" descr="/tmp/claude-0/-home-claude/750ff410-f4aa-5276-9360-1e19d018b112/scratchpad/c/assets/i-bot-br.png">    </p:cNvPr>
+          <p:cNvPr id="29" name="Image 4" descr="/tmp/claude-0/-home-claude/750ff410-f4aa-5276-9360-1e19d018b112/scratchpad/c/assets/i-gauge-cr.png">    </p:cNvPr>
           <p:cNvPicPr>
             <a:picLocks noChangeAspect="1"/>
           </p:cNvPicPr>
@@ -11932,8 +13029,8 @@
         </p:blipFill>
         <p:spPr>
           <a:xfrm>
-            <a:off x="10957255" y="3886200"/>
-            <a:ext cx="457200" cy="457200"/>
+            <a:off x="5821528" y="2880360"/>
+            <a:ext cx="548640" cy="548640"/>
           </a:xfrm>
           <a:prstGeom prst="rect">
             <a:avLst/>
@@ -11948,8 +13045,8 @@
         </p:nvSpPr>
         <p:spPr>
           <a:xfrm>
-            <a:off x="6446520" y="3611880"/>
-            <a:ext cx="4236415" cy="1005840"/>
+            <a:off x="4322978" y="3520440"/>
+            <a:ext cx="3545738" cy="365760"/>
           </a:xfrm>
           <a:prstGeom prst="rect">
             <a:avLst/>
@@ -11961,22 +13058,97 @@
           <a:bodyPr wrap="square" lIns="0" tIns="0" rIns="0" bIns="0" rtlCol="0" anchor="ctr"/>
           <a:lstStyle/>
           <a:p>
-            <a:pPr rtl="1" algn="r" indent="0" marL="0">
-              <a:lnSpc>
-                <a:spcPct val="110000"/>
-              </a:lnSpc>
+            <a:pPr rtl="1" algn="ctr" indent="0" marL="0">
+              <a:buNone/>
+            </a:pPr>
+            <a:r>
+              <a:rPr lang="en-US" sz="1700" b="1" dirty="0">
+                <a:solidFill>
+                  <a:srgbClr val="F1E4DF"/>
+                </a:solidFill>
+                <a:latin typeface="IBM Plex Sans Arabic" pitchFamily="34" charset="0"/>
+                <a:ea typeface="IBM Plex Sans Arabic" pitchFamily="34" charset="-122"/>
+                <a:cs typeface="IBM Plex Sans Arabic" pitchFamily="34" charset="-120"/>
+              </a:rPr>
+              <a:t>حسب الاستخدام</a:t>
+            </a:r>
+            <a:endParaRPr lang="en-US" sz="1700" dirty="0"/>
+          </a:p>
+        </p:txBody>
+      </p:sp>
+      <p:sp>
+        <p:nvSpPr>
+          <p:cNvPr id="31" name="Text 24"/>
+          <p:cNvSpPr txBox="1"/>
+          <p:nvPr/>
+        </p:nvSpPr>
+        <p:spPr>
+          <a:xfrm>
+            <a:off x="4322978" y="3886200"/>
+            <a:ext cx="3545738" cy="777240"/>
+          </a:xfrm>
+          <a:prstGeom prst="rect">
+            <a:avLst/>
+          </a:prstGeom>
+          <a:noFill/>
+          <a:ln/>
+        </p:spPr>
+        <p:txBody>
+          <a:bodyPr wrap="square" lIns="0" tIns="0" rIns="0" bIns="0" rtlCol="0" anchor="ctr"/>
+          <a:lstStyle/>
+          <a:p>
+            <a:pPr rtl="1" algn="ctr" indent="0" marL="0">
+              <a:buNone/>
+            </a:pPr>
+            <a:r>
+              <a:rPr lang="en-US" sz="4000" b="1" dirty="0">
+                <a:solidFill>
+                  <a:srgbClr val="FBF6EE"/>
+                </a:solidFill>
+                <a:latin typeface="IBM Plex Sans Arabic" pitchFamily="34" charset="0"/>
+                <a:ea typeface="IBM Plex Sans Arabic" pitchFamily="34" charset="-122"/>
+                <a:cs typeface="IBM Plex Sans Arabic" pitchFamily="34" charset="-120"/>
+              </a:rPr>
+              <a:t>من 15 ريال</a:t>
+            </a:r>
+            <a:endParaRPr lang="en-US" sz="4000" dirty="0"/>
+          </a:p>
+        </p:txBody>
+      </p:sp>
+      <p:sp>
+        <p:nvSpPr>
+          <p:cNvPr id="32" name="Text 25"/>
+          <p:cNvSpPr txBox="1"/>
+          <p:nvPr/>
+        </p:nvSpPr>
+        <p:spPr>
+          <a:xfrm>
+            <a:off x="4322978" y="4663440"/>
+            <a:ext cx="3545738" cy="365760"/>
+          </a:xfrm>
+          <a:prstGeom prst="rect">
+            <a:avLst/>
+          </a:prstGeom>
+          <a:noFill/>
+          <a:ln/>
+        </p:spPr>
+        <p:txBody>
+          <a:bodyPr wrap="square" lIns="0" tIns="0" rIns="0" bIns="0" rtlCol="0" anchor="ctr"/>
+          <a:lstStyle/>
+          <a:p>
+            <a:pPr rtl="1" algn="ctr" indent="0" marL="0">
               <a:buNone/>
             </a:pPr>
             <a:r>
               <a:rPr lang="en-US" sz="1600" dirty="0">
                 <a:solidFill>
-                  <a:srgbClr val="21141A"/>
-                </a:solidFill>
-                <a:latin typeface="IBM Plex Sans Arabic" pitchFamily="34" charset="0"/>
-                <a:ea typeface="IBM Plex Sans Arabic" pitchFamily="34" charset="-122"/>
-                <a:cs typeface="IBM Plex Sans Arabic" pitchFamily="34" charset="-120"/>
-              </a:rPr>
-              <a:t>نموذج ذكاء اصطناعي يمسح البنية فوراً ويطابقها مع أفضل الممارسات ويحلل الأحمال</a:t>
+                  <a:srgbClr val="FBF6EE"/>
+                </a:solidFill>
+                <a:latin typeface="IBM Plex Sans Arabic" pitchFamily="34" charset="0"/>
+                <a:ea typeface="IBM Plex Sans Arabic" pitchFamily="34" charset="-122"/>
+                <a:cs typeface="IBM Plex Sans Arabic" pitchFamily="34" charset="-120"/>
+              </a:rPr>
+              <a:t>لكل مورد شهرياً</a:t>
             </a:r>
             <a:endParaRPr lang="en-US" sz="1600" dirty="0"/>
           </a:p>
@@ -11984,18 +13156,18 @@
       </p:sp>
       <p:sp>
         <p:nvSpPr>
-          <p:cNvPr id="31" name="Shape 24"/>
-          <p:cNvSpPr/>
-          <p:nvPr/>
-        </p:nvSpPr>
-        <p:spPr>
-          <a:xfrm>
-            <a:off x="6172200" y="4800600"/>
-            <a:ext cx="5562295" cy="1005840"/>
+          <p:cNvPr id="33" name="Shape 26"/>
+          <p:cNvSpPr/>
+          <p:nvPr/>
+        </p:nvSpPr>
+        <p:spPr>
+          <a:xfrm>
+            <a:off x="457200" y="2606040"/>
+            <a:ext cx="3545738" cy="2606040"/>
           </a:xfrm>
           <a:prstGeom prst="roundRect">
             <a:avLst>
-              <a:gd name="adj" fmla="val 14545"/>
+              <a:gd name="adj" fmla="val 7018"/>
             </a:avLst>
           </a:prstGeom>
           <a:solidFill>
@@ -12009,31 +13181,9 @@
           </a:ln>
         </p:spPr>
       </p:sp>
-      <p:sp>
-        <p:nvSpPr>
-          <p:cNvPr id="32" name="Shape 25"/>
-          <p:cNvSpPr/>
-          <p:nvPr/>
-        </p:nvSpPr>
-        <p:spPr>
-          <a:xfrm>
-            <a:off x="10865815" y="4983480"/>
-            <a:ext cx="640080" cy="640080"/>
-          </a:xfrm>
-          <a:prstGeom prst="roundRect">
-            <a:avLst>
-              <a:gd name="adj" fmla="val 20000"/>
-            </a:avLst>
-          </a:prstGeom>
-          <a:solidFill>
-            <a:srgbClr val="F1E4DF"/>
-          </a:solidFill>
-          <a:ln/>
-        </p:spPr>
-      </p:sp>
       <p:pic>
         <p:nvPicPr>
-          <p:cNvPr id="33" name="Image 5" descr="/tmp/claude-0/-home-claude/750ff410-f4aa-5276-9360-1e19d018b112/scratchpad/c/assets/i-check-br.png">    </p:cNvPr>
+          <p:cNvPr id="34" name="Image 5" descr="/tmp/claude-0/-home-claude/750ff410-f4aa-5276-9360-1e19d018b112/scratchpad/c/assets/i-handshake-br.png">    </p:cNvPr>
           <p:cNvPicPr>
             <a:picLocks noChangeAspect="1"/>
           </p:cNvPicPr>
@@ -12047,8 +13197,8 @@
         </p:blipFill>
         <p:spPr>
           <a:xfrm>
-            <a:off x="10957255" y="5074920"/>
-            <a:ext cx="457200" cy="457200"/>
+            <a:off x="1955749" y="2880360"/>
+            <a:ext cx="548640" cy="548640"/>
           </a:xfrm>
           <a:prstGeom prst="rect">
             <a:avLst/>
@@ -12057,14 +13207,14 @@
       </p:pic>
       <p:sp>
         <p:nvSpPr>
-          <p:cNvPr id="34" name="Text 26"/>
-          <p:cNvSpPr txBox="1"/>
-          <p:nvPr/>
-        </p:nvSpPr>
-        <p:spPr>
-          <a:xfrm>
-            <a:off x="6446520" y="4800600"/>
-            <a:ext cx="4236415" cy="1005840"/>
+          <p:cNvPr id="35" name="Text 27"/>
+          <p:cNvSpPr txBox="1"/>
+          <p:nvPr/>
+        </p:nvSpPr>
+        <p:spPr>
+          <a:xfrm>
+            <a:off x="457200" y="3520440"/>
+            <a:ext cx="3545738" cy="365760"/>
           </a:xfrm>
           <a:prstGeom prst="rect">
             <a:avLst/>
@@ -12076,10 +13226,85 @@
           <a:bodyPr wrap="square" lIns="0" tIns="0" rIns="0" bIns="0" rtlCol="0" anchor="ctr"/>
           <a:lstStyle/>
           <a:p>
-            <a:pPr rtl="1" algn="r" indent="0" marL="0">
-              <a:lnSpc>
-                <a:spcPct val="110000"/>
-              </a:lnSpc>
+            <a:pPr rtl="1" algn="ctr" indent="0" marL="0">
+              <a:buNone/>
+            </a:pPr>
+            <a:r>
+              <a:rPr lang="en-US" sz="1700" b="1" dirty="0">
+                <a:solidFill>
+                  <a:srgbClr val="7F6C72"/>
+                </a:solidFill>
+                <a:latin typeface="IBM Plex Sans Arabic" pitchFamily="34" charset="0"/>
+                <a:ea typeface="IBM Plex Sans Arabic" pitchFamily="34" charset="-122"/>
+                <a:cs typeface="IBM Plex Sans Arabic" pitchFamily="34" charset="-120"/>
+              </a:rPr>
+              <a:t>استشارات FinOps</a:t>
+            </a:r>
+            <a:endParaRPr lang="en-US" sz="1700" dirty="0"/>
+          </a:p>
+        </p:txBody>
+      </p:sp>
+      <p:sp>
+        <p:nvSpPr>
+          <p:cNvPr id="36" name="Text 28"/>
+          <p:cNvSpPr txBox="1"/>
+          <p:nvPr/>
+        </p:nvSpPr>
+        <p:spPr>
+          <a:xfrm>
+            <a:off x="457200" y="3886200"/>
+            <a:ext cx="3545738" cy="777240"/>
+          </a:xfrm>
+          <a:prstGeom prst="rect">
+            <a:avLst/>
+          </a:prstGeom>
+          <a:noFill/>
+          <a:ln/>
+        </p:spPr>
+        <p:txBody>
+          <a:bodyPr wrap="square" lIns="0" tIns="0" rIns="0" bIns="0" rtlCol="0" anchor="ctr"/>
+          <a:lstStyle/>
+          <a:p>
+            <a:pPr rtl="1" algn="ctr" indent="0" marL="0">
+              <a:buNone/>
+            </a:pPr>
+            <a:r>
+              <a:rPr lang="en-US" sz="4000" b="1" dirty="0">
+                <a:solidFill>
+                  <a:srgbClr val="8E2F3C"/>
+                </a:solidFill>
+                <a:latin typeface="IBM Plex Sans Arabic" pitchFamily="34" charset="0"/>
+                <a:ea typeface="IBM Plex Sans Arabic" pitchFamily="34" charset="-122"/>
+                <a:cs typeface="IBM Plex Sans Arabic" pitchFamily="34" charset="-120"/>
+              </a:rPr>
+              <a:t>حسب المشروع</a:t>
+            </a:r>
+            <a:endParaRPr lang="en-US" sz="4000" dirty="0"/>
+          </a:p>
+        </p:txBody>
+      </p:sp>
+      <p:sp>
+        <p:nvSpPr>
+          <p:cNvPr id="37" name="Text 29"/>
+          <p:cNvSpPr txBox="1"/>
+          <p:nvPr/>
+        </p:nvSpPr>
+        <p:spPr>
+          <a:xfrm>
+            <a:off x="457200" y="4663440"/>
+            <a:ext cx="3545738" cy="365760"/>
+          </a:xfrm>
+          <a:prstGeom prst="rect">
+            <a:avLst/>
+          </a:prstGeom>
+          <a:noFill/>
+          <a:ln/>
+        </p:spPr>
+        <p:txBody>
+          <a:bodyPr wrap="square" lIns="0" tIns="0" rIns="0" bIns="0" rtlCol="0" anchor="ctr"/>
+          <a:lstStyle/>
+          <a:p>
+            <a:pPr rtl="1" algn="ctr" indent="0" marL="0">
               <a:buNone/>
             </a:pPr>
             <a:r>
@@ -12091,7 +13316,7 @@
                 <a:ea typeface="IBM Plex Sans Arabic" pitchFamily="34" charset="-122"/>
                 <a:cs typeface="IBM Plex Sans Arabic" pitchFamily="34" charset="-120"/>
               </a:rPr>
-              <a:t>زر تفاعلي بضغطة واحدة لإيقاف المورد أو تقليصه عبر API</a:t>
+              <a:t>مهندس FinOps مخصص</a:t>
             </a:r>
             <a:endParaRPr lang="en-US" sz="1600" dirty="0"/>
           </a:p>
@@ -12099,36 +13324,14 @@
       </p:sp>
       <p:sp>
         <p:nvSpPr>
-          <p:cNvPr id="35" name="Shape 27"/>
-          <p:cNvSpPr/>
-          <p:nvPr/>
-        </p:nvSpPr>
-        <p:spPr>
-          <a:xfrm>
-            <a:off x="457200" y="1691640"/>
-            <a:ext cx="5257800" cy="4114800"/>
-          </a:xfrm>
-          <a:prstGeom prst="roundRect">
-            <a:avLst>
-              <a:gd name="adj" fmla="val 4444"/>
-            </a:avLst>
-          </a:prstGeom>
-          <a:solidFill>
-            <a:srgbClr val="8E2F3C"/>
-          </a:solidFill>
-          <a:ln/>
-        </p:spPr>
-      </p:sp>
-      <p:sp>
-        <p:nvSpPr>
-          <p:cNvPr id="36" name="Text 28"/>
-          <p:cNvSpPr txBox="1"/>
-          <p:nvPr/>
-        </p:nvSpPr>
-        <p:spPr>
-          <a:xfrm>
-            <a:off x="777240" y="1920240"/>
-            <a:ext cx="4617720" cy="502920"/>
+          <p:cNvPr id="38" name="Text 30"/>
+          <p:cNvSpPr txBox="1"/>
+          <p:nvPr/>
+        </p:nvSpPr>
+        <p:spPr>
+          <a:xfrm>
+            <a:off x="457200" y="5486400"/>
+            <a:ext cx="11277295" cy="411480"/>
           </a:xfrm>
           <a:prstGeom prst="rect">
             <a:avLst/>
@@ -12140,274 +13343,19 @@
           <a:bodyPr wrap="square" lIns="0" tIns="0" rIns="0" bIns="0" rtlCol="0" anchor="ctr"/>
           <a:lstStyle/>
           <a:p>
-            <a:pPr rtl="1" algn="r" indent="0" marL="0">
-              <a:buNone/>
-            </a:pPr>
-            <a:r>
-              <a:rPr lang="en-US" sz="2100" b="1" dirty="0">
-                <a:solidFill>
-                  <a:srgbClr val="FBF6EE"/>
-                </a:solidFill>
-                <a:latin typeface="IBM Plex Sans Arabic" pitchFamily="34" charset="0"/>
-                <a:ea typeface="IBM Plex Sans Arabic" pitchFamily="34" charset="-122"/>
-                <a:cs typeface="IBM Plex Sans Arabic" pitchFamily="34" charset="-120"/>
-              </a:rPr>
-              <a:t>ما التقنيات المتوفرة لتنفيذه؟</a:t>
-            </a:r>
-            <a:endParaRPr lang="en-US" sz="2100" dirty="0"/>
-          </a:p>
-        </p:txBody>
-      </p:sp>
-      <p:sp>
-        <p:nvSpPr>
-          <p:cNvPr id="37" name="Shape 29"/>
-          <p:cNvSpPr/>
-          <p:nvPr/>
-        </p:nvSpPr>
-        <p:spPr>
-          <a:xfrm>
-            <a:off x="777240" y="2651760"/>
-            <a:ext cx="4617720" cy="804672"/>
-          </a:xfrm>
-          <a:prstGeom prst="roundRect">
-            <a:avLst>
-              <a:gd name="adj" fmla="val 15909"/>
-            </a:avLst>
-          </a:prstGeom>
-          <a:solidFill>
-            <a:srgbClr val="FBF6EE"/>
-          </a:solidFill>
-          <a:ln/>
-        </p:spPr>
-      </p:sp>
-      <p:pic>
-        <p:nvPicPr>
-          <p:cNvPr id="38" name="Image 6" descr="/tmp/claude-0/-home-claude/750ff410-f4aa-5276-9360-1e19d018b112/scratchpad/c/assets/i-cloud-br.png">    </p:cNvPr>
-          <p:cNvPicPr>
-            <a:picLocks noChangeAspect="1"/>
-          </p:cNvPicPr>
-          <p:nvPr/>
-        </p:nvPicPr>
-        <p:blipFill>
-          <a:blip r:embed="rId7"/>
-          <a:stretch>
-            <a:fillRect/>
-          </a:stretch>
-        </p:blipFill>
-        <p:spPr>
-          <a:xfrm>
-            <a:off x="4754880" y="2825496"/>
-            <a:ext cx="457200" cy="457200"/>
-          </a:xfrm>
-          <a:prstGeom prst="rect">
-            <a:avLst/>
-          </a:prstGeom>
-        </p:spPr>
-      </p:pic>
-      <p:sp>
-        <p:nvSpPr>
-          <p:cNvPr id="39" name="Text 30"/>
-          <p:cNvSpPr txBox="1"/>
-          <p:nvPr/>
-        </p:nvSpPr>
-        <p:spPr>
-          <a:xfrm>
-            <a:off x="1005840" y="2651760"/>
-            <a:ext cx="3657600" cy="804672"/>
-          </a:xfrm>
-          <a:prstGeom prst="rect">
-            <a:avLst/>
-          </a:prstGeom>
-          <a:noFill/>
-          <a:ln/>
-        </p:spPr>
-        <p:txBody>
-          <a:bodyPr wrap="square" lIns="0" tIns="0" rIns="0" bIns="0" rtlCol="0" anchor="ctr"/>
-          <a:lstStyle/>
-          <a:p>
-            <a:pPr rtl="1" algn="r" indent="0" marL="0">
+            <a:pPr rtl="1" algn="ctr" indent="0" marL="0">
               <a:buNone/>
             </a:pPr>
             <a:r>
               <a:rPr lang="en-US" sz="1800" b="1" dirty="0">
                 <a:solidFill>
-                  <a:srgbClr val="21141A"/>
-                </a:solidFill>
-                <a:latin typeface="IBM Plex Sans Arabic" pitchFamily="34" charset="0"/>
-                <a:ea typeface="IBM Plex Sans Arabic" pitchFamily="34" charset="-122"/>
-                <a:cs typeface="IBM Plex Sans Arabic" pitchFamily="34" charset="-120"/>
-              </a:rPr>
-              <a:t>Cloud APIs</a:t>
-            </a:r>
-            <a:endParaRPr lang="en-US" sz="1800" dirty="0"/>
-          </a:p>
-        </p:txBody>
-      </p:sp>
-      <p:sp>
-        <p:nvSpPr>
-          <p:cNvPr id="40" name="Shape 31"/>
-          <p:cNvSpPr/>
-          <p:nvPr/>
-        </p:nvSpPr>
-        <p:spPr>
-          <a:xfrm>
-            <a:off x="777240" y="3639312"/>
-            <a:ext cx="4617720" cy="804672"/>
-          </a:xfrm>
-          <a:prstGeom prst="roundRect">
-            <a:avLst>
-              <a:gd name="adj" fmla="val 15909"/>
-            </a:avLst>
-          </a:prstGeom>
-          <a:solidFill>
-            <a:srgbClr val="FBF6EE"/>
-          </a:solidFill>
-          <a:ln/>
-        </p:spPr>
-      </p:sp>
-      <p:pic>
-        <p:nvPicPr>
-          <p:cNvPr id="41" name="Image 7" descr="/tmp/claude-0/-home-claude/750ff410-f4aa-5276-9360-1e19d018b112/scratchpad/c/assets/i-brain-br.png">    </p:cNvPr>
-          <p:cNvPicPr>
-            <a:picLocks noChangeAspect="1"/>
-          </p:cNvPicPr>
-          <p:nvPr/>
-        </p:nvPicPr>
-        <p:blipFill>
-          <a:blip r:embed="rId8"/>
-          <a:stretch>
-            <a:fillRect/>
-          </a:stretch>
-        </p:blipFill>
-        <p:spPr>
-          <a:xfrm>
-            <a:off x="4754880" y="3813048"/>
-            <a:ext cx="457200" cy="457200"/>
-          </a:xfrm>
-          <a:prstGeom prst="rect">
-            <a:avLst/>
-          </a:prstGeom>
-        </p:spPr>
-      </p:pic>
-      <p:sp>
-        <p:nvSpPr>
-          <p:cNvPr id="42" name="Text 32"/>
-          <p:cNvSpPr txBox="1"/>
-          <p:nvPr/>
-        </p:nvSpPr>
-        <p:spPr>
-          <a:xfrm>
-            <a:off x="1005840" y="3639312"/>
-            <a:ext cx="3657600" cy="804672"/>
-          </a:xfrm>
-          <a:prstGeom prst="rect">
-            <a:avLst/>
-          </a:prstGeom>
-          <a:noFill/>
-          <a:ln/>
-        </p:spPr>
-        <p:txBody>
-          <a:bodyPr wrap="square" lIns="0" tIns="0" rIns="0" bIns="0" rtlCol="0" anchor="ctr"/>
-          <a:lstStyle/>
-          <a:p>
-            <a:pPr rtl="1" algn="r" indent="0" marL="0">
-              <a:buNone/>
-            </a:pPr>
-            <a:r>
-              <a:rPr lang="en-US" sz="1800" b="1" dirty="0">
-                <a:solidFill>
-                  <a:srgbClr val="21141A"/>
-                </a:solidFill>
-                <a:latin typeface="IBM Plex Sans Arabic" pitchFamily="34" charset="0"/>
-                <a:ea typeface="IBM Plex Sans Arabic" pitchFamily="34" charset="-122"/>
-                <a:cs typeface="IBM Plex Sans Arabic" pitchFamily="34" charset="-120"/>
-              </a:rPr>
-              <a:t>AI Models</a:t>
-            </a:r>
-            <a:endParaRPr lang="en-US" sz="1800" dirty="0"/>
-          </a:p>
-        </p:txBody>
-      </p:sp>
-      <p:sp>
-        <p:nvSpPr>
-          <p:cNvPr id="43" name="Shape 33"/>
-          <p:cNvSpPr/>
-          <p:nvPr/>
-        </p:nvSpPr>
-        <p:spPr>
-          <a:xfrm>
-            <a:off x="777240" y="4626864"/>
-            <a:ext cx="4617720" cy="804672"/>
-          </a:xfrm>
-          <a:prstGeom prst="roundRect">
-            <a:avLst>
-              <a:gd name="adj" fmla="val 15909"/>
-            </a:avLst>
-          </a:prstGeom>
-          <a:solidFill>
-            <a:srgbClr val="FBF6EE"/>
-          </a:solidFill>
-          <a:ln/>
-        </p:spPr>
-      </p:sp>
-      <p:pic>
-        <p:nvPicPr>
-          <p:cNvPr id="44" name="Image 8" descr="/tmp/claude-0/-home-claude/750ff410-f4aa-5276-9360-1e19d018b112/scratchpad/c/assets/i-code-br.png">    </p:cNvPr>
-          <p:cNvPicPr>
-            <a:picLocks noChangeAspect="1"/>
-          </p:cNvPicPr>
-          <p:nvPr/>
-        </p:nvPicPr>
-        <p:blipFill>
-          <a:blip r:embed="rId9"/>
-          <a:stretch>
-            <a:fillRect/>
-          </a:stretch>
-        </p:blipFill>
-        <p:spPr>
-          <a:xfrm>
-            <a:off x="4754880" y="4800600"/>
-            <a:ext cx="457200" cy="457200"/>
-          </a:xfrm>
-          <a:prstGeom prst="rect">
-            <a:avLst/>
-          </a:prstGeom>
-        </p:spPr>
-      </p:pic>
-      <p:sp>
-        <p:nvSpPr>
-          <p:cNvPr id="45" name="Text 34"/>
-          <p:cNvSpPr txBox="1"/>
-          <p:nvPr/>
-        </p:nvSpPr>
-        <p:spPr>
-          <a:xfrm>
-            <a:off x="1005840" y="4626864"/>
-            <a:ext cx="3657600" cy="804672"/>
-          </a:xfrm>
-          <a:prstGeom prst="rect">
-            <a:avLst/>
-          </a:prstGeom>
-          <a:noFill/>
-          <a:ln/>
-        </p:spPr>
-        <p:txBody>
-          <a:bodyPr wrap="square" lIns="0" tIns="0" rIns="0" bIns="0" rtlCol="0" anchor="ctr"/>
-          <a:lstStyle/>
-          <a:p>
-            <a:pPr rtl="1" algn="r" indent="0" marL="0">
-              <a:buNone/>
-            </a:pPr>
-            <a:r>
-              <a:rPr lang="en-US" sz="1800" b="1" dirty="0">
-                <a:solidFill>
-                  <a:srgbClr val="21141A"/>
-                </a:solidFill>
-                <a:latin typeface="IBM Plex Sans Arabic" pitchFamily="34" charset="0"/>
-                <a:ea typeface="IBM Plex Sans Arabic" pitchFamily="34" charset="-122"/>
-                <a:cs typeface="IBM Plex Sans Arabic" pitchFamily="34" charset="-120"/>
-              </a:rPr>
-              <a:t>أدوات تطوير الواجهات والمواقع</a:t>
+                  <a:srgbClr val="8E2F3C"/>
+                </a:solidFill>
+                <a:latin typeface="IBM Plex Sans Arabic" pitchFamily="34" charset="0"/>
+                <a:ea typeface="IBM Plex Sans Arabic" pitchFamily="34" charset="-122"/>
+                <a:cs typeface="IBM Plex Sans Arabic" pitchFamily="34" charset="-120"/>
+              </a:rPr>
+              <a:t>بلا اشتراك ثابت، وبسقف شهري تحدده أنت</a:t>
             </a:r>
             <a:endParaRPr lang="en-US" sz="1800" dirty="0"/>
           </a:p>
@@ -12827,7 +13775,7 @@
                 <a:ea typeface="IBM Plex Sans Arabic" pitchFamily="34" charset="-122"/>
                 <a:cs typeface="IBM Plex Sans Arabic" pitchFamily="34" charset="-120"/>
               </a:rPr>
-              <a:t>النموذج الأولي</a:t>
+              <a:t>قابلية التنفيذ</a:t>
             </a:r>
             <a:endParaRPr lang="en-US" sz="1300" dirty="0"/>
           </a:p>
@@ -12943,8 +13891,8 @@
         </p:nvSpPr>
         <p:spPr>
           <a:xfrm>
-            <a:off x="457200" y="1600200"/>
-            <a:ext cx="11277295" cy="731520"/>
+            <a:off x="6172200" y="1691640"/>
+            <a:ext cx="5562295" cy="502920"/>
           </a:xfrm>
           <a:prstGeom prst="rect">
             <a:avLst/>
@@ -12960,23 +13908,72 @@
               <a:buNone/>
             </a:pPr>
             <a:r>
-              <a:rPr lang="en-US" sz="3400" b="1" dirty="0">
-                <a:solidFill>
-                  <a:srgbClr val="21141A"/>
-                </a:solidFill>
-                <a:latin typeface="IBM Plex Sans Arabic" pitchFamily="34" charset="0"/>
-                <a:ea typeface="IBM Plex Sans Arabic" pitchFamily="34" charset="-122"/>
-                <a:cs typeface="IBM Plex Sans Arabic" pitchFamily="34" charset="-120"/>
-              </a:rPr>
-              <a:t>يعمل الآن، جرّبه بنفسك</a:t>
-            </a:r>
-            <a:endParaRPr lang="en-US" sz="3400" dirty="0"/>
-          </a:p>
-        </p:txBody>
+              <a:rPr lang="en-US" sz="2100" b="1" dirty="0">
+                <a:solidFill>
+                  <a:srgbClr val="8E2F3C"/>
+                </a:solidFill>
+                <a:latin typeface="IBM Plex Sans Arabic" pitchFamily="34" charset="0"/>
+                <a:ea typeface="IBM Plex Sans Arabic" pitchFamily="34" charset="-122"/>
+                <a:cs typeface="IBM Plex Sans Arabic" pitchFamily="34" charset="-120"/>
+              </a:rPr>
+              <a:t>كيف يمكن تنفيذ الحل في الوقت الحالي؟</a:t>
+            </a:r>
+            <a:endParaRPr lang="en-US" sz="2100" dirty="0"/>
+          </a:p>
+        </p:txBody>
+      </p:sp>
+      <p:sp>
+        <p:nvSpPr>
+          <p:cNvPr id="23" name="Shape 18"/>
+          <p:cNvSpPr/>
+          <p:nvPr/>
+        </p:nvSpPr>
+        <p:spPr>
+          <a:xfrm>
+            <a:off x="6172200" y="2423160"/>
+            <a:ext cx="5562295" cy="1005840"/>
+          </a:xfrm>
+          <a:prstGeom prst="roundRect">
+            <a:avLst>
+              <a:gd name="adj" fmla="val 14545"/>
+            </a:avLst>
+          </a:prstGeom>
+          <a:solidFill>
+            <a:srgbClr val="FFFBF8"/>
+          </a:solidFill>
+          <a:ln w="9525">
+            <a:solidFill>
+              <a:srgbClr val="E3D5CC"/>
+            </a:solidFill>
+            <a:prstDash val="solid"/>
+          </a:ln>
+        </p:spPr>
+      </p:sp>
+      <p:sp>
+        <p:nvSpPr>
+          <p:cNvPr id="24" name="Shape 19"/>
+          <p:cNvSpPr/>
+          <p:nvPr/>
+        </p:nvSpPr>
+        <p:spPr>
+          <a:xfrm>
+            <a:off x="10865815" y="2606040"/>
+            <a:ext cx="640080" cy="640080"/>
+          </a:xfrm>
+          <a:prstGeom prst="roundRect">
+            <a:avLst>
+              <a:gd name="adj" fmla="val 20000"/>
+            </a:avLst>
+          </a:prstGeom>
+          <a:solidFill>
+            <a:srgbClr val="F1E4DF"/>
+          </a:solidFill>
+          <a:ln/>
+        </p:spPr>
       </p:sp>
       <p:pic>
         <p:nvPicPr>
-          <p:cNvPr id="23" name="Image 3" descr="/tmp/claude-0/-home-claude/750ff410-f4aa-5276-9360-1e19d018b112/scratchpad/c/assets/m-lap-hero.png">    </p:cNvPr>
+          <p:cNvPr id="25" name="Image 3" descr="/tmp/claude-0/-home-claude/750ff410-f4aa-5276-9360-1e19d018b112/scratchpad/c/assets/i-plug-br.png">    </p:cNvPr>
           <p:cNvPicPr>
             <a:picLocks noChangeAspect="1"/>
           </p:cNvPicPr>
@@ -12990,17 +13987,108 @@
         </p:blipFill>
         <p:spPr>
           <a:xfrm>
-            <a:off x="6156655" y="2514600"/>
-            <a:ext cx="5577840" cy="3420196"/>
+            <a:off x="10957255" y="2697480"/>
+            <a:ext cx="457200" cy="457200"/>
           </a:xfrm>
           <a:prstGeom prst="rect">
             <a:avLst/>
           </a:prstGeom>
         </p:spPr>
       </p:pic>
+      <p:sp>
+        <p:nvSpPr>
+          <p:cNvPr id="26" name="Text 20"/>
+          <p:cNvSpPr txBox="1"/>
+          <p:nvPr/>
+        </p:nvSpPr>
+        <p:spPr>
+          <a:xfrm>
+            <a:off x="6446520" y="2423160"/>
+            <a:ext cx="4236415" cy="1005840"/>
+          </a:xfrm>
+          <a:prstGeom prst="rect">
+            <a:avLst/>
+          </a:prstGeom>
+          <a:noFill/>
+          <a:ln/>
+        </p:spPr>
+        <p:txBody>
+          <a:bodyPr wrap="square" lIns="0" tIns="0" rIns="0" bIns="0" rtlCol="0" anchor="ctr"/>
+          <a:lstStyle/>
+          <a:p>
+            <a:pPr rtl="1" algn="r" indent="0" marL="0">
+              <a:lnSpc>
+                <a:spcPct val="110000"/>
+              </a:lnSpc>
+              <a:buNone/>
+            </a:pPr>
+            <a:r>
+              <a:rPr lang="en-US" sz="1600" dirty="0">
+                <a:solidFill>
+                  <a:srgbClr val="21141A"/>
+                </a:solidFill>
+                <a:latin typeface="IBM Plex Sans Arabic" pitchFamily="34" charset="0"/>
+                <a:ea typeface="IBM Plex Sans Arabic" pitchFamily="34" charset="-122"/>
+                <a:cs typeface="IBM Plex Sans Arabic" pitchFamily="34" charset="-120"/>
+              </a:rPr>
+              <a:t>ربط المنصة بحساب الشركة السحابي عبر API</a:t>
+            </a:r>
+            <a:endParaRPr lang="en-US" sz="1600" dirty="0"/>
+          </a:p>
+        </p:txBody>
+      </p:sp>
+      <p:sp>
+        <p:nvSpPr>
+          <p:cNvPr id="27" name="Shape 21"/>
+          <p:cNvSpPr/>
+          <p:nvPr/>
+        </p:nvSpPr>
+        <p:spPr>
+          <a:xfrm>
+            <a:off x="6172200" y="3611880"/>
+            <a:ext cx="5562295" cy="1005840"/>
+          </a:xfrm>
+          <a:prstGeom prst="roundRect">
+            <a:avLst>
+              <a:gd name="adj" fmla="val 14545"/>
+            </a:avLst>
+          </a:prstGeom>
+          <a:solidFill>
+            <a:srgbClr val="FFFBF8"/>
+          </a:solidFill>
+          <a:ln w="9525">
+            <a:solidFill>
+              <a:srgbClr val="E3D5CC"/>
+            </a:solidFill>
+            <a:prstDash val="solid"/>
+          </a:ln>
+        </p:spPr>
+      </p:sp>
+      <p:sp>
+        <p:nvSpPr>
+          <p:cNvPr id="28" name="Shape 22"/>
+          <p:cNvSpPr/>
+          <p:nvPr/>
+        </p:nvSpPr>
+        <p:spPr>
+          <a:xfrm>
+            <a:off x="10865815" y="3794760"/>
+            <a:ext cx="640080" cy="640080"/>
+          </a:xfrm>
+          <a:prstGeom prst="roundRect">
+            <a:avLst>
+              <a:gd name="adj" fmla="val 20000"/>
+            </a:avLst>
+          </a:prstGeom>
+          <a:solidFill>
+            <a:srgbClr val="F1E4DF"/>
+          </a:solidFill>
+          <a:ln/>
+        </p:spPr>
+      </p:sp>
       <p:pic>
         <p:nvPicPr>
-          <p:cNvPr id="24" name="Image 4" descr="/tmp/claude-0/-home-claude/750ff410-f4aa-5276-9360-1e19d018b112/scratchpad/c/assets/m-ph-start.png">    </p:cNvPr>
+          <p:cNvPr id="29" name="Image 4" descr="/tmp/claude-0/-home-claude/750ff410-f4aa-5276-9360-1e19d018b112/scratchpad/c/assets/i-bot-br.png">    </p:cNvPr>
           <p:cNvPicPr>
             <a:picLocks noChangeAspect="1"/>
           </p:cNvPicPr>
@@ -13014,8 +14102,8 @@
         </p:blipFill>
         <p:spPr>
           <a:xfrm>
-            <a:off x="5090163" y="2697480"/>
-            <a:ext cx="1569412" cy="3246120"/>
+            <a:off x="10957255" y="3886200"/>
+            <a:ext cx="457200" cy="457200"/>
           </a:xfrm>
           <a:prstGeom prst="rect">
             <a:avLst/>
@@ -13024,51 +14112,98 @@
       </p:pic>
       <p:sp>
         <p:nvSpPr>
-          <p:cNvPr id="25" name="Shape 18"/>
-          <p:cNvSpPr/>
-          <p:nvPr/>
-        </p:nvSpPr>
-        <p:spPr>
-          <a:xfrm>
-            <a:off x="640080" y="2606040"/>
-            <a:ext cx="2651760" cy="3246120"/>
+          <p:cNvPr id="30" name="Text 23"/>
+          <p:cNvSpPr txBox="1"/>
+          <p:nvPr/>
+        </p:nvSpPr>
+        <p:spPr>
+          <a:xfrm>
+            <a:off x="6446520" y="3611880"/>
+            <a:ext cx="4236415" cy="1005840"/>
+          </a:xfrm>
+          <a:prstGeom prst="rect">
+            <a:avLst/>
+          </a:prstGeom>
+          <a:noFill/>
+          <a:ln/>
+        </p:spPr>
+        <p:txBody>
+          <a:bodyPr wrap="square" lIns="0" tIns="0" rIns="0" bIns="0" rtlCol="0" anchor="ctr"/>
+          <a:lstStyle/>
+          <a:p>
+            <a:pPr rtl="1" algn="r" indent="0" marL="0">
+              <a:lnSpc>
+                <a:spcPct val="110000"/>
+              </a:lnSpc>
+              <a:buNone/>
+            </a:pPr>
+            <a:r>
+              <a:rPr lang="en-US" sz="1600" dirty="0">
+                <a:solidFill>
+                  <a:srgbClr val="21141A"/>
+                </a:solidFill>
+                <a:latin typeface="IBM Plex Sans Arabic" pitchFamily="34" charset="0"/>
+                <a:ea typeface="IBM Plex Sans Arabic" pitchFamily="34" charset="-122"/>
+                <a:cs typeface="IBM Plex Sans Arabic" pitchFamily="34" charset="-120"/>
+              </a:rPr>
+              <a:t>نموذج ذكاء اصطناعي يمسح البنية فوراً ويطابقها مع أفضل الممارسات ويحلل الأحمال</a:t>
+            </a:r>
+            <a:endParaRPr lang="en-US" sz="1600" dirty="0"/>
+          </a:p>
+        </p:txBody>
+      </p:sp>
+      <p:sp>
+        <p:nvSpPr>
+          <p:cNvPr id="31" name="Shape 24"/>
+          <p:cNvSpPr/>
+          <p:nvPr/>
+        </p:nvSpPr>
+        <p:spPr>
+          <a:xfrm>
+            <a:off x="6172200" y="4800600"/>
+            <a:ext cx="5562295" cy="1005840"/>
           </a:xfrm>
           <a:prstGeom prst="roundRect">
             <a:avLst>
-              <a:gd name="adj" fmla="val 6207"/>
+              <a:gd name="adj" fmla="val 14545"/>
             </a:avLst>
           </a:prstGeom>
           <a:solidFill>
-            <a:srgbClr val="8E2F3C"/>
-          </a:solidFill>
-          <a:ln/>
-        </p:spPr>
-      </p:sp>
-      <p:sp>
-        <p:nvSpPr>
-          <p:cNvPr id="26" name="Shape 19"/>
-          <p:cNvSpPr/>
-          <p:nvPr/>
-        </p:nvSpPr>
-        <p:spPr>
-          <a:xfrm>
-            <a:off x="822960" y="2788920"/>
-            <a:ext cx="2286000" cy="2286000"/>
+            <a:srgbClr val="FFFBF8"/>
+          </a:solidFill>
+          <a:ln w="9525">
+            <a:solidFill>
+              <a:srgbClr val="E3D5CC"/>
+            </a:solidFill>
+            <a:prstDash val="solid"/>
+          </a:ln>
+        </p:spPr>
+      </p:sp>
+      <p:sp>
+        <p:nvSpPr>
+          <p:cNvPr id="32" name="Shape 25"/>
+          <p:cNvSpPr/>
+          <p:nvPr/>
+        </p:nvSpPr>
+        <p:spPr>
+          <a:xfrm>
+            <a:off x="10865815" y="4983480"/>
+            <a:ext cx="640080" cy="640080"/>
           </a:xfrm>
           <a:prstGeom prst="roundRect">
             <a:avLst>
-              <a:gd name="adj" fmla="val 4800"/>
+              <a:gd name="adj" fmla="val 20000"/>
             </a:avLst>
           </a:prstGeom>
           <a:solidFill>
-            <a:srgbClr val="FFFBF8"/>
+            <a:srgbClr val="F1E4DF"/>
           </a:solidFill>
           <a:ln/>
         </p:spPr>
       </p:sp>
       <p:pic>
         <p:nvPicPr>
-          <p:cNvPr id="27" name="Image 5" descr="/tmp/claude-0/-home-claude/750ff410-f4aa-5276-9360-1e19d018b112/scratchpad/c/assets/qr.png">    </p:cNvPr>
+          <p:cNvPr id="33" name="Image 5" descr="/tmp/claude-0/-home-claude/750ff410-f4aa-5276-9360-1e19d018b112/scratchpad/c/assets/i-check-br.png">    </p:cNvPr>
           <p:cNvPicPr>
             <a:picLocks noChangeAspect="1"/>
           </p:cNvPicPr>
@@ -13082,8 +14217,8 @@
         </p:blipFill>
         <p:spPr>
           <a:xfrm>
-            <a:off x="914400" y="2880360"/>
-            <a:ext cx="2103120" cy="2103120"/>
+            <a:off x="10957255" y="5074920"/>
+            <a:ext cx="457200" cy="457200"/>
           </a:xfrm>
           <a:prstGeom prst="rect">
             <a:avLst/>
@@ -13092,30 +14227,94 @@
       </p:pic>
       <p:sp>
         <p:nvSpPr>
-          <p:cNvPr id="28" name="Text 20"/>
-          <p:cNvSpPr txBox="1"/>
-          <p:nvPr/>
-        </p:nvSpPr>
-        <p:spPr>
-          <a:xfrm>
-            <a:off x="640080" y="5212080"/>
-            <a:ext cx="2651760" cy="365760"/>
-          </a:xfrm>
-          <a:prstGeom prst="rect">
-            <a:avLst/>
-          </a:prstGeom>
-          <a:noFill/>
-          <a:ln/>
-        </p:spPr>
-        <p:txBody>
-          <a:bodyPr wrap="square" lIns="0" tIns="0" rIns="0" bIns="0" rtlCol="0" anchor="t"/>
-          <a:lstStyle/>
-          <a:p>
-            <a:pPr rtl="1" algn="ctr" indent="0" marL="0">
-              <a:buNone/>
-            </a:pPr>
-            <a:r>
-              <a:rPr lang="en-US" sz="1600" b="1" dirty="0">
+          <p:cNvPr id="34" name="Text 26"/>
+          <p:cNvSpPr txBox="1"/>
+          <p:nvPr/>
+        </p:nvSpPr>
+        <p:spPr>
+          <a:xfrm>
+            <a:off x="6446520" y="4800600"/>
+            <a:ext cx="4236415" cy="1005840"/>
+          </a:xfrm>
+          <a:prstGeom prst="rect">
+            <a:avLst/>
+          </a:prstGeom>
+          <a:noFill/>
+          <a:ln/>
+        </p:spPr>
+        <p:txBody>
+          <a:bodyPr wrap="square" lIns="0" tIns="0" rIns="0" bIns="0" rtlCol="0" anchor="ctr"/>
+          <a:lstStyle/>
+          <a:p>
+            <a:pPr rtl="1" algn="r" indent="0" marL="0">
+              <a:lnSpc>
+                <a:spcPct val="110000"/>
+              </a:lnSpc>
+              <a:buNone/>
+            </a:pPr>
+            <a:r>
+              <a:rPr lang="en-US" sz="1600" dirty="0">
+                <a:solidFill>
+                  <a:srgbClr val="21141A"/>
+                </a:solidFill>
+                <a:latin typeface="IBM Plex Sans Arabic" pitchFamily="34" charset="0"/>
+                <a:ea typeface="IBM Plex Sans Arabic" pitchFamily="34" charset="-122"/>
+                <a:cs typeface="IBM Plex Sans Arabic" pitchFamily="34" charset="-120"/>
+              </a:rPr>
+              <a:t>زر تفاعلي بضغطة واحدة لإيقاف المورد أو تقليصه عبر API</a:t>
+            </a:r>
+            <a:endParaRPr lang="en-US" sz="1600" dirty="0"/>
+          </a:p>
+        </p:txBody>
+      </p:sp>
+      <p:sp>
+        <p:nvSpPr>
+          <p:cNvPr id="35" name="Shape 27"/>
+          <p:cNvSpPr/>
+          <p:nvPr/>
+        </p:nvSpPr>
+        <p:spPr>
+          <a:xfrm>
+            <a:off x="457200" y="1691640"/>
+            <a:ext cx="5257800" cy="4114800"/>
+          </a:xfrm>
+          <a:prstGeom prst="roundRect">
+            <a:avLst>
+              <a:gd name="adj" fmla="val 4444"/>
+            </a:avLst>
+          </a:prstGeom>
+          <a:solidFill>
+            <a:srgbClr val="8E2F3C"/>
+          </a:solidFill>
+          <a:ln/>
+        </p:spPr>
+      </p:sp>
+      <p:sp>
+        <p:nvSpPr>
+          <p:cNvPr id="36" name="Text 28"/>
+          <p:cNvSpPr txBox="1"/>
+          <p:nvPr/>
+        </p:nvSpPr>
+        <p:spPr>
+          <a:xfrm>
+            <a:off x="777240" y="1920240"/>
+            <a:ext cx="4617720" cy="502920"/>
+          </a:xfrm>
+          <a:prstGeom prst="rect">
+            <a:avLst/>
+          </a:prstGeom>
+          <a:noFill/>
+          <a:ln/>
+        </p:spPr>
+        <p:txBody>
+          <a:bodyPr wrap="square" lIns="0" tIns="0" rIns="0" bIns="0" rtlCol="0" anchor="ctr"/>
+          <a:lstStyle/>
+          <a:p>
+            <a:pPr rtl="1" algn="r" indent="0" marL="0">
+              <a:buNone/>
+            </a:pPr>
+            <a:r>
+              <a:rPr lang="en-US" sz="2100" b="1" dirty="0">
                 <a:solidFill>
                   <a:srgbClr val="FBF6EE"/>
                 </a:solidFill>
@@ -13123,9 +14322,264 @@
                 <a:ea typeface="IBM Plex Sans Arabic" pitchFamily="34" charset="-122"/>
                 <a:cs typeface="IBM Plex Sans Arabic" pitchFamily="34" charset="-120"/>
               </a:rPr>
-              <a:t>امسح وجرّب</a:t>
-            </a:r>
-            <a:endParaRPr lang="en-US" sz="1600" dirty="0"/>
+              <a:t>ما التقنيات المتوفرة لتنفيذه؟</a:t>
+            </a:r>
+            <a:endParaRPr lang="en-US" sz="2100" dirty="0"/>
+          </a:p>
+        </p:txBody>
+      </p:sp>
+      <p:sp>
+        <p:nvSpPr>
+          <p:cNvPr id="37" name="Shape 29"/>
+          <p:cNvSpPr/>
+          <p:nvPr/>
+        </p:nvSpPr>
+        <p:spPr>
+          <a:xfrm>
+            <a:off x="777240" y="2651760"/>
+            <a:ext cx="4617720" cy="804672"/>
+          </a:xfrm>
+          <a:prstGeom prst="roundRect">
+            <a:avLst>
+              <a:gd name="adj" fmla="val 15909"/>
+            </a:avLst>
+          </a:prstGeom>
+          <a:solidFill>
+            <a:srgbClr val="FBF6EE"/>
+          </a:solidFill>
+          <a:ln/>
+        </p:spPr>
+      </p:sp>
+      <p:pic>
+        <p:nvPicPr>
+          <p:cNvPr id="38" name="Image 6" descr="/tmp/claude-0/-home-claude/750ff410-f4aa-5276-9360-1e19d018b112/scratchpad/c/assets/i-cloud-br.png">    </p:cNvPr>
+          <p:cNvPicPr>
+            <a:picLocks noChangeAspect="1"/>
+          </p:cNvPicPr>
+          <p:nvPr/>
+        </p:nvPicPr>
+        <p:blipFill>
+          <a:blip r:embed="rId7"/>
+          <a:stretch>
+            <a:fillRect/>
+          </a:stretch>
+        </p:blipFill>
+        <p:spPr>
+          <a:xfrm>
+            <a:off x="4754880" y="2825496"/>
+            <a:ext cx="457200" cy="457200"/>
+          </a:xfrm>
+          <a:prstGeom prst="rect">
+            <a:avLst/>
+          </a:prstGeom>
+        </p:spPr>
+      </p:pic>
+      <p:sp>
+        <p:nvSpPr>
+          <p:cNvPr id="39" name="Text 30"/>
+          <p:cNvSpPr txBox="1"/>
+          <p:nvPr/>
+        </p:nvSpPr>
+        <p:spPr>
+          <a:xfrm>
+            <a:off x="1005840" y="2651760"/>
+            <a:ext cx="3657600" cy="804672"/>
+          </a:xfrm>
+          <a:prstGeom prst="rect">
+            <a:avLst/>
+          </a:prstGeom>
+          <a:noFill/>
+          <a:ln/>
+        </p:spPr>
+        <p:txBody>
+          <a:bodyPr wrap="square" lIns="0" tIns="0" rIns="0" bIns="0" rtlCol="0" anchor="ctr"/>
+          <a:lstStyle/>
+          <a:p>
+            <a:pPr rtl="1" algn="r" indent="0" marL="0">
+              <a:buNone/>
+            </a:pPr>
+            <a:r>
+              <a:rPr lang="en-US" sz="1800" b="1" dirty="0">
+                <a:solidFill>
+                  <a:srgbClr val="21141A"/>
+                </a:solidFill>
+                <a:latin typeface="IBM Plex Sans Arabic" pitchFamily="34" charset="0"/>
+                <a:ea typeface="IBM Plex Sans Arabic" pitchFamily="34" charset="-122"/>
+                <a:cs typeface="IBM Plex Sans Arabic" pitchFamily="34" charset="-120"/>
+              </a:rPr>
+              <a:t>Cloud APIs</a:t>
+            </a:r>
+            <a:endParaRPr lang="en-US" sz="1800" dirty="0"/>
+          </a:p>
+        </p:txBody>
+      </p:sp>
+      <p:sp>
+        <p:nvSpPr>
+          <p:cNvPr id="40" name="Shape 31"/>
+          <p:cNvSpPr/>
+          <p:nvPr/>
+        </p:nvSpPr>
+        <p:spPr>
+          <a:xfrm>
+            <a:off x="777240" y="3639312"/>
+            <a:ext cx="4617720" cy="804672"/>
+          </a:xfrm>
+          <a:prstGeom prst="roundRect">
+            <a:avLst>
+              <a:gd name="adj" fmla="val 15909"/>
+            </a:avLst>
+          </a:prstGeom>
+          <a:solidFill>
+            <a:srgbClr val="FBF6EE"/>
+          </a:solidFill>
+          <a:ln/>
+        </p:spPr>
+      </p:sp>
+      <p:pic>
+        <p:nvPicPr>
+          <p:cNvPr id="41" name="Image 7" descr="/tmp/claude-0/-home-claude/750ff410-f4aa-5276-9360-1e19d018b112/scratchpad/c/assets/i-brain-br.png">    </p:cNvPr>
+          <p:cNvPicPr>
+            <a:picLocks noChangeAspect="1"/>
+          </p:cNvPicPr>
+          <p:nvPr/>
+        </p:nvPicPr>
+        <p:blipFill>
+          <a:blip r:embed="rId8"/>
+          <a:stretch>
+            <a:fillRect/>
+          </a:stretch>
+        </p:blipFill>
+        <p:spPr>
+          <a:xfrm>
+            <a:off x="4754880" y="3813048"/>
+            <a:ext cx="457200" cy="457200"/>
+          </a:xfrm>
+          <a:prstGeom prst="rect">
+            <a:avLst/>
+          </a:prstGeom>
+        </p:spPr>
+      </p:pic>
+      <p:sp>
+        <p:nvSpPr>
+          <p:cNvPr id="42" name="Text 32"/>
+          <p:cNvSpPr txBox="1"/>
+          <p:nvPr/>
+        </p:nvSpPr>
+        <p:spPr>
+          <a:xfrm>
+            <a:off x="1005840" y="3639312"/>
+            <a:ext cx="3657600" cy="804672"/>
+          </a:xfrm>
+          <a:prstGeom prst="rect">
+            <a:avLst/>
+          </a:prstGeom>
+          <a:noFill/>
+          <a:ln/>
+        </p:spPr>
+        <p:txBody>
+          <a:bodyPr wrap="square" lIns="0" tIns="0" rIns="0" bIns="0" rtlCol="0" anchor="ctr"/>
+          <a:lstStyle/>
+          <a:p>
+            <a:pPr rtl="1" algn="r" indent="0" marL="0">
+              <a:buNone/>
+            </a:pPr>
+            <a:r>
+              <a:rPr lang="en-US" sz="1800" b="1" dirty="0">
+                <a:solidFill>
+                  <a:srgbClr val="21141A"/>
+                </a:solidFill>
+                <a:latin typeface="IBM Plex Sans Arabic" pitchFamily="34" charset="0"/>
+                <a:ea typeface="IBM Plex Sans Arabic" pitchFamily="34" charset="-122"/>
+                <a:cs typeface="IBM Plex Sans Arabic" pitchFamily="34" charset="-120"/>
+              </a:rPr>
+              <a:t>AI Models</a:t>
+            </a:r>
+            <a:endParaRPr lang="en-US" sz="1800" dirty="0"/>
+          </a:p>
+        </p:txBody>
+      </p:sp>
+      <p:sp>
+        <p:nvSpPr>
+          <p:cNvPr id="43" name="Shape 33"/>
+          <p:cNvSpPr/>
+          <p:nvPr/>
+        </p:nvSpPr>
+        <p:spPr>
+          <a:xfrm>
+            <a:off x="777240" y="4626864"/>
+            <a:ext cx="4617720" cy="804672"/>
+          </a:xfrm>
+          <a:prstGeom prst="roundRect">
+            <a:avLst>
+              <a:gd name="adj" fmla="val 15909"/>
+            </a:avLst>
+          </a:prstGeom>
+          <a:solidFill>
+            <a:srgbClr val="FBF6EE"/>
+          </a:solidFill>
+          <a:ln/>
+        </p:spPr>
+      </p:sp>
+      <p:pic>
+        <p:nvPicPr>
+          <p:cNvPr id="44" name="Image 8" descr="/tmp/claude-0/-home-claude/750ff410-f4aa-5276-9360-1e19d018b112/scratchpad/c/assets/i-code-br.png">    </p:cNvPr>
+          <p:cNvPicPr>
+            <a:picLocks noChangeAspect="1"/>
+          </p:cNvPicPr>
+          <p:nvPr/>
+        </p:nvPicPr>
+        <p:blipFill>
+          <a:blip r:embed="rId9"/>
+          <a:stretch>
+            <a:fillRect/>
+          </a:stretch>
+        </p:blipFill>
+        <p:spPr>
+          <a:xfrm>
+            <a:off x="4754880" y="4800600"/>
+            <a:ext cx="457200" cy="457200"/>
+          </a:xfrm>
+          <a:prstGeom prst="rect">
+            <a:avLst/>
+          </a:prstGeom>
+        </p:spPr>
+      </p:pic>
+      <p:sp>
+        <p:nvSpPr>
+          <p:cNvPr id="45" name="Text 34"/>
+          <p:cNvSpPr txBox="1"/>
+          <p:nvPr/>
+        </p:nvSpPr>
+        <p:spPr>
+          <a:xfrm>
+            <a:off x="1005840" y="4626864"/>
+            <a:ext cx="3657600" cy="804672"/>
+          </a:xfrm>
+          <a:prstGeom prst="rect">
+            <a:avLst/>
+          </a:prstGeom>
+          <a:noFill/>
+          <a:ln/>
+        </p:spPr>
+        <p:txBody>
+          <a:bodyPr wrap="square" lIns="0" tIns="0" rIns="0" bIns="0" rtlCol="0" anchor="ctr"/>
+          <a:lstStyle/>
+          <a:p>
+            <a:pPr rtl="1" algn="r" indent="0" marL="0">
+              <a:buNone/>
+            </a:pPr>
+            <a:r>
+              <a:rPr lang="en-US" sz="1800" b="1" dirty="0">
+                <a:solidFill>
+                  <a:srgbClr val="21141A"/>
+                </a:solidFill>
+                <a:latin typeface="IBM Plex Sans Arabic" pitchFamily="34" charset="0"/>
+                <a:ea typeface="IBM Plex Sans Arabic" pitchFamily="34" charset="-122"/>
+                <a:cs typeface="IBM Plex Sans Arabic" pitchFamily="34" charset="-120"/>
+              </a:rPr>
+              <a:t>أدوات تطوير الواجهات والمواقع</a:t>
+            </a:r>
+            <a:endParaRPr lang="en-US" sz="1800" dirty="0"/>
           </a:p>
         </p:txBody>
       </p:sp>
@@ -13496,8 +14950,8 @@
         </p:nvSpPr>
         <p:spPr>
           <a:xfrm>
-            <a:off x="8918143" y="987552"/>
-            <a:ext cx="2816352" cy="384048"/>
+            <a:off x="9759391" y="987552"/>
+            <a:ext cx="1975104" cy="384048"/>
           </a:xfrm>
           <a:prstGeom prst="roundRect">
             <a:avLst>
@@ -13518,8 +14972,8 @@
         </p:nvSpPr>
         <p:spPr>
           <a:xfrm>
-            <a:off x="8918143" y="987552"/>
-            <a:ext cx="2816352" cy="384048"/>
+            <a:off x="9759391" y="987552"/>
+            <a:ext cx="1975104" cy="384048"/>
           </a:xfrm>
           <a:prstGeom prst="rect">
             <a:avLst/>
@@ -13543,7 +14997,7 @@
                 <a:ea typeface="IBM Plex Sans Arabic" pitchFamily="34" charset="-122"/>
                 <a:cs typeface="IBM Plex Sans Arabic" pitchFamily="34" charset="-120"/>
               </a:rPr>
-              <a:t>الأثر والقيمة المتوقعة</a:t>
+              <a:t>النموذج الأولي</a:t>
             </a:r>
             <a:endParaRPr lang="en-US" sz="1300" dirty="0"/>
           </a:p>
@@ -13684,42 +15138,15 @@
                 <a:ea typeface="IBM Plex Sans Arabic" pitchFamily="34" charset="-122"/>
                 <a:cs typeface="IBM Plex Sans Arabic" pitchFamily="34" charset="-120"/>
               </a:rPr>
-              <a:t>أثر بالأرقام</a:t>
+              <a:t>يعمل الآن، جرّبه بنفسك</a:t>
             </a:r>
             <a:endParaRPr lang="en-US" sz="3400" dirty="0"/>
           </a:p>
         </p:txBody>
-      </p:sp>
-      <p:sp>
-        <p:nvSpPr>
-          <p:cNvPr id="23" name="Shape 18"/>
-          <p:cNvSpPr/>
-          <p:nvPr/>
-        </p:nvSpPr>
-        <p:spPr>
-          <a:xfrm>
-            <a:off x="8188757" y="2697480"/>
-            <a:ext cx="3545738" cy="2377440"/>
-          </a:xfrm>
-          <a:prstGeom prst="roundRect">
-            <a:avLst>
-              <a:gd name="adj" fmla="val 7692"/>
-            </a:avLst>
-          </a:prstGeom>
-          <a:solidFill>
-            <a:srgbClr val="FFFBF8"/>
-          </a:solidFill>
-          <a:ln w="9525">
-            <a:solidFill>
-              <a:srgbClr val="E3D5CC"/>
-            </a:solidFill>
-            <a:prstDash val="solid"/>
-          </a:ln>
-        </p:spPr>
       </p:sp>
       <p:pic>
         <p:nvPicPr>
-          <p:cNvPr id="24" name="Image 3" descr="/tmp/claude-0/-home-claude/750ff410-f4aa-5276-9360-1e19d018b112/scratchpad/c/assets/i-wallet-br.png">    </p:cNvPr>
+          <p:cNvPr id="23" name="Image 3" descr="/tmp/claude-0/-home-claude/750ff410-f4aa-5276-9360-1e19d018b112/scratchpad/c/assets/m-lap-hero.png">    </p:cNvPr>
           <p:cNvPicPr>
             <a:picLocks noChangeAspect="1"/>
           </p:cNvPicPr>
@@ -13733,117 +15160,17 @@
         </p:blipFill>
         <p:spPr>
           <a:xfrm>
-            <a:off x="9687306" y="2971800"/>
-            <a:ext cx="548640" cy="548640"/>
+            <a:off x="6156655" y="2514600"/>
+            <a:ext cx="5577840" cy="3420196"/>
           </a:xfrm>
           <a:prstGeom prst="rect">
             <a:avLst/>
           </a:prstGeom>
         </p:spPr>
       </p:pic>
-      <p:sp>
-        <p:nvSpPr>
-          <p:cNvPr id="25" name="Text 19"/>
-          <p:cNvSpPr txBox="1"/>
-          <p:nvPr/>
-        </p:nvSpPr>
-        <p:spPr>
-          <a:xfrm>
-            <a:off x="8188757" y="3566160"/>
-            <a:ext cx="3545738" cy="868680"/>
-          </a:xfrm>
-          <a:prstGeom prst="rect">
-            <a:avLst/>
-          </a:prstGeom>
-          <a:noFill/>
-          <a:ln/>
-        </p:spPr>
-        <p:txBody>
-          <a:bodyPr wrap="square" lIns="0" tIns="0" rIns="0" bIns="0" rtlCol="0" anchor="ctr"/>
-          <a:lstStyle/>
-          <a:p>
-            <a:pPr algn="ctr" indent="0" marL="0">
-              <a:buNone/>
-            </a:pPr>
-            <a:r>
-              <a:rPr lang="en-US" sz="5400" b="1" dirty="0">
-                <a:solidFill>
-                  <a:srgbClr val="8E2F3C"/>
-                </a:solidFill>
-                <a:latin typeface="IBM Plex Sans Arabic" pitchFamily="34" charset="0"/>
-                <a:ea typeface="IBM Plex Sans Arabic" pitchFamily="34" charset="-122"/>
-                <a:cs typeface="IBM Plex Sans Arabic" pitchFamily="34" charset="-120"/>
-              </a:rPr>
-              <a:t>10.8%</a:t>
-            </a:r>
-            <a:endParaRPr lang="en-US" sz="5400" dirty="0"/>
-          </a:p>
-        </p:txBody>
-      </p:sp>
-      <p:sp>
-        <p:nvSpPr>
-          <p:cNvPr id="26" name="Text 20"/>
-          <p:cNvSpPr txBox="1"/>
-          <p:nvPr/>
-        </p:nvSpPr>
-        <p:spPr>
-          <a:xfrm>
-            <a:off x="8463077" y="4480560"/>
-            <a:ext cx="2997098" cy="411480"/>
-          </a:xfrm>
-          <a:prstGeom prst="rect">
-            <a:avLst/>
-          </a:prstGeom>
-          <a:noFill/>
-          <a:ln/>
-        </p:spPr>
-        <p:txBody>
-          <a:bodyPr wrap="square" lIns="0" tIns="0" rIns="0" bIns="0" rtlCol="0" anchor="ctr"/>
-          <a:lstStyle/>
-          <a:p>
-            <a:pPr rtl="1" algn="ctr" indent="0" marL="0">
-              <a:buNone/>
-            </a:pPr>
-            <a:r>
-              <a:rPr lang="en-US" sz="1800" dirty="0">
-                <a:solidFill>
-                  <a:srgbClr val="21141A"/>
-                </a:solidFill>
-                <a:latin typeface="IBM Plex Sans Arabic" pitchFamily="34" charset="0"/>
-                <a:ea typeface="IBM Plex Sans Arabic" pitchFamily="34" charset="-122"/>
-                <a:cs typeface="IBM Plex Sans Arabic" pitchFamily="34" charset="-120"/>
-              </a:rPr>
-              <a:t>توفير من الفاتورة</a:t>
-            </a:r>
-            <a:endParaRPr lang="en-US" sz="1800" dirty="0"/>
-          </a:p>
-        </p:txBody>
-      </p:sp>
-      <p:sp>
-        <p:nvSpPr>
-          <p:cNvPr id="27" name="Shape 21"/>
-          <p:cNvSpPr/>
-          <p:nvPr/>
-        </p:nvSpPr>
-        <p:spPr>
-          <a:xfrm>
-            <a:off x="4322978" y="2697480"/>
-            <a:ext cx="3545738" cy="2377440"/>
-          </a:xfrm>
-          <a:prstGeom prst="roundRect">
-            <a:avLst>
-              <a:gd name="adj" fmla="val 7692"/>
-            </a:avLst>
-          </a:prstGeom>
-          <a:solidFill>
-            <a:srgbClr val="8E2F3C"/>
-          </a:solidFill>
-          <a:ln/>
-        </p:spPr>
-      </p:sp>
       <p:pic>
         <p:nvPicPr>
-          <p:cNvPr id="28" name="Image 4" descr="/tmp/claude-0/-home-claude/750ff410-f4aa-5276-9360-1e19d018b112/scratchpad/c/assets/i-trend-cr.png">    </p:cNvPr>
+          <p:cNvPr id="24" name="Image 4" descr="/tmp/claude-0/-home-claude/750ff410-f4aa-5276-9360-1e19d018b112/scratchpad/c/assets/m-ph-start.png">    </p:cNvPr>
           <p:cNvPicPr>
             <a:picLocks noChangeAspect="1"/>
           </p:cNvPicPr>
@@ -13857,8 +15184,8 @@
         </p:blipFill>
         <p:spPr>
           <a:xfrm>
-            <a:off x="5821528" y="2971800"/>
-            <a:ext cx="548640" cy="548640"/>
+            <a:off x="5090163" y="2697480"/>
+            <a:ext cx="1569412" cy="3246120"/>
           </a:xfrm>
           <a:prstGeom prst="rect">
             <a:avLst/>
@@ -13867,112 +15194,51 @@
       </p:pic>
       <p:sp>
         <p:nvSpPr>
-          <p:cNvPr id="29" name="Text 22"/>
-          <p:cNvSpPr txBox="1"/>
-          <p:nvPr/>
-        </p:nvSpPr>
-        <p:spPr>
-          <a:xfrm>
-            <a:off x="4322978" y="3566160"/>
-            <a:ext cx="3545738" cy="868680"/>
-          </a:xfrm>
-          <a:prstGeom prst="rect">
-            <a:avLst/>
-          </a:prstGeom>
-          <a:noFill/>
-          <a:ln/>
-        </p:spPr>
-        <p:txBody>
-          <a:bodyPr wrap="square" lIns="0" tIns="0" rIns="0" bIns="0" rtlCol="0" anchor="ctr"/>
-          <a:lstStyle/>
-          <a:p>
-            <a:pPr algn="ctr" indent="0" marL="0">
-              <a:buNone/>
-            </a:pPr>
-            <a:r>
-              <a:rPr lang="en-US" sz="5400" b="1" dirty="0">
-                <a:solidFill>
-                  <a:srgbClr val="FBF6EE"/>
-                </a:solidFill>
-                <a:latin typeface="IBM Plex Sans Arabic" pitchFamily="34" charset="0"/>
-                <a:ea typeface="IBM Plex Sans Arabic" pitchFamily="34" charset="-122"/>
-                <a:cs typeface="IBM Plex Sans Arabic" pitchFamily="34" charset="-120"/>
-              </a:rPr>
-              <a:t>110K</a:t>
-            </a:r>
-            <a:endParaRPr lang="en-US" sz="5400" dirty="0"/>
-          </a:p>
-        </p:txBody>
-      </p:sp>
-      <p:sp>
-        <p:nvSpPr>
-          <p:cNvPr id="30" name="Text 23"/>
-          <p:cNvSpPr txBox="1"/>
-          <p:nvPr/>
-        </p:nvSpPr>
-        <p:spPr>
-          <a:xfrm>
-            <a:off x="4597298" y="4480560"/>
-            <a:ext cx="2997098" cy="411480"/>
-          </a:xfrm>
-          <a:prstGeom prst="rect">
-            <a:avLst/>
-          </a:prstGeom>
-          <a:noFill/>
-          <a:ln/>
-        </p:spPr>
-        <p:txBody>
-          <a:bodyPr wrap="square" lIns="0" tIns="0" rIns="0" bIns="0" rtlCol="0" anchor="ctr"/>
-          <a:lstStyle/>
-          <a:p>
-            <a:pPr rtl="1" algn="ctr" indent="0" marL="0">
-              <a:buNone/>
-            </a:pPr>
-            <a:r>
-              <a:rPr lang="en-US" sz="1800" dirty="0">
-                <a:solidFill>
-                  <a:srgbClr val="FBF6EE"/>
-                </a:solidFill>
-                <a:latin typeface="IBM Plex Sans Arabic" pitchFamily="34" charset="0"/>
-                <a:ea typeface="IBM Plex Sans Arabic" pitchFamily="34" charset="-122"/>
-                <a:cs typeface="IBM Plex Sans Arabic" pitchFamily="34" charset="-120"/>
-              </a:rPr>
-              <a:t>ريال سنوياً</a:t>
-            </a:r>
-            <a:endParaRPr lang="en-US" sz="1800" dirty="0"/>
-          </a:p>
-        </p:txBody>
-      </p:sp>
-      <p:sp>
-        <p:nvSpPr>
-          <p:cNvPr id="31" name="Shape 24"/>
-          <p:cNvSpPr/>
-          <p:nvPr/>
-        </p:nvSpPr>
-        <p:spPr>
-          <a:xfrm>
-            <a:off x="457200" y="2697480"/>
-            <a:ext cx="3545738" cy="2377440"/>
+          <p:cNvPr id="25" name="Shape 18"/>
+          <p:cNvSpPr/>
+          <p:nvPr/>
+        </p:nvSpPr>
+        <p:spPr>
+          <a:xfrm>
+            <a:off x="640080" y="2606040"/>
+            <a:ext cx="2651760" cy="3246120"/>
           </a:xfrm>
           <a:prstGeom prst="roundRect">
             <a:avLst>
-              <a:gd name="adj" fmla="val 7692"/>
+              <a:gd name="adj" fmla="val 6207"/>
             </a:avLst>
           </a:prstGeom>
           <a:solidFill>
+            <a:srgbClr val="8E2F3C"/>
+          </a:solidFill>
+          <a:ln/>
+        </p:spPr>
+      </p:sp>
+      <p:sp>
+        <p:nvSpPr>
+          <p:cNvPr id="26" name="Shape 19"/>
+          <p:cNvSpPr/>
+          <p:nvPr/>
+        </p:nvSpPr>
+        <p:spPr>
+          <a:xfrm>
+            <a:off x="822960" y="2788920"/>
+            <a:ext cx="2286000" cy="2286000"/>
+          </a:xfrm>
+          <a:prstGeom prst="roundRect">
+            <a:avLst>
+              <a:gd name="adj" fmla="val 4800"/>
+            </a:avLst>
+          </a:prstGeom>
+          <a:solidFill>
             <a:srgbClr val="FFFBF8"/>
           </a:solidFill>
-          <a:ln w="9525">
-            <a:solidFill>
-              <a:srgbClr val="E3D5CC"/>
-            </a:solidFill>
-            <a:prstDash val="solid"/>
-          </a:ln>
+          <a:ln/>
         </p:spPr>
       </p:sp>
       <p:pic>
         <p:nvPicPr>
-          <p:cNvPr id="32" name="Image 5" descr="/tmp/claude-0/-home-claude/750ff410-f4aa-5276-9360-1e19d018b112/scratchpad/c/assets/i-clock-br.png">    </p:cNvPr>
+          <p:cNvPr id="27" name="Image 5" descr="/tmp/claude-0/-home-claude/750ff410-f4aa-5276-9360-1e19d018b112/scratchpad/c/assets/qr.png">    </p:cNvPr>
           <p:cNvPicPr>
             <a:picLocks noChangeAspect="1"/>
           </p:cNvPicPr>
@@ -13986,8 +15252,8 @@
         </p:blipFill>
         <p:spPr>
           <a:xfrm>
-            <a:off x="1955749" y="2971800"/>
-            <a:ext cx="548640" cy="548640"/>
+            <a:off x="914400" y="2880360"/>
+            <a:ext cx="2103120" cy="2103120"/>
           </a:xfrm>
           <a:prstGeom prst="rect">
             <a:avLst/>
@@ -13996,118 +15262,40 @@
       </p:pic>
       <p:sp>
         <p:nvSpPr>
-          <p:cNvPr id="33" name="Text 25"/>
-          <p:cNvSpPr txBox="1"/>
-          <p:nvPr/>
-        </p:nvSpPr>
-        <p:spPr>
-          <a:xfrm>
-            <a:off x="457200" y="3566160"/>
-            <a:ext cx="3545738" cy="868680"/>
-          </a:xfrm>
-          <a:prstGeom prst="rect">
-            <a:avLst/>
-          </a:prstGeom>
-          <a:noFill/>
-          <a:ln/>
-        </p:spPr>
-        <p:txBody>
-          <a:bodyPr wrap="square" lIns="0" tIns="0" rIns="0" bIns="0" rtlCol="0" anchor="ctr"/>
-          <a:lstStyle/>
-          <a:p>
-            <a:pPr algn="ctr" indent="0" marL="0">
-              <a:buNone/>
-            </a:pPr>
-            <a:r>
-              <a:rPr lang="en-US" sz="5400" b="1" dirty="0">
-                <a:solidFill>
-                  <a:srgbClr val="8E2F3C"/>
-                </a:solidFill>
-                <a:latin typeface="IBM Plex Sans Arabic" pitchFamily="34" charset="0"/>
-                <a:ea typeface="IBM Plex Sans Arabic" pitchFamily="34" charset="-122"/>
-                <a:cs typeface="IBM Plex Sans Arabic" pitchFamily="34" charset="-120"/>
-              </a:rPr>
-              <a:t>دقائق</a:t>
-            </a:r>
-            <a:endParaRPr lang="en-US" sz="5400" dirty="0"/>
-          </a:p>
-        </p:txBody>
-      </p:sp>
-      <p:sp>
-        <p:nvSpPr>
-          <p:cNvPr id="34" name="Text 26"/>
-          <p:cNvSpPr txBox="1"/>
-          <p:nvPr/>
-        </p:nvSpPr>
-        <p:spPr>
-          <a:xfrm>
-            <a:off x="731520" y="4480560"/>
-            <a:ext cx="2997098" cy="411480"/>
-          </a:xfrm>
-          <a:prstGeom prst="rect">
-            <a:avLst/>
-          </a:prstGeom>
-          <a:noFill/>
-          <a:ln/>
-        </p:spPr>
-        <p:txBody>
-          <a:bodyPr wrap="square" lIns="0" tIns="0" rIns="0" bIns="0" rtlCol="0" anchor="ctr"/>
+          <p:cNvPr id="28" name="Text 20"/>
+          <p:cNvSpPr txBox="1"/>
+          <p:nvPr/>
+        </p:nvSpPr>
+        <p:spPr>
+          <a:xfrm>
+            <a:off x="640080" y="5212080"/>
+            <a:ext cx="2651760" cy="365760"/>
+          </a:xfrm>
+          <a:prstGeom prst="rect">
+            <a:avLst/>
+          </a:prstGeom>
+          <a:noFill/>
+          <a:ln/>
+        </p:spPr>
+        <p:txBody>
+          <a:bodyPr wrap="square" lIns="0" tIns="0" rIns="0" bIns="0" rtlCol="0" anchor="t"/>
           <a:lstStyle/>
           <a:p>
             <a:pPr rtl="1" algn="ctr" indent="0" marL="0">
               <a:buNone/>
             </a:pPr>
             <a:r>
-              <a:rPr lang="en-US" sz="1800" dirty="0">
-                <a:solidFill>
-                  <a:srgbClr val="21141A"/>
-                </a:solidFill>
-                <a:latin typeface="IBM Plex Sans Arabic" pitchFamily="34" charset="0"/>
-                <a:ea typeface="IBM Plex Sans Arabic" pitchFamily="34" charset="-122"/>
-                <a:cs typeface="IBM Plex Sans Arabic" pitchFamily="34" charset="-120"/>
-              </a:rPr>
-              <a:t>بدل أسابيع</a:t>
-            </a:r>
-            <a:endParaRPr lang="en-US" sz="1800" dirty="0"/>
-          </a:p>
-        </p:txBody>
-      </p:sp>
-      <p:sp>
-        <p:nvSpPr>
-          <p:cNvPr id="35" name="Text 27"/>
-          <p:cNvSpPr txBox="1"/>
-          <p:nvPr/>
-        </p:nvSpPr>
-        <p:spPr>
-          <a:xfrm>
-            <a:off x="457200" y="5349240"/>
-            <a:ext cx="11277295" cy="365760"/>
-          </a:xfrm>
-          <a:prstGeom prst="rect">
-            <a:avLst/>
-          </a:prstGeom>
-          <a:noFill/>
-          <a:ln/>
-        </p:spPr>
-        <p:txBody>
-          <a:bodyPr wrap="square" lIns="0" tIns="0" rIns="0" bIns="0" rtlCol="0" anchor="t"/>
-          <a:lstStyle/>
-          <a:p>
-            <a:pPr rtl="1" algn="ctr" indent="0" marL="0">
-              <a:buNone/>
-            </a:pPr>
-            <a:r>
-              <a:rPr lang="en-US" sz="1500" dirty="0">
-                <a:solidFill>
-                  <a:srgbClr val="7F6C72"/>
-                </a:solidFill>
-                <a:latin typeface="IBM Plex Sans Arabic" pitchFamily="34" charset="0"/>
-                <a:ea typeface="IBM Plex Sans Arabic" pitchFamily="34" charset="-122"/>
-                <a:cs typeface="IBM Plex Sans Arabic" pitchFamily="34" charset="-120"/>
-              </a:rPr>
-              <a:t>مثال: شركة افتراضية من 120 موظفاً</a:t>
-            </a:r>
-            <a:endParaRPr lang="en-US" sz="1500" dirty="0"/>
+              <a:rPr lang="en-US" sz="1600" b="1" dirty="0">
+                <a:solidFill>
+                  <a:srgbClr val="FBF6EE"/>
+                </a:solidFill>
+                <a:latin typeface="IBM Plex Sans Arabic" pitchFamily="34" charset="0"/>
+                <a:ea typeface="IBM Plex Sans Arabic" pitchFamily="34" charset="-122"/>
+                <a:cs typeface="IBM Plex Sans Arabic" pitchFamily="34" charset="-120"/>
+              </a:rPr>
+              <a:t>امسح وجرّب</a:t>
+            </a:r>
+            <a:endParaRPr lang="en-US" sz="1600" dirty="0"/>
           </a:p>
         </p:txBody>
       </p:sp>

</xml_diff>

<commit_message>
Pitch deck: business model as a short-word canvas
Co-Authored-By: Claude Opus 5.5 (1M context) <noreply@anthropic.com>
Claude-Session: https://claude.ai/code/session_011TSHxy9drUC1JZWNcfUL3E
</commit_message>
<xml_diff>
--- a/pitch/SSB_VentureX.pptx
+++ b/pitch/SSB_VentureX.pptx
@@ -12786,57 +12786,18 @@
       </p:sp>
       <p:sp>
         <p:nvSpPr>
-          <p:cNvPr id="22" name="Text 17"/>
-          <p:cNvSpPr txBox="1"/>
-          <p:nvPr/>
-        </p:nvSpPr>
-        <p:spPr>
-          <a:xfrm>
-            <a:off x="457200" y="1600200"/>
-            <a:ext cx="11277295" cy="731520"/>
-          </a:xfrm>
-          <a:prstGeom prst="rect">
-            <a:avLst/>
-          </a:prstGeom>
-          <a:noFill/>
-          <a:ln/>
-        </p:spPr>
-        <p:txBody>
-          <a:bodyPr wrap="square" lIns="0" tIns="0" rIns="0" bIns="0" rtlCol="0" anchor="ctr"/>
-          <a:lstStyle/>
-          <a:p>
-            <a:pPr rtl="1" algn="r" indent="0" marL="0">
-              <a:buNone/>
-            </a:pPr>
-            <a:r>
-              <a:rPr lang="en-US" sz="3400" b="1" dirty="0">
-                <a:solidFill>
-                  <a:srgbClr val="21141A"/>
-                </a:solidFill>
-                <a:latin typeface="IBM Plex Sans Arabic" pitchFamily="34" charset="0"/>
-                <a:ea typeface="IBM Plex Sans Arabic" pitchFamily="34" charset="-122"/>
-                <a:cs typeface="IBM Plex Sans Arabic" pitchFamily="34" charset="-120"/>
-              </a:rPr>
-              <a:t>ابدأ مجاناً، ثم ادفع لكل مورد</a:t>
-            </a:r>
-            <a:endParaRPr lang="en-US" sz="3400" dirty="0"/>
-          </a:p>
-        </p:txBody>
-      </p:sp>
-      <p:sp>
-        <p:nvSpPr>
-          <p:cNvPr id="23" name="Shape 18"/>
-          <p:cNvSpPr/>
-          <p:nvPr/>
-        </p:nvSpPr>
-        <p:spPr>
-          <a:xfrm>
-            <a:off x="8188757" y="2606040"/>
-            <a:ext cx="3545738" cy="2606040"/>
+          <p:cNvPr id="22" name="Shape 17"/>
+          <p:cNvSpPr/>
+          <p:nvPr/>
+        </p:nvSpPr>
+        <p:spPr>
+          <a:xfrm>
+            <a:off x="9566819" y="1554480"/>
+            <a:ext cx="2167677" cy="3017520"/>
           </a:xfrm>
           <a:prstGeom prst="roundRect">
             <a:avLst>
-              <a:gd name="adj" fmla="val 7018"/>
+              <a:gd name="adj" fmla="val 5906"/>
             </a:avLst>
           </a:prstGeom>
           <a:solidFill>
@@ -12852,7 +12813,7 @@
       </p:sp>
       <p:pic>
         <p:nvPicPr>
-          <p:cNvPr id="24" name="Image 3" descr="/tmp/claude-0/-home-claude/750ff410-f4aa-5276-9360-1e19d018b112/scratchpad/c/assets/i-gift-br.png">    </p:cNvPr>
+          <p:cNvPr id="23" name="Image 3" descr="/tmp/claude-0/-home-claude/750ff410-f4aa-5276-9360-1e19d018b112/scratchpad/c/assets/i-users-br.png">    </p:cNvPr>
           <p:cNvPicPr>
             <a:picLocks noChangeAspect="1"/>
           </p:cNvPicPr>
@@ -12866,8 +12827,8 @@
         </p:blipFill>
         <p:spPr>
           <a:xfrm>
-            <a:off x="9687306" y="2880360"/>
-            <a:ext cx="548640" cy="548640"/>
+            <a:off x="11240719" y="1709928"/>
+            <a:ext cx="310896" cy="310896"/>
           </a:xfrm>
           <a:prstGeom prst="rect">
             <a:avLst/>
@@ -12876,14 +12837,14 @@
       </p:pic>
       <p:sp>
         <p:nvSpPr>
-          <p:cNvPr id="25" name="Text 19"/>
-          <p:cNvSpPr txBox="1"/>
-          <p:nvPr/>
-        </p:nvSpPr>
-        <p:spPr>
-          <a:xfrm>
-            <a:off x="8188757" y="3520440"/>
-            <a:ext cx="3545738" cy="365760"/>
+          <p:cNvPr id="24" name="Text 18"/>
+          <p:cNvSpPr txBox="1"/>
+          <p:nvPr/>
+        </p:nvSpPr>
+        <p:spPr>
+          <a:xfrm>
+            <a:off x="9703979" y="1682496"/>
+            <a:ext cx="1481877" cy="365760"/>
           </a:xfrm>
           <a:prstGeom prst="rect">
             <a:avLst/>
@@ -12895,23 +12856,43 @@
           <a:bodyPr wrap="square" lIns="0" tIns="0" rIns="0" bIns="0" rtlCol="0" anchor="ctr"/>
           <a:lstStyle/>
           <a:p>
-            <a:pPr rtl="1" algn="ctr" indent="0" marL="0">
-              <a:buNone/>
-            </a:pPr>
-            <a:r>
-              <a:rPr lang="en-US" sz="1700" b="1" dirty="0">
-                <a:solidFill>
-                  <a:srgbClr val="7F6C72"/>
-                </a:solidFill>
-                <a:latin typeface="IBM Plex Sans Arabic" pitchFamily="34" charset="0"/>
-                <a:ea typeface="IBM Plex Sans Arabic" pitchFamily="34" charset="-122"/>
-                <a:cs typeface="IBM Plex Sans Arabic" pitchFamily="34" charset="-120"/>
-              </a:rPr>
-              <a:t>الفحص الأول</a:t>
-            </a:r>
-            <a:endParaRPr lang="en-US" sz="1700" dirty="0"/>
-          </a:p>
-        </p:txBody>
+            <a:pPr rtl="1" algn="r" indent="0" marL="0">
+              <a:buNone/>
+            </a:pPr>
+            <a:r>
+              <a:rPr lang="en-US" sz="1400" b="1" dirty="0">
+                <a:solidFill>
+                  <a:srgbClr val="8E2F3C"/>
+                </a:solidFill>
+                <a:latin typeface="IBM Plex Sans Arabic" pitchFamily="34" charset="0"/>
+                <a:ea typeface="IBM Plex Sans Arabic" pitchFamily="34" charset="-122"/>
+                <a:cs typeface="IBM Plex Sans Arabic" pitchFamily="34" charset="-120"/>
+              </a:rPr>
+              <a:t>شرائح العملاء</a:t>
+            </a:r>
+            <a:endParaRPr lang="en-US" sz="1400" dirty="0"/>
+          </a:p>
+        </p:txBody>
+      </p:sp>
+      <p:sp>
+        <p:nvSpPr>
+          <p:cNvPr id="25" name="Shape 19"/>
+          <p:cNvSpPr/>
+          <p:nvPr/>
+        </p:nvSpPr>
+        <p:spPr>
+          <a:xfrm>
+            <a:off x="11460175" y="2295144"/>
+            <a:ext cx="82296" cy="82296"/>
+          </a:xfrm>
+          <a:prstGeom prst="rect">
+            <a:avLst/>
+          </a:prstGeom>
+          <a:solidFill>
+            <a:srgbClr val="D48A93"/>
+          </a:solidFill>
+          <a:ln/>
+        </p:spPr>
       </p:sp>
       <p:sp>
         <p:nvSpPr>
@@ -12921,8 +12902,8 @@
         </p:nvSpPr>
         <p:spPr>
           <a:xfrm>
-            <a:off x="8188757" y="3886200"/>
-            <a:ext cx="3545738" cy="777240"/>
+            <a:off x="9703979" y="2176272"/>
+            <a:ext cx="1664757" cy="329184"/>
           </a:xfrm>
           <a:prstGeom prst="rect">
             <a:avLst/>
@@ -12934,34 +12915,54 @@
           <a:bodyPr wrap="square" lIns="0" tIns="0" rIns="0" bIns="0" rtlCol="0" anchor="ctr"/>
           <a:lstStyle/>
           <a:p>
-            <a:pPr rtl="1" algn="ctr" indent="0" marL="0">
-              <a:buNone/>
-            </a:pPr>
-            <a:r>
-              <a:rPr lang="en-US" sz="4000" b="1" dirty="0">
-                <a:solidFill>
-                  <a:srgbClr val="8E2F3C"/>
-                </a:solidFill>
-                <a:latin typeface="IBM Plex Sans Arabic" pitchFamily="34" charset="0"/>
-                <a:ea typeface="IBM Plex Sans Arabic" pitchFamily="34" charset="-122"/>
-                <a:cs typeface="IBM Plex Sans Arabic" pitchFamily="34" charset="-120"/>
-              </a:rPr>
-              <a:t>مجاني</a:t>
-            </a:r>
-            <a:endParaRPr lang="en-US" sz="4000" dirty="0"/>
-          </a:p>
-        </p:txBody>
-      </p:sp>
-      <p:sp>
-        <p:nvSpPr>
-          <p:cNvPr id="27" name="Text 21"/>
-          <p:cNvSpPr txBox="1"/>
-          <p:nvPr/>
-        </p:nvSpPr>
-        <p:spPr>
-          <a:xfrm>
-            <a:off x="8188757" y="4663440"/>
-            <a:ext cx="3545738" cy="365760"/>
+            <a:pPr rtl="1" algn="r" indent="0" marL="0">
+              <a:buNone/>
+            </a:pPr>
+            <a:r>
+              <a:rPr lang="en-US" sz="1350" dirty="0">
+                <a:solidFill>
+                  <a:srgbClr val="21141A"/>
+                </a:solidFill>
+                <a:latin typeface="IBM Plex Sans Arabic" pitchFamily="34" charset="0"/>
+                <a:ea typeface="IBM Plex Sans Arabic" pitchFamily="34" charset="-122"/>
+                <a:cs typeface="IBM Plex Sans Arabic" pitchFamily="34" charset="-120"/>
+              </a:rPr>
+              <a:t>شركات 50 إلى 250 موظفاً</a:t>
+            </a:r>
+            <a:endParaRPr lang="en-US" sz="1350" dirty="0"/>
+          </a:p>
+        </p:txBody>
+      </p:sp>
+      <p:sp>
+        <p:nvSpPr>
+          <p:cNvPr id="27" name="Shape 21"/>
+          <p:cNvSpPr/>
+          <p:nvPr/>
+        </p:nvSpPr>
+        <p:spPr>
+          <a:xfrm>
+            <a:off x="11460175" y="2660904"/>
+            <a:ext cx="82296" cy="82296"/>
+          </a:xfrm>
+          <a:prstGeom prst="rect">
+            <a:avLst/>
+          </a:prstGeom>
+          <a:solidFill>
+            <a:srgbClr val="D48A93"/>
+          </a:solidFill>
+          <a:ln/>
+        </p:spPr>
+      </p:sp>
+      <p:sp>
+        <p:nvSpPr>
+          <p:cNvPr id="28" name="Text 22"/>
+          <p:cNvSpPr txBox="1"/>
+          <p:nvPr/>
+        </p:nvSpPr>
+        <p:spPr>
+          <a:xfrm>
+            <a:off x="9703979" y="2542032"/>
+            <a:ext cx="1664757" cy="329184"/>
           </a:xfrm>
           <a:prstGeom prst="rect">
             <a:avLst/>
@@ -12973,11 +12974,11 @@
           <a:bodyPr wrap="square" lIns="0" tIns="0" rIns="0" bIns="0" rtlCol="0" anchor="ctr"/>
           <a:lstStyle/>
           <a:p>
-            <a:pPr rtl="1" algn="ctr" indent="0" marL="0">
-              <a:buNone/>
-            </a:pPr>
-            <a:r>
-              <a:rPr lang="en-US" sz="1600" dirty="0">
+            <a:pPr rtl="1" algn="r" indent="0" marL="0">
+              <a:buNone/>
+            </a:pPr>
+            <a:r>
+              <a:rPr lang="en-US" sz="1350" dirty="0">
                 <a:solidFill>
                   <a:srgbClr val="21141A"/>
                 </a:solidFill>
@@ -12985,37 +12986,101 @@
                 <a:ea typeface="IBM Plex Sans Arabic" pitchFamily="34" charset="-122"/>
                 <a:cs typeface="IBM Plex Sans Arabic" pitchFamily="34" charset="-120"/>
               </a:rPr>
-              <a:t>تقرير الهدر كاملاً</a:t>
-            </a:r>
-            <a:endParaRPr lang="en-US" sz="1600" dirty="0"/>
-          </a:p>
-        </p:txBody>
-      </p:sp>
-      <p:sp>
-        <p:nvSpPr>
-          <p:cNvPr id="28" name="Shape 22"/>
-          <p:cNvSpPr/>
-          <p:nvPr/>
-        </p:nvSpPr>
-        <p:spPr>
-          <a:xfrm>
-            <a:off x="4322978" y="2606040"/>
-            <a:ext cx="3545738" cy="2606040"/>
+              <a:t>شركات ناشئة</a:t>
+            </a:r>
+            <a:endParaRPr lang="en-US" sz="1350" dirty="0"/>
+          </a:p>
+        </p:txBody>
+      </p:sp>
+      <p:sp>
+        <p:nvSpPr>
+          <p:cNvPr id="29" name="Shape 23"/>
+          <p:cNvSpPr/>
+          <p:nvPr/>
+        </p:nvSpPr>
+        <p:spPr>
+          <a:xfrm>
+            <a:off x="11460175" y="3026664"/>
+            <a:ext cx="82296" cy="82296"/>
+          </a:xfrm>
+          <a:prstGeom prst="rect">
+            <a:avLst/>
+          </a:prstGeom>
+          <a:solidFill>
+            <a:srgbClr val="D48A93"/>
+          </a:solidFill>
+          <a:ln/>
+        </p:spPr>
+      </p:sp>
+      <p:sp>
+        <p:nvSpPr>
+          <p:cNvPr id="30" name="Text 24"/>
+          <p:cNvSpPr txBox="1"/>
+          <p:nvPr/>
+        </p:nvSpPr>
+        <p:spPr>
+          <a:xfrm>
+            <a:off x="9703979" y="2907792"/>
+            <a:ext cx="1664757" cy="329184"/>
+          </a:xfrm>
+          <a:prstGeom prst="rect">
+            <a:avLst/>
+          </a:prstGeom>
+          <a:noFill/>
+          <a:ln/>
+        </p:spPr>
+        <p:txBody>
+          <a:bodyPr wrap="square" lIns="0" tIns="0" rIns="0" bIns="0" rtlCol="0" anchor="ctr"/>
+          <a:lstStyle/>
+          <a:p>
+            <a:pPr rtl="1" algn="r" indent="0" marL="0">
+              <a:buNone/>
+            </a:pPr>
+            <a:r>
+              <a:rPr lang="en-US" sz="1350" dirty="0">
+                <a:solidFill>
+                  <a:srgbClr val="21141A"/>
+                </a:solidFill>
+                <a:latin typeface="IBM Plex Sans Arabic" pitchFamily="34" charset="0"/>
+                <a:ea typeface="IBM Plex Sans Arabic" pitchFamily="34" charset="-122"/>
+                <a:cs typeface="IBM Plex Sans Arabic" pitchFamily="34" charset="-120"/>
+              </a:rPr>
+              <a:t>بلا فريق FinOps</a:t>
+            </a:r>
+            <a:endParaRPr lang="en-US" sz="1350" dirty="0"/>
+          </a:p>
+        </p:txBody>
+      </p:sp>
+      <p:sp>
+        <p:nvSpPr>
+          <p:cNvPr id="31" name="Shape 25"/>
+          <p:cNvSpPr/>
+          <p:nvPr/>
+        </p:nvSpPr>
+        <p:spPr>
+          <a:xfrm>
+            <a:off x="7289414" y="1554480"/>
+            <a:ext cx="2167677" cy="1453896"/>
           </a:xfrm>
           <a:prstGeom prst="roundRect">
             <a:avLst>
-              <a:gd name="adj" fmla="val 7018"/>
+              <a:gd name="adj" fmla="val 8805"/>
             </a:avLst>
           </a:prstGeom>
           <a:solidFill>
-            <a:srgbClr val="8E2F3C"/>
-          </a:solidFill>
-          <a:ln/>
+            <a:srgbClr val="FFFBF8"/>
+          </a:solidFill>
+          <a:ln w="9525">
+            <a:solidFill>
+              <a:srgbClr val="E3D5CC"/>
+            </a:solidFill>
+            <a:prstDash val="solid"/>
+          </a:ln>
         </p:spPr>
       </p:sp>
       <p:pic>
         <p:nvPicPr>
-          <p:cNvPr id="29" name="Image 4" descr="/tmp/claude-0/-home-claude/750ff410-f4aa-5276-9360-1e19d018b112/scratchpad/c/assets/i-gauge-cr.png">    </p:cNvPr>
+          <p:cNvPr id="32" name="Image 4" descr="/tmp/claude-0/-home-claude/750ff410-f4aa-5276-9360-1e19d018b112/scratchpad/c/assets/i-msg-br.png">    </p:cNvPr>
           <p:cNvPicPr>
             <a:picLocks noChangeAspect="1"/>
           </p:cNvPicPr>
@@ -13029,8 +13094,8 @@
         </p:blipFill>
         <p:spPr>
           <a:xfrm>
-            <a:off x="5821528" y="2880360"/>
-            <a:ext cx="548640" cy="548640"/>
+            <a:off x="8963315" y="1709928"/>
+            <a:ext cx="310896" cy="310896"/>
           </a:xfrm>
           <a:prstGeom prst="rect">
             <a:avLst/>
@@ -13039,14 +13104,14 @@
       </p:pic>
       <p:sp>
         <p:nvSpPr>
-          <p:cNvPr id="30" name="Text 23"/>
-          <p:cNvSpPr txBox="1"/>
-          <p:nvPr/>
-        </p:nvSpPr>
-        <p:spPr>
-          <a:xfrm>
-            <a:off x="4322978" y="3520440"/>
-            <a:ext cx="3545738" cy="365760"/>
+          <p:cNvPr id="33" name="Text 26"/>
+          <p:cNvSpPr txBox="1"/>
+          <p:nvPr/>
+        </p:nvSpPr>
+        <p:spPr>
+          <a:xfrm>
+            <a:off x="7426574" y="1682496"/>
+            <a:ext cx="1481877" cy="365760"/>
           </a:xfrm>
           <a:prstGeom prst="rect">
             <a:avLst/>
@@ -13058,34 +13123,54 @@
           <a:bodyPr wrap="square" lIns="0" tIns="0" rIns="0" bIns="0" rtlCol="0" anchor="ctr"/>
           <a:lstStyle/>
           <a:p>
-            <a:pPr rtl="1" algn="ctr" indent="0" marL="0">
-              <a:buNone/>
-            </a:pPr>
-            <a:r>
-              <a:rPr lang="en-US" sz="1700" b="1" dirty="0">
-                <a:solidFill>
-                  <a:srgbClr val="F1E4DF"/>
-                </a:solidFill>
-                <a:latin typeface="IBM Plex Sans Arabic" pitchFamily="34" charset="0"/>
-                <a:ea typeface="IBM Plex Sans Arabic" pitchFamily="34" charset="-122"/>
-                <a:cs typeface="IBM Plex Sans Arabic" pitchFamily="34" charset="-120"/>
-              </a:rPr>
-              <a:t>حسب الاستخدام</a:t>
-            </a:r>
-            <a:endParaRPr lang="en-US" sz="1700" dirty="0"/>
-          </a:p>
-        </p:txBody>
-      </p:sp>
-      <p:sp>
-        <p:nvSpPr>
-          <p:cNvPr id="31" name="Text 24"/>
-          <p:cNvSpPr txBox="1"/>
-          <p:nvPr/>
-        </p:nvSpPr>
-        <p:spPr>
-          <a:xfrm>
-            <a:off x="4322978" y="3886200"/>
-            <a:ext cx="3545738" cy="777240"/>
+            <a:pPr rtl="1" algn="r" indent="0" marL="0">
+              <a:buNone/>
+            </a:pPr>
+            <a:r>
+              <a:rPr lang="en-US" sz="1400" b="1" dirty="0">
+                <a:solidFill>
+                  <a:srgbClr val="8E2F3C"/>
+                </a:solidFill>
+                <a:latin typeface="IBM Plex Sans Arabic" pitchFamily="34" charset="0"/>
+                <a:ea typeface="IBM Plex Sans Arabic" pitchFamily="34" charset="-122"/>
+                <a:cs typeface="IBM Plex Sans Arabic" pitchFamily="34" charset="-120"/>
+              </a:rPr>
+              <a:t>العلاقات مع العملاء</a:t>
+            </a:r>
+            <a:endParaRPr lang="en-US" sz="1400" dirty="0"/>
+          </a:p>
+        </p:txBody>
+      </p:sp>
+      <p:sp>
+        <p:nvSpPr>
+          <p:cNvPr id="34" name="Shape 27"/>
+          <p:cNvSpPr/>
+          <p:nvPr/>
+        </p:nvSpPr>
+        <p:spPr>
+          <a:xfrm>
+            <a:off x="9182771" y="2295144"/>
+            <a:ext cx="82296" cy="82296"/>
+          </a:xfrm>
+          <a:prstGeom prst="rect">
+            <a:avLst/>
+          </a:prstGeom>
+          <a:solidFill>
+            <a:srgbClr val="D48A93"/>
+          </a:solidFill>
+          <a:ln/>
+        </p:spPr>
+      </p:sp>
+      <p:sp>
+        <p:nvSpPr>
+          <p:cNvPr id="35" name="Text 28"/>
+          <p:cNvSpPr txBox="1"/>
+          <p:nvPr/>
+        </p:nvSpPr>
+        <p:spPr>
+          <a:xfrm>
+            <a:off x="7426574" y="2176272"/>
+            <a:ext cx="1664757" cy="329184"/>
           </a:xfrm>
           <a:prstGeom prst="rect">
             <a:avLst/>
@@ -13097,34 +13182,54 @@
           <a:bodyPr wrap="square" lIns="0" tIns="0" rIns="0" bIns="0" rtlCol="0" anchor="ctr"/>
           <a:lstStyle/>
           <a:p>
-            <a:pPr rtl="1" algn="ctr" indent="0" marL="0">
-              <a:buNone/>
-            </a:pPr>
-            <a:r>
-              <a:rPr lang="en-US" sz="4000" b="1" dirty="0">
-                <a:solidFill>
-                  <a:srgbClr val="FBF6EE"/>
-                </a:solidFill>
-                <a:latin typeface="IBM Plex Sans Arabic" pitchFamily="34" charset="0"/>
-                <a:ea typeface="IBM Plex Sans Arabic" pitchFamily="34" charset="-122"/>
-                <a:cs typeface="IBM Plex Sans Arabic" pitchFamily="34" charset="-120"/>
-              </a:rPr>
-              <a:t>من 15 ريال</a:t>
-            </a:r>
-            <a:endParaRPr lang="en-US" sz="4000" dirty="0"/>
-          </a:p>
-        </p:txBody>
-      </p:sp>
-      <p:sp>
-        <p:nvSpPr>
-          <p:cNvPr id="32" name="Text 25"/>
-          <p:cNvSpPr txBox="1"/>
-          <p:nvPr/>
-        </p:nvSpPr>
-        <p:spPr>
-          <a:xfrm>
-            <a:off x="4322978" y="4663440"/>
-            <a:ext cx="3545738" cy="365760"/>
+            <a:pPr rtl="1" algn="r" indent="0" marL="0">
+              <a:buNone/>
+            </a:pPr>
+            <a:r>
+              <a:rPr lang="en-US" sz="1250" dirty="0">
+                <a:solidFill>
+                  <a:srgbClr val="21141A"/>
+                </a:solidFill>
+                <a:latin typeface="IBM Plex Sans Arabic" pitchFamily="34" charset="0"/>
+                <a:ea typeface="IBM Plex Sans Arabic" pitchFamily="34" charset="-122"/>
+                <a:cs typeface="IBM Plex Sans Arabic" pitchFamily="34" charset="-120"/>
+              </a:rPr>
+              <a:t>تنبيهات واتساب</a:t>
+            </a:r>
+            <a:endParaRPr lang="en-US" sz="1250" dirty="0"/>
+          </a:p>
+        </p:txBody>
+      </p:sp>
+      <p:sp>
+        <p:nvSpPr>
+          <p:cNvPr id="36" name="Shape 29"/>
+          <p:cNvSpPr/>
+          <p:nvPr/>
+        </p:nvSpPr>
+        <p:spPr>
+          <a:xfrm>
+            <a:off x="9182771" y="2624328"/>
+            <a:ext cx="82296" cy="82296"/>
+          </a:xfrm>
+          <a:prstGeom prst="rect">
+            <a:avLst/>
+          </a:prstGeom>
+          <a:solidFill>
+            <a:srgbClr val="D48A93"/>
+          </a:solidFill>
+          <a:ln/>
+        </p:spPr>
+      </p:sp>
+      <p:sp>
+        <p:nvSpPr>
+          <p:cNvPr id="37" name="Text 30"/>
+          <p:cNvSpPr txBox="1"/>
+          <p:nvPr/>
+        </p:nvSpPr>
+        <p:spPr>
+          <a:xfrm>
+            <a:off x="7426574" y="2505456"/>
+            <a:ext cx="1664757" cy="329184"/>
           </a:xfrm>
           <a:prstGeom prst="rect">
             <a:avLst/>
@@ -13136,38 +13241,38 @@
           <a:bodyPr wrap="square" lIns="0" tIns="0" rIns="0" bIns="0" rtlCol="0" anchor="ctr"/>
           <a:lstStyle/>
           <a:p>
-            <a:pPr rtl="1" algn="ctr" indent="0" marL="0">
-              <a:buNone/>
-            </a:pPr>
-            <a:r>
-              <a:rPr lang="en-US" sz="1600" dirty="0">
-                <a:solidFill>
-                  <a:srgbClr val="FBF6EE"/>
-                </a:solidFill>
-                <a:latin typeface="IBM Plex Sans Arabic" pitchFamily="34" charset="0"/>
-                <a:ea typeface="IBM Plex Sans Arabic" pitchFamily="34" charset="-122"/>
-                <a:cs typeface="IBM Plex Sans Arabic" pitchFamily="34" charset="-120"/>
-              </a:rPr>
-              <a:t>لكل مورد شهرياً</a:t>
-            </a:r>
-            <a:endParaRPr lang="en-US" sz="1600" dirty="0"/>
-          </a:p>
-        </p:txBody>
-      </p:sp>
-      <p:sp>
-        <p:nvSpPr>
-          <p:cNvPr id="33" name="Shape 26"/>
-          <p:cNvSpPr/>
-          <p:nvPr/>
-        </p:nvSpPr>
-        <p:spPr>
-          <a:xfrm>
-            <a:off x="457200" y="2606040"/>
-            <a:ext cx="3545738" cy="2606040"/>
+            <a:pPr rtl="1" algn="r" indent="0" marL="0">
+              <a:buNone/>
+            </a:pPr>
+            <a:r>
+              <a:rPr lang="en-US" sz="1250" dirty="0">
+                <a:solidFill>
+                  <a:srgbClr val="21141A"/>
+                </a:solidFill>
+                <a:latin typeface="IBM Plex Sans Arabic" pitchFamily="34" charset="0"/>
+                <a:ea typeface="IBM Plex Sans Arabic" pitchFamily="34" charset="-122"/>
+                <a:cs typeface="IBM Plex Sans Arabic" pitchFamily="34" charset="-120"/>
+              </a:rPr>
+              <a:t>دعم بالعربي</a:t>
+            </a:r>
+            <a:endParaRPr lang="en-US" sz="1250" dirty="0"/>
+          </a:p>
+        </p:txBody>
+      </p:sp>
+      <p:sp>
+        <p:nvSpPr>
+          <p:cNvPr id="38" name="Shape 31"/>
+          <p:cNvSpPr/>
+          <p:nvPr/>
+        </p:nvSpPr>
+        <p:spPr>
+          <a:xfrm>
+            <a:off x="7289414" y="3118104"/>
+            <a:ext cx="2167677" cy="1453896"/>
           </a:xfrm>
           <a:prstGeom prst="roundRect">
             <a:avLst>
-              <a:gd name="adj" fmla="val 7018"/>
+              <a:gd name="adj" fmla="val 8805"/>
             </a:avLst>
           </a:prstGeom>
           <a:solidFill>
@@ -13183,7 +13288,7 @@
       </p:sp>
       <p:pic>
         <p:nvPicPr>
-          <p:cNvPr id="34" name="Image 5" descr="/tmp/claude-0/-home-claude/750ff410-f4aa-5276-9360-1e19d018b112/scratchpad/c/assets/i-handshake-br.png">    </p:cNvPr>
+          <p:cNvPr id="39" name="Image 5" descr="/tmp/claude-0/-home-claude/750ff410-f4aa-5276-9360-1e19d018b112/scratchpad/c/assets/i-mega-br.png">    </p:cNvPr>
           <p:cNvPicPr>
             <a:picLocks noChangeAspect="1"/>
           </p:cNvPicPr>
@@ -13197,8 +13302,8 @@
         </p:blipFill>
         <p:spPr>
           <a:xfrm>
-            <a:off x="1955749" y="2880360"/>
-            <a:ext cx="548640" cy="548640"/>
+            <a:off x="8963315" y="3273552"/>
+            <a:ext cx="310896" cy="310896"/>
           </a:xfrm>
           <a:prstGeom prst="rect">
             <a:avLst/>
@@ -13207,14 +13312,14 @@
       </p:pic>
       <p:sp>
         <p:nvSpPr>
-          <p:cNvPr id="35" name="Text 27"/>
-          <p:cNvSpPr txBox="1"/>
-          <p:nvPr/>
-        </p:nvSpPr>
-        <p:spPr>
-          <a:xfrm>
-            <a:off x="457200" y="3520440"/>
-            <a:ext cx="3545738" cy="365760"/>
+          <p:cNvPr id="40" name="Text 32"/>
+          <p:cNvSpPr txBox="1"/>
+          <p:nvPr/>
+        </p:nvSpPr>
+        <p:spPr>
+          <a:xfrm>
+            <a:off x="7426574" y="3246120"/>
+            <a:ext cx="1481877" cy="365760"/>
           </a:xfrm>
           <a:prstGeom prst="rect">
             <a:avLst/>
@@ -13226,34 +13331,54 @@
           <a:bodyPr wrap="square" lIns="0" tIns="0" rIns="0" bIns="0" rtlCol="0" anchor="ctr"/>
           <a:lstStyle/>
           <a:p>
-            <a:pPr rtl="1" algn="ctr" indent="0" marL="0">
-              <a:buNone/>
-            </a:pPr>
-            <a:r>
-              <a:rPr lang="en-US" sz="1700" b="1" dirty="0">
-                <a:solidFill>
-                  <a:srgbClr val="7F6C72"/>
-                </a:solidFill>
-                <a:latin typeface="IBM Plex Sans Arabic" pitchFamily="34" charset="0"/>
-                <a:ea typeface="IBM Plex Sans Arabic" pitchFamily="34" charset="-122"/>
-                <a:cs typeface="IBM Plex Sans Arabic" pitchFamily="34" charset="-120"/>
-              </a:rPr>
-              <a:t>استشارات FinOps</a:t>
-            </a:r>
-            <a:endParaRPr lang="en-US" sz="1700" dirty="0"/>
-          </a:p>
-        </p:txBody>
-      </p:sp>
-      <p:sp>
-        <p:nvSpPr>
-          <p:cNvPr id="36" name="Text 28"/>
-          <p:cNvSpPr txBox="1"/>
-          <p:nvPr/>
-        </p:nvSpPr>
-        <p:spPr>
-          <a:xfrm>
-            <a:off x="457200" y="3886200"/>
-            <a:ext cx="3545738" cy="777240"/>
+            <a:pPr rtl="1" algn="r" indent="0" marL="0">
+              <a:buNone/>
+            </a:pPr>
+            <a:r>
+              <a:rPr lang="en-US" sz="1400" b="1" dirty="0">
+                <a:solidFill>
+                  <a:srgbClr val="8E2F3C"/>
+                </a:solidFill>
+                <a:latin typeface="IBM Plex Sans Arabic" pitchFamily="34" charset="0"/>
+                <a:ea typeface="IBM Plex Sans Arabic" pitchFamily="34" charset="-122"/>
+                <a:cs typeface="IBM Plex Sans Arabic" pitchFamily="34" charset="-120"/>
+              </a:rPr>
+              <a:t>القنوات</a:t>
+            </a:r>
+            <a:endParaRPr lang="en-US" sz="1400" dirty="0"/>
+          </a:p>
+        </p:txBody>
+      </p:sp>
+      <p:sp>
+        <p:nvSpPr>
+          <p:cNvPr id="41" name="Shape 33"/>
+          <p:cNvSpPr/>
+          <p:nvPr/>
+        </p:nvSpPr>
+        <p:spPr>
+          <a:xfrm>
+            <a:off x="9182771" y="3858768"/>
+            <a:ext cx="82296" cy="82296"/>
+          </a:xfrm>
+          <a:prstGeom prst="rect">
+            <a:avLst/>
+          </a:prstGeom>
+          <a:solidFill>
+            <a:srgbClr val="D48A93"/>
+          </a:solidFill>
+          <a:ln/>
+        </p:spPr>
+      </p:sp>
+      <p:sp>
+        <p:nvSpPr>
+          <p:cNvPr id="42" name="Text 34"/>
+          <p:cNvSpPr txBox="1"/>
+          <p:nvPr/>
+        </p:nvSpPr>
+        <p:spPr>
+          <a:xfrm>
+            <a:off x="7426574" y="3739896"/>
+            <a:ext cx="1664757" cy="329184"/>
           </a:xfrm>
           <a:prstGeom prst="rect">
             <a:avLst/>
@@ -13265,11 +13390,481 @@
           <a:bodyPr wrap="square" lIns="0" tIns="0" rIns="0" bIns="0" rtlCol="0" anchor="ctr"/>
           <a:lstStyle/>
           <a:p>
-            <a:pPr rtl="1" algn="ctr" indent="0" marL="0">
-              <a:buNone/>
-            </a:pPr>
-            <a:r>
-              <a:rPr lang="en-US" sz="4000" b="1" dirty="0">
+            <a:pPr rtl="1" algn="r" indent="0" marL="0">
+              <a:buNone/>
+            </a:pPr>
+            <a:r>
+              <a:rPr lang="en-US" sz="1250" dirty="0">
+                <a:solidFill>
+                  <a:srgbClr val="21141A"/>
+                </a:solidFill>
+                <a:latin typeface="IBM Plex Sans Arabic" pitchFamily="34" charset="0"/>
+                <a:ea typeface="IBM Plex Sans Arabic" pitchFamily="34" charset="-122"/>
+                <a:cs typeface="IBM Plex Sans Arabic" pitchFamily="34" charset="-120"/>
+              </a:rPr>
+              <a:t>الموقع والفحص المجاني</a:t>
+            </a:r>
+            <a:endParaRPr lang="en-US" sz="1250" dirty="0"/>
+          </a:p>
+        </p:txBody>
+      </p:sp>
+      <p:sp>
+        <p:nvSpPr>
+          <p:cNvPr id="43" name="Shape 35"/>
+          <p:cNvSpPr/>
+          <p:nvPr/>
+        </p:nvSpPr>
+        <p:spPr>
+          <a:xfrm>
+            <a:off x="9182771" y="4187952"/>
+            <a:ext cx="82296" cy="82296"/>
+          </a:xfrm>
+          <a:prstGeom prst="rect">
+            <a:avLst/>
+          </a:prstGeom>
+          <a:solidFill>
+            <a:srgbClr val="D48A93"/>
+          </a:solidFill>
+          <a:ln/>
+        </p:spPr>
+      </p:sp>
+      <p:sp>
+        <p:nvSpPr>
+          <p:cNvPr id="44" name="Text 36"/>
+          <p:cNvSpPr txBox="1"/>
+          <p:nvPr/>
+        </p:nvSpPr>
+        <p:spPr>
+          <a:xfrm>
+            <a:off x="7426574" y="4069080"/>
+            <a:ext cx="1664757" cy="329184"/>
+          </a:xfrm>
+          <a:prstGeom prst="rect">
+            <a:avLst/>
+          </a:prstGeom>
+          <a:noFill/>
+          <a:ln/>
+        </p:spPr>
+        <p:txBody>
+          <a:bodyPr wrap="square" lIns="0" tIns="0" rIns="0" bIns="0" rtlCol="0" anchor="ctr"/>
+          <a:lstStyle/>
+          <a:p>
+            <a:pPr rtl="1" algn="r" indent="0" marL="0">
+              <a:buNone/>
+            </a:pPr>
+            <a:r>
+              <a:rPr lang="en-US" sz="1250" dirty="0">
+                <a:solidFill>
+                  <a:srgbClr val="21141A"/>
+                </a:solidFill>
+                <a:latin typeface="IBM Plex Sans Arabic" pitchFamily="34" charset="0"/>
+                <a:ea typeface="IBM Plex Sans Arabic" pitchFamily="34" charset="-122"/>
+                <a:cs typeface="IBM Plex Sans Arabic" pitchFamily="34" charset="-120"/>
+              </a:rPr>
+              <a:t>شركاء السحابة</a:t>
+            </a:r>
+            <a:endParaRPr lang="en-US" sz="1250" dirty="0"/>
+          </a:p>
+        </p:txBody>
+      </p:sp>
+      <p:sp>
+        <p:nvSpPr>
+          <p:cNvPr id="45" name="Shape 37"/>
+          <p:cNvSpPr/>
+          <p:nvPr/>
+        </p:nvSpPr>
+        <p:spPr>
+          <a:xfrm>
+            <a:off x="5012009" y="1554480"/>
+            <a:ext cx="2167677" cy="3017520"/>
+          </a:xfrm>
+          <a:prstGeom prst="roundRect">
+            <a:avLst>
+              <a:gd name="adj" fmla="val 5906"/>
+            </a:avLst>
+          </a:prstGeom>
+          <a:solidFill>
+            <a:srgbClr val="8E2F3C"/>
+          </a:solidFill>
+          <a:ln/>
+        </p:spPr>
+      </p:sp>
+      <p:pic>
+        <p:nvPicPr>
+          <p:cNvPr id="46" name="Image 6" descr="/tmp/claude-0/-home-claude/750ff410-f4aa-5276-9360-1e19d018b112/scratchpad/c/assets/i-gem-cr.png">    </p:cNvPr>
+          <p:cNvPicPr>
+            <a:picLocks noChangeAspect="1"/>
+          </p:cNvPicPr>
+          <p:nvPr/>
+        </p:nvPicPr>
+        <p:blipFill>
+          <a:blip r:embed="rId7"/>
+          <a:stretch>
+            <a:fillRect/>
+          </a:stretch>
+        </p:blipFill>
+        <p:spPr>
+          <a:xfrm>
+            <a:off x="6685910" y="1709928"/>
+            <a:ext cx="310896" cy="310896"/>
+          </a:xfrm>
+          <a:prstGeom prst="rect">
+            <a:avLst/>
+          </a:prstGeom>
+        </p:spPr>
+      </p:pic>
+      <p:sp>
+        <p:nvSpPr>
+          <p:cNvPr id="47" name="Text 38"/>
+          <p:cNvSpPr txBox="1"/>
+          <p:nvPr/>
+        </p:nvSpPr>
+        <p:spPr>
+          <a:xfrm>
+            <a:off x="5149169" y="1682496"/>
+            <a:ext cx="1481877" cy="365760"/>
+          </a:xfrm>
+          <a:prstGeom prst="rect">
+            <a:avLst/>
+          </a:prstGeom>
+          <a:noFill/>
+          <a:ln/>
+        </p:spPr>
+        <p:txBody>
+          <a:bodyPr wrap="square" lIns="0" tIns="0" rIns="0" bIns="0" rtlCol="0" anchor="ctr"/>
+          <a:lstStyle/>
+          <a:p>
+            <a:pPr rtl="1" algn="r" indent="0" marL="0">
+              <a:buNone/>
+            </a:pPr>
+            <a:r>
+              <a:rPr lang="en-US" sz="1400" b="1" dirty="0">
+                <a:solidFill>
+                  <a:srgbClr val="FBF6EE"/>
+                </a:solidFill>
+                <a:latin typeface="IBM Plex Sans Arabic" pitchFamily="34" charset="0"/>
+                <a:ea typeface="IBM Plex Sans Arabic" pitchFamily="34" charset="-122"/>
+                <a:cs typeface="IBM Plex Sans Arabic" pitchFamily="34" charset="-120"/>
+              </a:rPr>
+              <a:t>القيم المقترحة</a:t>
+            </a:r>
+            <a:endParaRPr lang="en-US" sz="1400" dirty="0"/>
+          </a:p>
+        </p:txBody>
+      </p:sp>
+      <p:sp>
+        <p:nvSpPr>
+          <p:cNvPr id="48" name="Shape 39"/>
+          <p:cNvSpPr/>
+          <p:nvPr/>
+        </p:nvSpPr>
+        <p:spPr>
+          <a:xfrm>
+            <a:off x="6905366" y="2295144"/>
+            <a:ext cx="82296" cy="82296"/>
+          </a:xfrm>
+          <a:prstGeom prst="rect">
+            <a:avLst/>
+          </a:prstGeom>
+          <a:solidFill>
+            <a:srgbClr val="C9A46E"/>
+          </a:solidFill>
+          <a:ln/>
+        </p:spPr>
+      </p:sp>
+      <p:sp>
+        <p:nvSpPr>
+          <p:cNvPr id="49" name="Text 40"/>
+          <p:cNvSpPr txBox="1"/>
+          <p:nvPr/>
+        </p:nvSpPr>
+        <p:spPr>
+          <a:xfrm>
+            <a:off x="5149169" y="2176272"/>
+            <a:ext cx="1664757" cy="329184"/>
+          </a:xfrm>
+          <a:prstGeom prst="rect">
+            <a:avLst/>
+          </a:prstGeom>
+          <a:noFill/>
+          <a:ln/>
+        </p:spPr>
+        <p:txBody>
+          <a:bodyPr wrap="square" lIns="0" tIns="0" rIns="0" bIns="0" rtlCol="0" anchor="ctr"/>
+          <a:lstStyle/>
+          <a:p>
+            <a:pPr rtl="1" algn="r" indent="0" marL="0">
+              <a:buNone/>
+            </a:pPr>
+            <a:r>
+              <a:rPr lang="en-US" sz="1350" dirty="0">
+                <a:solidFill>
+                  <a:srgbClr val="FBF6EE"/>
+                </a:solidFill>
+                <a:latin typeface="IBM Plex Sans Arabic" pitchFamily="34" charset="0"/>
+                <a:ea typeface="IBM Plex Sans Arabic" pitchFamily="34" charset="-122"/>
+                <a:cs typeface="IBM Plex Sans Arabic" pitchFamily="34" charset="-120"/>
+              </a:rPr>
+              <a:t>فاتورة سحابة أقل</a:t>
+            </a:r>
+            <a:endParaRPr lang="en-US" sz="1350" dirty="0"/>
+          </a:p>
+        </p:txBody>
+      </p:sp>
+      <p:sp>
+        <p:nvSpPr>
+          <p:cNvPr id="50" name="Shape 41"/>
+          <p:cNvSpPr/>
+          <p:nvPr/>
+        </p:nvSpPr>
+        <p:spPr>
+          <a:xfrm>
+            <a:off x="6905366" y="2660904"/>
+            <a:ext cx="82296" cy="82296"/>
+          </a:xfrm>
+          <a:prstGeom prst="rect">
+            <a:avLst/>
+          </a:prstGeom>
+          <a:solidFill>
+            <a:srgbClr val="C9A46E"/>
+          </a:solidFill>
+          <a:ln/>
+        </p:spPr>
+      </p:sp>
+      <p:sp>
+        <p:nvSpPr>
+          <p:cNvPr id="51" name="Text 42"/>
+          <p:cNvSpPr txBox="1"/>
+          <p:nvPr/>
+        </p:nvSpPr>
+        <p:spPr>
+          <a:xfrm>
+            <a:off x="5149169" y="2542032"/>
+            <a:ext cx="1664757" cy="329184"/>
+          </a:xfrm>
+          <a:prstGeom prst="rect">
+            <a:avLst/>
+          </a:prstGeom>
+          <a:noFill/>
+          <a:ln/>
+        </p:spPr>
+        <p:txBody>
+          <a:bodyPr wrap="square" lIns="0" tIns="0" rIns="0" bIns="0" rtlCol="0" anchor="ctr"/>
+          <a:lstStyle/>
+          <a:p>
+            <a:pPr rtl="1" algn="r" indent="0" marL="0">
+              <a:buNone/>
+            </a:pPr>
+            <a:r>
+              <a:rPr lang="en-US" sz="1350" dirty="0">
+                <a:solidFill>
+                  <a:srgbClr val="FBF6EE"/>
+                </a:solidFill>
+                <a:latin typeface="IBM Plex Sans Arabic" pitchFamily="34" charset="0"/>
+                <a:ea typeface="IBM Plex Sans Arabic" pitchFamily="34" charset="-122"/>
+                <a:cs typeface="IBM Plex Sans Arabic" pitchFamily="34" charset="-120"/>
+              </a:rPr>
+              <a:t>قراءة فقط وآمن</a:t>
+            </a:r>
+            <a:endParaRPr lang="en-US" sz="1350" dirty="0"/>
+          </a:p>
+        </p:txBody>
+      </p:sp>
+      <p:sp>
+        <p:nvSpPr>
+          <p:cNvPr id="52" name="Shape 43"/>
+          <p:cNvSpPr/>
+          <p:nvPr/>
+        </p:nvSpPr>
+        <p:spPr>
+          <a:xfrm>
+            <a:off x="6905366" y="3026664"/>
+            <a:ext cx="82296" cy="82296"/>
+          </a:xfrm>
+          <a:prstGeom prst="rect">
+            <a:avLst/>
+          </a:prstGeom>
+          <a:solidFill>
+            <a:srgbClr val="C9A46E"/>
+          </a:solidFill>
+          <a:ln/>
+        </p:spPr>
+      </p:sp>
+      <p:sp>
+        <p:nvSpPr>
+          <p:cNvPr id="53" name="Text 44"/>
+          <p:cNvSpPr txBox="1"/>
+          <p:nvPr/>
+        </p:nvSpPr>
+        <p:spPr>
+          <a:xfrm>
+            <a:off x="5149169" y="2907792"/>
+            <a:ext cx="1664757" cy="329184"/>
+          </a:xfrm>
+          <a:prstGeom prst="rect">
+            <a:avLst/>
+          </a:prstGeom>
+          <a:noFill/>
+          <a:ln/>
+        </p:spPr>
+        <p:txBody>
+          <a:bodyPr wrap="square" lIns="0" tIns="0" rIns="0" bIns="0" rtlCol="0" anchor="ctr"/>
+          <a:lstStyle/>
+          <a:p>
+            <a:pPr rtl="1" algn="r" indent="0" marL="0">
+              <a:buNone/>
+            </a:pPr>
+            <a:r>
+              <a:rPr lang="en-US" sz="1350" dirty="0">
+                <a:solidFill>
+                  <a:srgbClr val="FBF6EE"/>
+                </a:solidFill>
+                <a:latin typeface="IBM Plex Sans Arabic" pitchFamily="34" charset="0"/>
+                <a:ea typeface="IBM Plex Sans Arabic" pitchFamily="34" charset="-122"/>
+                <a:cs typeface="IBM Plex Sans Arabic" pitchFamily="34" charset="-120"/>
+              </a:rPr>
+              <a:t>تنفيذ بموافقتك</a:t>
+            </a:r>
+            <a:endParaRPr lang="en-US" sz="1350" dirty="0"/>
+          </a:p>
+        </p:txBody>
+      </p:sp>
+      <p:sp>
+        <p:nvSpPr>
+          <p:cNvPr id="54" name="Shape 45"/>
+          <p:cNvSpPr/>
+          <p:nvPr/>
+        </p:nvSpPr>
+        <p:spPr>
+          <a:xfrm>
+            <a:off x="6905366" y="3392424"/>
+            <a:ext cx="82296" cy="82296"/>
+          </a:xfrm>
+          <a:prstGeom prst="rect">
+            <a:avLst/>
+          </a:prstGeom>
+          <a:solidFill>
+            <a:srgbClr val="C9A46E"/>
+          </a:solidFill>
+          <a:ln/>
+        </p:spPr>
+      </p:sp>
+      <p:sp>
+        <p:nvSpPr>
+          <p:cNvPr id="55" name="Text 46"/>
+          <p:cNvSpPr txBox="1"/>
+          <p:nvPr/>
+        </p:nvSpPr>
+        <p:spPr>
+          <a:xfrm>
+            <a:off x="5149169" y="3273552"/>
+            <a:ext cx="1664757" cy="329184"/>
+          </a:xfrm>
+          <a:prstGeom prst="rect">
+            <a:avLst/>
+          </a:prstGeom>
+          <a:noFill/>
+          <a:ln/>
+        </p:spPr>
+        <p:txBody>
+          <a:bodyPr wrap="square" lIns="0" tIns="0" rIns="0" bIns="0" rtlCol="0" anchor="ctr"/>
+          <a:lstStyle/>
+          <a:p>
+            <a:pPr rtl="1" algn="r" indent="0" marL="0">
+              <a:buNone/>
+            </a:pPr>
+            <a:r>
+              <a:rPr lang="en-US" sz="1350" dirty="0">
+                <a:solidFill>
+                  <a:srgbClr val="FBF6EE"/>
+                </a:solidFill>
+                <a:latin typeface="IBM Plex Sans Arabic" pitchFamily="34" charset="0"/>
+                <a:ea typeface="IBM Plex Sans Arabic" pitchFamily="34" charset="-122"/>
+                <a:cs typeface="IBM Plex Sans Arabic" pitchFamily="34" charset="-120"/>
+              </a:rPr>
+              <a:t>السحب المحلية والعالمية</a:t>
+            </a:r>
+            <a:endParaRPr lang="en-US" sz="1350" dirty="0"/>
+          </a:p>
+        </p:txBody>
+      </p:sp>
+      <p:sp>
+        <p:nvSpPr>
+          <p:cNvPr id="56" name="Shape 47"/>
+          <p:cNvSpPr/>
+          <p:nvPr/>
+        </p:nvSpPr>
+        <p:spPr>
+          <a:xfrm>
+            <a:off x="2734605" y="1554480"/>
+            <a:ext cx="2167677" cy="1453896"/>
+          </a:xfrm>
+          <a:prstGeom prst="roundRect">
+            <a:avLst>
+              <a:gd name="adj" fmla="val 8805"/>
+            </a:avLst>
+          </a:prstGeom>
+          <a:solidFill>
+            <a:srgbClr val="FFFBF8"/>
+          </a:solidFill>
+          <a:ln w="9525">
+            <a:solidFill>
+              <a:srgbClr val="E3D5CC"/>
+            </a:solidFill>
+            <a:prstDash val="solid"/>
+          </a:ln>
+        </p:spPr>
+      </p:sp>
+      <p:pic>
+        <p:nvPicPr>
+          <p:cNvPr id="57" name="Image 7" descr="/tmp/claude-0/-home-claude/750ff410-f4aa-5276-9360-1e19d018b112/scratchpad/c/assets/i-act-br.png">    </p:cNvPr>
+          <p:cNvPicPr>
+            <a:picLocks noChangeAspect="1"/>
+          </p:cNvPicPr>
+          <p:nvPr/>
+        </p:nvPicPr>
+        <p:blipFill>
+          <a:blip r:embed="rId8"/>
+          <a:stretch>
+            <a:fillRect/>
+          </a:stretch>
+        </p:blipFill>
+        <p:spPr>
+          <a:xfrm>
+            <a:off x="4408505" y="1709928"/>
+            <a:ext cx="310896" cy="310896"/>
+          </a:xfrm>
+          <a:prstGeom prst="rect">
+            <a:avLst/>
+          </a:prstGeom>
+        </p:spPr>
+      </p:pic>
+      <p:sp>
+        <p:nvSpPr>
+          <p:cNvPr id="58" name="Text 48"/>
+          <p:cNvSpPr txBox="1"/>
+          <p:nvPr/>
+        </p:nvSpPr>
+        <p:spPr>
+          <a:xfrm>
+            <a:off x="2871765" y="1682496"/>
+            <a:ext cx="1481877" cy="365760"/>
+          </a:xfrm>
+          <a:prstGeom prst="rect">
+            <a:avLst/>
+          </a:prstGeom>
+          <a:noFill/>
+          <a:ln/>
+        </p:spPr>
+        <p:txBody>
+          <a:bodyPr wrap="square" lIns="0" tIns="0" rIns="0" bIns="0" rtlCol="0" anchor="ctr"/>
+          <a:lstStyle/>
+          <a:p>
+            <a:pPr rtl="1" algn="r" indent="0" marL="0">
+              <a:buNone/>
+            </a:pPr>
+            <a:r>
+              <a:rPr lang="en-US" sz="1400" b="1" dirty="0">
                 <a:solidFill>
                   <a:srgbClr val="8E2F3C"/>
                 </a:solidFill>
@@ -13277,22 +13872,42 @@
                 <a:ea typeface="IBM Plex Sans Arabic" pitchFamily="34" charset="-122"/>
                 <a:cs typeface="IBM Plex Sans Arabic" pitchFamily="34" charset="-120"/>
               </a:rPr>
-              <a:t>حسب المشروع</a:t>
-            </a:r>
-            <a:endParaRPr lang="en-US" sz="4000" dirty="0"/>
-          </a:p>
-        </p:txBody>
-      </p:sp>
-      <p:sp>
-        <p:nvSpPr>
-          <p:cNvPr id="37" name="Text 29"/>
-          <p:cNvSpPr txBox="1"/>
-          <p:nvPr/>
-        </p:nvSpPr>
-        <p:spPr>
-          <a:xfrm>
-            <a:off x="457200" y="4663440"/>
-            <a:ext cx="3545738" cy="365760"/>
+              <a:t>الأنشطة الرئيسية</a:t>
+            </a:r>
+            <a:endParaRPr lang="en-US" sz="1400" dirty="0"/>
+          </a:p>
+        </p:txBody>
+      </p:sp>
+      <p:sp>
+        <p:nvSpPr>
+          <p:cNvPr id="59" name="Shape 49"/>
+          <p:cNvSpPr/>
+          <p:nvPr/>
+        </p:nvSpPr>
+        <p:spPr>
+          <a:xfrm>
+            <a:off x="4627961" y="2295144"/>
+            <a:ext cx="82296" cy="82296"/>
+          </a:xfrm>
+          <a:prstGeom prst="rect">
+            <a:avLst/>
+          </a:prstGeom>
+          <a:solidFill>
+            <a:srgbClr val="D48A93"/>
+          </a:solidFill>
+          <a:ln/>
+        </p:spPr>
+      </p:sp>
+      <p:sp>
+        <p:nvSpPr>
+          <p:cNvPr id="60" name="Text 50"/>
+          <p:cNvSpPr txBox="1"/>
+          <p:nvPr/>
+        </p:nvSpPr>
+        <p:spPr>
+          <a:xfrm>
+            <a:off x="2871765" y="2176272"/>
+            <a:ext cx="1664757" cy="329184"/>
           </a:xfrm>
           <a:prstGeom prst="rect">
             <a:avLst/>
@@ -13304,11 +13919,11 @@
           <a:bodyPr wrap="square" lIns="0" tIns="0" rIns="0" bIns="0" rtlCol="0" anchor="ctr"/>
           <a:lstStyle/>
           <a:p>
-            <a:pPr rtl="1" algn="ctr" indent="0" marL="0">
-              <a:buNone/>
-            </a:pPr>
-            <a:r>
-              <a:rPr lang="en-US" sz="1600" dirty="0">
+            <a:pPr rtl="1" algn="r" indent="0" marL="0">
+              <a:buNone/>
+            </a:pPr>
+            <a:r>
+              <a:rPr lang="en-US" sz="1250" dirty="0">
                 <a:solidFill>
                   <a:srgbClr val="21141A"/>
                 </a:solidFill>
@@ -13316,22 +13931,42 @@
                 <a:ea typeface="IBM Plex Sans Arabic" pitchFamily="34" charset="-122"/>
                 <a:cs typeface="IBM Plex Sans Arabic" pitchFamily="34" charset="-120"/>
               </a:rPr>
-              <a:t>مهندس FinOps مخصص</a:t>
-            </a:r>
-            <a:endParaRPr lang="en-US" sz="1600" dirty="0"/>
-          </a:p>
-        </p:txBody>
-      </p:sp>
-      <p:sp>
-        <p:nvSpPr>
-          <p:cNvPr id="38" name="Text 30"/>
-          <p:cNvSpPr txBox="1"/>
-          <p:nvPr/>
-        </p:nvSpPr>
-        <p:spPr>
-          <a:xfrm>
-            <a:off x="457200" y="5486400"/>
-            <a:ext cx="11277295" cy="411480"/>
+              <a:t>كشف الهدر وتحليله</a:t>
+            </a:r>
+            <a:endParaRPr lang="en-US" sz="1250" dirty="0"/>
+          </a:p>
+        </p:txBody>
+      </p:sp>
+      <p:sp>
+        <p:nvSpPr>
+          <p:cNvPr id="61" name="Shape 51"/>
+          <p:cNvSpPr/>
+          <p:nvPr/>
+        </p:nvSpPr>
+        <p:spPr>
+          <a:xfrm>
+            <a:off x="4627961" y="2624328"/>
+            <a:ext cx="82296" cy="82296"/>
+          </a:xfrm>
+          <a:prstGeom prst="rect">
+            <a:avLst/>
+          </a:prstGeom>
+          <a:solidFill>
+            <a:srgbClr val="D48A93"/>
+          </a:solidFill>
+          <a:ln/>
+        </p:spPr>
+      </p:sp>
+      <p:sp>
+        <p:nvSpPr>
+          <p:cNvPr id="62" name="Text 52"/>
+          <p:cNvSpPr txBox="1"/>
+          <p:nvPr/>
+        </p:nvSpPr>
+        <p:spPr>
+          <a:xfrm>
+            <a:off x="2871765" y="2505456"/>
+            <a:ext cx="1664757" cy="329184"/>
           </a:xfrm>
           <a:prstGeom prst="rect">
             <a:avLst/>
@@ -13343,11 +13978,101 @@
           <a:bodyPr wrap="square" lIns="0" tIns="0" rIns="0" bIns="0" rtlCol="0" anchor="ctr"/>
           <a:lstStyle/>
           <a:p>
-            <a:pPr rtl="1" algn="ctr" indent="0" marL="0">
-              <a:buNone/>
-            </a:pPr>
-            <a:r>
-              <a:rPr lang="en-US" sz="1800" b="1" dirty="0">
+            <a:pPr rtl="1" algn="r" indent="0" marL="0">
+              <a:buNone/>
+            </a:pPr>
+            <a:r>
+              <a:rPr lang="en-US" sz="1250" dirty="0">
+                <a:solidFill>
+                  <a:srgbClr val="21141A"/>
+                </a:solidFill>
+                <a:latin typeface="IBM Plex Sans Arabic" pitchFamily="34" charset="0"/>
+                <a:ea typeface="IBM Plex Sans Arabic" pitchFamily="34" charset="-122"/>
+                <a:cs typeface="IBM Plex Sans Arabic" pitchFamily="34" charset="-120"/>
+              </a:rPr>
+              <a:t>تطوير المنصة</a:t>
+            </a:r>
+            <a:endParaRPr lang="en-US" sz="1250" dirty="0"/>
+          </a:p>
+        </p:txBody>
+      </p:sp>
+      <p:sp>
+        <p:nvSpPr>
+          <p:cNvPr id="63" name="Shape 53"/>
+          <p:cNvSpPr/>
+          <p:nvPr/>
+        </p:nvSpPr>
+        <p:spPr>
+          <a:xfrm>
+            <a:off x="2734605" y="3118104"/>
+            <a:ext cx="2167677" cy="1453896"/>
+          </a:xfrm>
+          <a:prstGeom prst="roundRect">
+            <a:avLst>
+              <a:gd name="adj" fmla="val 8805"/>
+            </a:avLst>
+          </a:prstGeom>
+          <a:solidFill>
+            <a:srgbClr val="FFFBF8"/>
+          </a:solidFill>
+          <a:ln w="9525">
+            <a:solidFill>
+              <a:srgbClr val="E3D5CC"/>
+            </a:solidFill>
+            <a:prstDash val="solid"/>
+          </a:ln>
+        </p:spPr>
+      </p:sp>
+      <p:pic>
+        <p:nvPicPr>
+          <p:cNvPr id="64" name="Image 8" descr="/tmp/claude-0/-home-claude/750ff410-f4aa-5276-9360-1e19d018b112/scratchpad/c/assets/i-box-br.png">    </p:cNvPr>
+          <p:cNvPicPr>
+            <a:picLocks noChangeAspect="1"/>
+          </p:cNvPicPr>
+          <p:nvPr/>
+        </p:nvPicPr>
+        <p:blipFill>
+          <a:blip r:embed="rId9"/>
+          <a:stretch>
+            <a:fillRect/>
+          </a:stretch>
+        </p:blipFill>
+        <p:spPr>
+          <a:xfrm>
+            <a:off x="4408505" y="3273552"/>
+            <a:ext cx="310896" cy="310896"/>
+          </a:xfrm>
+          <a:prstGeom prst="rect">
+            <a:avLst/>
+          </a:prstGeom>
+        </p:spPr>
+      </p:pic>
+      <p:sp>
+        <p:nvSpPr>
+          <p:cNvPr id="65" name="Text 54"/>
+          <p:cNvSpPr txBox="1"/>
+          <p:nvPr/>
+        </p:nvSpPr>
+        <p:spPr>
+          <a:xfrm>
+            <a:off x="2871765" y="3246120"/>
+            <a:ext cx="1481877" cy="365760"/>
+          </a:xfrm>
+          <a:prstGeom prst="rect">
+            <a:avLst/>
+          </a:prstGeom>
+          <a:noFill/>
+          <a:ln/>
+        </p:spPr>
+        <p:txBody>
+          <a:bodyPr wrap="square" lIns="0" tIns="0" rIns="0" bIns="0" rtlCol="0" anchor="ctr"/>
+          <a:lstStyle/>
+          <a:p>
+            <a:pPr rtl="1" algn="r" indent="0" marL="0">
+              <a:buNone/>
+            </a:pPr>
+            <a:r>
+              <a:rPr lang="en-US" sz="1400" b="1" dirty="0">
                 <a:solidFill>
                   <a:srgbClr val="8E2F3C"/>
                 </a:solidFill>
@@ -13355,9 +14080,810 @@
                 <a:ea typeface="IBM Plex Sans Arabic" pitchFamily="34" charset="-122"/>
                 <a:cs typeface="IBM Plex Sans Arabic" pitchFamily="34" charset="-120"/>
               </a:rPr>
-              <a:t>بلا اشتراك ثابت، وبسقف شهري تحدده أنت</a:t>
-            </a:r>
-            <a:endParaRPr lang="en-US" sz="1800" dirty="0"/>
+              <a:t>الموارد الرئيسية</a:t>
+            </a:r>
+            <a:endParaRPr lang="en-US" sz="1400" dirty="0"/>
+          </a:p>
+        </p:txBody>
+      </p:sp>
+      <p:sp>
+        <p:nvSpPr>
+          <p:cNvPr id="66" name="Shape 55"/>
+          <p:cNvSpPr/>
+          <p:nvPr/>
+        </p:nvSpPr>
+        <p:spPr>
+          <a:xfrm>
+            <a:off x="4627961" y="3858768"/>
+            <a:ext cx="82296" cy="82296"/>
+          </a:xfrm>
+          <a:prstGeom prst="rect">
+            <a:avLst/>
+          </a:prstGeom>
+          <a:solidFill>
+            <a:srgbClr val="D48A93"/>
+          </a:solidFill>
+          <a:ln/>
+        </p:spPr>
+      </p:sp>
+      <p:sp>
+        <p:nvSpPr>
+          <p:cNvPr id="67" name="Text 56"/>
+          <p:cNvSpPr txBox="1"/>
+          <p:nvPr/>
+        </p:nvSpPr>
+        <p:spPr>
+          <a:xfrm>
+            <a:off x="2871765" y="3739896"/>
+            <a:ext cx="1664757" cy="329184"/>
+          </a:xfrm>
+          <a:prstGeom prst="rect">
+            <a:avLst/>
+          </a:prstGeom>
+          <a:noFill/>
+          <a:ln/>
+        </p:spPr>
+        <p:txBody>
+          <a:bodyPr wrap="square" lIns="0" tIns="0" rIns="0" bIns="0" rtlCol="0" anchor="ctr"/>
+          <a:lstStyle/>
+          <a:p>
+            <a:pPr rtl="1" algn="r" indent="0" marL="0">
+              <a:buNone/>
+            </a:pPr>
+            <a:r>
+              <a:rPr lang="en-US" sz="1250" dirty="0">
+                <a:solidFill>
+                  <a:srgbClr val="21141A"/>
+                </a:solidFill>
+                <a:latin typeface="IBM Plex Sans Arabic" pitchFamily="34" charset="0"/>
+                <a:ea typeface="IBM Plex Sans Arabic" pitchFamily="34" charset="-122"/>
+                <a:cs typeface="IBM Plex Sans Arabic" pitchFamily="34" charset="-120"/>
+              </a:rPr>
+              <a:t>نموذج الذكاء الاصطناعي</a:t>
+            </a:r>
+            <a:endParaRPr lang="en-US" sz="1250" dirty="0"/>
+          </a:p>
+        </p:txBody>
+      </p:sp>
+      <p:sp>
+        <p:nvSpPr>
+          <p:cNvPr id="68" name="Shape 57"/>
+          <p:cNvSpPr/>
+          <p:nvPr/>
+        </p:nvSpPr>
+        <p:spPr>
+          <a:xfrm>
+            <a:off x="4627961" y="4187952"/>
+            <a:ext cx="82296" cy="82296"/>
+          </a:xfrm>
+          <a:prstGeom prst="rect">
+            <a:avLst/>
+          </a:prstGeom>
+          <a:solidFill>
+            <a:srgbClr val="D48A93"/>
+          </a:solidFill>
+          <a:ln/>
+        </p:spPr>
+      </p:sp>
+      <p:sp>
+        <p:nvSpPr>
+          <p:cNvPr id="69" name="Text 58"/>
+          <p:cNvSpPr txBox="1"/>
+          <p:nvPr/>
+        </p:nvSpPr>
+        <p:spPr>
+          <a:xfrm>
+            <a:off x="2871765" y="4069080"/>
+            <a:ext cx="1664757" cy="329184"/>
+          </a:xfrm>
+          <a:prstGeom prst="rect">
+            <a:avLst/>
+          </a:prstGeom>
+          <a:noFill/>
+          <a:ln/>
+        </p:spPr>
+        <p:txBody>
+          <a:bodyPr wrap="square" lIns="0" tIns="0" rIns="0" bIns="0" rtlCol="0" anchor="ctr"/>
+          <a:lstStyle/>
+          <a:p>
+            <a:pPr rtl="1" algn="r" indent="0" marL="0">
+              <a:buNone/>
+            </a:pPr>
+            <a:r>
+              <a:rPr lang="en-US" sz="1250" dirty="0">
+                <a:solidFill>
+                  <a:srgbClr val="21141A"/>
+                </a:solidFill>
+                <a:latin typeface="IBM Plex Sans Arabic" pitchFamily="34" charset="0"/>
+                <a:ea typeface="IBM Plex Sans Arabic" pitchFamily="34" charset="-122"/>
+                <a:cs typeface="IBM Plex Sans Arabic" pitchFamily="34" charset="-120"/>
+              </a:rPr>
+              <a:t>فريق تقني وFinOps</a:t>
+            </a:r>
+            <a:endParaRPr lang="en-US" sz="1250" dirty="0"/>
+          </a:p>
+        </p:txBody>
+      </p:sp>
+      <p:sp>
+        <p:nvSpPr>
+          <p:cNvPr id="70" name="Shape 59"/>
+          <p:cNvSpPr/>
+          <p:nvPr/>
+        </p:nvSpPr>
+        <p:spPr>
+          <a:xfrm>
+            <a:off x="457200" y="1554480"/>
+            <a:ext cx="2167677" cy="3017520"/>
+          </a:xfrm>
+          <a:prstGeom prst="roundRect">
+            <a:avLst>
+              <a:gd name="adj" fmla="val 5906"/>
+            </a:avLst>
+          </a:prstGeom>
+          <a:solidFill>
+            <a:srgbClr val="FFFBF8"/>
+          </a:solidFill>
+          <a:ln w="9525">
+            <a:solidFill>
+              <a:srgbClr val="E3D5CC"/>
+            </a:solidFill>
+            <a:prstDash val="solid"/>
+          </a:ln>
+        </p:spPr>
+      </p:sp>
+      <p:pic>
+        <p:nvPicPr>
+          <p:cNvPr id="71" name="Image 9" descr="/tmp/claude-0/-home-claude/750ff410-f4aa-5276-9360-1e19d018b112/scratchpad/c/assets/i-handshake-br.png">    </p:cNvPr>
+          <p:cNvPicPr>
+            <a:picLocks noChangeAspect="1"/>
+          </p:cNvPicPr>
+          <p:nvPr/>
+        </p:nvPicPr>
+        <p:blipFill>
+          <a:blip r:embed="rId10"/>
+          <a:stretch>
+            <a:fillRect/>
+          </a:stretch>
+        </p:blipFill>
+        <p:spPr>
+          <a:xfrm>
+            <a:off x="2131101" y="1709928"/>
+            <a:ext cx="310896" cy="310896"/>
+          </a:xfrm>
+          <a:prstGeom prst="rect">
+            <a:avLst/>
+          </a:prstGeom>
+        </p:spPr>
+      </p:pic>
+      <p:sp>
+        <p:nvSpPr>
+          <p:cNvPr id="72" name="Text 60"/>
+          <p:cNvSpPr txBox="1"/>
+          <p:nvPr/>
+        </p:nvSpPr>
+        <p:spPr>
+          <a:xfrm>
+            <a:off x="594360" y="1682496"/>
+            <a:ext cx="1481877" cy="365760"/>
+          </a:xfrm>
+          <a:prstGeom prst="rect">
+            <a:avLst/>
+          </a:prstGeom>
+          <a:noFill/>
+          <a:ln/>
+        </p:spPr>
+        <p:txBody>
+          <a:bodyPr wrap="square" lIns="0" tIns="0" rIns="0" bIns="0" rtlCol="0" anchor="ctr"/>
+          <a:lstStyle/>
+          <a:p>
+            <a:pPr rtl="1" algn="r" indent="0" marL="0">
+              <a:buNone/>
+            </a:pPr>
+            <a:r>
+              <a:rPr lang="en-US" sz="1400" b="1" dirty="0">
+                <a:solidFill>
+                  <a:srgbClr val="8E2F3C"/>
+                </a:solidFill>
+                <a:latin typeface="IBM Plex Sans Arabic" pitchFamily="34" charset="0"/>
+                <a:ea typeface="IBM Plex Sans Arabic" pitchFamily="34" charset="-122"/>
+                <a:cs typeface="IBM Plex Sans Arabic" pitchFamily="34" charset="-120"/>
+              </a:rPr>
+              <a:t>الشراكات الرئيسية</a:t>
+            </a:r>
+            <a:endParaRPr lang="en-US" sz="1400" dirty="0"/>
+          </a:p>
+        </p:txBody>
+      </p:sp>
+      <p:sp>
+        <p:nvSpPr>
+          <p:cNvPr id="73" name="Shape 61"/>
+          <p:cNvSpPr/>
+          <p:nvPr/>
+        </p:nvSpPr>
+        <p:spPr>
+          <a:xfrm>
+            <a:off x="2350557" y="2295144"/>
+            <a:ext cx="82296" cy="82296"/>
+          </a:xfrm>
+          <a:prstGeom prst="rect">
+            <a:avLst/>
+          </a:prstGeom>
+          <a:solidFill>
+            <a:srgbClr val="D48A93"/>
+          </a:solidFill>
+          <a:ln/>
+        </p:spPr>
+      </p:sp>
+      <p:sp>
+        <p:nvSpPr>
+          <p:cNvPr id="74" name="Text 62"/>
+          <p:cNvSpPr txBox="1"/>
+          <p:nvPr/>
+        </p:nvSpPr>
+        <p:spPr>
+          <a:xfrm>
+            <a:off x="594360" y="2176272"/>
+            <a:ext cx="1664757" cy="329184"/>
+          </a:xfrm>
+          <a:prstGeom prst="rect">
+            <a:avLst/>
+          </a:prstGeom>
+          <a:noFill/>
+          <a:ln/>
+        </p:spPr>
+        <p:txBody>
+          <a:bodyPr wrap="square" lIns="0" tIns="0" rIns="0" bIns="0" rtlCol="0" anchor="ctr"/>
+          <a:lstStyle/>
+          <a:p>
+            <a:pPr rtl="1" algn="r" indent="0" marL="0">
+              <a:buNone/>
+            </a:pPr>
+            <a:r>
+              <a:rPr lang="en-US" sz="1350" dirty="0">
+                <a:solidFill>
+                  <a:srgbClr val="21141A"/>
+                </a:solidFill>
+                <a:latin typeface="IBM Plex Sans Arabic" pitchFamily="34" charset="0"/>
+                <a:ea typeface="IBM Plex Sans Arabic" pitchFamily="34" charset="-122"/>
+                <a:cs typeface="IBM Plex Sans Arabic" pitchFamily="34" charset="-120"/>
+              </a:rPr>
+              <a:t>AWS وAzure وGCP</a:t>
+            </a:r>
+            <a:endParaRPr lang="en-US" sz="1350" dirty="0"/>
+          </a:p>
+        </p:txBody>
+      </p:sp>
+      <p:sp>
+        <p:nvSpPr>
+          <p:cNvPr id="75" name="Shape 63"/>
+          <p:cNvSpPr/>
+          <p:nvPr/>
+        </p:nvSpPr>
+        <p:spPr>
+          <a:xfrm>
+            <a:off x="2350557" y="2660904"/>
+            <a:ext cx="82296" cy="82296"/>
+          </a:xfrm>
+          <a:prstGeom prst="rect">
+            <a:avLst/>
+          </a:prstGeom>
+          <a:solidFill>
+            <a:srgbClr val="D48A93"/>
+          </a:solidFill>
+          <a:ln/>
+        </p:spPr>
+      </p:sp>
+      <p:sp>
+        <p:nvSpPr>
+          <p:cNvPr id="76" name="Text 64"/>
+          <p:cNvSpPr txBox="1"/>
+          <p:nvPr/>
+        </p:nvSpPr>
+        <p:spPr>
+          <a:xfrm>
+            <a:off x="594360" y="2542032"/>
+            <a:ext cx="1664757" cy="329184"/>
+          </a:xfrm>
+          <a:prstGeom prst="rect">
+            <a:avLst/>
+          </a:prstGeom>
+          <a:noFill/>
+          <a:ln/>
+        </p:spPr>
+        <p:txBody>
+          <a:bodyPr wrap="square" lIns="0" tIns="0" rIns="0" bIns="0" rtlCol="0" anchor="ctr"/>
+          <a:lstStyle/>
+          <a:p>
+            <a:pPr rtl="1" algn="r" indent="0" marL="0">
+              <a:buNone/>
+            </a:pPr>
+            <a:r>
+              <a:rPr lang="en-US" sz="1350" dirty="0">
+                <a:solidFill>
+                  <a:srgbClr val="21141A"/>
+                </a:solidFill>
+                <a:latin typeface="IBM Plex Sans Arabic" pitchFamily="34" charset="0"/>
+                <a:ea typeface="IBM Plex Sans Arabic" pitchFamily="34" charset="-122"/>
+                <a:cs typeface="IBM Plex Sans Arabic" pitchFamily="34" charset="-120"/>
+              </a:rPr>
+              <a:t>STC وSCCC وCNTXT</a:t>
+            </a:r>
+            <a:endParaRPr lang="en-US" sz="1350" dirty="0"/>
+          </a:p>
+        </p:txBody>
+      </p:sp>
+      <p:sp>
+        <p:nvSpPr>
+          <p:cNvPr id="77" name="Shape 65"/>
+          <p:cNvSpPr/>
+          <p:nvPr/>
+        </p:nvSpPr>
+        <p:spPr>
+          <a:xfrm>
+            <a:off x="2350557" y="3026664"/>
+            <a:ext cx="82296" cy="82296"/>
+          </a:xfrm>
+          <a:prstGeom prst="rect">
+            <a:avLst/>
+          </a:prstGeom>
+          <a:solidFill>
+            <a:srgbClr val="D48A93"/>
+          </a:solidFill>
+          <a:ln/>
+        </p:spPr>
+      </p:sp>
+      <p:sp>
+        <p:nvSpPr>
+          <p:cNvPr id="78" name="Text 66"/>
+          <p:cNvSpPr txBox="1"/>
+          <p:nvPr/>
+        </p:nvSpPr>
+        <p:spPr>
+          <a:xfrm>
+            <a:off x="594360" y="2907792"/>
+            <a:ext cx="1664757" cy="329184"/>
+          </a:xfrm>
+          <a:prstGeom prst="rect">
+            <a:avLst/>
+          </a:prstGeom>
+          <a:noFill/>
+          <a:ln/>
+        </p:spPr>
+        <p:txBody>
+          <a:bodyPr wrap="square" lIns="0" tIns="0" rIns="0" bIns="0" rtlCol="0" anchor="ctr"/>
+          <a:lstStyle/>
+          <a:p>
+            <a:pPr rtl="1" algn="r" indent="0" marL="0">
+              <a:buNone/>
+            </a:pPr>
+            <a:r>
+              <a:rPr lang="en-US" sz="1350" dirty="0">
+                <a:solidFill>
+                  <a:srgbClr val="21141A"/>
+                </a:solidFill>
+                <a:latin typeface="IBM Plex Sans Arabic" pitchFamily="34" charset="0"/>
+                <a:ea typeface="IBM Plex Sans Arabic" pitchFamily="34" charset="-122"/>
+                <a:cs typeface="IBM Plex Sans Arabic" pitchFamily="34" charset="-120"/>
+              </a:rPr>
+              <a:t>واتساب للأعمال</a:t>
+            </a:r>
+            <a:endParaRPr lang="en-US" sz="1350" dirty="0"/>
+          </a:p>
+        </p:txBody>
+      </p:sp>
+      <p:sp>
+        <p:nvSpPr>
+          <p:cNvPr id="79" name="Shape 67"/>
+          <p:cNvSpPr/>
+          <p:nvPr/>
+        </p:nvSpPr>
+        <p:spPr>
+          <a:xfrm>
+            <a:off x="6150712" y="4681728"/>
+            <a:ext cx="5583784" cy="1417320"/>
+          </a:xfrm>
+          <a:prstGeom prst="roundRect">
+            <a:avLst>
+              <a:gd name="adj" fmla="val 9032"/>
+            </a:avLst>
+          </a:prstGeom>
+          <a:solidFill>
+            <a:srgbClr val="FFFBF8"/>
+          </a:solidFill>
+          <a:ln w="9525">
+            <a:solidFill>
+              <a:srgbClr val="E3D5CC"/>
+            </a:solidFill>
+            <a:prstDash val="solid"/>
+          </a:ln>
+        </p:spPr>
+      </p:sp>
+      <p:pic>
+        <p:nvPicPr>
+          <p:cNvPr id="80" name="Image 10" descr="/tmp/claude-0/-home-claude/750ff410-f4aa-5276-9360-1e19d018b112/scratchpad/c/assets/i-coins-br.png">    </p:cNvPr>
+          <p:cNvPicPr>
+            <a:picLocks noChangeAspect="1"/>
+          </p:cNvPicPr>
+          <p:nvPr/>
+        </p:nvPicPr>
+        <p:blipFill>
+          <a:blip r:embed="rId11"/>
+          <a:stretch>
+            <a:fillRect/>
+          </a:stretch>
+        </p:blipFill>
+        <p:spPr>
+          <a:xfrm>
+            <a:off x="11240719" y="4837176"/>
+            <a:ext cx="310896" cy="310896"/>
+          </a:xfrm>
+          <a:prstGeom prst="rect">
+            <a:avLst/>
+          </a:prstGeom>
+        </p:spPr>
+      </p:pic>
+      <p:sp>
+        <p:nvSpPr>
+          <p:cNvPr id="81" name="Text 68"/>
+          <p:cNvSpPr txBox="1"/>
+          <p:nvPr/>
+        </p:nvSpPr>
+        <p:spPr>
+          <a:xfrm>
+            <a:off x="6287872" y="4809744"/>
+            <a:ext cx="4897984" cy="365760"/>
+          </a:xfrm>
+          <a:prstGeom prst="rect">
+            <a:avLst/>
+          </a:prstGeom>
+          <a:noFill/>
+          <a:ln/>
+        </p:spPr>
+        <p:txBody>
+          <a:bodyPr wrap="square" lIns="0" tIns="0" rIns="0" bIns="0" rtlCol="0" anchor="ctr"/>
+          <a:lstStyle/>
+          <a:p>
+            <a:pPr rtl="1" algn="r" indent="0" marL="0">
+              <a:buNone/>
+            </a:pPr>
+            <a:r>
+              <a:rPr lang="en-US" sz="1400" b="1" dirty="0">
+                <a:solidFill>
+                  <a:srgbClr val="8E2F3C"/>
+                </a:solidFill>
+                <a:latin typeface="IBM Plex Sans Arabic" pitchFamily="34" charset="0"/>
+                <a:ea typeface="IBM Plex Sans Arabic" pitchFamily="34" charset="-122"/>
+                <a:cs typeface="IBM Plex Sans Arabic" pitchFamily="34" charset="-120"/>
+              </a:rPr>
+              <a:t>مصادر الإيرادات</a:t>
+            </a:r>
+            <a:endParaRPr lang="en-US" sz="1400" dirty="0"/>
+          </a:p>
+        </p:txBody>
+      </p:sp>
+      <p:sp>
+        <p:nvSpPr>
+          <p:cNvPr id="82" name="Shape 69"/>
+          <p:cNvSpPr/>
+          <p:nvPr/>
+        </p:nvSpPr>
+        <p:spPr>
+          <a:xfrm>
+            <a:off x="11460175" y="5422392"/>
+            <a:ext cx="82296" cy="82296"/>
+          </a:xfrm>
+          <a:prstGeom prst="rect">
+            <a:avLst/>
+          </a:prstGeom>
+          <a:solidFill>
+            <a:srgbClr val="D48A93"/>
+          </a:solidFill>
+          <a:ln/>
+        </p:spPr>
+      </p:sp>
+      <p:sp>
+        <p:nvSpPr>
+          <p:cNvPr id="83" name="Text 70"/>
+          <p:cNvSpPr txBox="1"/>
+          <p:nvPr/>
+        </p:nvSpPr>
+        <p:spPr>
+          <a:xfrm>
+            <a:off x="6287872" y="5303520"/>
+            <a:ext cx="5080864" cy="329184"/>
+          </a:xfrm>
+          <a:prstGeom prst="rect">
+            <a:avLst/>
+          </a:prstGeom>
+          <a:noFill/>
+          <a:ln/>
+        </p:spPr>
+        <p:txBody>
+          <a:bodyPr wrap="square" lIns="0" tIns="0" rIns="0" bIns="0" rtlCol="0" anchor="ctr"/>
+          <a:lstStyle/>
+          <a:p>
+            <a:pPr rtl="1" algn="r" indent="0" marL="0">
+              <a:buNone/>
+            </a:pPr>
+            <a:r>
+              <a:rPr lang="en-US" sz="1350" dirty="0">
+                <a:solidFill>
+                  <a:srgbClr val="21141A"/>
+                </a:solidFill>
+                <a:latin typeface="IBM Plex Sans Arabic" pitchFamily="34" charset="0"/>
+                <a:ea typeface="IBM Plex Sans Arabic" pitchFamily="34" charset="-122"/>
+                <a:cs typeface="IBM Plex Sans Arabic" pitchFamily="34" charset="-120"/>
+              </a:rPr>
+              <a:t>فحص أول مجاني · من 15 ريال لكل مورد</a:t>
+            </a:r>
+            <a:endParaRPr lang="en-US" sz="1350" dirty="0"/>
+          </a:p>
+        </p:txBody>
+      </p:sp>
+      <p:sp>
+        <p:nvSpPr>
+          <p:cNvPr id="84" name="Shape 71"/>
+          <p:cNvSpPr/>
+          <p:nvPr/>
+        </p:nvSpPr>
+        <p:spPr>
+          <a:xfrm>
+            <a:off x="11460175" y="5788152"/>
+            <a:ext cx="82296" cy="82296"/>
+          </a:xfrm>
+          <a:prstGeom prst="rect">
+            <a:avLst/>
+          </a:prstGeom>
+          <a:solidFill>
+            <a:srgbClr val="D48A93"/>
+          </a:solidFill>
+          <a:ln/>
+        </p:spPr>
+      </p:sp>
+      <p:sp>
+        <p:nvSpPr>
+          <p:cNvPr id="85" name="Text 72"/>
+          <p:cNvSpPr txBox="1"/>
+          <p:nvPr/>
+        </p:nvSpPr>
+        <p:spPr>
+          <a:xfrm>
+            <a:off x="6287872" y="5669280"/>
+            <a:ext cx="5080864" cy="329184"/>
+          </a:xfrm>
+          <a:prstGeom prst="rect">
+            <a:avLst/>
+          </a:prstGeom>
+          <a:noFill/>
+          <a:ln/>
+        </p:spPr>
+        <p:txBody>
+          <a:bodyPr wrap="square" lIns="0" tIns="0" rIns="0" bIns="0" rtlCol="0" anchor="ctr"/>
+          <a:lstStyle/>
+          <a:p>
+            <a:pPr rtl="1" algn="r" indent="0" marL="0">
+              <a:buNone/>
+            </a:pPr>
+            <a:r>
+              <a:rPr lang="en-US" sz="1350" dirty="0">
+                <a:solidFill>
+                  <a:srgbClr val="21141A"/>
+                </a:solidFill>
+                <a:latin typeface="IBM Plex Sans Arabic" pitchFamily="34" charset="0"/>
+                <a:ea typeface="IBM Plex Sans Arabic" pitchFamily="34" charset="-122"/>
+                <a:cs typeface="IBM Plex Sans Arabic" pitchFamily="34" charset="-120"/>
+              </a:rPr>
+              <a:t>استشارات FinOps حسب المشروع</a:t>
+            </a:r>
+            <a:endParaRPr lang="en-US" sz="1350" dirty="0"/>
+          </a:p>
+        </p:txBody>
+      </p:sp>
+      <p:sp>
+        <p:nvSpPr>
+          <p:cNvPr id="86" name="Shape 73"/>
+          <p:cNvSpPr/>
+          <p:nvPr/>
+        </p:nvSpPr>
+        <p:spPr>
+          <a:xfrm>
+            <a:off x="457200" y="4681728"/>
+            <a:ext cx="5583784" cy="1417320"/>
+          </a:xfrm>
+          <a:prstGeom prst="roundRect">
+            <a:avLst>
+              <a:gd name="adj" fmla="val 9032"/>
+            </a:avLst>
+          </a:prstGeom>
+          <a:solidFill>
+            <a:srgbClr val="FFFBF8"/>
+          </a:solidFill>
+          <a:ln w="9525">
+            <a:solidFill>
+              <a:srgbClr val="E3D5CC"/>
+            </a:solidFill>
+            <a:prstDash val="solid"/>
+          </a:ln>
+        </p:spPr>
+      </p:sp>
+      <p:pic>
+        <p:nvPicPr>
+          <p:cNvPr id="87" name="Image 11" descr="/tmp/claude-0/-home-claude/750ff410-f4aa-5276-9360-1e19d018b112/scratchpad/c/assets/i-receipt-br.png">    </p:cNvPr>
+          <p:cNvPicPr>
+            <a:picLocks noChangeAspect="1"/>
+          </p:cNvPicPr>
+          <p:nvPr/>
+        </p:nvPicPr>
+        <p:blipFill>
+          <a:blip r:embed="rId12"/>
+          <a:stretch>
+            <a:fillRect/>
+          </a:stretch>
+        </p:blipFill>
+        <p:spPr>
+          <a:xfrm>
+            <a:off x="5547208" y="4837176"/>
+            <a:ext cx="310896" cy="310896"/>
+          </a:xfrm>
+          <a:prstGeom prst="rect">
+            <a:avLst/>
+          </a:prstGeom>
+        </p:spPr>
+      </p:pic>
+      <p:sp>
+        <p:nvSpPr>
+          <p:cNvPr id="88" name="Text 74"/>
+          <p:cNvSpPr txBox="1"/>
+          <p:nvPr/>
+        </p:nvSpPr>
+        <p:spPr>
+          <a:xfrm>
+            <a:off x="594360" y="4809744"/>
+            <a:ext cx="4897984" cy="365760"/>
+          </a:xfrm>
+          <a:prstGeom prst="rect">
+            <a:avLst/>
+          </a:prstGeom>
+          <a:noFill/>
+          <a:ln/>
+        </p:spPr>
+        <p:txBody>
+          <a:bodyPr wrap="square" lIns="0" tIns="0" rIns="0" bIns="0" rtlCol="0" anchor="ctr"/>
+          <a:lstStyle/>
+          <a:p>
+            <a:pPr rtl="1" algn="r" indent="0" marL="0">
+              <a:buNone/>
+            </a:pPr>
+            <a:r>
+              <a:rPr lang="en-US" sz="1400" b="1" dirty="0">
+                <a:solidFill>
+                  <a:srgbClr val="8E2F3C"/>
+                </a:solidFill>
+                <a:latin typeface="IBM Plex Sans Arabic" pitchFamily="34" charset="0"/>
+                <a:ea typeface="IBM Plex Sans Arabic" pitchFamily="34" charset="-122"/>
+                <a:cs typeface="IBM Plex Sans Arabic" pitchFamily="34" charset="-120"/>
+              </a:rPr>
+              <a:t>هيكل التكاليف</a:t>
+            </a:r>
+            <a:endParaRPr lang="en-US" sz="1400" dirty="0"/>
+          </a:p>
+        </p:txBody>
+      </p:sp>
+      <p:sp>
+        <p:nvSpPr>
+          <p:cNvPr id="89" name="Shape 75"/>
+          <p:cNvSpPr/>
+          <p:nvPr/>
+        </p:nvSpPr>
+        <p:spPr>
+          <a:xfrm>
+            <a:off x="5766664" y="5422392"/>
+            <a:ext cx="82296" cy="82296"/>
+          </a:xfrm>
+          <a:prstGeom prst="rect">
+            <a:avLst/>
+          </a:prstGeom>
+          <a:solidFill>
+            <a:srgbClr val="D48A93"/>
+          </a:solidFill>
+          <a:ln/>
+        </p:spPr>
+      </p:sp>
+      <p:sp>
+        <p:nvSpPr>
+          <p:cNvPr id="90" name="Text 76"/>
+          <p:cNvSpPr txBox="1"/>
+          <p:nvPr/>
+        </p:nvSpPr>
+        <p:spPr>
+          <a:xfrm>
+            <a:off x="594360" y="5303520"/>
+            <a:ext cx="5080864" cy="329184"/>
+          </a:xfrm>
+          <a:prstGeom prst="rect">
+            <a:avLst/>
+          </a:prstGeom>
+          <a:noFill/>
+          <a:ln/>
+        </p:spPr>
+        <p:txBody>
+          <a:bodyPr wrap="square" lIns="0" tIns="0" rIns="0" bIns="0" rtlCol="0" anchor="ctr"/>
+          <a:lstStyle/>
+          <a:p>
+            <a:pPr rtl="1" algn="r" indent="0" marL="0">
+              <a:buNone/>
+            </a:pPr>
+            <a:r>
+              <a:rPr lang="en-US" sz="1350" dirty="0">
+                <a:solidFill>
+                  <a:srgbClr val="21141A"/>
+                </a:solidFill>
+                <a:latin typeface="IBM Plex Sans Arabic" pitchFamily="34" charset="0"/>
+                <a:ea typeface="IBM Plex Sans Arabic" pitchFamily="34" charset="-122"/>
+                <a:cs typeface="IBM Plex Sans Arabic" pitchFamily="34" charset="-120"/>
+              </a:rPr>
+              <a:t>الاستضافة والذكاء الاصطناعي</a:t>
+            </a:r>
+            <a:endParaRPr lang="en-US" sz="1350" dirty="0"/>
+          </a:p>
+        </p:txBody>
+      </p:sp>
+      <p:sp>
+        <p:nvSpPr>
+          <p:cNvPr id="91" name="Shape 77"/>
+          <p:cNvSpPr/>
+          <p:nvPr/>
+        </p:nvSpPr>
+        <p:spPr>
+          <a:xfrm>
+            <a:off x="5766664" y="5788152"/>
+            <a:ext cx="82296" cy="82296"/>
+          </a:xfrm>
+          <a:prstGeom prst="rect">
+            <a:avLst/>
+          </a:prstGeom>
+          <a:solidFill>
+            <a:srgbClr val="D48A93"/>
+          </a:solidFill>
+          <a:ln/>
+        </p:spPr>
+      </p:sp>
+      <p:sp>
+        <p:nvSpPr>
+          <p:cNvPr id="92" name="Text 78"/>
+          <p:cNvSpPr txBox="1"/>
+          <p:nvPr/>
+        </p:nvSpPr>
+        <p:spPr>
+          <a:xfrm>
+            <a:off x="594360" y="5669280"/>
+            <a:ext cx="5080864" cy="329184"/>
+          </a:xfrm>
+          <a:prstGeom prst="rect">
+            <a:avLst/>
+          </a:prstGeom>
+          <a:noFill/>
+          <a:ln/>
+        </p:spPr>
+        <p:txBody>
+          <a:bodyPr wrap="square" lIns="0" tIns="0" rIns="0" bIns="0" rtlCol="0" anchor="ctr"/>
+          <a:lstStyle/>
+          <a:p>
+            <a:pPr rtl="1" algn="r" indent="0" marL="0">
+              <a:buNone/>
+            </a:pPr>
+            <a:r>
+              <a:rPr lang="en-US" sz="1350" dirty="0">
+                <a:solidFill>
+                  <a:srgbClr val="21141A"/>
+                </a:solidFill>
+                <a:latin typeface="IBM Plex Sans Arabic" pitchFamily="34" charset="0"/>
+                <a:ea typeface="IBM Plex Sans Arabic" pitchFamily="34" charset="-122"/>
+                <a:cs typeface="IBM Plex Sans Arabic" pitchFamily="34" charset="-120"/>
+              </a:rPr>
+              <a:t>الفريق والتطوير · التسويق</a:t>
+            </a:r>
+            <a:endParaRPr lang="en-US" sz="1350" dirty="0"/>
           </a:p>
         </p:txBody>
       </p:sp>

</xml_diff>

<commit_message>
Pitch deck: Sulaiman's Oct 16 wording (competitors by criteria, flexible SaaS revenue, MVP title)
Co-Authored-By: Claude Opus 5.5 (1M context) <noreply@anthropic.com>
Claude-Session: https://claude.ai/code/session_011TSHxy9drUC1JZWNcfUL3E
</commit_message>
<xml_diff>
--- a/pitch/SSB_VentureX.pptx
+++ b/pitch/SSB_VentureX.pptx
@@ -7382,7 +7382,7 @@
                 <a:ea typeface="IBM Plex Sans Arabic" pitchFamily="34" charset="-122"/>
                 <a:cs typeface="IBM Plex Sans Arabic" pitchFamily="34" charset="-120"/>
               </a:rPr>
-              <a:t>ولا يوجد مختص FinOps في الشركات المتوسطة</a:t>
+              <a:t>والأدوات العالمية معقدة وباهظة ومصممة للمؤسسات الكبرى، بلا دعم محلي</a:t>
             </a:r>
             <a:endParaRPr lang="en-US" sz="1800" dirty="0"/>
           </a:p>
@@ -8276,15 +8276,54 @@
                 <a:ea typeface="IBM Plex Sans Arabic" pitchFamily="34" charset="-122"/>
                 <a:cs typeface="IBM Plex Sans Arabic" pitchFamily="34" charset="-120"/>
               </a:rPr>
-              <a:t>توافق بنقرة واحدة… وتوفّر</a:t>
+              <a:t>توصيات ذكية وتنفيذ بموافقة مسبقة</a:t>
             </a:r>
             <a:endParaRPr lang="en-US" sz="2000" dirty="0"/>
+          </a:p>
+        </p:txBody>
+      </p:sp>
+      <p:sp>
+        <p:nvSpPr>
+          <p:cNvPr id="32" name="Text 27"/>
+          <p:cNvSpPr txBox="1"/>
+          <p:nvPr/>
+        </p:nvSpPr>
+        <p:spPr>
+          <a:xfrm>
+            <a:off x="6766560" y="5321808"/>
+            <a:ext cx="4190695" cy="365760"/>
+          </a:xfrm>
+          <a:prstGeom prst="rect">
+            <a:avLst/>
+          </a:prstGeom>
+          <a:noFill/>
+          <a:ln/>
+        </p:spPr>
+        <p:txBody>
+          <a:bodyPr wrap="square" lIns="0" tIns="0" rIns="0" bIns="0" rtlCol="0" anchor="ctr"/>
+          <a:lstStyle/>
+          <a:p>
+            <a:pPr rtl="1" algn="r" indent="0" marL="0">
+              <a:buNone/>
+            </a:pPr>
+            <a:r>
+              <a:rPr lang="en-US" sz="1500" dirty="0">
+                <a:solidFill>
+                  <a:srgbClr val="7F6C72"/>
+                </a:solidFill>
+                <a:latin typeface="IBM Plex Sans Arabic" pitchFamily="34" charset="0"/>
+                <a:ea typeface="IBM Plex Sans Arabic" pitchFamily="34" charset="-122"/>
+                <a:cs typeface="IBM Plex Sans Arabic" pitchFamily="34" charset="-120"/>
+              </a:rPr>
+              <a:t>أو أتمتة مشروطة، لتفادي أخطاء الإنتاج</a:t>
+            </a:r>
+            <a:endParaRPr lang="en-US" sz="1500" dirty="0"/>
           </a:p>
         </p:txBody>
       </p:sp>
       <p:pic>
         <p:nvPicPr>
-          <p:cNvPr id="32" name="Image 3" descr="/tmp/claude-0/-home-claude/750ff410-f4aa-5276-9360-1e19d018b112/scratchpad/c/assets/m-lap-demo.png">    </p:cNvPr>
+          <p:cNvPr id="33" name="Image 3" descr="/tmp/claude-0/-home-claude/750ff410-f4aa-5276-9360-1e19d018b112/scratchpad/c/assets/m-lap-demo.png">    </p:cNvPr>
           <p:cNvPicPr>
             <a:picLocks noChangeAspect="1"/>
           </p:cNvPicPr>
@@ -8861,7 +8900,7 @@
                 <a:ea typeface="IBM Plex Sans Arabic" pitchFamily="34" charset="-122"/>
                 <a:cs typeface="IBM Plex Sans Arabic" pitchFamily="34" charset="-120"/>
               </a:rPr>
-              <a:t>CloudTrim مقابل أدوات المزودين</a:t>
+              <a:t>كل السحب في لوحة واحدة، بسعر يناسب الشركات المتوسطة</a:t>
             </a:r>
             <a:endParaRPr lang="en-US" sz="3400" dirty="0"/>
           </a:p>
@@ -8875,12 +8914,12 @@
         </p:nvSpPr>
         <p:spPr>
           <a:xfrm>
-            <a:off x="6601968" y="2468880"/>
-            <a:ext cx="1371600" cy="3337560"/>
+            <a:off x="6382512" y="2423160"/>
+            <a:ext cx="2779776" cy="3337560"/>
           </a:xfrm>
           <a:prstGeom prst="roundRect">
             <a:avLst>
-              <a:gd name="adj" fmla="val 9333"/>
+              <a:gd name="adj" fmla="val 4605"/>
             </a:avLst>
           </a:prstGeom>
           <a:solidFill>
@@ -8897,8 +8936,8 @@
         </p:nvSpPr>
         <p:spPr>
           <a:xfrm>
-            <a:off x="6528816" y="2514600"/>
-            <a:ext cx="1517904" cy="594360"/>
+            <a:off x="6309360" y="2468880"/>
+            <a:ext cx="2926080" cy="640080"/>
           </a:xfrm>
           <a:prstGeom prst="rect">
             <a:avLst/>
@@ -8914,7 +8953,7 @@
               <a:buNone/>
             </a:pPr>
             <a:r>
-              <a:rPr lang="en-US" sz="1600" b="1" dirty="0">
+              <a:rPr lang="en-US" sz="1800" b="1" dirty="0">
                 <a:solidFill>
                   <a:srgbClr val="8E2F3C"/>
                 </a:solidFill>
@@ -8924,7 +8963,7 @@
               </a:rPr>
               <a:t>CloudTrim</a:t>
             </a:r>
-            <a:endParaRPr lang="en-US" sz="1600" dirty="0"/>
+            <a:endParaRPr lang="en-US" sz="1800" dirty="0"/>
           </a:p>
         </p:txBody>
       </p:sp>
@@ -8936,8 +8975,8 @@
         </p:nvSpPr>
         <p:spPr>
           <a:xfrm>
-            <a:off x="5010912" y="2532888"/>
-            <a:ext cx="1517904" cy="292608"/>
+            <a:off x="3383280" y="2487168"/>
+            <a:ext cx="2926080" cy="329184"/>
           </a:xfrm>
           <a:prstGeom prst="rect">
             <a:avLst/>
@@ -8949,11 +8988,89 @@
           <a:bodyPr wrap="square" lIns="0" tIns="0" rIns="0" bIns="0" rtlCol="0" anchor="ctr"/>
           <a:lstStyle/>
           <a:p>
+            <a:pPr rtl="1" algn="ctr" indent="0" marL="0">
+              <a:buNone/>
+            </a:pPr>
+            <a:r>
+              <a:rPr lang="en-US" sz="1500" b="1" dirty="0">
+                <a:solidFill>
+                  <a:srgbClr val="21141A"/>
+                </a:solidFill>
+                <a:latin typeface="IBM Plex Sans Arabic" pitchFamily="34" charset="0"/>
+                <a:ea typeface="IBM Plex Sans Arabic" pitchFamily="34" charset="-122"/>
+                <a:cs typeface="IBM Plex Sans Arabic" pitchFamily="34" charset="-120"/>
+              </a:rPr>
+              <a:t>أدوات المزودين</a:t>
+            </a:r>
+            <a:endParaRPr lang="en-US" sz="1500" dirty="0"/>
+          </a:p>
+        </p:txBody>
+      </p:sp>
+      <p:sp>
+        <p:nvSpPr>
+          <p:cNvPr id="26" name="Text 21"/>
+          <p:cNvSpPr txBox="1"/>
+          <p:nvPr/>
+        </p:nvSpPr>
+        <p:spPr>
+          <a:xfrm>
+            <a:off x="3383280" y="2816352"/>
+            <a:ext cx="2926080" cy="256032"/>
+          </a:xfrm>
+          <a:prstGeom prst="rect">
+            <a:avLst/>
+          </a:prstGeom>
+          <a:noFill/>
+          <a:ln/>
+        </p:spPr>
+        <p:txBody>
+          <a:bodyPr wrap="square" lIns="0" tIns="0" rIns="0" bIns="0" rtlCol="0" anchor="ctr"/>
+          <a:lstStyle/>
+          <a:p>
             <a:pPr algn="ctr" indent="0" marL="0">
               <a:buNone/>
             </a:pPr>
             <a:r>
-              <a:rPr lang="en-US" sz="1300" b="1" dirty="0">
+              <a:rPr lang="en-US" sz="1050" dirty="0">
+                <a:solidFill>
+                  <a:srgbClr val="7F6C72"/>
+                </a:solidFill>
+                <a:latin typeface="IBM Plex Sans Arabic" pitchFamily="34" charset="0"/>
+                <a:ea typeface="IBM Plex Sans Arabic" pitchFamily="34" charset="-122"/>
+                <a:cs typeface="IBM Plex Sans Arabic" pitchFamily="34" charset="-120"/>
+              </a:rPr>
+              <a:t>AWS / Azure Cost Management</a:t>
+            </a:r>
+            <a:endParaRPr lang="en-US" sz="1050" dirty="0"/>
+          </a:p>
+        </p:txBody>
+      </p:sp>
+      <p:sp>
+        <p:nvSpPr>
+          <p:cNvPr id="27" name="Text 22"/>
+          <p:cNvSpPr txBox="1"/>
+          <p:nvPr/>
+        </p:nvSpPr>
+        <p:spPr>
+          <a:xfrm>
+            <a:off x="457200" y="2487168"/>
+            <a:ext cx="2926080" cy="329184"/>
+          </a:xfrm>
+          <a:prstGeom prst="rect">
+            <a:avLst/>
+          </a:prstGeom>
+          <a:noFill/>
+          <a:ln/>
+        </p:spPr>
+        <p:txBody>
+          <a:bodyPr wrap="square" lIns="0" tIns="0" rIns="0" bIns="0" rtlCol="0" anchor="ctr"/>
+          <a:lstStyle/>
+          <a:p>
+            <a:pPr rtl="1" algn="ctr" indent="0" marL="0">
+              <a:buNone/>
+            </a:pPr>
+            <a:r>
+              <a:rPr lang="en-US" sz="1500" b="1" dirty="0">
                 <a:solidFill>
                   <a:srgbClr val="21141A"/>
                 </a:solidFill>
@@ -8961,22 +9078,22 @@
                 <a:ea typeface="IBM Plex Sans Arabic" pitchFamily="34" charset="-122"/>
                 <a:cs typeface="IBM Plex Sans Arabic" pitchFamily="34" charset="-120"/>
               </a:rPr>
-              <a:t>AWS</a:t>
-            </a:r>
-            <a:endParaRPr lang="en-US" sz="1300" dirty="0"/>
-          </a:p>
-        </p:txBody>
-      </p:sp>
-      <p:sp>
-        <p:nvSpPr>
-          <p:cNvPr id="26" name="Text 21"/>
-          <p:cNvSpPr txBox="1"/>
-          <p:nvPr/>
-        </p:nvSpPr>
-        <p:spPr>
-          <a:xfrm>
-            <a:off x="5010912" y="2825496"/>
-            <a:ext cx="1517904" cy="256032"/>
+              <a:t>حلول المؤسسات</a:t>
+            </a:r>
+            <a:endParaRPr lang="en-US" sz="1500" dirty="0"/>
+          </a:p>
+        </p:txBody>
+      </p:sp>
+      <p:sp>
+        <p:nvSpPr>
+          <p:cNvPr id="28" name="Text 23"/>
+          <p:cNvSpPr txBox="1"/>
+          <p:nvPr/>
+        </p:nvSpPr>
+        <p:spPr>
+          <a:xfrm>
+            <a:off x="457200" y="2816352"/>
+            <a:ext cx="2926080" cy="256032"/>
           </a:xfrm>
           <a:prstGeom prst="rect">
             <a:avLst/>
@@ -9000,7 +9117,7 @@
                 <a:ea typeface="IBM Plex Sans Arabic" pitchFamily="34" charset="-122"/>
                 <a:cs typeface="IBM Plex Sans Arabic" pitchFamily="34" charset="-120"/>
               </a:rPr>
-              <a:t>Cost Management</a:t>
+              <a:t>STC Multi-Cloud</a:t>
             </a:r>
             <a:endParaRPr lang="en-US" sz="1050" dirty="0"/>
           </a:p>
@@ -9008,280 +9125,7 @@
       </p:sp>
       <p:sp>
         <p:nvSpPr>
-          <p:cNvPr id="27" name="Text 22"/>
-          <p:cNvSpPr txBox="1"/>
-          <p:nvPr/>
-        </p:nvSpPr>
-        <p:spPr>
-          <a:xfrm>
-            <a:off x="3493008" y="2532888"/>
-            <a:ext cx="1517904" cy="292608"/>
-          </a:xfrm>
-          <a:prstGeom prst="rect">
-            <a:avLst/>
-          </a:prstGeom>
-          <a:noFill/>
-          <a:ln/>
-        </p:spPr>
-        <p:txBody>
-          <a:bodyPr wrap="square" lIns="0" tIns="0" rIns="0" bIns="0" rtlCol="0" anchor="ctr"/>
-          <a:lstStyle/>
-          <a:p>
-            <a:pPr algn="ctr" indent="0" marL="0">
-              <a:buNone/>
-            </a:pPr>
-            <a:r>
-              <a:rPr lang="en-US" sz="1300" b="1" dirty="0">
-                <a:solidFill>
-                  <a:srgbClr val="21141A"/>
-                </a:solidFill>
-                <a:latin typeface="IBM Plex Sans Arabic" pitchFamily="34" charset="0"/>
-                <a:ea typeface="IBM Plex Sans Arabic" pitchFamily="34" charset="-122"/>
-                <a:cs typeface="IBM Plex Sans Arabic" pitchFamily="34" charset="-120"/>
-              </a:rPr>
-              <a:t>Google Cloud</a:t>
-            </a:r>
-            <a:endParaRPr lang="en-US" sz="1300" dirty="0"/>
-          </a:p>
-        </p:txBody>
-      </p:sp>
-      <p:sp>
-        <p:nvSpPr>
-          <p:cNvPr id="28" name="Text 23"/>
-          <p:cNvSpPr txBox="1"/>
-          <p:nvPr/>
-        </p:nvSpPr>
-        <p:spPr>
-          <a:xfrm>
-            <a:off x="3493008" y="2825496"/>
-            <a:ext cx="1517904" cy="256032"/>
-          </a:xfrm>
-          <a:prstGeom prst="rect">
-            <a:avLst/>
-          </a:prstGeom>
-          <a:noFill/>
-          <a:ln/>
-        </p:spPr>
-        <p:txBody>
-          <a:bodyPr wrap="square" lIns="0" tIns="0" rIns="0" bIns="0" rtlCol="0" anchor="ctr"/>
-          <a:lstStyle/>
-          <a:p>
-            <a:pPr algn="ctr" indent="0" marL="0">
-              <a:buNone/>
-            </a:pPr>
-            <a:r>
-              <a:rPr lang="en-US" sz="1050" dirty="0">
-                <a:solidFill>
-                  <a:srgbClr val="7F6C72"/>
-                </a:solidFill>
-                <a:latin typeface="IBM Plex Sans Arabic" pitchFamily="34" charset="0"/>
-                <a:ea typeface="IBM Plex Sans Arabic" pitchFamily="34" charset="-122"/>
-                <a:cs typeface="IBM Plex Sans Arabic" pitchFamily="34" charset="-120"/>
-              </a:rPr>
-              <a:t>Cost Management</a:t>
-            </a:r>
-            <a:endParaRPr lang="en-US" sz="1050" dirty="0"/>
-          </a:p>
-        </p:txBody>
-      </p:sp>
-      <p:sp>
-        <p:nvSpPr>
-          <p:cNvPr id="29" name="Text 24"/>
-          <p:cNvSpPr txBox="1"/>
-          <p:nvPr/>
-        </p:nvSpPr>
-        <p:spPr>
-          <a:xfrm>
-            <a:off x="1975104" y="2532888"/>
-            <a:ext cx="1517904" cy="292608"/>
-          </a:xfrm>
-          <a:prstGeom prst="rect">
-            <a:avLst/>
-          </a:prstGeom>
-          <a:noFill/>
-          <a:ln/>
-        </p:spPr>
-        <p:txBody>
-          <a:bodyPr wrap="square" lIns="0" tIns="0" rIns="0" bIns="0" rtlCol="0" anchor="ctr"/>
-          <a:lstStyle/>
-          <a:p>
-            <a:pPr algn="ctr" indent="0" marL="0">
-              <a:buNone/>
-            </a:pPr>
-            <a:r>
-              <a:rPr lang="en-US" sz="1300" b="1" dirty="0">
-                <a:solidFill>
-                  <a:srgbClr val="21141A"/>
-                </a:solidFill>
-                <a:latin typeface="IBM Plex Sans Arabic" pitchFamily="34" charset="0"/>
-                <a:ea typeface="IBM Plex Sans Arabic" pitchFamily="34" charset="-122"/>
-                <a:cs typeface="IBM Plex Sans Arabic" pitchFamily="34" charset="-120"/>
-              </a:rPr>
-              <a:t>Microsoft Azure</a:t>
-            </a:r>
-            <a:endParaRPr lang="en-US" sz="1300" dirty="0"/>
-          </a:p>
-        </p:txBody>
-      </p:sp>
-      <p:sp>
-        <p:nvSpPr>
-          <p:cNvPr id="30" name="Text 25"/>
-          <p:cNvSpPr txBox="1"/>
-          <p:nvPr/>
-        </p:nvSpPr>
-        <p:spPr>
-          <a:xfrm>
-            <a:off x="1975104" y="2825496"/>
-            <a:ext cx="1517904" cy="256032"/>
-          </a:xfrm>
-          <a:prstGeom prst="rect">
-            <a:avLst/>
-          </a:prstGeom>
-          <a:noFill/>
-          <a:ln/>
-        </p:spPr>
-        <p:txBody>
-          <a:bodyPr wrap="square" lIns="0" tIns="0" rIns="0" bIns="0" rtlCol="0" anchor="ctr"/>
-          <a:lstStyle/>
-          <a:p>
-            <a:pPr algn="ctr" indent="0" marL="0">
-              <a:buNone/>
-            </a:pPr>
-            <a:r>
-              <a:rPr lang="en-US" sz="1050" dirty="0">
-                <a:solidFill>
-                  <a:srgbClr val="7F6C72"/>
-                </a:solidFill>
-                <a:latin typeface="IBM Plex Sans Arabic" pitchFamily="34" charset="0"/>
-                <a:ea typeface="IBM Plex Sans Arabic" pitchFamily="34" charset="-122"/>
-                <a:cs typeface="IBM Plex Sans Arabic" pitchFamily="34" charset="-120"/>
-              </a:rPr>
-              <a:t>Cost Management</a:t>
-            </a:r>
-            <a:endParaRPr lang="en-US" sz="1050" dirty="0"/>
-          </a:p>
-        </p:txBody>
-      </p:sp>
-      <p:sp>
-        <p:nvSpPr>
-          <p:cNvPr id="31" name="Text 26"/>
-          <p:cNvSpPr txBox="1"/>
-          <p:nvPr/>
-        </p:nvSpPr>
-        <p:spPr>
-          <a:xfrm>
-            <a:off x="457200" y="2532888"/>
-            <a:ext cx="1517904" cy="292608"/>
-          </a:xfrm>
-          <a:prstGeom prst="rect">
-            <a:avLst/>
-          </a:prstGeom>
-          <a:noFill/>
-          <a:ln/>
-        </p:spPr>
-        <p:txBody>
-          <a:bodyPr wrap="square" lIns="0" tIns="0" rIns="0" bIns="0" rtlCol="0" anchor="ctr"/>
-          <a:lstStyle/>
-          <a:p>
-            <a:pPr algn="ctr" indent="0" marL="0">
-              <a:buNone/>
-            </a:pPr>
-            <a:r>
-              <a:rPr lang="en-US" sz="1300" b="1" dirty="0">
-                <a:solidFill>
-                  <a:srgbClr val="21141A"/>
-                </a:solidFill>
-                <a:latin typeface="IBM Plex Sans Arabic" pitchFamily="34" charset="0"/>
-                <a:ea typeface="IBM Plex Sans Arabic" pitchFamily="34" charset="-122"/>
-                <a:cs typeface="IBM Plex Sans Arabic" pitchFamily="34" charset="-120"/>
-              </a:rPr>
-              <a:t>Oracle Cloud</a:t>
-            </a:r>
-            <a:endParaRPr lang="en-US" sz="1300" dirty="0"/>
-          </a:p>
-        </p:txBody>
-      </p:sp>
-      <p:sp>
-        <p:nvSpPr>
-          <p:cNvPr id="32" name="Text 27"/>
-          <p:cNvSpPr txBox="1"/>
-          <p:nvPr/>
-        </p:nvSpPr>
-        <p:spPr>
-          <a:xfrm>
-            <a:off x="457200" y="2825496"/>
-            <a:ext cx="1517904" cy="256032"/>
-          </a:xfrm>
-          <a:prstGeom prst="rect">
-            <a:avLst/>
-          </a:prstGeom>
-          <a:noFill/>
-          <a:ln/>
-        </p:spPr>
-        <p:txBody>
-          <a:bodyPr wrap="square" lIns="0" tIns="0" rIns="0" bIns="0" rtlCol="0" anchor="ctr"/>
-          <a:lstStyle/>
-          <a:p>
-            <a:pPr algn="ctr" indent="0" marL="0">
-              <a:buNone/>
-            </a:pPr>
-            <a:r>
-              <a:rPr lang="en-US" sz="1050" dirty="0">
-                <a:solidFill>
-                  <a:srgbClr val="7F6C72"/>
-                </a:solidFill>
-                <a:latin typeface="IBM Plex Sans Arabic" pitchFamily="34" charset="0"/>
-                <a:ea typeface="IBM Plex Sans Arabic" pitchFamily="34" charset="-122"/>
-                <a:cs typeface="IBM Plex Sans Arabic" pitchFamily="34" charset="-120"/>
-              </a:rPr>
-              <a:t>Infrastructure</a:t>
-            </a:r>
-            <a:endParaRPr lang="en-US" sz="1050" dirty="0"/>
-          </a:p>
-        </p:txBody>
-      </p:sp>
-      <p:sp>
-        <p:nvSpPr>
-          <p:cNvPr id="33" name="Text 28"/>
-          <p:cNvSpPr txBox="1"/>
-          <p:nvPr/>
-        </p:nvSpPr>
-        <p:spPr>
-          <a:xfrm>
-            <a:off x="8229600" y="2514600"/>
-            <a:ext cx="3504895" cy="594360"/>
-          </a:xfrm>
-          <a:prstGeom prst="rect">
-            <a:avLst/>
-          </a:prstGeom>
-          <a:noFill/>
-          <a:ln/>
-        </p:spPr>
-        <p:txBody>
-          <a:bodyPr wrap="square" lIns="0" tIns="0" rIns="0" bIns="0" rtlCol="0" anchor="ctr"/>
-          <a:lstStyle/>
-          <a:p>
-            <a:pPr rtl="1" algn="r" indent="0" marL="0">
-              <a:buNone/>
-            </a:pPr>
-            <a:r>
-              <a:rPr lang="en-US" sz="1400" b="1" dirty="0">
-                <a:solidFill>
-                  <a:srgbClr val="7F6C72"/>
-                </a:solidFill>
-                <a:latin typeface="IBM Plex Sans Arabic" pitchFamily="34" charset="0"/>
-                <a:ea typeface="IBM Plex Sans Arabic" pitchFamily="34" charset="-122"/>
-                <a:cs typeface="IBM Plex Sans Arabic" pitchFamily="34" charset="-120"/>
-              </a:rPr>
-              <a:t>الميزة</a:t>
-            </a:r>
-            <a:endParaRPr lang="en-US" sz="1400" dirty="0"/>
-          </a:p>
-        </p:txBody>
-      </p:sp>
-      <p:sp>
-        <p:nvSpPr>
-          <p:cNvPr id="34" name="Shape 29"/>
+          <p:cNvPr id="29" name="Shape 24"/>
           <p:cNvSpPr/>
           <p:nvPr/>
         </p:nvSpPr>
@@ -9304,14 +9148,14 @@
       </p:sp>
       <p:sp>
         <p:nvSpPr>
-          <p:cNvPr id="35" name="Text 30"/>
-          <p:cNvSpPr txBox="1"/>
-          <p:nvPr/>
-        </p:nvSpPr>
-        <p:spPr>
-          <a:xfrm>
-            <a:off x="8229600" y="3200400"/>
-            <a:ext cx="3504895" cy="512064"/>
+          <p:cNvPr id="30" name="Text 25"/>
+          <p:cNvSpPr txBox="1"/>
+          <p:nvPr/>
+        </p:nvSpPr>
+        <p:spPr>
+          <a:xfrm>
+            <a:off x="9418320" y="3200400"/>
+            <a:ext cx="2316175" cy="502920"/>
           </a:xfrm>
           <a:prstGeom prst="rect">
             <a:avLst/>
@@ -9327,7 +9171,85 @@
               <a:buNone/>
             </a:pPr>
             <a:r>
-              <a:rPr lang="en-US" sz="1500" dirty="0">
+              <a:rPr lang="en-US" sz="1500" b="1" dirty="0">
+                <a:solidFill>
+                  <a:srgbClr val="7F6C72"/>
+                </a:solidFill>
+                <a:latin typeface="IBM Plex Sans Arabic" pitchFamily="34" charset="0"/>
+                <a:ea typeface="IBM Plex Sans Arabic" pitchFamily="34" charset="-122"/>
+                <a:cs typeface="IBM Plex Sans Arabic" pitchFamily="34" charset="-120"/>
+              </a:rPr>
+              <a:t>الجمهور المستهدف</a:t>
+            </a:r>
+            <a:endParaRPr lang="en-US" sz="1500" dirty="0"/>
+          </a:p>
+        </p:txBody>
+      </p:sp>
+      <p:sp>
+        <p:nvSpPr>
+          <p:cNvPr id="31" name="Text 26"/>
+          <p:cNvSpPr txBox="1"/>
+          <p:nvPr/>
+        </p:nvSpPr>
+        <p:spPr>
+          <a:xfrm>
+            <a:off x="6400800" y="3200400"/>
+            <a:ext cx="2743200" cy="502920"/>
+          </a:xfrm>
+          <a:prstGeom prst="rect">
+            <a:avLst/>
+          </a:prstGeom>
+          <a:noFill/>
+          <a:ln/>
+        </p:spPr>
+        <p:txBody>
+          <a:bodyPr wrap="square" lIns="0" tIns="0" rIns="0" bIns="0" rtlCol="0" anchor="ctr"/>
+          <a:lstStyle/>
+          <a:p>
+            <a:pPr rtl="1" algn="ctr" indent="0" marL="0">
+              <a:buNone/>
+            </a:pPr>
+            <a:r>
+              <a:rPr lang="en-US" sz="1500" b="1" dirty="0">
+                <a:solidFill>
+                  <a:srgbClr val="8E2F3C"/>
+                </a:solidFill>
+                <a:latin typeface="IBM Plex Sans Arabic" pitchFamily="34" charset="0"/>
+                <a:ea typeface="IBM Plex Sans Arabic" pitchFamily="34" charset="-122"/>
+                <a:cs typeface="IBM Plex Sans Arabic" pitchFamily="34" charset="-120"/>
+              </a:rPr>
+              <a:t>الشركات الناشئة والمتوسطة</a:t>
+            </a:r>
+            <a:endParaRPr lang="en-US" sz="1500" dirty="0"/>
+          </a:p>
+        </p:txBody>
+      </p:sp>
+      <p:sp>
+        <p:nvSpPr>
+          <p:cNvPr id="32" name="Text 27"/>
+          <p:cNvSpPr txBox="1"/>
+          <p:nvPr/>
+        </p:nvSpPr>
+        <p:spPr>
+          <a:xfrm>
+            <a:off x="3474720" y="3200400"/>
+            <a:ext cx="2743200" cy="502920"/>
+          </a:xfrm>
+          <a:prstGeom prst="rect">
+            <a:avLst/>
+          </a:prstGeom>
+          <a:noFill/>
+          <a:ln/>
+        </p:spPr>
+        <p:txBody>
+          <a:bodyPr wrap="square" lIns="0" tIns="0" rIns="0" bIns="0" rtlCol="0" anchor="ctr"/>
+          <a:lstStyle/>
+          <a:p>
+            <a:pPr rtl="1" algn="ctr" indent="0" marL="0">
+              <a:buNone/>
+            </a:pPr>
+            <a:r>
+              <a:rPr lang="en-US" sz="1400" dirty="0">
                 <a:solidFill>
                   <a:srgbClr val="21141A"/>
                 </a:solidFill>
@@ -9335,42 +9257,22 @@
                 <a:ea typeface="IBM Plex Sans Arabic" pitchFamily="34" charset="-122"/>
                 <a:cs typeface="IBM Plex Sans Arabic" pitchFamily="34" charset="-120"/>
               </a:rPr>
-              <a:t>STC وSCCC وCNTXT</a:t>
-            </a:r>
-            <a:endParaRPr lang="en-US" sz="1500" dirty="0"/>
-          </a:p>
-        </p:txBody>
-      </p:sp>
-      <p:sp>
-        <p:nvSpPr>
-          <p:cNvPr id="36" name="Shape 31"/>
-          <p:cNvSpPr/>
-          <p:nvPr/>
-        </p:nvSpPr>
-        <p:spPr>
-          <a:xfrm>
-            <a:off x="7114032" y="3282696"/>
-            <a:ext cx="347472" cy="347472"/>
-          </a:xfrm>
-          <a:prstGeom prst="ellipse">
-            <a:avLst/>
-          </a:prstGeom>
-          <a:solidFill>
-            <a:srgbClr val="7FB27A"/>
-          </a:solidFill>
-          <a:ln/>
-        </p:spPr>
-      </p:sp>
-      <p:sp>
-        <p:nvSpPr>
-          <p:cNvPr id="37" name="Text 32"/>
-          <p:cNvSpPr txBox="1"/>
-          <p:nvPr/>
-        </p:nvSpPr>
-        <p:spPr>
-          <a:xfrm>
-            <a:off x="7114032" y="3282696"/>
-            <a:ext cx="347472" cy="347472"/>
+              <a:t>مستخدمو سحابة واحدة</a:t>
+            </a:r>
+            <a:endParaRPr lang="en-US" sz="1400" dirty="0"/>
+          </a:p>
+        </p:txBody>
+      </p:sp>
+      <p:sp>
+        <p:nvSpPr>
+          <p:cNvPr id="33" name="Text 28"/>
+          <p:cNvSpPr txBox="1"/>
+          <p:nvPr/>
+        </p:nvSpPr>
+        <p:spPr>
+          <a:xfrm>
+            <a:off x="548640" y="3200400"/>
+            <a:ext cx="2743200" cy="502920"/>
           </a:xfrm>
           <a:prstGeom prst="rect">
             <a:avLst/>
@@ -9382,269 +9284,33 @@
           <a:bodyPr wrap="square" lIns="0" tIns="0" rIns="0" bIns="0" rtlCol="0" anchor="ctr"/>
           <a:lstStyle/>
           <a:p>
-            <a:pPr algn="ctr" indent="0" marL="0">
-              <a:buNone/>
-            </a:pPr>
-            <a:r>
-              <a:rPr lang="en-US" sz="1300" b="1" dirty="0">
-                <a:solidFill>
-                  <a:srgbClr val="FFFFFF"/>
-                </a:solidFill>
-                <a:latin typeface="IBM Plex Sans Arabic" pitchFamily="34" charset="0"/>
-                <a:ea typeface="IBM Plex Sans Arabic" pitchFamily="34" charset="-122"/>
-                <a:cs typeface="IBM Plex Sans Arabic" pitchFamily="34" charset="-120"/>
-              </a:rPr>
-              <a:t>✓</a:t>
-            </a:r>
-            <a:endParaRPr lang="en-US" sz="1300" dirty="0"/>
-          </a:p>
-        </p:txBody>
-      </p:sp>
-      <p:sp>
-        <p:nvSpPr>
-          <p:cNvPr id="38" name="Shape 33"/>
-          <p:cNvSpPr/>
-          <p:nvPr/>
-        </p:nvSpPr>
-        <p:spPr>
-          <a:xfrm>
-            <a:off x="5596128" y="3282696"/>
-            <a:ext cx="347472" cy="347472"/>
-          </a:xfrm>
-          <a:prstGeom prst="ellipse">
-            <a:avLst/>
-          </a:prstGeom>
-          <a:solidFill>
-            <a:srgbClr val="D48A93"/>
-          </a:solidFill>
-          <a:ln/>
-        </p:spPr>
-      </p:sp>
-      <p:sp>
-        <p:nvSpPr>
-          <p:cNvPr id="39" name="Text 34"/>
-          <p:cNvSpPr txBox="1"/>
-          <p:nvPr/>
-        </p:nvSpPr>
-        <p:spPr>
-          <a:xfrm>
-            <a:off x="5596128" y="3282696"/>
-            <a:ext cx="347472" cy="347472"/>
-          </a:xfrm>
-          <a:prstGeom prst="rect">
-            <a:avLst/>
-          </a:prstGeom>
-          <a:noFill/>
-          <a:ln/>
-        </p:spPr>
-        <p:txBody>
-          <a:bodyPr wrap="square" lIns="0" tIns="0" rIns="0" bIns="0" rtlCol="0" anchor="ctr"/>
-          <a:lstStyle/>
-          <a:p>
-            <a:pPr algn="ctr" indent="0" marL="0">
-              <a:buNone/>
-            </a:pPr>
-            <a:r>
-              <a:rPr lang="en-US" sz="1300" b="1" dirty="0">
-                <a:solidFill>
-                  <a:srgbClr val="FFFFFF"/>
-                </a:solidFill>
-                <a:latin typeface="IBM Plex Sans Arabic" pitchFamily="34" charset="0"/>
-                <a:ea typeface="IBM Plex Sans Arabic" pitchFamily="34" charset="-122"/>
-                <a:cs typeface="IBM Plex Sans Arabic" pitchFamily="34" charset="-120"/>
-              </a:rPr>
-              <a:t>✕</a:t>
-            </a:r>
-            <a:endParaRPr lang="en-US" sz="1300" dirty="0"/>
-          </a:p>
-        </p:txBody>
-      </p:sp>
-      <p:sp>
-        <p:nvSpPr>
-          <p:cNvPr id="40" name="Shape 35"/>
-          <p:cNvSpPr/>
-          <p:nvPr/>
-        </p:nvSpPr>
-        <p:spPr>
-          <a:xfrm>
-            <a:off x="4078224" y="3282696"/>
-            <a:ext cx="347472" cy="347472"/>
-          </a:xfrm>
-          <a:prstGeom prst="ellipse">
-            <a:avLst/>
-          </a:prstGeom>
-          <a:solidFill>
-            <a:srgbClr val="D48A93"/>
-          </a:solidFill>
-          <a:ln/>
-        </p:spPr>
-      </p:sp>
-      <p:sp>
-        <p:nvSpPr>
-          <p:cNvPr id="41" name="Text 36"/>
-          <p:cNvSpPr txBox="1"/>
-          <p:nvPr/>
-        </p:nvSpPr>
-        <p:spPr>
-          <a:xfrm>
-            <a:off x="4078224" y="3282696"/>
-            <a:ext cx="347472" cy="347472"/>
-          </a:xfrm>
-          <a:prstGeom prst="rect">
-            <a:avLst/>
-          </a:prstGeom>
-          <a:noFill/>
-          <a:ln/>
-        </p:spPr>
-        <p:txBody>
-          <a:bodyPr wrap="square" lIns="0" tIns="0" rIns="0" bIns="0" rtlCol="0" anchor="ctr"/>
-          <a:lstStyle/>
-          <a:p>
-            <a:pPr algn="ctr" indent="0" marL="0">
-              <a:buNone/>
-            </a:pPr>
-            <a:r>
-              <a:rPr lang="en-US" sz="1300" b="1" dirty="0">
-                <a:solidFill>
-                  <a:srgbClr val="FFFFFF"/>
-                </a:solidFill>
-                <a:latin typeface="IBM Plex Sans Arabic" pitchFamily="34" charset="0"/>
-                <a:ea typeface="IBM Plex Sans Arabic" pitchFamily="34" charset="-122"/>
-                <a:cs typeface="IBM Plex Sans Arabic" pitchFamily="34" charset="-120"/>
-              </a:rPr>
-              <a:t>✕</a:t>
-            </a:r>
-            <a:endParaRPr lang="en-US" sz="1300" dirty="0"/>
-          </a:p>
-        </p:txBody>
-      </p:sp>
-      <p:sp>
-        <p:nvSpPr>
-          <p:cNvPr id="42" name="Shape 37"/>
-          <p:cNvSpPr/>
-          <p:nvPr/>
-        </p:nvSpPr>
-        <p:spPr>
-          <a:xfrm>
-            <a:off x="2560320" y="3282696"/>
-            <a:ext cx="347472" cy="347472"/>
-          </a:xfrm>
-          <a:prstGeom prst="ellipse">
-            <a:avLst/>
-          </a:prstGeom>
-          <a:solidFill>
-            <a:srgbClr val="D48A93"/>
-          </a:solidFill>
-          <a:ln/>
-        </p:spPr>
-      </p:sp>
-      <p:sp>
-        <p:nvSpPr>
-          <p:cNvPr id="43" name="Text 38"/>
-          <p:cNvSpPr txBox="1"/>
-          <p:nvPr/>
-        </p:nvSpPr>
-        <p:spPr>
-          <a:xfrm>
-            <a:off x="2560320" y="3282696"/>
-            <a:ext cx="347472" cy="347472"/>
-          </a:xfrm>
-          <a:prstGeom prst="rect">
-            <a:avLst/>
-          </a:prstGeom>
-          <a:noFill/>
-          <a:ln/>
-        </p:spPr>
-        <p:txBody>
-          <a:bodyPr wrap="square" lIns="0" tIns="0" rIns="0" bIns="0" rtlCol="0" anchor="ctr"/>
-          <a:lstStyle/>
-          <a:p>
-            <a:pPr algn="ctr" indent="0" marL="0">
-              <a:buNone/>
-            </a:pPr>
-            <a:r>
-              <a:rPr lang="en-US" sz="1300" b="1" dirty="0">
-                <a:solidFill>
-                  <a:srgbClr val="FFFFFF"/>
-                </a:solidFill>
-                <a:latin typeface="IBM Plex Sans Arabic" pitchFamily="34" charset="0"/>
-                <a:ea typeface="IBM Plex Sans Arabic" pitchFamily="34" charset="-122"/>
-                <a:cs typeface="IBM Plex Sans Arabic" pitchFamily="34" charset="-120"/>
-              </a:rPr>
-              <a:t>✕</a:t>
-            </a:r>
-            <a:endParaRPr lang="en-US" sz="1300" dirty="0"/>
-          </a:p>
-        </p:txBody>
-      </p:sp>
-      <p:sp>
-        <p:nvSpPr>
-          <p:cNvPr id="44" name="Shape 39"/>
-          <p:cNvSpPr/>
-          <p:nvPr/>
-        </p:nvSpPr>
-        <p:spPr>
-          <a:xfrm>
-            <a:off x="1042416" y="3282696"/>
-            <a:ext cx="347472" cy="347472"/>
-          </a:xfrm>
-          <a:prstGeom prst="ellipse">
-            <a:avLst/>
-          </a:prstGeom>
-          <a:solidFill>
-            <a:srgbClr val="D48A93"/>
-          </a:solidFill>
-          <a:ln/>
-        </p:spPr>
-      </p:sp>
-      <p:sp>
-        <p:nvSpPr>
-          <p:cNvPr id="45" name="Text 40"/>
-          <p:cNvSpPr txBox="1"/>
-          <p:nvPr/>
-        </p:nvSpPr>
-        <p:spPr>
-          <a:xfrm>
-            <a:off x="1042416" y="3282696"/>
-            <a:ext cx="347472" cy="347472"/>
-          </a:xfrm>
-          <a:prstGeom prst="rect">
-            <a:avLst/>
-          </a:prstGeom>
-          <a:noFill/>
-          <a:ln/>
-        </p:spPr>
-        <p:txBody>
-          <a:bodyPr wrap="square" lIns="0" tIns="0" rIns="0" bIns="0" rtlCol="0" anchor="ctr"/>
-          <a:lstStyle/>
-          <a:p>
-            <a:pPr algn="ctr" indent="0" marL="0">
-              <a:buNone/>
-            </a:pPr>
-            <a:r>
-              <a:rPr lang="en-US" sz="1300" b="1" dirty="0">
-                <a:solidFill>
-                  <a:srgbClr val="FFFFFF"/>
-                </a:solidFill>
-                <a:latin typeface="IBM Plex Sans Arabic" pitchFamily="34" charset="0"/>
-                <a:ea typeface="IBM Plex Sans Arabic" pitchFamily="34" charset="-122"/>
-                <a:cs typeface="IBM Plex Sans Arabic" pitchFamily="34" charset="-120"/>
-              </a:rPr>
-              <a:t>✕</a:t>
-            </a:r>
-            <a:endParaRPr lang="en-US" sz="1300" dirty="0"/>
-          </a:p>
-        </p:txBody>
-      </p:sp>
-      <p:sp>
-        <p:nvSpPr>
-          <p:cNvPr id="46" name="Shape 41"/>
-          <p:cNvSpPr/>
-          <p:nvPr/>
-        </p:nvSpPr>
-        <p:spPr>
-          <a:xfrm>
-            <a:off x="457200" y="3712464"/>
+            <a:pPr rtl="1" algn="ctr" indent="0" marL="0">
+              <a:buNone/>
+            </a:pPr>
+            <a:r>
+              <a:rPr lang="en-US" sz="1400" dirty="0">
+                <a:solidFill>
+                  <a:srgbClr val="21141A"/>
+                </a:solidFill>
+                <a:latin typeface="IBM Plex Sans Arabic" pitchFamily="34" charset="0"/>
+                <a:ea typeface="IBM Plex Sans Arabic" pitchFamily="34" charset="-122"/>
+                <a:cs typeface="IBM Plex Sans Arabic" pitchFamily="34" charset="-120"/>
+              </a:rPr>
+              <a:t>المؤسسات والجهات الحكومية</a:t>
+            </a:r>
+            <a:endParaRPr lang="en-US" sz="1400" dirty="0"/>
+          </a:p>
+        </p:txBody>
+      </p:sp>
+      <p:sp>
+        <p:nvSpPr>
+          <p:cNvPr id="34" name="Shape 29"/>
+          <p:cNvSpPr/>
+          <p:nvPr/>
+        </p:nvSpPr>
+        <p:spPr>
+          <a:xfrm>
+            <a:off x="457200" y="3703320"/>
             <a:ext cx="11277295" cy="0"/>
           </a:xfrm>
           <a:prstGeom prst="line">
@@ -9661,14 +9327,14 @@
       </p:sp>
       <p:sp>
         <p:nvSpPr>
-          <p:cNvPr id="47" name="Text 42"/>
-          <p:cNvSpPr txBox="1"/>
-          <p:nvPr/>
-        </p:nvSpPr>
-        <p:spPr>
-          <a:xfrm>
-            <a:off x="8229600" y="3712464"/>
-            <a:ext cx="3504895" cy="512064"/>
+          <p:cNvPr id="35" name="Text 30"/>
+          <p:cNvSpPr txBox="1"/>
+          <p:nvPr/>
+        </p:nvSpPr>
+        <p:spPr>
+          <a:xfrm>
+            <a:off x="9418320" y="3703320"/>
+            <a:ext cx="2316175" cy="502920"/>
           </a:xfrm>
           <a:prstGeom prst="rect">
             <a:avLst/>
@@ -9684,7 +9350,85 @@
               <a:buNone/>
             </a:pPr>
             <a:r>
-              <a:rPr lang="en-US" sz="1500" dirty="0">
+              <a:rPr lang="en-US" sz="1500" b="1" dirty="0">
+                <a:solidFill>
+                  <a:srgbClr val="7F6C72"/>
+                </a:solidFill>
+                <a:latin typeface="IBM Plex Sans Arabic" pitchFamily="34" charset="0"/>
+                <a:ea typeface="IBM Plex Sans Arabic" pitchFamily="34" charset="-122"/>
+                <a:cs typeface="IBM Plex Sans Arabic" pitchFamily="34" charset="-120"/>
+              </a:rPr>
+              <a:t>السحب المدعومة</a:t>
+            </a:r>
+            <a:endParaRPr lang="en-US" sz="1500" dirty="0"/>
+          </a:p>
+        </p:txBody>
+      </p:sp>
+      <p:sp>
+        <p:nvSpPr>
+          <p:cNvPr id="36" name="Text 31"/>
+          <p:cNvSpPr txBox="1"/>
+          <p:nvPr/>
+        </p:nvSpPr>
+        <p:spPr>
+          <a:xfrm>
+            <a:off x="6400800" y="3703320"/>
+            <a:ext cx="2743200" cy="502920"/>
+          </a:xfrm>
+          <a:prstGeom prst="rect">
+            <a:avLst/>
+          </a:prstGeom>
+          <a:noFill/>
+          <a:ln/>
+        </p:spPr>
+        <p:txBody>
+          <a:bodyPr wrap="square" lIns="0" tIns="0" rIns="0" bIns="0" rtlCol="0" anchor="ctr"/>
+          <a:lstStyle/>
+          <a:p>
+            <a:pPr rtl="1" algn="ctr" indent="0" marL="0">
+              <a:buNone/>
+            </a:pPr>
+            <a:r>
+              <a:rPr lang="en-US" sz="1500" b="1" dirty="0">
+                <a:solidFill>
+                  <a:srgbClr val="8E2F3C"/>
+                </a:solidFill>
+                <a:latin typeface="IBM Plex Sans Arabic" pitchFamily="34" charset="0"/>
+                <a:ea typeface="IBM Plex Sans Arabic" pitchFamily="34" charset="-122"/>
+                <a:cs typeface="IBM Plex Sans Arabic" pitchFamily="34" charset="-120"/>
+              </a:rPr>
+              <a:t>العالمية والمحلية معاً</a:t>
+            </a:r>
+            <a:endParaRPr lang="en-US" sz="1500" dirty="0"/>
+          </a:p>
+        </p:txBody>
+      </p:sp>
+      <p:sp>
+        <p:nvSpPr>
+          <p:cNvPr id="37" name="Text 32"/>
+          <p:cNvSpPr txBox="1"/>
+          <p:nvPr/>
+        </p:nvSpPr>
+        <p:spPr>
+          <a:xfrm>
+            <a:off x="3474720" y="3703320"/>
+            <a:ext cx="2743200" cy="502920"/>
+          </a:xfrm>
+          <a:prstGeom prst="rect">
+            <a:avLst/>
+          </a:prstGeom>
+          <a:noFill/>
+          <a:ln/>
+        </p:spPr>
+        <p:txBody>
+          <a:bodyPr wrap="square" lIns="0" tIns="0" rIns="0" bIns="0" rtlCol="0" anchor="ctr"/>
+          <a:lstStyle/>
+          <a:p>
+            <a:pPr rtl="1" algn="ctr" indent="0" marL="0">
+              <a:buNone/>
+            </a:pPr>
+            <a:r>
+              <a:rPr lang="en-US" sz="1400" dirty="0">
                 <a:solidFill>
                   <a:srgbClr val="21141A"/>
                 </a:solidFill>
@@ -9692,42 +9436,22 @@
                 <a:ea typeface="IBM Plex Sans Arabic" pitchFamily="34" charset="-122"/>
                 <a:cs typeface="IBM Plex Sans Arabic" pitchFamily="34" charset="-120"/>
               </a:rPr>
-              <a:t>كل السحابات في لوحة واحدة</a:t>
-            </a:r>
-            <a:endParaRPr lang="en-US" sz="1500" dirty="0"/>
-          </a:p>
-        </p:txBody>
-      </p:sp>
-      <p:sp>
-        <p:nvSpPr>
-          <p:cNvPr id="48" name="Shape 43"/>
-          <p:cNvSpPr/>
-          <p:nvPr/>
-        </p:nvSpPr>
-        <p:spPr>
-          <a:xfrm>
-            <a:off x="7114032" y="3794760"/>
-            <a:ext cx="347472" cy="347472"/>
-          </a:xfrm>
-          <a:prstGeom prst="ellipse">
-            <a:avLst/>
-          </a:prstGeom>
-          <a:solidFill>
-            <a:srgbClr val="7FB27A"/>
-          </a:solidFill>
-          <a:ln/>
-        </p:spPr>
-      </p:sp>
-      <p:sp>
-        <p:nvSpPr>
-          <p:cNvPr id="49" name="Text 44"/>
-          <p:cNvSpPr txBox="1"/>
-          <p:nvPr/>
-        </p:nvSpPr>
-        <p:spPr>
-          <a:xfrm>
-            <a:off x="7114032" y="3794760"/>
-            <a:ext cx="347472" cy="347472"/>
+              <a:t>سحابة المزود فقط</a:t>
+            </a:r>
+            <a:endParaRPr lang="en-US" sz="1400" dirty="0"/>
+          </a:p>
+        </p:txBody>
+      </p:sp>
+      <p:sp>
+        <p:nvSpPr>
+          <p:cNvPr id="38" name="Text 33"/>
+          <p:cNvSpPr txBox="1"/>
+          <p:nvPr/>
+        </p:nvSpPr>
+        <p:spPr>
+          <a:xfrm>
+            <a:off x="548640" y="3703320"/>
+            <a:ext cx="2743200" cy="502920"/>
           </a:xfrm>
           <a:prstGeom prst="rect">
             <a:avLst/>
@@ -9739,269 +9463,33 @@
           <a:bodyPr wrap="square" lIns="0" tIns="0" rIns="0" bIns="0" rtlCol="0" anchor="ctr"/>
           <a:lstStyle/>
           <a:p>
-            <a:pPr algn="ctr" indent="0" marL="0">
-              <a:buNone/>
-            </a:pPr>
-            <a:r>
-              <a:rPr lang="en-US" sz="1300" b="1" dirty="0">
-                <a:solidFill>
-                  <a:srgbClr val="FFFFFF"/>
-                </a:solidFill>
-                <a:latin typeface="IBM Plex Sans Arabic" pitchFamily="34" charset="0"/>
-                <a:ea typeface="IBM Plex Sans Arabic" pitchFamily="34" charset="-122"/>
-                <a:cs typeface="IBM Plex Sans Arabic" pitchFamily="34" charset="-120"/>
-              </a:rPr>
-              <a:t>✓</a:t>
-            </a:r>
-            <a:endParaRPr lang="en-US" sz="1300" dirty="0"/>
-          </a:p>
-        </p:txBody>
-      </p:sp>
-      <p:sp>
-        <p:nvSpPr>
-          <p:cNvPr id="50" name="Shape 45"/>
-          <p:cNvSpPr/>
-          <p:nvPr/>
-        </p:nvSpPr>
-        <p:spPr>
-          <a:xfrm>
-            <a:off x="5596128" y="3794760"/>
-            <a:ext cx="347472" cy="347472"/>
-          </a:xfrm>
-          <a:prstGeom prst="ellipse">
-            <a:avLst/>
-          </a:prstGeom>
-          <a:solidFill>
-            <a:srgbClr val="D48A93"/>
-          </a:solidFill>
-          <a:ln/>
-        </p:spPr>
-      </p:sp>
-      <p:sp>
-        <p:nvSpPr>
-          <p:cNvPr id="51" name="Text 46"/>
-          <p:cNvSpPr txBox="1"/>
-          <p:nvPr/>
-        </p:nvSpPr>
-        <p:spPr>
-          <a:xfrm>
-            <a:off x="5596128" y="3794760"/>
-            <a:ext cx="347472" cy="347472"/>
-          </a:xfrm>
-          <a:prstGeom prst="rect">
-            <a:avLst/>
-          </a:prstGeom>
-          <a:noFill/>
-          <a:ln/>
-        </p:spPr>
-        <p:txBody>
-          <a:bodyPr wrap="square" lIns="0" tIns="0" rIns="0" bIns="0" rtlCol="0" anchor="ctr"/>
-          <a:lstStyle/>
-          <a:p>
-            <a:pPr algn="ctr" indent="0" marL="0">
-              <a:buNone/>
-            </a:pPr>
-            <a:r>
-              <a:rPr lang="en-US" sz="1300" b="1" dirty="0">
-                <a:solidFill>
-                  <a:srgbClr val="FFFFFF"/>
-                </a:solidFill>
-                <a:latin typeface="IBM Plex Sans Arabic" pitchFamily="34" charset="0"/>
-                <a:ea typeface="IBM Plex Sans Arabic" pitchFamily="34" charset="-122"/>
-                <a:cs typeface="IBM Plex Sans Arabic" pitchFamily="34" charset="-120"/>
-              </a:rPr>
-              <a:t>✕</a:t>
-            </a:r>
-            <a:endParaRPr lang="en-US" sz="1300" dirty="0"/>
-          </a:p>
-        </p:txBody>
-      </p:sp>
-      <p:sp>
-        <p:nvSpPr>
-          <p:cNvPr id="52" name="Shape 47"/>
-          <p:cNvSpPr/>
-          <p:nvPr/>
-        </p:nvSpPr>
-        <p:spPr>
-          <a:xfrm>
-            <a:off x="4078224" y="3794760"/>
-            <a:ext cx="347472" cy="347472"/>
-          </a:xfrm>
-          <a:prstGeom prst="ellipse">
-            <a:avLst/>
-          </a:prstGeom>
-          <a:solidFill>
-            <a:srgbClr val="D48A93"/>
-          </a:solidFill>
-          <a:ln/>
-        </p:spPr>
-      </p:sp>
-      <p:sp>
-        <p:nvSpPr>
-          <p:cNvPr id="53" name="Text 48"/>
-          <p:cNvSpPr txBox="1"/>
-          <p:nvPr/>
-        </p:nvSpPr>
-        <p:spPr>
-          <a:xfrm>
-            <a:off x="4078224" y="3794760"/>
-            <a:ext cx="347472" cy="347472"/>
-          </a:xfrm>
-          <a:prstGeom prst="rect">
-            <a:avLst/>
-          </a:prstGeom>
-          <a:noFill/>
-          <a:ln/>
-        </p:spPr>
-        <p:txBody>
-          <a:bodyPr wrap="square" lIns="0" tIns="0" rIns="0" bIns="0" rtlCol="0" anchor="ctr"/>
-          <a:lstStyle/>
-          <a:p>
-            <a:pPr algn="ctr" indent="0" marL="0">
-              <a:buNone/>
-            </a:pPr>
-            <a:r>
-              <a:rPr lang="en-US" sz="1300" b="1" dirty="0">
-                <a:solidFill>
-                  <a:srgbClr val="FFFFFF"/>
-                </a:solidFill>
-                <a:latin typeface="IBM Plex Sans Arabic" pitchFamily="34" charset="0"/>
-                <a:ea typeface="IBM Plex Sans Arabic" pitchFamily="34" charset="-122"/>
-                <a:cs typeface="IBM Plex Sans Arabic" pitchFamily="34" charset="-120"/>
-              </a:rPr>
-              <a:t>✕</a:t>
-            </a:r>
-            <a:endParaRPr lang="en-US" sz="1300" dirty="0"/>
-          </a:p>
-        </p:txBody>
-      </p:sp>
-      <p:sp>
-        <p:nvSpPr>
-          <p:cNvPr id="54" name="Shape 49"/>
-          <p:cNvSpPr/>
-          <p:nvPr/>
-        </p:nvSpPr>
-        <p:spPr>
-          <a:xfrm>
-            <a:off x="2560320" y="3794760"/>
-            <a:ext cx="347472" cy="347472"/>
-          </a:xfrm>
-          <a:prstGeom prst="ellipse">
-            <a:avLst/>
-          </a:prstGeom>
-          <a:solidFill>
-            <a:srgbClr val="D48A93"/>
-          </a:solidFill>
-          <a:ln/>
-        </p:spPr>
-      </p:sp>
-      <p:sp>
-        <p:nvSpPr>
-          <p:cNvPr id="55" name="Text 50"/>
-          <p:cNvSpPr txBox="1"/>
-          <p:nvPr/>
-        </p:nvSpPr>
-        <p:spPr>
-          <a:xfrm>
-            <a:off x="2560320" y="3794760"/>
-            <a:ext cx="347472" cy="347472"/>
-          </a:xfrm>
-          <a:prstGeom prst="rect">
-            <a:avLst/>
-          </a:prstGeom>
-          <a:noFill/>
-          <a:ln/>
-        </p:spPr>
-        <p:txBody>
-          <a:bodyPr wrap="square" lIns="0" tIns="0" rIns="0" bIns="0" rtlCol="0" anchor="ctr"/>
-          <a:lstStyle/>
-          <a:p>
-            <a:pPr algn="ctr" indent="0" marL="0">
-              <a:buNone/>
-            </a:pPr>
-            <a:r>
-              <a:rPr lang="en-US" sz="1300" b="1" dirty="0">
-                <a:solidFill>
-                  <a:srgbClr val="FFFFFF"/>
-                </a:solidFill>
-                <a:latin typeface="IBM Plex Sans Arabic" pitchFamily="34" charset="0"/>
-                <a:ea typeface="IBM Plex Sans Arabic" pitchFamily="34" charset="-122"/>
-                <a:cs typeface="IBM Plex Sans Arabic" pitchFamily="34" charset="-120"/>
-              </a:rPr>
-              <a:t>✕</a:t>
-            </a:r>
-            <a:endParaRPr lang="en-US" sz="1300" dirty="0"/>
-          </a:p>
-        </p:txBody>
-      </p:sp>
-      <p:sp>
-        <p:nvSpPr>
-          <p:cNvPr id="56" name="Shape 51"/>
-          <p:cNvSpPr/>
-          <p:nvPr/>
-        </p:nvSpPr>
-        <p:spPr>
-          <a:xfrm>
-            <a:off x="1042416" y="3794760"/>
-            <a:ext cx="347472" cy="347472"/>
-          </a:xfrm>
-          <a:prstGeom prst="ellipse">
-            <a:avLst/>
-          </a:prstGeom>
-          <a:solidFill>
-            <a:srgbClr val="D48A93"/>
-          </a:solidFill>
-          <a:ln/>
-        </p:spPr>
-      </p:sp>
-      <p:sp>
-        <p:nvSpPr>
-          <p:cNvPr id="57" name="Text 52"/>
-          <p:cNvSpPr txBox="1"/>
-          <p:nvPr/>
-        </p:nvSpPr>
-        <p:spPr>
-          <a:xfrm>
-            <a:off x="1042416" y="3794760"/>
-            <a:ext cx="347472" cy="347472"/>
-          </a:xfrm>
-          <a:prstGeom prst="rect">
-            <a:avLst/>
-          </a:prstGeom>
-          <a:noFill/>
-          <a:ln/>
-        </p:spPr>
-        <p:txBody>
-          <a:bodyPr wrap="square" lIns="0" tIns="0" rIns="0" bIns="0" rtlCol="0" anchor="ctr"/>
-          <a:lstStyle/>
-          <a:p>
-            <a:pPr algn="ctr" indent="0" marL="0">
-              <a:buNone/>
-            </a:pPr>
-            <a:r>
-              <a:rPr lang="en-US" sz="1300" b="1" dirty="0">
-                <a:solidFill>
-                  <a:srgbClr val="FFFFFF"/>
-                </a:solidFill>
-                <a:latin typeface="IBM Plex Sans Arabic" pitchFamily="34" charset="0"/>
-                <a:ea typeface="IBM Plex Sans Arabic" pitchFamily="34" charset="-122"/>
-                <a:cs typeface="IBM Plex Sans Arabic" pitchFamily="34" charset="-120"/>
-              </a:rPr>
-              <a:t>✕</a:t>
-            </a:r>
-            <a:endParaRPr lang="en-US" sz="1300" dirty="0"/>
-          </a:p>
-        </p:txBody>
-      </p:sp>
-      <p:sp>
-        <p:nvSpPr>
-          <p:cNvPr id="58" name="Shape 53"/>
-          <p:cNvSpPr/>
-          <p:nvPr/>
-        </p:nvSpPr>
-        <p:spPr>
-          <a:xfrm>
-            <a:off x="457200" y="4224528"/>
+            <a:pPr rtl="1" algn="ctr" indent="0" marL="0">
+              <a:buNone/>
+            </a:pPr>
+            <a:r>
+              <a:rPr lang="en-US" sz="1400" dirty="0">
+                <a:solidFill>
+                  <a:srgbClr val="21141A"/>
+                </a:solidFill>
+                <a:latin typeface="IBM Plex Sans Arabic" pitchFamily="34" charset="0"/>
+                <a:ea typeface="IBM Plex Sans Arabic" pitchFamily="34" charset="-122"/>
+                <a:cs typeface="IBM Plex Sans Arabic" pitchFamily="34" charset="-120"/>
+              </a:rPr>
+              <a:t>متعددة بعقد مؤسسي</a:t>
+            </a:r>
+            <a:endParaRPr lang="en-US" sz="1400" dirty="0"/>
+          </a:p>
+        </p:txBody>
+      </p:sp>
+      <p:sp>
+        <p:nvSpPr>
+          <p:cNvPr id="39" name="Shape 34"/>
+          <p:cNvSpPr/>
+          <p:nvPr/>
+        </p:nvSpPr>
+        <p:spPr>
+          <a:xfrm>
+            <a:off x="457200" y="4206240"/>
             <a:ext cx="11277295" cy="0"/>
           </a:xfrm>
           <a:prstGeom prst="line">
@@ -10018,14 +9506,14 @@
       </p:sp>
       <p:sp>
         <p:nvSpPr>
-          <p:cNvPr id="59" name="Text 54"/>
-          <p:cNvSpPr txBox="1"/>
-          <p:nvPr/>
-        </p:nvSpPr>
-        <p:spPr>
-          <a:xfrm>
-            <a:off x="8229600" y="4224528"/>
-            <a:ext cx="3504895" cy="512064"/>
+          <p:cNvPr id="40" name="Text 35"/>
+          <p:cNvSpPr txBox="1"/>
+          <p:nvPr/>
+        </p:nvSpPr>
+        <p:spPr>
+          <a:xfrm>
+            <a:off x="9418320" y="4206240"/>
+            <a:ext cx="2316175" cy="502920"/>
           </a:xfrm>
           <a:prstGeom prst="rect">
             <a:avLst/>
@@ -10041,7 +9529,85 @@
               <a:buNone/>
             </a:pPr>
             <a:r>
-              <a:rPr lang="en-US" sz="1500" dirty="0">
+              <a:rPr lang="en-US" sz="1500" b="1" dirty="0">
+                <a:solidFill>
+                  <a:srgbClr val="7F6C72"/>
+                </a:solidFill>
+                <a:latin typeface="IBM Plex Sans Arabic" pitchFamily="34" charset="0"/>
+                <a:ea typeface="IBM Plex Sans Arabic" pitchFamily="34" charset="-122"/>
+                <a:cs typeface="IBM Plex Sans Arabic" pitchFamily="34" charset="-120"/>
+              </a:rPr>
+              <a:t>سرعة التفعيل</a:t>
+            </a:r>
+            <a:endParaRPr lang="en-US" sz="1500" dirty="0"/>
+          </a:p>
+        </p:txBody>
+      </p:sp>
+      <p:sp>
+        <p:nvSpPr>
+          <p:cNvPr id="41" name="Text 36"/>
+          <p:cNvSpPr txBox="1"/>
+          <p:nvPr/>
+        </p:nvSpPr>
+        <p:spPr>
+          <a:xfrm>
+            <a:off x="6400800" y="4206240"/>
+            <a:ext cx="2743200" cy="502920"/>
+          </a:xfrm>
+          <a:prstGeom prst="rect">
+            <a:avLst/>
+          </a:prstGeom>
+          <a:noFill/>
+          <a:ln/>
+        </p:spPr>
+        <p:txBody>
+          <a:bodyPr wrap="square" lIns="0" tIns="0" rIns="0" bIns="0" rtlCol="0" anchor="ctr"/>
+          <a:lstStyle/>
+          <a:p>
+            <a:pPr rtl="1" algn="ctr" indent="0" marL="0">
+              <a:buNone/>
+            </a:pPr>
+            <a:r>
+              <a:rPr lang="en-US" sz="1500" b="1" dirty="0">
+                <a:solidFill>
+                  <a:srgbClr val="8E2F3C"/>
+                </a:solidFill>
+                <a:latin typeface="IBM Plex Sans Arabic" pitchFamily="34" charset="0"/>
+                <a:ea typeface="IBM Plex Sans Arabic" pitchFamily="34" charset="-122"/>
+                <a:cs typeface="IBM Plex Sans Arabic" pitchFamily="34" charset="-120"/>
+              </a:rPr>
+              <a:t>ذاتي خلال دقائق</a:t>
+            </a:r>
+            <a:endParaRPr lang="en-US" sz="1500" dirty="0"/>
+          </a:p>
+        </p:txBody>
+      </p:sp>
+      <p:sp>
+        <p:nvSpPr>
+          <p:cNvPr id="42" name="Text 37"/>
+          <p:cNvSpPr txBox="1"/>
+          <p:nvPr/>
+        </p:nvSpPr>
+        <p:spPr>
+          <a:xfrm>
+            <a:off x="3474720" y="4206240"/>
+            <a:ext cx="2743200" cy="502920"/>
+          </a:xfrm>
+          <a:prstGeom prst="rect">
+            <a:avLst/>
+          </a:prstGeom>
+          <a:noFill/>
+          <a:ln/>
+        </p:spPr>
+        <p:txBody>
+          <a:bodyPr wrap="square" lIns="0" tIns="0" rIns="0" bIns="0" rtlCol="0" anchor="ctr"/>
+          <a:lstStyle/>
+          <a:p>
+            <a:pPr rtl="1" algn="ctr" indent="0" marL="0">
+              <a:buNone/>
+            </a:pPr>
+            <a:r>
+              <a:rPr lang="en-US" sz="1400" dirty="0">
                 <a:solidFill>
                   <a:srgbClr val="21141A"/>
                 </a:solidFill>
@@ -10049,42 +9615,22 @@
                 <a:ea typeface="IBM Plex Sans Arabic" pitchFamily="34" charset="-122"/>
                 <a:cs typeface="IBM Plex Sans Arabic" pitchFamily="34" charset="-120"/>
               </a:rPr>
-              <a:t>تنفيذ بنقرة بعد موافقتك</a:t>
-            </a:r>
-            <a:endParaRPr lang="en-US" sz="1500" dirty="0"/>
-          </a:p>
-        </p:txBody>
-      </p:sp>
-      <p:sp>
-        <p:nvSpPr>
-          <p:cNvPr id="60" name="Shape 55"/>
-          <p:cNvSpPr/>
-          <p:nvPr/>
-        </p:nvSpPr>
-        <p:spPr>
-          <a:xfrm>
-            <a:off x="7114032" y="4306824"/>
-            <a:ext cx="347472" cy="347472"/>
-          </a:xfrm>
-          <a:prstGeom prst="ellipse">
-            <a:avLst/>
-          </a:prstGeom>
-          <a:solidFill>
-            <a:srgbClr val="7FB27A"/>
-          </a:solidFill>
-          <a:ln/>
-        </p:spPr>
-      </p:sp>
-      <p:sp>
-        <p:nvSpPr>
-          <p:cNvPr id="61" name="Text 56"/>
-          <p:cNvSpPr txBox="1"/>
-          <p:nvPr/>
-        </p:nvSpPr>
-        <p:spPr>
-          <a:xfrm>
-            <a:off x="7114032" y="4306824"/>
-            <a:ext cx="347472" cy="347472"/>
+              <a:t>إعداد هندسي معقد</a:t>
+            </a:r>
+            <a:endParaRPr lang="en-US" sz="1400" dirty="0"/>
+          </a:p>
+        </p:txBody>
+      </p:sp>
+      <p:sp>
+        <p:nvSpPr>
+          <p:cNvPr id="43" name="Text 38"/>
+          <p:cNvSpPr txBox="1"/>
+          <p:nvPr/>
+        </p:nvSpPr>
+        <p:spPr>
+          <a:xfrm>
+            <a:off x="548640" y="4206240"/>
+            <a:ext cx="2743200" cy="502920"/>
           </a:xfrm>
           <a:prstGeom prst="rect">
             <a:avLst/>
@@ -10096,269 +9642,33 @@
           <a:bodyPr wrap="square" lIns="0" tIns="0" rIns="0" bIns="0" rtlCol="0" anchor="ctr"/>
           <a:lstStyle/>
           <a:p>
-            <a:pPr algn="ctr" indent="0" marL="0">
-              <a:buNone/>
-            </a:pPr>
-            <a:r>
-              <a:rPr lang="en-US" sz="1300" b="1" dirty="0">
-                <a:solidFill>
-                  <a:srgbClr val="FFFFFF"/>
-                </a:solidFill>
-                <a:latin typeface="IBM Plex Sans Arabic" pitchFamily="34" charset="0"/>
-                <a:ea typeface="IBM Plex Sans Arabic" pitchFamily="34" charset="-122"/>
-                <a:cs typeface="IBM Plex Sans Arabic" pitchFamily="34" charset="-120"/>
-              </a:rPr>
-              <a:t>✓</a:t>
-            </a:r>
-            <a:endParaRPr lang="en-US" sz="1300" dirty="0"/>
-          </a:p>
-        </p:txBody>
-      </p:sp>
-      <p:sp>
-        <p:nvSpPr>
-          <p:cNvPr id="62" name="Shape 57"/>
-          <p:cNvSpPr/>
-          <p:nvPr/>
-        </p:nvSpPr>
-        <p:spPr>
-          <a:xfrm>
-            <a:off x="5596128" y="4306824"/>
-            <a:ext cx="347472" cy="347472"/>
-          </a:xfrm>
-          <a:prstGeom prst="ellipse">
-            <a:avLst/>
-          </a:prstGeom>
-          <a:solidFill>
-            <a:srgbClr val="C9A46E"/>
-          </a:solidFill>
-          <a:ln/>
-        </p:spPr>
-      </p:sp>
-      <p:sp>
-        <p:nvSpPr>
-          <p:cNvPr id="63" name="Text 58"/>
-          <p:cNvSpPr txBox="1"/>
-          <p:nvPr/>
-        </p:nvSpPr>
-        <p:spPr>
-          <a:xfrm>
-            <a:off x="5596128" y="4306824"/>
-            <a:ext cx="347472" cy="347472"/>
-          </a:xfrm>
-          <a:prstGeom prst="rect">
-            <a:avLst/>
-          </a:prstGeom>
-          <a:noFill/>
-          <a:ln/>
-        </p:spPr>
-        <p:txBody>
-          <a:bodyPr wrap="square" lIns="0" tIns="0" rIns="0" bIns="0" rtlCol="0" anchor="ctr"/>
-          <a:lstStyle/>
-          <a:p>
-            <a:pPr algn="ctr" indent="0" marL="0">
-              <a:buNone/>
-            </a:pPr>
-            <a:r>
-              <a:rPr lang="en-US" sz="1300" b="1" dirty="0">
-                <a:solidFill>
-                  <a:srgbClr val="FFFFFF"/>
-                </a:solidFill>
-                <a:latin typeface="IBM Plex Sans Arabic" pitchFamily="34" charset="0"/>
-                <a:ea typeface="IBM Plex Sans Arabic" pitchFamily="34" charset="-122"/>
-                <a:cs typeface="IBM Plex Sans Arabic" pitchFamily="34" charset="-120"/>
-              </a:rPr>
-              <a:t>~</a:t>
-            </a:r>
-            <a:endParaRPr lang="en-US" sz="1300" dirty="0"/>
-          </a:p>
-        </p:txBody>
-      </p:sp>
-      <p:sp>
-        <p:nvSpPr>
-          <p:cNvPr id="64" name="Shape 59"/>
-          <p:cNvSpPr/>
-          <p:nvPr/>
-        </p:nvSpPr>
-        <p:spPr>
-          <a:xfrm>
-            <a:off x="4078224" y="4306824"/>
-            <a:ext cx="347472" cy="347472"/>
-          </a:xfrm>
-          <a:prstGeom prst="ellipse">
-            <a:avLst/>
-          </a:prstGeom>
-          <a:solidFill>
-            <a:srgbClr val="C9A46E"/>
-          </a:solidFill>
-          <a:ln/>
-        </p:spPr>
-      </p:sp>
-      <p:sp>
-        <p:nvSpPr>
-          <p:cNvPr id="65" name="Text 60"/>
-          <p:cNvSpPr txBox="1"/>
-          <p:nvPr/>
-        </p:nvSpPr>
-        <p:spPr>
-          <a:xfrm>
-            <a:off x="4078224" y="4306824"/>
-            <a:ext cx="347472" cy="347472"/>
-          </a:xfrm>
-          <a:prstGeom prst="rect">
-            <a:avLst/>
-          </a:prstGeom>
-          <a:noFill/>
-          <a:ln/>
-        </p:spPr>
-        <p:txBody>
-          <a:bodyPr wrap="square" lIns="0" tIns="0" rIns="0" bIns="0" rtlCol="0" anchor="ctr"/>
-          <a:lstStyle/>
-          <a:p>
-            <a:pPr algn="ctr" indent="0" marL="0">
-              <a:buNone/>
-            </a:pPr>
-            <a:r>
-              <a:rPr lang="en-US" sz="1300" b="1" dirty="0">
-                <a:solidFill>
-                  <a:srgbClr val="FFFFFF"/>
-                </a:solidFill>
-                <a:latin typeface="IBM Plex Sans Arabic" pitchFamily="34" charset="0"/>
-                <a:ea typeface="IBM Plex Sans Arabic" pitchFamily="34" charset="-122"/>
-                <a:cs typeface="IBM Plex Sans Arabic" pitchFamily="34" charset="-120"/>
-              </a:rPr>
-              <a:t>~</a:t>
-            </a:r>
-            <a:endParaRPr lang="en-US" sz="1300" dirty="0"/>
-          </a:p>
-        </p:txBody>
-      </p:sp>
-      <p:sp>
-        <p:nvSpPr>
-          <p:cNvPr id="66" name="Shape 61"/>
-          <p:cNvSpPr/>
-          <p:nvPr/>
-        </p:nvSpPr>
-        <p:spPr>
-          <a:xfrm>
-            <a:off x="2560320" y="4306824"/>
-            <a:ext cx="347472" cy="347472"/>
-          </a:xfrm>
-          <a:prstGeom prst="ellipse">
-            <a:avLst/>
-          </a:prstGeom>
-          <a:solidFill>
-            <a:srgbClr val="C9A46E"/>
-          </a:solidFill>
-          <a:ln/>
-        </p:spPr>
-      </p:sp>
-      <p:sp>
-        <p:nvSpPr>
-          <p:cNvPr id="67" name="Text 62"/>
-          <p:cNvSpPr txBox="1"/>
-          <p:nvPr/>
-        </p:nvSpPr>
-        <p:spPr>
-          <a:xfrm>
-            <a:off x="2560320" y="4306824"/>
-            <a:ext cx="347472" cy="347472"/>
-          </a:xfrm>
-          <a:prstGeom prst="rect">
-            <a:avLst/>
-          </a:prstGeom>
-          <a:noFill/>
-          <a:ln/>
-        </p:spPr>
-        <p:txBody>
-          <a:bodyPr wrap="square" lIns="0" tIns="0" rIns="0" bIns="0" rtlCol="0" anchor="ctr"/>
-          <a:lstStyle/>
-          <a:p>
-            <a:pPr algn="ctr" indent="0" marL="0">
-              <a:buNone/>
-            </a:pPr>
-            <a:r>
-              <a:rPr lang="en-US" sz="1300" b="1" dirty="0">
-                <a:solidFill>
-                  <a:srgbClr val="FFFFFF"/>
-                </a:solidFill>
-                <a:latin typeface="IBM Plex Sans Arabic" pitchFamily="34" charset="0"/>
-                <a:ea typeface="IBM Plex Sans Arabic" pitchFamily="34" charset="-122"/>
-                <a:cs typeface="IBM Plex Sans Arabic" pitchFamily="34" charset="-120"/>
-              </a:rPr>
-              <a:t>~</a:t>
-            </a:r>
-            <a:endParaRPr lang="en-US" sz="1300" dirty="0"/>
-          </a:p>
-        </p:txBody>
-      </p:sp>
-      <p:sp>
-        <p:nvSpPr>
-          <p:cNvPr id="68" name="Shape 63"/>
-          <p:cNvSpPr/>
-          <p:nvPr/>
-        </p:nvSpPr>
-        <p:spPr>
-          <a:xfrm>
-            <a:off x="1042416" y="4306824"/>
-            <a:ext cx="347472" cy="347472"/>
-          </a:xfrm>
-          <a:prstGeom prst="ellipse">
-            <a:avLst/>
-          </a:prstGeom>
-          <a:solidFill>
-            <a:srgbClr val="C9A46E"/>
-          </a:solidFill>
-          <a:ln/>
-        </p:spPr>
-      </p:sp>
-      <p:sp>
-        <p:nvSpPr>
-          <p:cNvPr id="69" name="Text 64"/>
-          <p:cNvSpPr txBox="1"/>
-          <p:nvPr/>
-        </p:nvSpPr>
-        <p:spPr>
-          <a:xfrm>
-            <a:off x="1042416" y="4306824"/>
-            <a:ext cx="347472" cy="347472"/>
-          </a:xfrm>
-          <a:prstGeom prst="rect">
-            <a:avLst/>
-          </a:prstGeom>
-          <a:noFill/>
-          <a:ln/>
-        </p:spPr>
-        <p:txBody>
-          <a:bodyPr wrap="square" lIns="0" tIns="0" rIns="0" bIns="0" rtlCol="0" anchor="ctr"/>
-          <a:lstStyle/>
-          <a:p>
-            <a:pPr algn="ctr" indent="0" marL="0">
-              <a:buNone/>
-            </a:pPr>
-            <a:r>
-              <a:rPr lang="en-US" sz="1300" b="1" dirty="0">
-                <a:solidFill>
-                  <a:srgbClr val="FFFFFF"/>
-                </a:solidFill>
-                <a:latin typeface="IBM Plex Sans Arabic" pitchFamily="34" charset="0"/>
-                <a:ea typeface="IBM Plex Sans Arabic" pitchFamily="34" charset="-122"/>
-                <a:cs typeface="IBM Plex Sans Arabic" pitchFamily="34" charset="-120"/>
-              </a:rPr>
-              <a:t>~</a:t>
-            </a:r>
-            <a:endParaRPr lang="en-US" sz="1300" dirty="0"/>
-          </a:p>
-        </p:txBody>
-      </p:sp>
-      <p:sp>
-        <p:nvSpPr>
-          <p:cNvPr id="70" name="Shape 65"/>
-          <p:cNvSpPr/>
-          <p:nvPr/>
-        </p:nvSpPr>
-        <p:spPr>
-          <a:xfrm>
-            <a:off x="457200" y="4736592"/>
+            <a:pPr rtl="1" algn="ctr" indent="0" marL="0">
+              <a:buNone/>
+            </a:pPr>
+            <a:r>
+              <a:rPr lang="en-US" sz="1400" dirty="0">
+                <a:solidFill>
+                  <a:srgbClr val="21141A"/>
+                </a:solidFill>
+                <a:latin typeface="IBM Plex Sans Arabic" pitchFamily="34" charset="0"/>
+                <a:ea typeface="IBM Plex Sans Arabic" pitchFamily="34" charset="-122"/>
+                <a:cs typeface="IBM Plex Sans Arabic" pitchFamily="34" charset="-120"/>
+              </a:rPr>
+              <a:t>عقود واجتماعات طويلة</a:t>
+            </a:r>
+            <a:endParaRPr lang="en-US" sz="1400" dirty="0"/>
+          </a:p>
+        </p:txBody>
+      </p:sp>
+      <p:sp>
+        <p:nvSpPr>
+          <p:cNvPr id="44" name="Shape 39"/>
+          <p:cNvSpPr/>
+          <p:nvPr/>
+        </p:nvSpPr>
+        <p:spPr>
+          <a:xfrm>
+            <a:off x="457200" y="4709160"/>
             <a:ext cx="11277295" cy="0"/>
           </a:xfrm>
           <a:prstGeom prst="line">
@@ -10375,14 +9685,14 @@
       </p:sp>
       <p:sp>
         <p:nvSpPr>
-          <p:cNvPr id="71" name="Text 66"/>
-          <p:cNvSpPr txBox="1"/>
-          <p:nvPr/>
-        </p:nvSpPr>
-        <p:spPr>
-          <a:xfrm>
-            <a:off x="8229600" y="4736592"/>
-            <a:ext cx="3504895" cy="512064"/>
+          <p:cNvPr id="45" name="Text 40"/>
+          <p:cNvSpPr txBox="1"/>
+          <p:nvPr/>
+        </p:nvSpPr>
+        <p:spPr>
+          <a:xfrm>
+            <a:off x="9418320" y="4709160"/>
+            <a:ext cx="2316175" cy="502920"/>
           </a:xfrm>
           <a:prstGeom prst="rect">
             <a:avLst/>
@@ -10398,7 +9708,85 @@
               <a:buNone/>
             </a:pPr>
             <a:r>
-              <a:rPr lang="en-US" sz="1500" dirty="0">
+              <a:rPr lang="en-US" sz="1500" b="1" dirty="0">
+                <a:solidFill>
+                  <a:srgbClr val="7F6C72"/>
+                </a:solidFill>
+                <a:latin typeface="IBM Plex Sans Arabic" pitchFamily="34" charset="0"/>
+                <a:ea typeface="IBM Plex Sans Arabic" pitchFamily="34" charset="-122"/>
+                <a:cs typeface="IBM Plex Sans Arabic" pitchFamily="34" charset="-120"/>
+              </a:rPr>
+              <a:t>نموذج التسعير</a:t>
+            </a:r>
+            <a:endParaRPr lang="en-US" sz="1500" dirty="0"/>
+          </a:p>
+        </p:txBody>
+      </p:sp>
+      <p:sp>
+        <p:nvSpPr>
+          <p:cNvPr id="46" name="Text 41"/>
+          <p:cNvSpPr txBox="1"/>
+          <p:nvPr/>
+        </p:nvSpPr>
+        <p:spPr>
+          <a:xfrm>
+            <a:off x="6400800" y="4709160"/>
+            <a:ext cx="2743200" cy="502920"/>
+          </a:xfrm>
+          <a:prstGeom prst="rect">
+            <a:avLst/>
+          </a:prstGeom>
+          <a:noFill/>
+          <a:ln/>
+        </p:spPr>
+        <p:txBody>
+          <a:bodyPr wrap="square" lIns="0" tIns="0" rIns="0" bIns="0" rtlCol="0" anchor="ctr"/>
+          <a:lstStyle/>
+          <a:p>
+            <a:pPr rtl="1" algn="ctr" indent="0" marL="0">
+              <a:buNone/>
+            </a:pPr>
+            <a:r>
+              <a:rPr lang="en-US" sz="1500" b="1" dirty="0">
+                <a:solidFill>
+                  <a:srgbClr val="8E2F3C"/>
+                </a:solidFill>
+                <a:latin typeface="IBM Plex Sans Arabic" pitchFamily="34" charset="0"/>
+                <a:ea typeface="IBM Plex Sans Arabic" pitchFamily="34" charset="-122"/>
+                <a:cs typeface="IBM Plex Sans Arabic" pitchFamily="34" charset="-120"/>
+              </a:rPr>
+              <a:t>اشتراك SaaS مرن</a:t>
+            </a:r>
+            <a:endParaRPr lang="en-US" sz="1500" dirty="0"/>
+          </a:p>
+        </p:txBody>
+      </p:sp>
+      <p:sp>
+        <p:nvSpPr>
+          <p:cNvPr id="47" name="Text 42"/>
+          <p:cNvSpPr txBox="1"/>
+          <p:nvPr/>
+        </p:nvSpPr>
+        <p:spPr>
+          <a:xfrm>
+            <a:off x="3474720" y="4709160"/>
+            <a:ext cx="2743200" cy="502920"/>
+          </a:xfrm>
+          <a:prstGeom prst="rect">
+            <a:avLst/>
+          </a:prstGeom>
+          <a:noFill/>
+          <a:ln/>
+        </p:spPr>
+        <p:txBody>
+          <a:bodyPr wrap="square" lIns="0" tIns="0" rIns="0" bIns="0" rtlCol="0" anchor="ctr"/>
+          <a:lstStyle/>
+          <a:p>
+            <a:pPr rtl="1" algn="ctr" indent="0" marL="0">
+              <a:buNone/>
+            </a:pPr>
+            <a:r>
+              <a:rPr lang="en-US" sz="1400" dirty="0">
                 <a:solidFill>
                   <a:srgbClr val="21141A"/>
                 </a:solidFill>
@@ -10406,42 +9794,22 @@
                 <a:ea typeface="IBM Plex Sans Arabic" pitchFamily="34" charset="-122"/>
                 <a:cs typeface="IBM Plex Sans Arabic" pitchFamily="34" charset="-120"/>
               </a:rPr>
-              <a:t>تنبيهات واتساب وتيليجرام</a:t>
-            </a:r>
-            <a:endParaRPr lang="en-US" sz="1500" dirty="0"/>
-          </a:p>
-        </p:txBody>
-      </p:sp>
-      <p:sp>
-        <p:nvSpPr>
-          <p:cNvPr id="72" name="Shape 67"/>
-          <p:cNvSpPr/>
-          <p:nvPr/>
-        </p:nvSpPr>
-        <p:spPr>
-          <a:xfrm>
-            <a:off x="7114032" y="4818888"/>
-            <a:ext cx="347472" cy="347472"/>
-          </a:xfrm>
-          <a:prstGeom prst="ellipse">
-            <a:avLst/>
-          </a:prstGeom>
-          <a:solidFill>
-            <a:srgbClr val="7FB27A"/>
-          </a:solidFill>
-          <a:ln/>
-        </p:spPr>
-      </p:sp>
-      <p:sp>
-        <p:nvSpPr>
-          <p:cNvPr id="73" name="Text 68"/>
-          <p:cNvSpPr txBox="1"/>
-          <p:nvPr/>
-        </p:nvSpPr>
-        <p:spPr>
-          <a:xfrm>
-            <a:off x="7114032" y="4818888"/>
-            <a:ext cx="347472" cy="347472"/>
+              <a:t>مجاني ضمن السحابة</a:t>
+            </a:r>
+            <a:endParaRPr lang="en-US" sz="1400" dirty="0"/>
+          </a:p>
+        </p:txBody>
+      </p:sp>
+      <p:sp>
+        <p:nvSpPr>
+          <p:cNvPr id="48" name="Text 43"/>
+          <p:cNvSpPr txBox="1"/>
+          <p:nvPr/>
+        </p:nvSpPr>
+        <p:spPr>
+          <a:xfrm>
+            <a:off x="548640" y="4709160"/>
+            <a:ext cx="2743200" cy="502920"/>
           </a:xfrm>
           <a:prstGeom prst="rect">
             <a:avLst/>
@@ -10453,269 +9821,33 @@
           <a:bodyPr wrap="square" lIns="0" tIns="0" rIns="0" bIns="0" rtlCol="0" anchor="ctr"/>
           <a:lstStyle/>
           <a:p>
-            <a:pPr algn="ctr" indent="0" marL="0">
-              <a:buNone/>
-            </a:pPr>
-            <a:r>
-              <a:rPr lang="en-US" sz="1300" b="1" dirty="0">
-                <a:solidFill>
-                  <a:srgbClr val="FFFFFF"/>
-                </a:solidFill>
-                <a:latin typeface="IBM Plex Sans Arabic" pitchFamily="34" charset="0"/>
-                <a:ea typeface="IBM Plex Sans Arabic" pitchFamily="34" charset="-122"/>
-                <a:cs typeface="IBM Plex Sans Arabic" pitchFamily="34" charset="-120"/>
-              </a:rPr>
-              <a:t>✓</a:t>
-            </a:r>
-            <a:endParaRPr lang="en-US" sz="1300" dirty="0"/>
-          </a:p>
-        </p:txBody>
-      </p:sp>
-      <p:sp>
-        <p:nvSpPr>
-          <p:cNvPr id="74" name="Shape 69"/>
-          <p:cNvSpPr/>
-          <p:nvPr/>
-        </p:nvSpPr>
-        <p:spPr>
-          <a:xfrm>
-            <a:off x="5596128" y="4818888"/>
-            <a:ext cx="347472" cy="347472"/>
-          </a:xfrm>
-          <a:prstGeom prst="ellipse">
-            <a:avLst/>
-          </a:prstGeom>
-          <a:solidFill>
-            <a:srgbClr val="D48A93"/>
-          </a:solidFill>
-          <a:ln/>
-        </p:spPr>
-      </p:sp>
-      <p:sp>
-        <p:nvSpPr>
-          <p:cNvPr id="75" name="Text 70"/>
-          <p:cNvSpPr txBox="1"/>
-          <p:nvPr/>
-        </p:nvSpPr>
-        <p:spPr>
-          <a:xfrm>
-            <a:off x="5596128" y="4818888"/>
-            <a:ext cx="347472" cy="347472"/>
-          </a:xfrm>
-          <a:prstGeom prst="rect">
-            <a:avLst/>
-          </a:prstGeom>
-          <a:noFill/>
-          <a:ln/>
-        </p:spPr>
-        <p:txBody>
-          <a:bodyPr wrap="square" lIns="0" tIns="0" rIns="0" bIns="0" rtlCol="0" anchor="ctr"/>
-          <a:lstStyle/>
-          <a:p>
-            <a:pPr algn="ctr" indent="0" marL="0">
-              <a:buNone/>
-            </a:pPr>
-            <a:r>
-              <a:rPr lang="en-US" sz="1300" b="1" dirty="0">
-                <a:solidFill>
-                  <a:srgbClr val="FFFFFF"/>
-                </a:solidFill>
-                <a:latin typeface="IBM Plex Sans Arabic" pitchFamily="34" charset="0"/>
-                <a:ea typeface="IBM Plex Sans Arabic" pitchFamily="34" charset="-122"/>
-                <a:cs typeface="IBM Plex Sans Arabic" pitchFamily="34" charset="-120"/>
-              </a:rPr>
-              <a:t>✕</a:t>
-            </a:r>
-            <a:endParaRPr lang="en-US" sz="1300" dirty="0"/>
-          </a:p>
-        </p:txBody>
-      </p:sp>
-      <p:sp>
-        <p:nvSpPr>
-          <p:cNvPr id="76" name="Shape 71"/>
-          <p:cNvSpPr/>
-          <p:nvPr/>
-        </p:nvSpPr>
-        <p:spPr>
-          <a:xfrm>
-            <a:off x="4078224" y="4818888"/>
-            <a:ext cx="347472" cy="347472"/>
-          </a:xfrm>
-          <a:prstGeom prst="ellipse">
-            <a:avLst/>
-          </a:prstGeom>
-          <a:solidFill>
-            <a:srgbClr val="D48A93"/>
-          </a:solidFill>
-          <a:ln/>
-        </p:spPr>
-      </p:sp>
-      <p:sp>
-        <p:nvSpPr>
-          <p:cNvPr id="77" name="Text 72"/>
-          <p:cNvSpPr txBox="1"/>
-          <p:nvPr/>
-        </p:nvSpPr>
-        <p:spPr>
-          <a:xfrm>
-            <a:off x="4078224" y="4818888"/>
-            <a:ext cx="347472" cy="347472"/>
-          </a:xfrm>
-          <a:prstGeom prst="rect">
-            <a:avLst/>
-          </a:prstGeom>
-          <a:noFill/>
-          <a:ln/>
-        </p:spPr>
-        <p:txBody>
-          <a:bodyPr wrap="square" lIns="0" tIns="0" rIns="0" bIns="0" rtlCol="0" anchor="ctr"/>
-          <a:lstStyle/>
-          <a:p>
-            <a:pPr algn="ctr" indent="0" marL="0">
-              <a:buNone/>
-            </a:pPr>
-            <a:r>
-              <a:rPr lang="en-US" sz="1300" b="1" dirty="0">
-                <a:solidFill>
-                  <a:srgbClr val="FFFFFF"/>
-                </a:solidFill>
-                <a:latin typeface="IBM Plex Sans Arabic" pitchFamily="34" charset="0"/>
-                <a:ea typeface="IBM Plex Sans Arabic" pitchFamily="34" charset="-122"/>
-                <a:cs typeface="IBM Plex Sans Arabic" pitchFamily="34" charset="-120"/>
-              </a:rPr>
-              <a:t>✕</a:t>
-            </a:r>
-            <a:endParaRPr lang="en-US" sz="1300" dirty="0"/>
-          </a:p>
-        </p:txBody>
-      </p:sp>
-      <p:sp>
-        <p:nvSpPr>
-          <p:cNvPr id="78" name="Shape 73"/>
-          <p:cNvSpPr/>
-          <p:nvPr/>
-        </p:nvSpPr>
-        <p:spPr>
-          <a:xfrm>
-            <a:off x="2560320" y="4818888"/>
-            <a:ext cx="347472" cy="347472"/>
-          </a:xfrm>
-          <a:prstGeom prst="ellipse">
-            <a:avLst/>
-          </a:prstGeom>
-          <a:solidFill>
-            <a:srgbClr val="D48A93"/>
-          </a:solidFill>
-          <a:ln/>
-        </p:spPr>
-      </p:sp>
-      <p:sp>
-        <p:nvSpPr>
-          <p:cNvPr id="79" name="Text 74"/>
-          <p:cNvSpPr txBox="1"/>
-          <p:nvPr/>
-        </p:nvSpPr>
-        <p:spPr>
-          <a:xfrm>
-            <a:off x="2560320" y="4818888"/>
-            <a:ext cx="347472" cy="347472"/>
-          </a:xfrm>
-          <a:prstGeom prst="rect">
-            <a:avLst/>
-          </a:prstGeom>
-          <a:noFill/>
-          <a:ln/>
-        </p:spPr>
-        <p:txBody>
-          <a:bodyPr wrap="square" lIns="0" tIns="0" rIns="0" bIns="0" rtlCol="0" anchor="ctr"/>
-          <a:lstStyle/>
-          <a:p>
-            <a:pPr algn="ctr" indent="0" marL="0">
-              <a:buNone/>
-            </a:pPr>
-            <a:r>
-              <a:rPr lang="en-US" sz="1300" b="1" dirty="0">
-                <a:solidFill>
-                  <a:srgbClr val="FFFFFF"/>
-                </a:solidFill>
-                <a:latin typeface="IBM Plex Sans Arabic" pitchFamily="34" charset="0"/>
-                <a:ea typeface="IBM Plex Sans Arabic" pitchFamily="34" charset="-122"/>
-                <a:cs typeface="IBM Plex Sans Arabic" pitchFamily="34" charset="-120"/>
-              </a:rPr>
-              <a:t>✕</a:t>
-            </a:r>
-            <a:endParaRPr lang="en-US" sz="1300" dirty="0"/>
-          </a:p>
-        </p:txBody>
-      </p:sp>
-      <p:sp>
-        <p:nvSpPr>
-          <p:cNvPr id="80" name="Shape 75"/>
-          <p:cNvSpPr/>
-          <p:nvPr/>
-        </p:nvSpPr>
-        <p:spPr>
-          <a:xfrm>
-            <a:off x="1042416" y="4818888"/>
-            <a:ext cx="347472" cy="347472"/>
-          </a:xfrm>
-          <a:prstGeom prst="ellipse">
-            <a:avLst/>
-          </a:prstGeom>
-          <a:solidFill>
-            <a:srgbClr val="D48A93"/>
-          </a:solidFill>
-          <a:ln/>
-        </p:spPr>
-      </p:sp>
-      <p:sp>
-        <p:nvSpPr>
-          <p:cNvPr id="81" name="Text 76"/>
-          <p:cNvSpPr txBox="1"/>
-          <p:nvPr/>
-        </p:nvSpPr>
-        <p:spPr>
-          <a:xfrm>
-            <a:off x="1042416" y="4818888"/>
-            <a:ext cx="347472" cy="347472"/>
-          </a:xfrm>
-          <a:prstGeom prst="rect">
-            <a:avLst/>
-          </a:prstGeom>
-          <a:noFill/>
-          <a:ln/>
-        </p:spPr>
-        <p:txBody>
-          <a:bodyPr wrap="square" lIns="0" tIns="0" rIns="0" bIns="0" rtlCol="0" anchor="ctr"/>
-          <a:lstStyle/>
-          <a:p>
-            <a:pPr algn="ctr" indent="0" marL="0">
-              <a:buNone/>
-            </a:pPr>
-            <a:r>
-              <a:rPr lang="en-US" sz="1300" b="1" dirty="0">
-                <a:solidFill>
-                  <a:srgbClr val="FFFFFF"/>
-                </a:solidFill>
-                <a:latin typeface="IBM Plex Sans Arabic" pitchFamily="34" charset="0"/>
-                <a:ea typeface="IBM Plex Sans Arabic" pitchFamily="34" charset="-122"/>
-                <a:cs typeface="IBM Plex Sans Arabic" pitchFamily="34" charset="-120"/>
-              </a:rPr>
-              <a:t>✕</a:t>
-            </a:r>
-            <a:endParaRPr lang="en-US" sz="1300" dirty="0"/>
-          </a:p>
-        </p:txBody>
-      </p:sp>
-      <p:sp>
-        <p:nvSpPr>
-          <p:cNvPr id="82" name="Shape 77"/>
-          <p:cNvSpPr/>
-          <p:nvPr/>
-        </p:nvSpPr>
-        <p:spPr>
-          <a:xfrm>
-            <a:off x="457200" y="5248656"/>
+            <a:pPr rtl="1" algn="ctr" indent="0" marL="0">
+              <a:buNone/>
+            </a:pPr>
+            <a:r>
+              <a:rPr lang="en-US" sz="1400" dirty="0">
+                <a:solidFill>
+                  <a:srgbClr val="21141A"/>
+                </a:solidFill>
+                <a:latin typeface="IBM Plex Sans Arabic" pitchFamily="34" charset="0"/>
+                <a:ea typeface="IBM Plex Sans Arabic" pitchFamily="34" charset="-122"/>
+                <a:cs typeface="IBM Plex Sans Arabic" pitchFamily="34" charset="-120"/>
+              </a:rPr>
+              <a:t>خدمات مدارة مكلفة</a:t>
+            </a:r>
+            <a:endParaRPr lang="en-US" sz="1400" dirty="0"/>
+          </a:p>
+        </p:txBody>
+      </p:sp>
+      <p:sp>
+        <p:nvSpPr>
+          <p:cNvPr id="49" name="Shape 44"/>
+          <p:cNvSpPr/>
+          <p:nvPr/>
+        </p:nvSpPr>
+        <p:spPr>
+          <a:xfrm>
+            <a:off x="457200" y="5212080"/>
             <a:ext cx="11277295" cy="0"/>
           </a:xfrm>
           <a:prstGeom prst="line">
@@ -10732,14 +9864,14 @@
       </p:sp>
       <p:sp>
         <p:nvSpPr>
-          <p:cNvPr id="83" name="Text 78"/>
-          <p:cNvSpPr txBox="1"/>
-          <p:nvPr/>
-        </p:nvSpPr>
-        <p:spPr>
-          <a:xfrm>
-            <a:off x="8229600" y="5248656"/>
-            <a:ext cx="3504895" cy="512064"/>
+          <p:cNvPr id="50" name="Text 45"/>
+          <p:cNvSpPr txBox="1"/>
+          <p:nvPr/>
+        </p:nvSpPr>
+        <p:spPr>
+          <a:xfrm>
+            <a:off x="9418320" y="5212080"/>
+            <a:ext cx="2316175" cy="502920"/>
           </a:xfrm>
           <a:prstGeom prst="rect">
             <a:avLst/>
@@ -10755,7 +9887,85 @@
               <a:buNone/>
             </a:pPr>
             <a:r>
-              <a:rPr lang="en-US" sz="1500" dirty="0">
+              <a:rPr lang="en-US" sz="1500" b="1" dirty="0">
+                <a:solidFill>
+                  <a:srgbClr val="7F6C72"/>
+                </a:solidFill>
+                <a:latin typeface="IBM Plex Sans Arabic" pitchFamily="34" charset="0"/>
+                <a:ea typeface="IBM Plex Sans Arabic" pitchFamily="34" charset="-122"/>
+                <a:cs typeface="IBM Plex Sans Arabic" pitchFamily="34" charset="-120"/>
+              </a:rPr>
+              <a:t>التركيز</a:t>
+            </a:r>
+            <a:endParaRPr lang="en-US" sz="1500" dirty="0"/>
+          </a:p>
+        </p:txBody>
+      </p:sp>
+      <p:sp>
+        <p:nvSpPr>
+          <p:cNvPr id="51" name="Text 46"/>
+          <p:cNvSpPr txBox="1"/>
+          <p:nvPr/>
+        </p:nvSpPr>
+        <p:spPr>
+          <a:xfrm>
+            <a:off x="6400800" y="5212080"/>
+            <a:ext cx="2743200" cy="502920"/>
+          </a:xfrm>
+          <a:prstGeom prst="rect">
+            <a:avLst/>
+          </a:prstGeom>
+          <a:noFill/>
+          <a:ln/>
+        </p:spPr>
+        <p:txBody>
+          <a:bodyPr wrap="square" lIns="0" tIns="0" rIns="0" bIns="0" rtlCol="0" anchor="ctr"/>
+          <a:lstStyle/>
+          <a:p>
+            <a:pPr rtl="1" algn="ctr" indent="0" marL="0">
+              <a:buNone/>
+            </a:pPr>
+            <a:r>
+              <a:rPr lang="en-US" sz="1500" b="1" dirty="0">
+                <a:solidFill>
+                  <a:srgbClr val="8E2F3C"/>
+                </a:solidFill>
+                <a:latin typeface="IBM Plex Sans Arabic" pitchFamily="34" charset="0"/>
+                <a:ea typeface="IBM Plex Sans Arabic" pitchFamily="34" charset="-122"/>
+                <a:cs typeface="IBM Plex Sans Arabic" pitchFamily="34" charset="-120"/>
+              </a:rPr>
+              <a:t>توفير فوري ومبسط</a:t>
+            </a:r>
+            <a:endParaRPr lang="en-US" sz="1500" dirty="0"/>
+          </a:p>
+        </p:txBody>
+      </p:sp>
+      <p:sp>
+        <p:nvSpPr>
+          <p:cNvPr id="52" name="Text 47"/>
+          <p:cNvSpPr txBox="1"/>
+          <p:nvPr/>
+        </p:nvSpPr>
+        <p:spPr>
+          <a:xfrm>
+            <a:off x="3474720" y="5212080"/>
+            <a:ext cx="2743200" cy="502920"/>
+          </a:xfrm>
+          <a:prstGeom prst="rect">
+            <a:avLst/>
+          </a:prstGeom>
+          <a:noFill/>
+          <a:ln/>
+        </p:spPr>
+        <p:txBody>
+          <a:bodyPr wrap="square" lIns="0" tIns="0" rIns="0" bIns="0" rtlCol="0" anchor="ctr"/>
+          <a:lstStyle/>
+          <a:p>
+            <a:pPr rtl="1" algn="ctr" indent="0" marL="0">
+              <a:buNone/>
+            </a:pPr>
+            <a:r>
+              <a:rPr lang="en-US" sz="1400" dirty="0">
                 <a:solidFill>
                   <a:srgbClr val="21141A"/>
                 </a:solidFill>
@@ -10763,481 +9973,87 @@
                 <a:ea typeface="IBM Plex Sans Arabic" pitchFamily="34" charset="-122"/>
                 <a:cs typeface="IBM Plex Sans Arabic" pitchFamily="34" charset="-120"/>
               </a:rPr>
-              <a:t>سعر مناسب للشركات المتوسطة</a:t>
+              <a:t>أدوات لمهندسي البنية</a:t>
+            </a:r>
+            <a:endParaRPr lang="en-US" sz="1400" dirty="0"/>
+          </a:p>
+        </p:txBody>
+      </p:sp>
+      <p:sp>
+        <p:nvSpPr>
+          <p:cNvPr id="53" name="Text 48"/>
+          <p:cNvSpPr txBox="1"/>
+          <p:nvPr/>
+        </p:nvSpPr>
+        <p:spPr>
+          <a:xfrm>
+            <a:off x="548640" y="5212080"/>
+            <a:ext cx="2743200" cy="502920"/>
+          </a:xfrm>
+          <a:prstGeom prst="rect">
+            <a:avLst/>
+          </a:prstGeom>
+          <a:noFill/>
+          <a:ln/>
+        </p:spPr>
+        <p:txBody>
+          <a:bodyPr wrap="square" lIns="0" tIns="0" rIns="0" bIns="0" rtlCol="0" anchor="ctr"/>
+          <a:lstStyle/>
+          <a:p>
+            <a:pPr rtl="1" algn="ctr" indent="0" marL="0">
+              <a:buNone/>
+            </a:pPr>
+            <a:r>
+              <a:rPr lang="en-US" sz="1400" dirty="0">
+                <a:solidFill>
+                  <a:srgbClr val="21141A"/>
+                </a:solidFill>
+                <a:latin typeface="IBM Plex Sans Arabic" pitchFamily="34" charset="0"/>
+                <a:ea typeface="IBM Plex Sans Arabic" pitchFamily="34" charset="-122"/>
+                <a:cs typeface="IBM Plex Sans Arabic" pitchFamily="34" charset="-120"/>
+              </a:rPr>
+              <a:t>البنية والسيادة</a:t>
+            </a:r>
+            <a:endParaRPr lang="en-US" sz="1400" dirty="0"/>
+          </a:p>
+        </p:txBody>
+      </p:sp>
+      <p:sp>
+        <p:nvSpPr>
+          <p:cNvPr id="54" name="Text 49"/>
+          <p:cNvSpPr txBox="1"/>
+          <p:nvPr/>
+        </p:nvSpPr>
+        <p:spPr>
+          <a:xfrm>
+            <a:off x="457200" y="5870448"/>
+            <a:ext cx="11277295" cy="365760"/>
+          </a:xfrm>
+          <a:prstGeom prst="rect">
+            <a:avLst/>
+          </a:prstGeom>
+          <a:noFill/>
+          <a:ln/>
+        </p:spPr>
+        <p:txBody>
+          <a:bodyPr wrap="square" lIns="0" tIns="0" rIns="0" bIns="0" rtlCol="0" anchor="ctr"/>
+          <a:lstStyle/>
+          <a:p>
+            <a:pPr rtl="1" algn="ctr" indent="0" marL="0">
+              <a:buNone/>
+            </a:pPr>
+            <a:r>
+              <a:rPr lang="en-US" sz="1500" b="1" dirty="0">
+                <a:solidFill>
+                  <a:srgbClr val="8E2F3C"/>
+                </a:solidFill>
+                <a:latin typeface="IBM Plex Sans Arabic" pitchFamily="34" charset="0"/>
+                <a:ea typeface="IBM Plex Sans Arabic" pitchFamily="34" charset="-122"/>
+                <a:cs typeface="IBM Plex Sans Arabic" pitchFamily="34" charset="-120"/>
+              </a:rPr>
+              <a:t>ميزتنا ليست تقنية مستحيلة، بل البساطة والسعر المرن، بلا عقود Enterprise</a:t>
             </a:r>
             <a:endParaRPr lang="en-US" sz="1500" dirty="0"/>
-          </a:p>
-        </p:txBody>
-      </p:sp>
-      <p:sp>
-        <p:nvSpPr>
-          <p:cNvPr id="84" name="Shape 79"/>
-          <p:cNvSpPr/>
-          <p:nvPr/>
-        </p:nvSpPr>
-        <p:spPr>
-          <a:xfrm>
-            <a:off x="7114032" y="5330952"/>
-            <a:ext cx="347472" cy="347472"/>
-          </a:xfrm>
-          <a:prstGeom prst="ellipse">
-            <a:avLst/>
-          </a:prstGeom>
-          <a:solidFill>
-            <a:srgbClr val="7FB27A"/>
-          </a:solidFill>
-          <a:ln/>
-        </p:spPr>
-      </p:sp>
-      <p:sp>
-        <p:nvSpPr>
-          <p:cNvPr id="85" name="Text 80"/>
-          <p:cNvSpPr txBox="1"/>
-          <p:nvPr/>
-        </p:nvSpPr>
-        <p:spPr>
-          <a:xfrm>
-            <a:off x="7114032" y="5330952"/>
-            <a:ext cx="347472" cy="347472"/>
-          </a:xfrm>
-          <a:prstGeom prst="rect">
-            <a:avLst/>
-          </a:prstGeom>
-          <a:noFill/>
-          <a:ln/>
-        </p:spPr>
-        <p:txBody>
-          <a:bodyPr wrap="square" lIns="0" tIns="0" rIns="0" bIns="0" rtlCol="0" anchor="ctr"/>
-          <a:lstStyle/>
-          <a:p>
-            <a:pPr algn="ctr" indent="0" marL="0">
-              <a:buNone/>
-            </a:pPr>
-            <a:r>
-              <a:rPr lang="en-US" sz="1300" b="1" dirty="0">
-                <a:solidFill>
-                  <a:srgbClr val="FFFFFF"/>
-                </a:solidFill>
-                <a:latin typeface="IBM Plex Sans Arabic" pitchFamily="34" charset="0"/>
-                <a:ea typeface="IBM Plex Sans Arabic" pitchFamily="34" charset="-122"/>
-                <a:cs typeface="IBM Plex Sans Arabic" pitchFamily="34" charset="-120"/>
-              </a:rPr>
-              <a:t>✓</a:t>
-            </a:r>
-            <a:endParaRPr lang="en-US" sz="1300" dirty="0"/>
-          </a:p>
-        </p:txBody>
-      </p:sp>
-      <p:sp>
-        <p:nvSpPr>
-          <p:cNvPr id="86" name="Shape 81"/>
-          <p:cNvSpPr/>
-          <p:nvPr/>
-        </p:nvSpPr>
-        <p:spPr>
-          <a:xfrm>
-            <a:off x="5596128" y="5330952"/>
-            <a:ext cx="347472" cy="347472"/>
-          </a:xfrm>
-          <a:prstGeom prst="ellipse">
-            <a:avLst/>
-          </a:prstGeom>
-          <a:solidFill>
-            <a:srgbClr val="7FB27A"/>
-          </a:solidFill>
-          <a:ln/>
-        </p:spPr>
-      </p:sp>
-      <p:sp>
-        <p:nvSpPr>
-          <p:cNvPr id="87" name="Text 82"/>
-          <p:cNvSpPr txBox="1"/>
-          <p:nvPr/>
-        </p:nvSpPr>
-        <p:spPr>
-          <a:xfrm>
-            <a:off x="5596128" y="5330952"/>
-            <a:ext cx="347472" cy="347472"/>
-          </a:xfrm>
-          <a:prstGeom prst="rect">
-            <a:avLst/>
-          </a:prstGeom>
-          <a:noFill/>
-          <a:ln/>
-        </p:spPr>
-        <p:txBody>
-          <a:bodyPr wrap="square" lIns="0" tIns="0" rIns="0" bIns="0" rtlCol="0" anchor="ctr"/>
-          <a:lstStyle/>
-          <a:p>
-            <a:pPr algn="ctr" indent="0" marL="0">
-              <a:buNone/>
-            </a:pPr>
-            <a:r>
-              <a:rPr lang="en-US" sz="1300" b="1" dirty="0">
-                <a:solidFill>
-                  <a:srgbClr val="FFFFFF"/>
-                </a:solidFill>
-                <a:latin typeface="IBM Plex Sans Arabic" pitchFamily="34" charset="0"/>
-                <a:ea typeface="IBM Plex Sans Arabic" pitchFamily="34" charset="-122"/>
-                <a:cs typeface="IBM Plex Sans Arabic" pitchFamily="34" charset="-120"/>
-              </a:rPr>
-              <a:t>✓</a:t>
-            </a:r>
-            <a:endParaRPr lang="en-US" sz="1300" dirty="0"/>
-          </a:p>
-        </p:txBody>
-      </p:sp>
-      <p:sp>
-        <p:nvSpPr>
-          <p:cNvPr id="88" name="Shape 83"/>
-          <p:cNvSpPr/>
-          <p:nvPr/>
-        </p:nvSpPr>
-        <p:spPr>
-          <a:xfrm>
-            <a:off x="4078224" y="5330952"/>
-            <a:ext cx="347472" cy="347472"/>
-          </a:xfrm>
-          <a:prstGeom prst="ellipse">
-            <a:avLst/>
-          </a:prstGeom>
-          <a:solidFill>
-            <a:srgbClr val="7FB27A"/>
-          </a:solidFill>
-          <a:ln/>
-        </p:spPr>
-      </p:sp>
-      <p:sp>
-        <p:nvSpPr>
-          <p:cNvPr id="89" name="Text 84"/>
-          <p:cNvSpPr txBox="1"/>
-          <p:nvPr/>
-        </p:nvSpPr>
-        <p:spPr>
-          <a:xfrm>
-            <a:off x="4078224" y="5330952"/>
-            <a:ext cx="347472" cy="347472"/>
-          </a:xfrm>
-          <a:prstGeom prst="rect">
-            <a:avLst/>
-          </a:prstGeom>
-          <a:noFill/>
-          <a:ln/>
-        </p:spPr>
-        <p:txBody>
-          <a:bodyPr wrap="square" lIns="0" tIns="0" rIns="0" bIns="0" rtlCol="0" anchor="ctr"/>
-          <a:lstStyle/>
-          <a:p>
-            <a:pPr algn="ctr" indent="0" marL="0">
-              <a:buNone/>
-            </a:pPr>
-            <a:r>
-              <a:rPr lang="en-US" sz="1300" b="1" dirty="0">
-                <a:solidFill>
-                  <a:srgbClr val="FFFFFF"/>
-                </a:solidFill>
-                <a:latin typeface="IBM Plex Sans Arabic" pitchFamily="34" charset="0"/>
-                <a:ea typeface="IBM Plex Sans Arabic" pitchFamily="34" charset="-122"/>
-                <a:cs typeface="IBM Plex Sans Arabic" pitchFamily="34" charset="-120"/>
-              </a:rPr>
-              <a:t>✓</a:t>
-            </a:r>
-            <a:endParaRPr lang="en-US" sz="1300" dirty="0"/>
-          </a:p>
-        </p:txBody>
-      </p:sp>
-      <p:sp>
-        <p:nvSpPr>
-          <p:cNvPr id="90" name="Shape 85"/>
-          <p:cNvSpPr/>
-          <p:nvPr/>
-        </p:nvSpPr>
-        <p:spPr>
-          <a:xfrm>
-            <a:off x="2560320" y="5330952"/>
-            <a:ext cx="347472" cy="347472"/>
-          </a:xfrm>
-          <a:prstGeom prst="ellipse">
-            <a:avLst/>
-          </a:prstGeom>
-          <a:solidFill>
-            <a:srgbClr val="7FB27A"/>
-          </a:solidFill>
-          <a:ln/>
-        </p:spPr>
-      </p:sp>
-      <p:sp>
-        <p:nvSpPr>
-          <p:cNvPr id="91" name="Text 86"/>
-          <p:cNvSpPr txBox="1"/>
-          <p:nvPr/>
-        </p:nvSpPr>
-        <p:spPr>
-          <a:xfrm>
-            <a:off x="2560320" y="5330952"/>
-            <a:ext cx="347472" cy="347472"/>
-          </a:xfrm>
-          <a:prstGeom prst="rect">
-            <a:avLst/>
-          </a:prstGeom>
-          <a:noFill/>
-          <a:ln/>
-        </p:spPr>
-        <p:txBody>
-          <a:bodyPr wrap="square" lIns="0" tIns="0" rIns="0" bIns="0" rtlCol="0" anchor="ctr"/>
-          <a:lstStyle/>
-          <a:p>
-            <a:pPr algn="ctr" indent="0" marL="0">
-              <a:buNone/>
-            </a:pPr>
-            <a:r>
-              <a:rPr lang="en-US" sz="1300" b="1" dirty="0">
-                <a:solidFill>
-                  <a:srgbClr val="FFFFFF"/>
-                </a:solidFill>
-                <a:latin typeface="IBM Plex Sans Arabic" pitchFamily="34" charset="0"/>
-                <a:ea typeface="IBM Plex Sans Arabic" pitchFamily="34" charset="-122"/>
-                <a:cs typeface="IBM Plex Sans Arabic" pitchFamily="34" charset="-120"/>
-              </a:rPr>
-              <a:t>✓</a:t>
-            </a:r>
-            <a:endParaRPr lang="en-US" sz="1300" dirty="0"/>
-          </a:p>
-        </p:txBody>
-      </p:sp>
-      <p:sp>
-        <p:nvSpPr>
-          <p:cNvPr id="92" name="Shape 87"/>
-          <p:cNvSpPr/>
-          <p:nvPr/>
-        </p:nvSpPr>
-        <p:spPr>
-          <a:xfrm>
-            <a:off x="1042416" y="5330952"/>
-            <a:ext cx="347472" cy="347472"/>
-          </a:xfrm>
-          <a:prstGeom prst="ellipse">
-            <a:avLst/>
-          </a:prstGeom>
-          <a:solidFill>
-            <a:srgbClr val="7FB27A"/>
-          </a:solidFill>
-          <a:ln/>
-        </p:spPr>
-      </p:sp>
-      <p:sp>
-        <p:nvSpPr>
-          <p:cNvPr id="93" name="Text 88"/>
-          <p:cNvSpPr txBox="1"/>
-          <p:nvPr/>
-        </p:nvSpPr>
-        <p:spPr>
-          <a:xfrm>
-            <a:off x="1042416" y="5330952"/>
-            <a:ext cx="347472" cy="347472"/>
-          </a:xfrm>
-          <a:prstGeom prst="rect">
-            <a:avLst/>
-          </a:prstGeom>
-          <a:noFill/>
-          <a:ln/>
-        </p:spPr>
-        <p:txBody>
-          <a:bodyPr wrap="square" lIns="0" tIns="0" rIns="0" bIns="0" rtlCol="0" anchor="ctr"/>
-          <a:lstStyle/>
-          <a:p>
-            <a:pPr algn="ctr" indent="0" marL="0">
-              <a:buNone/>
-            </a:pPr>
-            <a:r>
-              <a:rPr lang="en-US" sz="1300" b="1" dirty="0">
-                <a:solidFill>
-                  <a:srgbClr val="FFFFFF"/>
-                </a:solidFill>
-                <a:latin typeface="IBM Plex Sans Arabic" pitchFamily="34" charset="0"/>
-                <a:ea typeface="IBM Plex Sans Arabic" pitchFamily="34" charset="-122"/>
-                <a:cs typeface="IBM Plex Sans Arabic" pitchFamily="34" charset="-120"/>
-              </a:rPr>
-              <a:t>✓</a:t>
-            </a:r>
-            <a:endParaRPr lang="en-US" sz="1300" dirty="0"/>
-          </a:p>
-        </p:txBody>
-      </p:sp>
-      <p:sp>
-        <p:nvSpPr>
-          <p:cNvPr id="94" name="Shape 89"/>
-          <p:cNvSpPr/>
-          <p:nvPr/>
-        </p:nvSpPr>
-        <p:spPr>
-          <a:xfrm>
-            <a:off x="11551615" y="5943600"/>
-            <a:ext cx="182880" cy="182880"/>
-          </a:xfrm>
-          <a:prstGeom prst="ellipse">
-            <a:avLst/>
-          </a:prstGeom>
-          <a:solidFill>
-            <a:srgbClr val="7FB27A"/>
-          </a:solidFill>
-          <a:ln/>
-        </p:spPr>
-      </p:sp>
-      <p:sp>
-        <p:nvSpPr>
-          <p:cNvPr id="95" name="Text 90"/>
-          <p:cNvSpPr txBox="1"/>
-          <p:nvPr/>
-        </p:nvSpPr>
-        <p:spPr>
-          <a:xfrm>
-            <a:off x="10865815" y="5879592"/>
-            <a:ext cx="612648" cy="310896"/>
-          </a:xfrm>
-          <a:prstGeom prst="rect">
-            <a:avLst/>
-          </a:prstGeom>
-          <a:noFill/>
-          <a:ln/>
-        </p:spPr>
-        <p:txBody>
-          <a:bodyPr wrap="square" lIns="0" tIns="0" rIns="0" bIns="0" rtlCol="0" anchor="t"/>
-          <a:lstStyle/>
-          <a:p>
-            <a:pPr rtl="1" algn="r" indent="0" marL="0">
-              <a:buNone/>
-            </a:pPr>
-            <a:r>
-              <a:rPr lang="en-US" sz="1200" dirty="0">
-                <a:solidFill>
-                  <a:srgbClr val="7F6C72"/>
-                </a:solidFill>
-                <a:latin typeface="IBM Plex Sans Arabic" pitchFamily="34" charset="0"/>
-                <a:ea typeface="IBM Plex Sans Arabic" pitchFamily="34" charset="-122"/>
-                <a:cs typeface="IBM Plex Sans Arabic" pitchFamily="34" charset="-120"/>
-              </a:rPr>
-              <a:t>نعم</a:t>
-            </a:r>
-            <a:endParaRPr lang="en-US" sz="1200" dirty="0"/>
-          </a:p>
-        </p:txBody>
-      </p:sp>
-      <p:sp>
-        <p:nvSpPr>
-          <p:cNvPr id="96" name="Shape 91"/>
-          <p:cNvSpPr/>
-          <p:nvPr/>
-        </p:nvSpPr>
-        <p:spPr>
-          <a:xfrm>
-            <a:off x="10591495" y="5943600"/>
-            <a:ext cx="182880" cy="182880"/>
-          </a:xfrm>
-          <a:prstGeom prst="ellipse">
-            <a:avLst/>
-          </a:prstGeom>
-          <a:solidFill>
-            <a:srgbClr val="C9A46E"/>
-          </a:solidFill>
-          <a:ln/>
-        </p:spPr>
-      </p:sp>
-      <p:sp>
-        <p:nvSpPr>
-          <p:cNvPr id="97" name="Text 92"/>
-          <p:cNvSpPr txBox="1"/>
-          <p:nvPr/>
-        </p:nvSpPr>
-        <p:spPr>
-          <a:xfrm>
-            <a:off x="9905695" y="5879592"/>
-            <a:ext cx="612648" cy="310896"/>
-          </a:xfrm>
-          <a:prstGeom prst="rect">
-            <a:avLst/>
-          </a:prstGeom>
-          <a:noFill/>
-          <a:ln/>
-        </p:spPr>
-        <p:txBody>
-          <a:bodyPr wrap="square" lIns="0" tIns="0" rIns="0" bIns="0" rtlCol="0" anchor="t"/>
-          <a:lstStyle/>
-          <a:p>
-            <a:pPr rtl="1" algn="r" indent="0" marL="0">
-              <a:buNone/>
-            </a:pPr>
-            <a:r>
-              <a:rPr lang="en-US" sz="1200" dirty="0">
-                <a:solidFill>
-                  <a:srgbClr val="7F6C72"/>
-                </a:solidFill>
-                <a:latin typeface="IBM Plex Sans Arabic" pitchFamily="34" charset="0"/>
-                <a:ea typeface="IBM Plex Sans Arabic" pitchFamily="34" charset="-122"/>
-                <a:cs typeface="IBM Plex Sans Arabic" pitchFamily="34" charset="-120"/>
-              </a:rPr>
-              <a:t>جزئياً</a:t>
-            </a:r>
-            <a:endParaRPr lang="en-US" sz="1200" dirty="0"/>
-          </a:p>
-        </p:txBody>
-      </p:sp>
-      <p:sp>
-        <p:nvSpPr>
-          <p:cNvPr id="98" name="Shape 93"/>
-          <p:cNvSpPr/>
-          <p:nvPr/>
-        </p:nvSpPr>
-        <p:spPr>
-          <a:xfrm>
-            <a:off x="9631375" y="5943600"/>
-            <a:ext cx="182880" cy="182880"/>
-          </a:xfrm>
-          <a:prstGeom prst="ellipse">
-            <a:avLst/>
-          </a:prstGeom>
-          <a:solidFill>
-            <a:srgbClr val="D48A93"/>
-          </a:solidFill>
-          <a:ln/>
-        </p:spPr>
-      </p:sp>
-      <p:sp>
-        <p:nvSpPr>
-          <p:cNvPr id="99" name="Text 94"/>
-          <p:cNvSpPr txBox="1"/>
-          <p:nvPr/>
-        </p:nvSpPr>
-        <p:spPr>
-          <a:xfrm>
-            <a:off x="8945575" y="5879592"/>
-            <a:ext cx="612648" cy="310896"/>
-          </a:xfrm>
-          <a:prstGeom prst="rect">
-            <a:avLst/>
-          </a:prstGeom>
-          <a:noFill/>
-          <a:ln/>
-        </p:spPr>
-        <p:txBody>
-          <a:bodyPr wrap="square" lIns="0" tIns="0" rIns="0" bIns="0" rtlCol="0" anchor="t"/>
-          <a:lstStyle/>
-          <a:p>
-            <a:pPr rtl="1" algn="r" indent="0" marL="0">
-              <a:buNone/>
-            </a:pPr>
-            <a:r>
-              <a:rPr lang="en-US" sz="1200" dirty="0">
-                <a:solidFill>
-                  <a:srgbClr val="7F6C72"/>
-                </a:solidFill>
-                <a:latin typeface="IBM Plex Sans Arabic" pitchFamily="34" charset="0"/>
-                <a:ea typeface="IBM Plex Sans Arabic" pitchFamily="34" charset="-122"/>
-                <a:cs typeface="IBM Plex Sans Arabic" pitchFamily="34" charset="-120"/>
-              </a:rPr>
-              <a:t>لا</a:t>
-            </a:r>
-            <a:endParaRPr lang="en-US" sz="1200" dirty="0"/>
           </a:p>
         </p:txBody>
       </p:sp>
@@ -11796,7 +10612,7 @@
                 <a:ea typeface="IBM Plex Sans Arabic" pitchFamily="34" charset="-122"/>
                 <a:cs typeface="IBM Plex Sans Arabic" pitchFamily="34" charset="-120"/>
               </a:rPr>
-              <a:t>شركات سعودية من 50 إلى 250 موظفاً</a:t>
+              <a:t>شركات فاتورتها السحابية عشرات الآلاف شهرياً</a:t>
             </a:r>
             <a:endParaRPr lang="en-US" sz="3400" dirty="0"/>
           </a:p>
@@ -11835,7 +10651,7 @@
                 <a:ea typeface="IBM Plex Sans Arabic" pitchFamily="34" charset="-122"/>
                 <a:cs typeface="IBM Plex Sans Arabic" pitchFamily="34" charset="-120"/>
               </a:rPr>
-              <a:t>بلا فريق FinOps، وفاتورتها عشرات الآلاف شهرياً</a:t>
+              <a:t>50 إلى 250 موظفاً، وهدر مؤلم يجعل عائد الاشتراك واضحاً</a:t>
             </a:r>
             <a:endParaRPr lang="en-US" sz="1800" dirty="0"/>
           </a:p>
@@ -12793,7 +11609,7 @@
         <p:spPr>
           <a:xfrm>
             <a:off x="9566819" y="1554480"/>
-            <a:ext cx="2167677" cy="3017520"/>
+            <a:ext cx="2167677" cy="2834640"/>
           </a:xfrm>
           <a:prstGeom prst="roundRect">
             <a:avLst>
@@ -13060,11 +11876,11 @@
         <p:spPr>
           <a:xfrm>
             <a:off x="7289414" y="1554480"/>
-            <a:ext cx="2167677" cy="1453896"/>
+            <a:ext cx="2167677" cy="1362456"/>
           </a:xfrm>
           <a:prstGeom prst="roundRect">
             <a:avLst>
-              <a:gd name="adj" fmla="val 8805"/>
+              <a:gd name="adj" fmla="val 9396"/>
             </a:avLst>
           </a:prstGeom>
           <a:solidFill>
@@ -13267,12 +12083,12 @@
         </p:nvSpPr>
         <p:spPr>
           <a:xfrm>
-            <a:off x="7289414" y="3118104"/>
-            <a:ext cx="2167677" cy="1453896"/>
+            <a:off x="7289414" y="3026664"/>
+            <a:ext cx="2167677" cy="1362456"/>
           </a:xfrm>
           <a:prstGeom prst="roundRect">
             <a:avLst>
-              <a:gd name="adj" fmla="val 8805"/>
+              <a:gd name="adj" fmla="val 9396"/>
             </a:avLst>
           </a:prstGeom>
           <a:solidFill>
@@ -13302,7 +12118,7 @@
         </p:blipFill>
         <p:spPr>
           <a:xfrm>
-            <a:off x="8963315" y="3273552"/>
+            <a:off x="8963315" y="3182112"/>
             <a:ext cx="310896" cy="310896"/>
           </a:xfrm>
           <a:prstGeom prst="rect">
@@ -13318,7 +12134,7 @@
         </p:nvSpPr>
         <p:spPr>
           <a:xfrm>
-            <a:off x="7426574" y="3246120"/>
+            <a:off x="7426574" y="3154680"/>
             <a:ext cx="1481877" cy="365760"/>
           </a:xfrm>
           <a:prstGeom prst="rect">
@@ -13357,7 +12173,7 @@
         </p:nvSpPr>
         <p:spPr>
           <a:xfrm>
-            <a:off x="9182771" y="3858768"/>
+            <a:off x="9182771" y="3767328"/>
             <a:ext cx="82296" cy="82296"/>
           </a:xfrm>
           <a:prstGeom prst="rect">
@@ -13377,7 +12193,7 @@
         </p:nvSpPr>
         <p:spPr>
           <a:xfrm>
-            <a:off x="7426574" y="3739896"/>
+            <a:off x="7426574" y="3648456"/>
             <a:ext cx="1664757" cy="329184"/>
           </a:xfrm>
           <a:prstGeom prst="rect">
@@ -13402,7 +12218,7 @@
                 <a:ea typeface="IBM Plex Sans Arabic" pitchFamily="34" charset="-122"/>
                 <a:cs typeface="IBM Plex Sans Arabic" pitchFamily="34" charset="-120"/>
               </a:rPr>
-              <a:t>الموقع والفحص المجاني</a:t>
+              <a:t>الموقع والفحص</a:t>
             </a:r>
             <a:endParaRPr lang="en-US" sz="1250" dirty="0"/>
           </a:p>
@@ -13416,7 +12232,7 @@
         </p:nvSpPr>
         <p:spPr>
           <a:xfrm>
-            <a:off x="9182771" y="4187952"/>
+            <a:off x="9182771" y="4096512"/>
             <a:ext cx="82296" cy="82296"/>
           </a:xfrm>
           <a:prstGeom prst="rect">
@@ -13436,7 +12252,7 @@
         </p:nvSpPr>
         <p:spPr>
           <a:xfrm>
-            <a:off x="7426574" y="4069080"/>
+            <a:off x="7426574" y="3977640"/>
             <a:ext cx="1664757" cy="329184"/>
           </a:xfrm>
           <a:prstGeom prst="rect">
@@ -13476,7 +12292,7 @@
         <p:spPr>
           <a:xfrm>
             <a:off x="5012009" y="1554480"/>
-            <a:ext cx="2167677" cy="3017520"/>
+            <a:ext cx="2167677" cy="2834640"/>
           </a:xfrm>
           <a:prstGeom prst="roundRect">
             <a:avLst>
@@ -13797,11 +12613,11 @@
         <p:spPr>
           <a:xfrm>
             <a:off x="2734605" y="1554480"/>
-            <a:ext cx="2167677" cy="1453896"/>
+            <a:ext cx="2167677" cy="1362456"/>
           </a:xfrm>
           <a:prstGeom prst="roundRect">
             <a:avLst>
-              <a:gd name="adj" fmla="val 8805"/>
+              <a:gd name="adj" fmla="val 9396"/>
             </a:avLst>
           </a:prstGeom>
           <a:solidFill>
@@ -14004,12 +12820,12 @@
         </p:nvSpPr>
         <p:spPr>
           <a:xfrm>
-            <a:off x="2734605" y="3118104"/>
-            <a:ext cx="2167677" cy="1453896"/>
+            <a:off x="2734605" y="3026664"/>
+            <a:ext cx="2167677" cy="1362456"/>
           </a:xfrm>
           <a:prstGeom prst="roundRect">
             <a:avLst>
-              <a:gd name="adj" fmla="val 8805"/>
+              <a:gd name="adj" fmla="val 9396"/>
             </a:avLst>
           </a:prstGeom>
           <a:solidFill>
@@ -14039,7 +12855,7 @@
         </p:blipFill>
         <p:spPr>
           <a:xfrm>
-            <a:off x="4408505" y="3273552"/>
+            <a:off x="4408505" y="3182112"/>
             <a:ext cx="310896" cy="310896"/>
           </a:xfrm>
           <a:prstGeom prst="rect">
@@ -14055,7 +12871,7 @@
         </p:nvSpPr>
         <p:spPr>
           <a:xfrm>
-            <a:off x="2871765" y="3246120"/>
+            <a:off x="2871765" y="3154680"/>
             <a:ext cx="1481877" cy="365760"/>
           </a:xfrm>
           <a:prstGeom prst="rect">
@@ -14094,7 +12910,7 @@
         </p:nvSpPr>
         <p:spPr>
           <a:xfrm>
-            <a:off x="4627961" y="3858768"/>
+            <a:off x="4627961" y="3767328"/>
             <a:ext cx="82296" cy="82296"/>
           </a:xfrm>
           <a:prstGeom prst="rect">
@@ -14114,7 +12930,7 @@
         </p:nvSpPr>
         <p:spPr>
           <a:xfrm>
-            <a:off x="2871765" y="3739896"/>
+            <a:off x="2871765" y="3648456"/>
             <a:ext cx="1664757" cy="329184"/>
           </a:xfrm>
           <a:prstGeom prst="rect">
@@ -14153,7 +12969,7 @@
         </p:nvSpPr>
         <p:spPr>
           <a:xfrm>
-            <a:off x="4627961" y="4187952"/>
+            <a:off x="4627961" y="4096512"/>
             <a:ext cx="82296" cy="82296"/>
           </a:xfrm>
           <a:prstGeom prst="rect">
@@ -14173,7 +12989,7 @@
         </p:nvSpPr>
         <p:spPr>
           <a:xfrm>
-            <a:off x="2871765" y="4069080"/>
+            <a:off x="2871765" y="3977640"/>
             <a:ext cx="1664757" cy="329184"/>
           </a:xfrm>
           <a:prstGeom prst="rect">
@@ -14213,7 +13029,7 @@
         <p:spPr>
           <a:xfrm>
             <a:off x="457200" y="1554480"/>
-            <a:ext cx="2167677" cy="3017520"/>
+            <a:ext cx="2167677" cy="2834640"/>
           </a:xfrm>
           <a:prstGeom prst="roundRect">
             <a:avLst>
@@ -14479,12 +13295,12 @@
         </p:nvSpPr>
         <p:spPr>
           <a:xfrm>
-            <a:off x="6150712" y="4681728"/>
-            <a:ext cx="5583784" cy="1417320"/>
+            <a:off x="6150712" y="4498848"/>
+            <a:ext cx="5583784" cy="1600200"/>
           </a:xfrm>
           <a:prstGeom prst="roundRect">
             <a:avLst>
-              <a:gd name="adj" fmla="val 9032"/>
+              <a:gd name="adj" fmla="val 8000"/>
             </a:avLst>
           </a:prstGeom>
           <a:solidFill>
@@ -14514,7 +13330,7 @@
         </p:blipFill>
         <p:spPr>
           <a:xfrm>
-            <a:off x="11240719" y="4837176"/>
+            <a:off x="11240719" y="4654296"/>
             <a:ext cx="310896" cy="310896"/>
           </a:xfrm>
           <a:prstGeom prst="rect">
@@ -14530,7 +13346,7 @@
         </p:nvSpPr>
         <p:spPr>
           <a:xfrm>
-            <a:off x="6287872" y="4809744"/>
+            <a:off x="6287872" y="4626864"/>
             <a:ext cx="4897984" cy="365760"/>
           </a:xfrm>
           <a:prstGeom prst="rect">
@@ -14569,7 +13385,7 @@
         </p:nvSpPr>
         <p:spPr>
           <a:xfrm>
-            <a:off x="11460175" y="5422392"/>
+            <a:off x="11460175" y="5239512"/>
             <a:ext cx="82296" cy="82296"/>
           </a:xfrm>
           <a:prstGeom prst="rect">
@@ -14589,7 +13405,7 @@
         </p:nvSpPr>
         <p:spPr>
           <a:xfrm>
-            <a:off x="6287872" y="5303520"/>
+            <a:off x="6287872" y="5120640"/>
             <a:ext cx="5080864" cy="329184"/>
           </a:xfrm>
           <a:prstGeom prst="rect">
@@ -14606,7 +13422,7 @@
               <a:buNone/>
             </a:pPr>
             <a:r>
-              <a:rPr lang="en-US" sz="1350" dirty="0">
+              <a:rPr lang="en-US" sz="1300" dirty="0">
                 <a:solidFill>
                   <a:srgbClr val="21141A"/>
                 </a:solidFill>
@@ -14614,9 +13430,9 @@
                 <a:ea typeface="IBM Plex Sans Arabic" pitchFamily="34" charset="-122"/>
                 <a:cs typeface="IBM Plex Sans Arabic" pitchFamily="34" charset="-120"/>
               </a:rPr>
-              <a:t>فحص أول مجاني · من 15 ريال لكل مورد</a:t>
-            </a:r>
-            <a:endParaRPr lang="en-US" sz="1350" dirty="0"/>
+              <a:t>اشتراك SaaS مرن حسب حجم الفاتورة</a:t>
+            </a:r>
+            <a:endParaRPr lang="en-US" sz="1300" dirty="0"/>
           </a:p>
         </p:txBody>
       </p:sp>
@@ -14628,7 +13444,7 @@
         </p:nvSpPr>
         <p:spPr>
           <a:xfrm>
-            <a:off x="11460175" y="5788152"/>
+            <a:off x="11460175" y="5568696"/>
             <a:ext cx="82296" cy="82296"/>
           </a:xfrm>
           <a:prstGeom prst="rect">
@@ -14648,7 +13464,7 @@
         </p:nvSpPr>
         <p:spPr>
           <a:xfrm>
-            <a:off x="6287872" y="5669280"/>
+            <a:off x="6287872" y="5449824"/>
             <a:ext cx="5080864" cy="329184"/>
           </a:xfrm>
           <a:prstGeom prst="rect">
@@ -14665,7 +13481,7 @@
               <a:buNone/>
             </a:pPr>
             <a:r>
-              <a:rPr lang="en-US" sz="1350" dirty="0">
+              <a:rPr lang="en-US" sz="1300" dirty="0">
                 <a:solidFill>
                   <a:srgbClr val="21141A"/>
                 </a:solidFill>
@@ -14673,9 +13489,9 @@
                 <a:ea typeface="IBM Plex Sans Arabic" pitchFamily="34" charset="-122"/>
                 <a:cs typeface="IBM Plex Sans Arabic" pitchFamily="34" charset="-120"/>
               </a:rPr>
-              <a:t>استشارات FinOps حسب المشروع</a:t>
-            </a:r>
-            <a:endParaRPr lang="en-US" sz="1350" dirty="0"/>
+              <a:t>أو نسبة من التوفير المحقق</a:t>
+            </a:r>
+            <a:endParaRPr lang="en-US" sz="1300" dirty="0"/>
           </a:p>
         </p:txBody>
       </p:sp>
@@ -14687,12 +13503,71 @@
         </p:nvSpPr>
         <p:spPr>
           <a:xfrm>
-            <a:off x="457200" y="4681728"/>
-            <a:ext cx="5583784" cy="1417320"/>
+            <a:off x="11460175" y="5897880"/>
+            <a:ext cx="82296" cy="82296"/>
+          </a:xfrm>
+          <a:prstGeom prst="rect">
+            <a:avLst/>
+          </a:prstGeom>
+          <a:solidFill>
+            <a:srgbClr val="D48A93"/>
+          </a:solidFill>
+          <a:ln/>
+        </p:spPr>
+      </p:sp>
+      <p:sp>
+        <p:nvSpPr>
+          <p:cNvPr id="87" name="Text 74"/>
+          <p:cNvSpPr txBox="1"/>
+          <p:nvPr/>
+        </p:nvSpPr>
+        <p:spPr>
+          <a:xfrm>
+            <a:off x="6287872" y="5779008"/>
+            <a:ext cx="5080864" cy="329184"/>
+          </a:xfrm>
+          <a:prstGeom prst="rect">
+            <a:avLst/>
+          </a:prstGeom>
+          <a:noFill/>
+          <a:ln/>
+        </p:spPr>
+        <p:txBody>
+          <a:bodyPr wrap="square" lIns="0" tIns="0" rIns="0" bIns="0" rtlCol="0" anchor="ctr"/>
+          <a:lstStyle/>
+          <a:p>
+            <a:pPr rtl="1" algn="r" indent="0" marL="0">
+              <a:buNone/>
+            </a:pPr>
+            <a:r>
+              <a:rPr lang="en-US" sz="1300" dirty="0">
+                <a:solidFill>
+                  <a:srgbClr val="21141A"/>
+                </a:solidFill>
+                <a:latin typeface="IBM Plex Sans Arabic" pitchFamily="34" charset="0"/>
+                <a:ea typeface="IBM Plex Sans Arabic" pitchFamily="34" charset="-122"/>
+                <a:cs typeface="IBM Plex Sans Arabic" pitchFamily="34" charset="-120"/>
+              </a:rPr>
+              <a:t>فحص أول مجاني · استشارات FinOps</a:t>
+            </a:r>
+            <a:endParaRPr lang="en-US" sz="1300" dirty="0"/>
+          </a:p>
+        </p:txBody>
+      </p:sp>
+      <p:sp>
+        <p:nvSpPr>
+          <p:cNvPr id="88" name="Shape 75"/>
+          <p:cNvSpPr/>
+          <p:nvPr/>
+        </p:nvSpPr>
+        <p:spPr>
+          <a:xfrm>
+            <a:off x="457200" y="4498848"/>
+            <a:ext cx="5583784" cy="1600200"/>
           </a:xfrm>
           <a:prstGeom prst="roundRect">
             <a:avLst>
-              <a:gd name="adj" fmla="val 9032"/>
+              <a:gd name="adj" fmla="val 8000"/>
             </a:avLst>
           </a:prstGeom>
           <a:solidFill>
@@ -14708,7 +13583,7 @@
       </p:sp>
       <p:pic>
         <p:nvPicPr>
-          <p:cNvPr id="87" name="Image 11" descr="/tmp/claude-0/-home-claude/750ff410-f4aa-5276-9360-1e19d018b112/scratchpad/c/assets/i-receipt-br.png">    </p:cNvPr>
+          <p:cNvPr id="89" name="Image 11" descr="/tmp/claude-0/-home-claude/750ff410-f4aa-5276-9360-1e19d018b112/scratchpad/c/assets/i-receipt-br.png">    </p:cNvPr>
           <p:cNvPicPr>
             <a:picLocks noChangeAspect="1"/>
           </p:cNvPicPr>
@@ -14722,7 +13597,7 @@
         </p:blipFill>
         <p:spPr>
           <a:xfrm>
-            <a:off x="5547208" y="4837176"/>
+            <a:off x="5547208" y="4654296"/>
             <a:ext cx="310896" cy="310896"/>
           </a:xfrm>
           <a:prstGeom prst="rect">
@@ -14732,13 +13607,13 @@
       </p:pic>
       <p:sp>
         <p:nvSpPr>
-          <p:cNvPr id="88" name="Text 74"/>
-          <p:cNvSpPr txBox="1"/>
-          <p:nvPr/>
-        </p:nvSpPr>
-        <p:spPr>
-          <a:xfrm>
-            <a:off x="594360" y="4809744"/>
+          <p:cNvPr id="90" name="Text 76"/>
+          <p:cNvSpPr txBox="1"/>
+          <p:nvPr/>
+        </p:nvSpPr>
+        <p:spPr>
+          <a:xfrm>
+            <a:off x="594360" y="4626864"/>
             <a:ext cx="4897984" cy="365760"/>
           </a:xfrm>
           <a:prstGeom prst="rect">
@@ -14771,13 +13646,13 @@
       </p:sp>
       <p:sp>
         <p:nvSpPr>
-          <p:cNvPr id="89" name="Shape 75"/>
-          <p:cNvSpPr/>
-          <p:nvPr/>
-        </p:nvSpPr>
-        <p:spPr>
-          <a:xfrm>
-            <a:off x="5766664" y="5422392"/>
+          <p:cNvPr id="91" name="Shape 77"/>
+          <p:cNvSpPr/>
+          <p:nvPr/>
+        </p:nvSpPr>
+        <p:spPr>
+          <a:xfrm>
+            <a:off x="5766664" y="5239512"/>
             <a:ext cx="82296" cy="82296"/>
           </a:xfrm>
           <a:prstGeom prst="rect">
@@ -14791,13 +13666,13 @@
       </p:sp>
       <p:sp>
         <p:nvSpPr>
-          <p:cNvPr id="90" name="Text 76"/>
-          <p:cNvSpPr txBox="1"/>
-          <p:nvPr/>
-        </p:nvSpPr>
-        <p:spPr>
-          <a:xfrm>
-            <a:off x="594360" y="5303520"/>
+          <p:cNvPr id="92" name="Text 78"/>
+          <p:cNvSpPr txBox="1"/>
+          <p:nvPr/>
+        </p:nvSpPr>
+        <p:spPr>
+          <a:xfrm>
+            <a:off x="594360" y="5120640"/>
             <a:ext cx="5080864" cy="329184"/>
           </a:xfrm>
           <a:prstGeom prst="rect">
@@ -14830,13 +13705,13 @@
       </p:sp>
       <p:sp>
         <p:nvSpPr>
-          <p:cNvPr id="91" name="Shape 77"/>
-          <p:cNvSpPr/>
-          <p:nvPr/>
-        </p:nvSpPr>
-        <p:spPr>
-          <a:xfrm>
-            <a:off x="5766664" y="5788152"/>
+          <p:cNvPr id="93" name="Shape 79"/>
+          <p:cNvSpPr/>
+          <p:nvPr/>
+        </p:nvSpPr>
+        <p:spPr>
+          <a:xfrm>
+            <a:off x="5766664" y="5605272"/>
             <a:ext cx="82296" cy="82296"/>
           </a:xfrm>
           <a:prstGeom prst="rect">
@@ -14850,13 +13725,13 @@
       </p:sp>
       <p:sp>
         <p:nvSpPr>
-          <p:cNvPr id="92" name="Text 78"/>
-          <p:cNvSpPr txBox="1"/>
-          <p:nvPr/>
-        </p:nvSpPr>
-        <p:spPr>
-          <a:xfrm>
-            <a:off x="594360" y="5669280"/>
+          <p:cNvPr id="94" name="Text 80"/>
+          <p:cNvSpPr txBox="1"/>
+          <p:nvPr/>
+        </p:nvSpPr>
+        <p:spPr>
+          <a:xfrm>
+            <a:off x="594360" y="5486400"/>
             <a:ext cx="5080864" cy="329184"/>
           </a:xfrm>
           <a:prstGeom prst="rect">
@@ -15672,7 +14547,7 @@
                 <a:ea typeface="IBM Plex Sans Arabic" pitchFamily="34" charset="-122"/>
                 <a:cs typeface="IBM Plex Sans Arabic" pitchFamily="34" charset="-120"/>
               </a:rPr>
-              <a:t>نموذج ذكاء اصطناعي يمسح البنية فوراً ويطابقها مع أفضل الممارسات ويحلل الأحمال</a:t>
+              <a:t>الذكاء الاصطناعي يحلل مخرجات الـ APIs ويطبّق قواعد FinOps القياسية</a:t>
             </a:r>
             <a:endParaRPr lang="en-US" sz="1600" dirty="0"/>
           </a:p>
@@ -16664,7 +15539,7 @@
                 <a:ea typeface="IBM Plex Sans Arabic" pitchFamily="34" charset="-122"/>
                 <a:cs typeface="IBM Plex Sans Arabic" pitchFamily="34" charset="-120"/>
               </a:rPr>
-              <a:t>يعمل الآن، جرّبه بنفسك</a:t>
+              <a:t>لقطات تجريبية من الواجهات · MVP Design</a:t>
             </a:r>
             <a:endParaRPr lang="en-US" sz="3400" dirty="0"/>
           </a:p>

</xml_diff>